<commit_message>
Single-layer to 3-layer (1064nm)
Formatted to Opt. Commun.
</commit_message>
<xml_diff>
--- a/figs/figures.pptx
+++ b/figs/figures.pptx
@@ -208,7 +208,7 @@
           <a:p>
             <a:fld id="{2DD6ECBE-534E-4AEE-8ADA-897E2D67A90F}" type="datetimeFigureOut">
               <a:rPr lang="en-GB" smtClean="0"/>
-              <a:t>19/03/2026</a:t>
+              <a:t>07/04/2026</a:t>
             </a:fld>
             <a:endParaRPr lang="en-GB"/>
           </a:p>
@@ -709,7 +709,7 @@
           <a:p>
             <a:fld id="{6DA190FC-D844-4E0A-A0A2-219D558319DC}" type="datetimeFigureOut">
               <a:rPr lang="en-GB" smtClean="0"/>
-              <a:t>19/03/2026</a:t>
+              <a:t>07/04/2026</a:t>
             </a:fld>
             <a:endParaRPr lang="en-GB"/>
           </a:p>
@@ -909,7 +909,7 @@
           <a:p>
             <a:fld id="{6DA190FC-D844-4E0A-A0A2-219D558319DC}" type="datetimeFigureOut">
               <a:rPr lang="en-GB" smtClean="0"/>
-              <a:t>19/03/2026</a:t>
+              <a:t>07/04/2026</a:t>
             </a:fld>
             <a:endParaRPr lang="en-GB"/>
           </a:p>
@@ -1119,7 +1119,7 @@
           <a:p>
             <a:fld id="{6DA190FC-D844-4E0A-A0A2-219D558319DC}" type="datetimeFigureOut">
               <a:rPr lang="en-GB" smtClean="0"/>
-              <a:t>19/03/2026</a:t>
+              <a:t>07/04/2026</a:t>
             </a:fld>
             <a:endParaRPr lang="en-GB"/>
           </a:p>
@@ -1319,7 +1319,7 @@
           <a:p>
             <a:fld id="{6DA190FC-D844-4E0A-A0A2-219D558319DC}" type="datetimeFigureOut">
               <a:rPr lang="en-GB" smtClean="0"/>
-              <a:t>19/03/2026</a:t>
+              <a:t>07/04/2026</a:t>
             </a:fld>
             <a:endParaRPr lang="en-GB"/>
           </a:p>
@@ -1595,7 +1595,7 @@
           <a:p>
             <a:fld id="{6DA190FC-D844-4E0A-A0A2-219D558319DC}" type="datetimeFigureOut">
               <a:rPr lang="en-GB" smtClean="0"/>
-              <a:t>19/03/2026</a:t>
+              <a:t>07/04/2026</a:t>
             </a:fld>
             <a:endParaRPr lang="en-GB"/>
           </a:p>
@@ -1863,7 +1863,7 @@
           <a:p>
             <a:fld id="{6DA190FC-D844-4E0A-A0A2-219D558319DC}" type="datetimeFigureOut">
               <a:rPr lang="en-GB" smtClean="0"/>
-              <a:t>19/03/2026</a:t>
+              <a:t>07/04/2026</a:t>
             </a:fld>
             <a:endParaRPr lang="en-GB"/>
           </a:p>
@@ -2278,7 +2278,7 @@
           <a:p>
             <a:fld id="{6DA190FC-D844-4E0A-A0A2-219D558319DC}" type="datetimeFigureOut">
               <a:rPr lang="en-GB" smtClean="0"/>
-              <a:t>19/03/2026</a:t>
+              <a:t>07/04/2026</a:t>
             </a:fld>
             <a:endParaRPr lang="en-GB"/>
           </a:p>
@@ -2420,7 +2420,7 @@
           <a:p>
             <a:fld id="{6DA190FC-D844-4E0A-A0A2-219D558319DC}" type="datetimeFigureOut">
               <a:rPr lang="en-GB" smtClean="0"/>
-              <a:t>19/03/2026</a:t>
+              <a:t>07/04/2026</a:t>
             </a:fld>
             <a:endParaRPr lang="en-GB"/>
           </a:p>
@@ -2533,7 +2533,7 @@
           <a:p>
             <a:fld id="{6DA190FC-D844-4E0A-A0A2-219D558319DC}" type="datetimeFigureOut">
               <a:rPr lang="en-GB" smtClean="0"/>
-              <a:t>19/03/2026</a:t>
+              <a:t>07/04/2026</a:t>
             </a:fld>
             <a:endParaRPr lang="en-GB"/>
           </a:p>
@@ -2846,7 +2846,7 @@
           <a:p>
             <a:fld id="{6DA190FC-D844-4E0A-A0A2-219D558319DC}" type="datetimeFigureOut">
               <a:rPr lang="en-GB" smtClean="0"/>
-              <a:t>19/03/2026</a:t>
+              <a:t>07/04/2026</a:t>
             </a:fld>
             <a:endParaRPr lang="en-GB"/>
           </a:p>
@@ -3135,7 +3135,7 @@
           <a:p>
             <a:fld id="{6DA190FC-D844-4E0A-A0A2-219D558319DC}" type="datetimeFigureOut">
               <a:rPr lang="en-GB" smtClean="0"/>
-              <a:t>19/03/2026</a:t>
+              <a:t>07/04/2026</a:t>
             </a:fld>
             <a:endParaRPr lang="en-GB"/>
           </a:p>
@@ -3378,7 +3378,7 @@
           <a:p>
             <a:fld id="{6DA190FC-D844-4E0A-A0A2-219D558319DC}" type="datetimeFigureOut">
               <a:rPr lang="en-GB" smtClean="0"/>
-              <a:t>19/03/2026</a:t>
+              <a:t>07/04/2026</a:t>
             </a:fld>
             <a:endParaRPr lang="en-GB"/>
           </a:p>
@@ -5434,7 +5434,7 @@
                 <a:latin typeface="Arial" panose="020B0604020202020204" pitchFamily="34" charset="0"/>
                 <a:cs typeface="Arial" panose="020B0604020202020204" pitchFamily="34" charset="0"/>
               </a:rPr>
-              <a:t>1</a:t>
+              <a:t>2</a:t>
             </a:r>
             <a:endParaRPr lang="en-GB" sz="2400" dirty="0">
               <a:latin typeface="Arial" panose="020B0604020202020204" pitchFamily="34" charset="0"/>
@@ -5483,7 +5483,7 @@
                 <a:latin typeface="Arial" panose="020B0604020202020204" pitchFamily="34" charset="0"/>
                 <a:cs typeface="Arial" panose="020B0604020202020204" pitchFamily="34" charset="0"/>
               </a:rPr>
-              <a:t>2</a:t>
+              <a:t>1</a:t>
             </a:r>
             <a:endParaRPr lang="en-GB" sz="2400" dirty="0">
               <a:latin typeface="Arial" panose="020B0604020202020204" pitchFamily="34" charset="0"/>
@@ -5551,7 +5551,7 @@
         </p:nvSpPr>
         <p:spPr>
           <a:xfrm>
-            <a:off x="8207277" y="2812310"/>
+            <a:off x="8207277" y="2829562"/>
             <a:ext cx="213360" cy="1030700"/>
           </a:xfrm>
           <a:prstGeom prst="rightBrace">
@@ -5605,7 +5605,7 @@
             </p:nvSpPr>
             <p:spPr>
               <a:xfrm>
-                <a:off x="8420637" y="2932006"/>
+                <a:off x="8377507" y="2966510"/>
                 <a:ext cx="417102" cy="791307"/>
               </a:xfrm>
               <a:prstGeom prst="rect">
@@ -5619,6 +5619,7 @@
               </a:bodyPr>
               <a:lstStyle/>
               <a:p>
+                <a:pPr/>
                 <a14:m>
                   <m:oMathPara xmlns:m="http://schemas.openxmlformats.org/officeDocument/2006/math">
                     <m:oMathParaPr>
@@ -5676,7 +5677,7 @@
             </p:nvSpPr>
             <p:spPr>
               <a:xfrm>
-                <a:off x="8420637" y="2932006"/>
+                <a:off x="8377507" y="2966510"/>
                 <a:ext cx="417102" cy="791307"/>
               </a:xfrm>
               <a:prstGeom prst="rect">

</xml_diff>

<commit_message>
Before tunable filter simulation
</commit_message>
<xml_diff>
--- a/figs/figures.pptx
+++ b/figs/figures.pptx
@@ -5,7 +5,7 @@
     <p:sldMasterId id="2147483648" r:id="rId1"/>
   </p:sldMasterIdLst>
   <p:notesMasterIdLst>
-    <p:notesMasterId r:id="rId21"/>
+    <p:notesMasterId r:id="rId24"/>
   </p:notesMasterIdLst>
   <p:sldIdLst>
     <p:sldId id="267" r:id="rId2"/>
@@ -14,19 +14,22 @@
     <p:sldId id="270" r:id="rId5"/>
     <p:sldId id="271" r:id="rId6"/>
     <p:sldId id="272" r:id="rId7"/>
-    <p:sldId id="273" r:id="rId8"/>
-    <p:sldId id="275" r:id="rId9"/>
-    <p:sldId id="274" r:id="rId10"/>
-    <p:sldId id="266" r:id="rId11"/>
-    <p:sldId id="256" r:id="rId12"/>
-    <p:sldId id="257" r:id="rId13"/>
-    <p:sldId id="258" r:id="rId14"/>
-    <p:sldId id="260" r:id="rId15"/>
-    <p:sldId id="261" r:id="rId16"/>
-    <p:sldId id="262" r:id="rId17"/>
-    <p:sldId id="264" r:id="rId18"/>
-    <p:sldId id="265" r:id="rId19"/>
-    <p:sldId id="259" r:id="rId20"/>
+    <p:sldId id="275" r:id="rId8"/>
+    <p:sldId id="274" r:id="rId9"/>
+    <p:sldId id="276" r:id="rId10"/>
+    <p:sldId id="277" r:id="rId11"/>
+    <p:sldId id="278" r:id="rId12"/>
+    <p:sldId id="273" r:id="rId13"/>
+    <p:sldId id="266" r:id="rId14"/>
+    <p:sldId id="256" r:id="rId15"/>
+    <p:sldId id="257" r:id="rId16"/>
+    <p:sldId id="258" r:id="rId17"/>
+    <p:sldId id="260" r:id="rId18"/>
+    <p:sldId id="261" r:id="rId19"/>
+    <p:sldId id="262" r:id="rId20"/>
+    <p:sldId id="264" r:id="rId21"/>
+    <p:sldId id="265" r:id="rId22"/>
+    <p:sldId id="259" r:id="rId23"/>
   </p:sldIdLst>
   <p:sldSz cx="12192000" cy="6858000"/>
   <p:notesSz cx="6858000" cy="9144000"/>
@@ -215,7 +218,7 @@
           <a:p>
             <a:fld id="{2DD6ECBE-534E-4AEE-8ADA-897E2D67A90F}" type="datetimeFigureOut">
               <a:rPr lang="en-GB" smtClean="0"/>
-              <a:t>12/06/2026</a:t>
+              <a:t>16/06/2026</a:t>
             </a:fld>
             <a:endParaRPr lang="en-GB"/>
           </a:p>
@@ -730,7 +733,7 @@
           <a:p>
             <a:fld id="{03090B90-D4C3-44FA-A94E-B53CE27CF914}" type="slidenum">
               <a:rPr lang="en-GB" smtClean="0"/>
-              <a:t>7</a:t>
+              <a:t>12</a:t>
             </a:fld>
             <a:endParaRPr lang="en-GB"/>
           </a:p>
@@ -898,7 +901,7 @@
           <a:p>
             <a:fld id="{6DA190FC-D844-4E0A-A0A2-219D558319DC}" type="datetimeFigureOut">
               <a:rPr lang="en-GB" smtClean="0"/>
-              <a:t>12/06/2026</a:t>
+              <a:t>16/06/2026</a:t>
             </a:fld>
             <a:endParaRPr lang="en-GB"/>
           </a:p>
@@ -1098,7 +1101,7 @@
           <a:p>
             <a:fld id="{6DA190FC-D844-4E0A-A0A2-219D558319DC}" type="datetimeFigureOut">
               <a:rPr lang="en-GB" smtClean="0"/>
-              <a:t>12/06/2026</a:t>
+              <a:t>16/06/2026</a:t>
             </a:fld>
             <a:endParaRPr lang="en-GB"/>
           </a:p>
@@ -1308,7 +1311,7 @@
           <a:p>
             <a:fld id="{6DA190FC-D844-4E0A-A0A2-219D558319DC}" type="datetimeFigureOut">
               <a:rPr lang="en-GB" smtClean="0"/>
-              <a:t>12/06/2026</a:t>
+              <a:t>16/06/2026</a:t>
             </a:fld>
             <a:endParaRPr lang="en-GB"/>
           </a:p>
@@ -1508,7 +1511,7 @@
           <a:p>
             <a:fld id="{6DA190FC-D844-4E0A-A0A2-219D558319DC}" type="datetimeFigureOut">
               <a:rPr lang="en-GB" smtClean="0"/>
-              <a:t>12/06/2026</a:t>
+              <a:t>16/06/2026</a:t>
             </a:fld>
             <a:endParaRPr lang="en-GB"/>
           </a:p>
@@ -1784,7 +1787,7 @@
           <a:p>
             <a:fld id="{6DA190FC-D844-4E0A-A0A2-219D558319DC}" type="datetimeFigureOut">
               <a:rPr lang="en-GB" smtClean="0"/>
-              <a:t>12/06/2026</a:t>
+              <a:t>16/06/2026</a:t>
             </a:fld>
             <a:endParaRPr lang="en-GB"/>
           </a:p>
@@ -2052,7 +2055,7 @@
           <a:p>
             <a:fld id="{6DA190FC-D844-4E0A-A0A2-219D558319DC}" type="datetimeFigureOut">
               <a:rPr lang="en-GB" smtClean="0"/>
-              <a:t>12/06/2026</a:t>
+              <a:t>16/06/2026</a:t>
             </a:fld>
             <a:endParaRPr lang="en-GB"/>
           </a:p>
@@ -2467,7 +2470,7 @@
           <a:p>
             <a:fld id="{6DA190FC-D844-4E0A-A0A2-219D558319DC}" type="datetimeFigureOut">
               <a:rPr lang="en-GB" smtClean="0"/>
-              <a:t>12/06/2026</a:t>
+              <a:t>16/06/2026</a:t>
             </a:fld>
             <a:endParaRPr lang="en-GB"/>
           </a:p>
@@ -2609,7 +2612,7 @@
           <a:p>
             <a:fld id="{6DA190FC-D844-4E0A-A0A2-219D558319DC}" type="datetimeFigureOut">
               <a:rPr lang="en-GB" smtClean="0"/>
-              <a:t>12/06/2026</a:t>
+              <a:t>16/06/2026</a:t>
             </a:fld>
             <a:endParaRPr lang="en-GB"/>
           </a:p>
@@ -2722,7 +2725,7 @@
           <a:p>
             <a:fld id="{6DA190FC-D844-4E0A-A0A2-219D558319DC}" type="datetimeFigureOut">
               <a:rPr lang="en-GB" smtClean="0"/>
-              <a:t>12/06/2026</a:t>
+              <a:t>16/06/2026</a:t>
             </a:fld>
             <a:endParaRPr lang="en-GB"/>
           </a:p>
@@ -3035,7 +3038,7 @@
           <a:p>
             <a:fld id="{6DA190FC-D844-4E0A-A0A2-219D558319DC}" type="datetimeFigureOut">
               <a:rPr lang="en-GB" smtClean="0"/>
-              <a:t>12/06/2026</a:t>
+              <a:t>16/06/2026</a:t>
             </a:fld>
             <a:endParaRPr lang="en-GB"/>
           </a:p>
@@ -3324,7 +3327,7 @@
           <a:p>
             <a:fld id="{6DA190FC-D844-4E0A-A0A2-219D558319DC}" type="datetimeFigureOut">
               <a:rPr lang="en-GB" smtClean="0"/>
-              <a:t>12/06/2026</a:t>
+              <a:t>16/06/2026</a:t>
             </a:fld>
             <a:endParaRPr lang="en-GB"/>
           </a:p>
@@ -3567,7 +3570,7 @@
           <a:p>
             <a:fld id="{6DA190FC-D844-4E0A-A0A2-219D558319DC}" type="datetimeFigureOut">
               <a:rPr lang="en-GB" smtClean="0"/>
-              <a:t>12/06/2026</a:t>
+              <a:t>16/06/2026</a:t>
             </a:fld>
             <a:endParaRPr lang="en-GB"/>
           </a:p>
@@ -4135,6 +4138,1396 @@
 </file>
 
 <file path=ppt/slides/slide10.xml><?xml version="1.0" encoding="utf-8"?>
+<p:sld xmlns:a="http://schemas.openxmlformats.org/drawingml/2006/main" xmlns:r="http://schemas.openxmlformats.org/officeDocument/2006/relationships" xmlns:p="http://schemas.openxmlformats.org/presentationml/2006/main">
+  <p:cSld>
+    <p:spTree>
+      <p:nvGrpSpPr>
+        <p:cNvPr id="1" name=""/>
+        <p:cNvGrpSpPr/>
+        <p:nvPr/>
+      </p:nvGrpSpPr>
+      <p:grpSpPr>
+        <a:xfrm>
+          <a:off x="0" y="0"/>
+          <a:ext cx="0" cy="0"/>
+          <a:chOff x="0" y="0"/>
+          <a:chExt cx="0" cy="0"/>
+        </a:xfrm>
+      </p:grpSpPr>
+      <p:sp>
+        <p:nvSpPr>
+          <p:cNvPr id="5" name="Text Box 2">
+            <a:extLst>
+              <a:ext uri="{FF2B5EF4-FFF2-40B4-BE49-F238E27FC236}">
+                <a16:creationId xmlns:a16="http://schemas.microsoft.com/office/drawing/2014/main" id="{3722726E-9D0F-633C-0D2D-BB4C6A009C8E}"/>
+              </a:ext>
+            </a:extLst>
+          </p:cNvPr>
+          <p:cNvSpPr txBox="1">
+            <a:spLocks noChangeArrowheads="1"/>
+          </p:cNvSpPr>
+          <p:nvPr/>
+        </p:nvSpPr>
+        <p:spPr bwMode="auto">
+          <a:xfrm>
+            <a:off x="546652" y="1711048"/>
+            <a:ext cx="3269974" cy="307777"/>
+          </a:xfrm>
+          <a:prstGeom prst="rect">
+            <a:avLst/>
+          </a:prstGeom>
+          <a:noFill/>
+          <a:ln w="9525">
+            <a:noFill/>
+            <a:miter lim="800000"/>
+            <a:headEnd/>
+            <a:tailEnd/>
+          </a:ln>
+        </p:spPr>
+        <p:txBody>
+          <a:bodyPr rot="0" vert="horz" wrap="square" lIns="91440" tIns="45720" rIns="91440" bIns="45720" anchor="t" anchorCtr="0">
+            <a:spAutoFit/>
+          </a:bodyPr>
+          <a:lstStyle/>
+          <a:p>
+            <a:pPr algn="just"/>
+            <a:r>
+              <a:rPr lang="en-GB" sz="1400" b="1" dirty="0">
+                <a:effectLst/>
+                <a:latin typeface="Arial" panose="020B0604020202020204" pitchFamily="34" charset="0"/>
+                <a:ea typeface="TH Sarabun PSK"/>
+                <a:cs typeface="TH Sarabun PSK"/>
+              </a:rPr>
+              <a:t>(a) Single-layer design (Sb</a:t>
+            </a:r>
+            <a:r>
+              <a:rPr lang="en-GB" sz="1400" b="1" baseline="-25000" dirty="0">
+                <a:effectLst/>
+                <a:latin typeface="Arial" panose="020B0604020202020204" pitchFamily="34" charset="0"/>
+                <a:ea typeface="TH Sarabun PSK"/>
+                <a:cs typeface="TH Sarabun PSK"/>
+              </a:rPr>
+              <a:t>2</a:t>
+            </a:r>
+            <a:r>
+              <a:rPr lang="en-GB" sz="1400" b="1" dirty="0">
+                <a:effectLst/>
+                <a:latin typeface="Arial" panose="020B0604020202020204" pitchFamily="34" charset="0"/>
+                <a:ea typeface="TH Sarabun PSK"/>
+                <a:cs typeface="TH Sarabun PSK"/>
+              </a:rPr>
+              <a:t>Se</a:t>
+            </a:r>
+            <a:r>
+              <a:rPr lang="en-GB" sz="1400" b="1" baseline="-25000" dirty="0">
+                <a:effectLst/>
+                <a:latin typeface="Arial" panose="020B0604020202020204" pitchFamily="34" charset="0"/>
+                <a:ea typeface="TH Sarabun PSK"/>
+                <a:cs typeface="TH Sarabun PSK"/>
+              </a:rPr>
+              <a:t>3</a:t>
+            </a:r>
+            <a:r>
+              <a:rPr lang="en-GB" sz="1400" b="1" dirty="0">
+                <a:effectLst/>
+                <a:latin typeface="Arial" panose="020B0604020202020204" pitchFamily="34" charset="0"/>
+                <a:ea typeface="TH Sarabun PSK"/>
+                <a:cs typeface="TH Sarabun PSK"/>
+              </a:rPr>
+              <a:t>)</a:t>
+            </a:r>
+          </a:p>
+        </p:txBody>
+      </p:sp>
+      <p:sp>
+        <p:nvSpPr>
+          <p:cNvPr id="6" name="Text Box 2">
+            <a:extLst>
+              <a:ext uri="{FF2B5EF4-FFF2-40B4-BE49-F238E27FC236}">
+                <a16:creationId xmlns:a16="http://schemas.microsoft.com/office/drawing/2014/main" id="{1D00D169-D2F3-BEF0-8513-9D2E99BC0A62}"/>
+              </a:ext>
+            </a:extLst>
+          </p:cNvPr>
+          <p:cNvSpPr txBox="1">
+            <a:spLocks noChangeArrowheads="1"/>
+          </p:cNvSpPr>
+          <p:nvPr/>
+        </p:nvSpPr>
+        <p:spPr bwMode="auto">
+          <a:xfrm>
+            <a:off x="4534283" y="1705439"/>
+            <a:ext cx="3269974" cy="307777"/>
+          </a:xfrm>
+          <a:prstGeom prst="rect">
+            <a:avLst/>
+          </a:prstGeom>
+          <a:noFill/>
+          <a:ln w="9525">
+            <a:noFill/>
+            <a:miter lim="800000"/>
+            <a:headEnd/>
+            <a:tailEnd/>
+          </a:ln>
+        </p:spPr>
+        <p:txBody>
+          <a:bodyPr rot="0" vert="horz" wrap="square" lIns="91440" tIns="45720" rIns="91440" bIns="45720" anchor="t" anchorCtr="0">
+            <a:spAutoFit/>
+          </a:bodyPr>
+          <a:lstStyle/>
+          <a:p>
+            <a:pPr algn="just"/>
+            <a:r>
+              <a:rPr lang="en-GB" sz="1400" b="1" dirty="0">
+                <a:effectLst/>
+                <a:latin typeface="Arial" panose="020B0604020202020204" pitchFamily="34" charset="0"/>
+                <a:ea typeface="TH Sarabun PSK"/>
+                <a:cs typeface="TH Sarabun PSK"/>
+              </a:rPr>
+              <a:t>(b) Two-layers design (Sb</a:t>
+            </a:r>
+            <a:r>
+              <a:rPr lang="en-GB" sz="1400" b="1" baseline="-25000" dirty="0">
+                <a:effectLst/>
+                <a:latin typeface="Arial" panose="020B0604020202020204" pitchFamily="34" charset="0"/>
+                <a:ea typeface="TH Sarabun PSK"/>
+                <a:cs typeface="TH Sarabun PSK"/>
+              </a:rPr>
+              <a:t>2</a:t>
+            </a:r>
+            <a:r>
+              <a:rPr lang="en-GB" sz="1400" b="1" dirty="0">
+                <a:effectLst/>
+                <a:latin typeface="Arial" panose="020B0604020202020204" pitchFamily="34" charset="0"/>
+                <a:ea typeface="TH Sarabun PSK"/>
+                <a:cs typeface="TH Sarabun PSK"/>
+              </a:rPr>
+              <a:t>Se</a:t>
+            </a:r>
+            <a:r>
+              <a:rPr lang="en-GB" sz="1400" b="1" baseline="-25000" dirty="0">
+                <a:effectLst/>
+                <a:latin typeface="Arial" panose="020B0604020202020204" pitchFamily="34" charset="0"/>
+                <a:ea typeface="TH Sarabun PSK"/>
+                <a:cs typeface="TH Sarabun PSK"/>
+              </a:rPr>
+              <a:t>3</a:t>
+            </a:r>
+            <a:r>
+              <a:rPr lang="en-GB" sz="1400" b="1" dirty="0">
+                <a:effectLst/>
+                <a:latin typeface="Arial" panose="020B0604020202020204" pitchFamily="34" charset="0"/>
+                <a:ea typeface="TH Sarabun PSK"/>
+                <a:cs typeface="TH Sarabun PSK"/>
+              </a:rPr>
+              <a:t>/TiO</a:t>
+            </a:r>
+            <a:r>
+              <a:rPr lang="en-GB" sz="1400" b="1" baseline="-25000" dirty="0">
+                <a:effectLst/>
+                <a:latin typeface="Arial" panose="020B0604020202020204" pitchFamily="34" charset="0"/>
+                <a:ea typeface="TH Sarabun PSK"/>
+                <a:cs typeface="TH Sarabun PSK"/>
+              </a:rPr>
+              <a:t>2</a:t>
+            </a:r>
+            <a:r>
+              <a:rPr lang="en-GB" sz="1400" b="1" dirty="0">
+                <a:effectLst/>
+                <a:latin typeface="Arial" panose="020B0604020202020204" pitchFamily="34" charset="0"/>
+                <a:ea typeface="TH Sarabun PSK"/>
+                <a:cs typeface="TH Sarabun PSK"/>
+              </a:rPr>
+              <a:t>)</a:t>
+            </a:r>
+          </a:p>
+        </p:txBody>
+      </p:sp>
+      <mc:AlternateContent xmlns:mc="http://schemas.openxmlformats.org/markup-compatibility/2006">
+        <mc:Choice xmlns:a14="http://schemas.microsoft.com/office/drawing/2010/main" Requires="a14">
+          <p:sp>
+            <p:nvSpPr>
+              <p:cNvPr id="7" name="Text Box 2">
+                <a:extLst>
+                  <a:ext uri="{FF2B5EF4-FFF2-40B4-BE49-F238E27FC236}">
+                    <a16:creationId xmlns:a16="http://schemas.microsoft.com/office/drawing/2014/main" id="{164FE6B1-FAA3-FB4F-70AE-BDFC9FD9BBA3}"/>
+                  </a:ext>
+                </a:extLst>
+              </p:cNvPr>
+              <p:cNvSpPr txBox="1">
+                <a:spLocks noChangeArrowheads="1"/>
+              </p:cNvSpPr>
+              <p:nvPr/>
+            </p:nvSpPr>
+            <p:spPr bwMode="auto">
+              <a:xfrm>
+                <a:off x="8521914" y="1661453"/>
+                <a:ext cx="3269974" cy="383375"/>
+              </a:xfrm>
+              <a:prstGeom prst="rect">
+                <a:avLst/>
+              </a:prstGeom>
+              <a:noFill/>
+              <a:ln w="9525">
+                <a:noFill/>
+                <a:miter lim="800000"/>
+                <a:headEnd/>
+                <a:tailEnd/>
+              </a:ln>
+            </p:spPr>
+            <p:txBody>
+              <a:bodyPr rot="0" vert="horz" wrap="square" lIns="91440" tIns="45720" rIns="91440" bIns="45720" anchor="t" anchorCtr="0">
+                <a:spAutoFit/>
+              </a:bodyPr>
+              <a:lstStyle/>
+              <a:p>
+                <a:pPr algn="just"/>
+                <a:r>
+                  <a:rPr lang="en-GB" sz="1300" b="1" dirty="0">
+                    <a:effectLst/>
+                    <a:latin typeface="Arial" panose="020B0604020202020204" pitchFamily="34" charset="0"/>
+                    <a:ea typeface="TH Sarabun PSK"/>
+                    <a:cs typeface="TH Sarabun PSK"/>
+                  </a:rPr>
+                  <a:t>(</a:t>
+                </a:r>
+                <a:r>
+                  <a:rPr lang="en-GB" sz="1300" b="1" dirty="0">
+                    <a:latin typeface="Arial" panose="020B0604020202020204" pitchFamily="34" charset="0"/>
+                    <a:ea typeface="TH Sarabun PSK"/>
+                    <a:cs typeface="TH Sarabun PSK"/>
+                  </a:rPr>
+                  <a:t>c</a:t>
+                </a:r>
+                <a:r>
+                  <a:rPr lang="en-GB" sz="1300" b="1" dirty="0">
+                    <a:effectLst/>
+                    <a:latin typeface="Arial" panose="020B0604020202020204" pitchFamily="34" charset="0"/>
+                    <a:ea typeface="TH Sarabun PSK"/>
+                    <a:cs typeface="TH Sarabun PSK"/>
+                  </a:rPr>
+                  <a:t>) Edge-filter design </a:t>
+                </a:r>
+                <a14:m>
+                  <m:oMath xmlns:m="http://schemas.openxmlformats.org/officeDocument/2006/math">
+                    <m:sSup>
+                      <m:sSupPr>
+                        <m:ctrlPr>
+                          <a:rPr lang="en-GB" sz="1300" b="1" i="1" smtClean="0">
+                            <a:effectLst/>
+                            <a:latin typeface="Cambria Math" panose="02040503050406030204" pitchFamily="18" charset="0"/>
+                            <a:cs typeface="Times New Roman" panose="02020603050405020304" pitchFamily="18" charset="0"/>
+                          </a:rPr>
+                        </m:ctrlPr>
+                      </m:sSupPr>
+                      <m:e>
+                        <m:r>
+                          <a:rPr lang="en-GB" sz="1300" b="1">
+                            <a:effectLst/>
+                            <a:latin typeface="Cambria Math" panose="02040503050406030204" pitchFamily="18" charset="0"/>
+                            <a:ea typeface="Yu Gothic" panose="020B0400000000000000" pitchFamily="34" charset="-128"/>
+                            <a:cs typeface="Times New Roman" panose="02020603050405020304" pitchFamily="18" charset="0"/>
+                          </a:rPr>
+                          <m:t>(</m:t>
+                        </m:r>
+                        <m:f>
+                          <m:fPr>
+                            <m:ctrlPr>
+                              <a:rPr lang="en-GB" sz="1300" b="1" i="1">
+                                <a:effectLst/>
+                                <a:latin typeface="Cambria Math" panose="02040503050406030204" pitchFamily="18" charset="0"/>
+                                <a:cs typeface="Times New Roman" panose="02020603050405020304" pitchFamily="18" charset="0"/>
+                              </a:rPr>
+                            </m:ctrlPr>
+                          </m:fPr>
+                          <m:num>
+                            <m:r>
+                              <a:rPr lang="en-GB" sz="1300" b="1" i="1">
+                                <a:effectLst/>
+                                <a:latin typeface="Cambria Math" panose="02040503050406030204" pitchFamily="18" charset="0"/>
+                                <a:ea typeface="Yu Gothic" panose="020B0400000000000000" pitchFamily="34" charset="-128"/>
+                                <a:cs typeface="Times New Roman" panose="02020603050405020304" pitchFamily="18" charset="0"/>
+                              </a:rPr>
+                              <m:t>𝑺𝒃𝑺𝒆</m:t>
+                            </m:r>
+                          </m:num>
+                          <m:den>
+                            <m:r>
+                              <a:rPr lang="en-GB" sz="1300" b="1" i="1">
+                                <a:effectLst/>
+                                <a:latin typeface="Cambria Math" panose="02040503050406030204" pitchFamily="18" charset="0"/>
+                                <a:ea typeface="Yu Gothic" panose="020B0400000000000000" pitchFamily="34" charset="-128"/>
+                                <a:cs typeface="Times New Roman" panose="02020603050405020304" pitchFamily="18" charset="0"/>
+                              </a:rPr>
+                              <m:t>𝟐</m:t>
+                            </m:r>
+                          </m:den>
+                        </m:f>
+                        <m:r>
+                          <a:rPr lang="en-GB" sz="1300" b="1">
+                            <a:effectLst/>
+                            <a:latin typeface="Cambria Math" panose="02040503050406030204" pitchFamily="18" charset="0"/>
+                            <a:ea typeface="Yu Gothic" panose="020B0400000000000000" pitchFamily="34" charset="-128"/>
+                            <a:cs typeface="Times New Roman" panose="02020603050405020304" pitchFamily="18" charset="0"/>
+                          </a:rPr>
+                          <m:t>/</m:t>
+                        </m:r>
+                        <m:r>
+                          <a:rPr lang="en-GB" sz="1300" b="1" i="1">
+                            <a:effectLst/>
+                            <a:latin typeface="Cambria Math" panose="02040503050406030204" pitchFamily="18" charset="0"/>
+                            <a:ea typeface="Yu Gothic" panose="020B0400000000000000" pitchFamily="34" charset="-128"/>
+                            <a:cs typeface="Times New Roman" panose="02020603050405020304" pitchFamily="18" charset="0"/>
+                          </a:rPr>
+                          <m:t>𝐌𝐠𝐅</m:t>
+                        </m:r>
+                        <m:r>
+                          <a:rPr lang="en-GB" sz="1300" b="1">
+                            <a:effectLst/>
+                            <a:latin typeface="Cambria Math" panose="02040503050406030204" pitchFamily="18" charset="0"/>
+                            <a:ea typeface="Yu Gothic" panose="020B0400000000000000" pitchFamily="34" charset="-128"/>
+                            <a:cs typeface="Times New Roman" panose="02020603050405020304" pitchFamily="18" charset="0"/>
+                          </a:rPr>
+                          <m:t>/</m:t>
+                        </m:r>
+                        <m:f>
+                          <m:fPr>
+                            <m:ctrlPr>
+                              <a:rPr lang="en-GB" sz="1300" b="1" i="1">
+                                <a:effectLst/>
+                                <a:latin typeface="Cambria Math" panose="02040503050406030204" pitchFamily="18" charset="0"/>
+                                <a:cs typeface="Times New Roman" panose="02020603050405020304" pitchFamily="18" charset="0"/>
+                              </a:rPr>
+                            </m:ctrlPr>
+                          </m:fPr>
+                          <m:num>
+                            <m:r>
+                              <a:rPr lang="en-GB" sz="1300" b="1" i="1">
+                                <a:effectLst/>
+                                <a:latin typeface="Cambria Math" panose="02040503050406030204" pitchFamily="18" charset="0"/>
+                                <a:ea typeface="Yu Gothic" panose="020B0400000000000000" pitchFamily="34" charset="-128"/>
+                                <a:cs typeface="Times New Roman" panose="02020603050405020304" pitchFamily="18" charset="0"/>
+                              </a:rPr>
+                              <m:t>𝑺𝒃𝑺𝒆</m:t>
+                            </m:r>
+                          </m:num>
+                          <m:den>
+                            <m:r>
+                              <a:rPr lang="en-GB" sz="1300" b="1" i="1">
+                                <a:effectLst/>
+                                <a:latin typeface="Cambria Math" panose="02040503050406030204" pitchFamily="18" charset="0"/>
+                                <a:ea typeface="Yu Gothic" panose="020B0400000000000000" pitchFamily="34" charset="-128"/>
+                                <a:cs typeface="Times New Roman" panose="02020603050405020304" pitchFamily="18" charset="0"/>
+                              </a:rPr>
+                              <m:t>𝟐</m:t>
+                            </m:r>
+                          </m:den>
+                        </m:f>
+                        <m:r>
+                          <a:rPr lang="en-GB" sz="1300" b="1">
+                            <a:effectLst/>
+                            <a:latin typeface="Cambria Math" panose="02040503050406030204" pitchFamily="18" charset="0"/>
+                            <a:ea typeface="Yu Gothic" panose="020B0400000000000000" pitchFamily="34" charset="-128"/>
+                            <a:cs typeface="Times New Roman" panose="02020603050405020304" pitchFamily="18" charset="0"/>
+                          </a:rPr>
+                          <m:t>)</m:t>
+                        </m:r>
+                      </m:e>
+                      <m:sup>
+                        <m:r>
+                          <a:rPr lang="en-GB" sz="1300" b="1" i="1">
+                            <a:effectLst/>
+                            <a:latin typeface="Cambria Math" panose="02040503050406030204" pitchFamily="18" charset="0"/>
+                            <a:ea typeface="Yu Gothic" panose="020B0400000000000000" pitchFamily="34" charset="-128"/>
+                            <a:cs typeface="Times New Roman" panose="02020603050405020304" pitchFamily="18" charset="0"/>
+                          </a:rPr>
+                          <m:t>𝟓</m:t>
+                        </m:r>
+                      </m:sup>
+                    </m:sSup>
+                  </m:oMath>
+                </a14:m>
+                <a:endParaRPr lang="en-GB" sz="1300" b="1" dirty="0">
+                  <a:effectLst/>
+                  <a:latin typeface="Arial" panose="020B0604020202020204" pitchFamily="34" charset="0"/>
+                  <a:ea typeface="TH Sarabun PSK"/>
+                  <a:cs typeface="TH Sarabun PSK"/>
+                </a:endParaRPr>
+              </a:p>
+            </p:txBody>
+          </p:sp>
+        </mc:Choice>
+        <mc:Fallback>
+          <p:sp>
+            <p:nvSpPr>
+              <p:cNvPr id="7" name="Text Box 2">
+                <a:extLst>
+                  <a:ext uri="{FF2B5EF4-FFF2-40B4-BE49-F238E27FC236}">
+                    <a16:creationId xmlns:a16="http://schemas.microsoft.com/office/drawing/2014/main" id="{164FE6B1-FAA3-FB4F-70AE-BDFC9FD9BBA3}"/>
+                  </a:ext>
+                </a:extLst>
+              </p:cNvPr>
+              <p:cNvSpPr txBox="1">
+                <a:spLocks noRot="1" noChangeAspect="1" noMove="1" noResize="1" noEditPoints="1" noAdjustHandles="1" noChangeArrowheads="1" noChangeShapeType="1" noTextEdit="1"/>
+              </p:cNvSpPr>
+              <p:nvPr/>
+            </p:nvSpPr>
+            <p:spPr bwMode="auto">
+              <a:xfrm>
+                <a:off x="8521914" y="1661453"/>
+                <a:ext cx="3269974" cy="383375"/>
+              </a:xfrm>
+              <a:prstGeom prst="rect">
+                <a:avLst/>
+              </a:prstGeom>
+              <a:blipFill>
+                <a:blip r:embed="rId2"/>
+                <a:stretch>
+                  <a:fillRect l="-373" b="-3226"/>
+                </a:stretch>
+              </a:blipFill>
+              <a:ln w="9525">
+                <a:noFill/>
+                <a:miter lim="800000"/>
+                <a:headEnd/>
+                <a:tailEnd/>
+              </a:ln>
+            </p:spPr>
+            <p:txBody>
+              <a:bodyPr/>
+              <a:lstStyle/>
+              <a:p>
+                <a:r>
+                  <a:rPr lang="en-GB">
+                    <a:noFill/>
+                  </a:rPr>
+                  <a:t> </a:t>
+                </a:r>
+              </a:p>
+            </p:txBody>
+          </p:sp>
+        </mc:Fallback>
+      </mc:AlternateContent>
+      <p:pic>
+        <p:nvPicPr>
+          <p:cNvPr id="9" name="Picture 8">
+            <a:extLst>
+              <a:ext uri="{FF2B5EF4-FFF2-40B4-BE49-F238E27FC236}">
+                <a16:creationId xmlns:a16="http://schemas.microsoft.com/office/drawing/2014/main" id="{F4B570C0-0E3D-34F7-D76A-257CE161CE7F}"/>
+              </a:ext>
+            </a:extLst>
+          </p:cNvPr>
+          <p:cNvPicPr>
+            <a:picLocks noChangeAspect="1"/>
+          </p:cNvPicPr>
+          <p:nvPr/>
+        </p:nvPicPr>
+        <p:blipFill>
+          <a:blip r:embed="rId3" cstate="print">
+            <a:extLst>
+              <a:ext uri="{28A0092B-C50C-407E-A947-70E740481C1C}">
+                <a14:useLocalDpi xmlns:a14="http://schemas.microsoft.com/office/drawing/2010/main" val="0"/>
+              </a:ext>
+            </a:extLst>
+          </a:blip>
+          <a:srcRect t="5473"/>
+          <a:stretch>
+            <a:fillRect/>
+          </a:stretch>
+        </p:blipFill>
+        <p:spPr>
+          <a:xfrm>
+            <a:off x="3632" y="2013216"/>
+            <a:ext cx="4214670" cy="2988000"/>
+          </a:xfrm>
+          <a:prstGeom prst="rect">
+            <a:avLst/>
+          </a:prstGeom>
+        </p:spPr>
+      </p:pic>
+      <p:pic>
+        <p:nvPicPr>
+          <p:cNvPr id="10" name="Picture 9">
+            <a:extLst>
+              <a:ext uri="{FF2B5EF4-FFF2-40B4-BE49-F238E27FC236}">
+                <a16:creationId xmlns:a16="http://schemas.microsoft.com/office/drawing/2014/main" id="{610F2CFE-5179-83B6-5338-4E4914E4018C}"/>
+              </a:ext>
+            </a:extLst>
+          </p:cNvPr>
+          <p:cNvPicPr>
+            <a:picLocks noChangeAspect="1"/>
+          </p:cNvPicPr>
+          <p:nvPr/>
+        </p:nvPicPr>
+        <p:blipFill>
+          <a:blip r:embed="rId4" cstate="print">
+            <a:extLst>
+              <a:ext uri="{28A0092B-C50C-407E-A947-70E740481C1C}">
+                <a14:useLocalDpi xmlns:a14="http://schemas.microsoft.com/office/drawing/2010/main" val="0"/>
+              </a:ext>
+            </a:extLst>
+          </a:blip>
+          <a:srcRect t="5285"/>
+          <a:stretch>
+            <a:fillRect/>
+          </a:stretch>
+        </p:blipFill>
+        <p:spPr>
+          <a:xfrm>
+            <a:off x="4066112" y="2018825"/>
+            <a:ext cx="4206317" cy="2988000"/>
+          </a:xfrm>
+          <a:prstGeom prst="rect">
+            <a:avLst/>
+          </a:prstGeom>
+        </p:spPr>
+      </p:pic>
+      <p:pic>
+        <p:nvPicPr>
+          <p:cNvPr id="11" name="Picture 10">
+            <a:extLst>
+              <a:ext uri="{FF2B5EF4-FFF2-40B4-BE49-F238E27FC236}">
+                <a16:creationId xmlns:a16="http://schemas.microsoft.com/office/drawing/2014/main" id="{CAD3B1FD-3143-8B08-F70A-2593605E5B36}"/>
+              </a:ext>
+            </a:extLst>
+          </p:cNvPr>
+          <p:cNvPicPr>
+            <a:picLocks noChangeAspect="1"/>
+          </p:cNvPicPr>
+          <p:nvPr/>
+        </p:nvPicPr>
+        <p:blipFill>
+          <a:blip r:embed="rId5" cstate="print">
+            <a:extLst>
+              <a:ext uri="{28A0092B-C50C-407E-A947-70E740481C1C}">
+                <a14:useLocalDpi xmlns:a14="http://schemas.microsoft.com/office/drawing/2010/main" val="0"/>
+              </a:ext>
+            </a:extLst>
+          </a:blip>
+          <a:srcRect t="5285"/>
+          <a:stretch>
+            <a:fillRect/>
+          </a:stretch>
+        </p:blipFill>
+        <p:spPr>
+          <a:xfrm>
+            <a:off x="8053743" y="2013216"/>
+            <a:ext cx="4206315" cy="2988000"/>
+          </a:xfrm>
+          <a:prstGeom prst="rect">
+            <a:avLst/>
+          </a:prstGeom>
+        </p:spPr>
+      </p:pic>
+    </p:spTree>
+    <p:extLst>
+      <p:ext uri="{BB962C8B-B14F-4D97-AF65-F5344CB8AC3E}">
+        <p14:creationId xmlns:p14="http://schemas.microsoft.com/office/powerpoint/2010/main" val="3705930841"/>
+      </p:ext>
+    </p:extLst>
+  </p:cSld>
+  <p:clrMapOvr>
+    <a:masterClrMapping/>
+  </p:clrMapOvr>
+</p:sld>
+</file>
+
+<file path=ppt/slides/slide11.xml><?xml version="1.0" encoding="utf-8"?>
+<p:sld xmlns:a="http://schemas.openxmlformats.org/drawingml/2006/main" xmlns:r="http://schemas.openxmlformats.org/officeDocument/2006/relationships" xmlns:p="http://schemas.openxmlformats.org/presentationml/2006/main">
+  <p:cSld>
+    <p:spTree>
+      <p:nvGrpSpPr>
+        <p:cNvPr id="1" name=""/>
+        <p:cNvGrpSpPr/>
+        <p:nvPr/>
+      </p:nvGrpSpPr>
+      <p:grpSpPr>
+        <a:xfrm>
+          <a:off x="0" y="0"/>
+          <a:ext cx="0" cy="0"/>
+          <a:chOff x="0" y="0"/>
+          <a:chExt cx="0" cy="0"/>
+        </a:xfrm>
+      </p:grpSpPr>
+      <p:sp>
+        <p:nvSpPr>
+          <p:cNvPr id="2" name="Text Box 2">
+            <a:extLst>
+              <a:ext uri="{FF2B5EF4-FFF2-40B4-BE49-F238E27FC236}">
+                <a16:creationId xmlns:a16="http://schemas.microsoft.com/office/drawing/2014/main" id="{22DD4592-C813-C159-9140-B52E7561EE08}"/>
+              </a:ext>
+            </a:extLst>
+          </p:cNvPr>
+          <p:cNvSpPr txBox="1">
+            <a:spLocks noChangeArrowheads="1"/>
+          </p:cNvSpPr>
+          <p:nvPr/>
+        </p:nvSpPr>
+        <p:spPr bwMode="auto">
+          <a:xfrm>
+            <a:off x="546652" y="1711048"/>
+            <a:ext cx="3269974" cy="307777"/>
+          </a:xfrm>
+          <a:prstGeom prst="rect">
+            <a:avLst/>
+          </a:prstGeom>
+          <a:noFill/>
+          <a:ln w="9525">
+            <a:noFill/>
+            <a:miter lim="800000"/>
+            <a:headEnd/>
+            <a:tailEnd/>
+          </a:ln>
+        </p:spPr>
+        <p:txBody>
+          <a:bodyPr rot="0" vert="horz" wrap="square" lIns="91440" tIns="45720" rIns="91440" bIns="45720" anchor="t" anchorCtr="0">
+            <a:spAutoFit/>
+          </a:bodyPr>
+          <a:lstStyle/>
+          <a:p>
+            <a:pPr algn="just"/>
+            <a:r>
+              <a:rPr lang="en-GB" sz="1400" b="1" dirty="0">
+                <a:effectLst/>
+                <a:latin typeface="Arial" panose="020B0604020202020204" pitchFamily="34" charset="0"/>
+                <a:ea typeface="TH Sarabun PSK"/>
+                <a:cs typeface="TH Sarabun PSK"/>
+              </a:rPr>
+              <a:t>(a) Single-layer design (Sb</a:t>
+            </a:r>
+            <a:r>
+              <a:rPr lang="en-GB" sz="1400" b="1" baseline="-25000" dirty="0">
+                <a:effectLst/>
+                <a:latin typeface="Arial" panose="020B0604020202020204" pitchFamily="34" charset="0"/>
+                <a:ea typeface="TH Sarabun PSK"/>
+                <a:cs typeface="TH Sarabun PSK"/>
+              </a:rPr>
+              <a:t>2</a:t>
+            </a:r>
+            <a:r>
+              <a:rPr lang="en-GB" sz="1400" b="1" dirty="0">
+                <a:effectLst/>
+                <a:latin typeface="Arial" panose="020B0604020202020204" pitchFamily="34" charset="0"/>
+                <a:ea typeface="TH Sarabun PSK"/>
+                <a:cs typeface="TH Sarabun PSK"/>
+              </a:rPr>
+              <a:t>Se</a:t>
+            </a:r>
+            <a:r>
+              <a:rPr lang="en-GB" sz="1400" b="1" baseline="-25000" dirty="0">
+                <a:effectLst/>
+                <a:latin typeface="Arial" panose="020B0604020202020204" pitchFamily="34" charset="0"/>
+                <a:ea typeface="TH Sarabun PSK"/>
+                <a:cs typeface="TH Sarabun PSK"/>
+              </a:rPr>
+              <a:t>3</a:t>
+            </a:r>
+            <a:r>
+              <a:rPr lang="en-GB" sz="1400" b="1" dirty="0">
+                <a:effectLst/>
+                <a:latin typeface="Arial" panose="020B0604020202020204" pitchFamily="34" charset="0"/>
+                <a:ea typeface="TH Sarabun PSK"/>
+                <a:cs typeface="TH Sarabun PSK"/>
+              </a:rPr>
+              <a:t>)</a:t>
+            </a:r>
+          </a:p>
+        </p:txBody>
+      </p:sp>
+      <p:sp>
+        <p:nvSpPr>
+          <p:cNvPr id="3" name="Text Box 2">
+            <a:extLst>
+              <a:ext uri="{FF2B5EF4-FFF2-40B4-BE49-F238E27FC236}">
+                <a16:creationId xmlns:a16="http://schemas.microsoft.com/office/drawing/2014/main" id="{891522A2-9C35-6074-051C-2C3A338AD372}"/>
+              </a:ext>
+            </a:extLst>
+          </p:cNvPr>
+          <p:cNvSpPr txBox="1">
+            <a:spLocks noChangeArrowheads="1"/>
+          </p:cNvSpPr>
+          <p:nvPr/>
+        </p:nvSpPr>
+        <p:spPr bwMode="auto">
+          <a:xfrm>
+            <a:off x="4534283" y="1705439"/>
+            <a:ext cx="3269974" cy="307777"/>
+          </a:xfrm>
+          <a:prstGeom prst="rect">
+            <a:avLst/>
+          </a:prstGeom>
+          <a:noFill/>
+          <a:ln w="9525">
+            <a:noFill/>
+            <a:miter lim="800000"/>
+            <a:headEnd/>
+            <a:tailEnd/>
+          </a:ln>
+        </p:spPr>
+        <p:txBody>
+          <a:bodyPr rot="0" vert="horz" wrap="square" lIns="91440" tIns="45720" rIns="91440" bIns="45720" anchor="t" anchorCtr="0">
+            <a:spAutoFit/>
+          </a:bodyPr>
+          <a:lstStyle/>
+          <a:p>
+            <a:pPr algn="just"/>
+            <a:r>
+              <a:rPr lang="en-GB" sz="1400" b="1" dirty="0">
+                <a:effectLst/>
+                <a:latin typeface="Arial" panose="020B0604020202020204" pitchFamily="34" charset="0"/>
+                <a:ea typeface="TH Sarabun PSK"/>
+                <a:cs typeface="TH Sarabun PSK"/>
+              </a:rPr>
+              <a:t>(b) Two-layers design (Sb</a:t>
+            </a:r>
+            <a:r>
+              <a:rPr lang="en-GB" sz="1400" b="1" baseline="-25000" dirty="0">
+                <a:effectLst/>
+                <a:latin typeface="Arial" panose="020B0604020202020204" pitchFamily="34" charset="0"/>
+                <a:ea typeface="TH Sarabun PSK"/>
+                <a:cs typeface="TH Sarabun PSK"/>
+              </a:rPr>
+              <a:t>2</a:t>
+            </a:r>
+            <a:r>
+              <a:rPr lang="en-GB" sz="1400" b="1" dirty="0">
+                <a:effectLst/>
+                <a:latin typeface="Arial" panose="020B0604020202020204" pitchFamily="34" charset="0"/>
+                <a:ea typeface="TH Sarabun PSK"/>
+                <a:cs typeface="TH Sarabun PSK"/>
+              </a:rPr>
+              <a:t>Se</a:t>
+            </a:r>
+            <a:r>
+              <a:rPr lang="en-GB" sz="1400" b="1" baseline="-25000" dirty="0">
+                <a:effectLst/>
+                <a:latin typeface="Arial" panose="020B0604020202020204" pitchFamily="34" charset="0"/>
+                <a:ea typeface="TH Sarabun PSK"/>
+                <a:cs typeface="TH Sarabun PSK"/>
+              </a:rPr>
+              <a:t>3</a:t>
+            </a:r>
+            <a:r>
+              <a:rPr lang="en-GB" sz="1400" b="1" dirty="0">
+                <a:effectLst/>
+                <a:latin typeface="Arial" panose="020B0604020202020204" pitchFamily="34" charset="0"/>
+                <a:ea typeface="TH Sarabun PSK"/>
+                <a:cs typeface="TH Sarabun PSK"/>
+              </a:rPr>
+              <a:t>/TiO</a:t>
+            </a:r>
+            <a:r>
+              <a:rPr lang="en-GB" sz="1400" b="1" baseline="-25000" dirty="0">
+                <a:effectLst/>
+                <a:latin typeface="Arial" panose="020B0604020202020204" pitchFamily="34" charset="0"/>
+                <a:ea typeface="TH Sarabun PSK"/>
+                <a:cs typeface="TH Sarabun PSK"/>
+              </a:rPr>
+              <a:t>2</a:t>
+            </a:r>
+            <a:r>
+              <a:rPr lang="en-GB" sz="1400" b="1" dirty="0">
+                <a:effectLst/>
+                <a:latin typeface="Arial" panose="020B0604020202020204" pitchFamily="34" charset="0"/>
+                <a:ea typeface="TH Sarabun PSK"/>
+                <a:cs typeface="TH Sarabun PSK"/>
+              </a:rPr>
+              <a:t>)</a:t>
+            </a:r>
+          </a:p>
+        </p:txBody>
+      </p:sp>
+      <mc:AlternateContent xmlns:mc="http://schemas.openxmlformats.org/markup-compatibility/2006">
+        <mc:Choice xmlns:a14="http://schemas.microsoft.com/office/drawing/2010/main" Requires="a14">
+          <p:sp>
+            <p:nvSpPr>
+              <p:cNvPr id="4" name="Text Box 2">
+                <a:extLst>
+                  <a:ext uri="{FF2B5EF4-FFF2-40B4-BE49-F238E27FC236}">
+                    <a16:creationId xmlns:a16="http://schemas.microsoft.com/office/drawing/2014/main" id="{40AFA504-9F42-ED86-D381-969A7B8B6964}"/>
+                  </a:ext>
+                </a:extLst>
+              </p:cNvPr>
+              <p:cNvSpPr txBox="1">
+                <a:spLocks noChangeArrowheads="1"/>
+              </p:cNvSpPr>
+              <p:nvPr/>
+            </p:nvSpPr>
+            <p:spPr bwMode="auto">
+              <a:xfrm>
+                <a:off x="8521914" y="1661453"/>
+                <a:ext cx="3269974" cy="383375"/>
+              </a:xfrm>
+              <a:prstGeom prst="rect">
+                <a:avLst/>
+              </a:prstGeom>
+              <a:noFill/>
+              <a:ln w="9525">
+                <a:noFill/>
+                <a:miter lim="800000"/>
+                <a:headEnd/>
+                <a:tailEnd/>
+              </a:ln>
+            </p:spPr>
+            <p:txBody>
+              <a:bodyPr rot="0" vert="horz" wrap="square" lIns="91440" tIns="45720" rIns="91440" bIns="45720" anchor="t" anchorCtr="0">
+                <a:spAutoFit/>
+              </a:bodyPr>
+              <a:lstStyle/>
+              <a:p>
+                <a:pPr algn="just"/>
+                <a:r>
+                  <a:rPr lang="en-GB" sz="1300" b="1" dirty="0">
+                    <a:effectLst/>
+                    <a:latin typeface="Arial" panose="020B0604020202020204" pitchFamily="34" charset="0"/>
+                    <a:ea typeface="TH Sarabun PSK"/>
+                    <a:cs typeface="TH Sarabun PSK"/>
+                  </a:rPr>
+                  <a:t>(</a:t>
+                </a:r>
+                <a:r>
+                  <a:rPr lang="en-GB" sz="1300" b="1" dirty="0">
+                    <a:latin typeface="Arial" panose="020B0604020202020204" pitchFamily="34" charset="0"/>
+                    <a:ea typeface="TH Sarabun PSK"/>
+                    <a:cs typeface="TH Sarabun PSK"/>
+                  </a:rPr>
+                  <a:t>c</a:t>
+                </a:r>
+                <a:r>
+                  <a:rPr lang="en-GB" sz="1300" b="1" dirty="0">
+                    <a:effectLst/>
+                    <a:latin typeface="Arial" panose="020B0604020202020204" pitchFamily="34" charset="0"/>
+                    <a:ea typeface="TH Sarabun PSK"/>
+                    <a:cs typeface="TH Sarabun PSK"/>
+                  </a:rPr>
+                  <a:t>) Edge-filter design </a:t>
+                </a:r>
+                <a14:m>
+                  <m:oMath xmlns:m="http://schemas.openxmlformats.org/officeDocument/2006/math">
+                    <m:sSup>
+                      <m:sSupPr>
+                        <m:ctrlPr>
+                          <a:rPr lang="en-GB" sz="1300" b="1" i="1" smtClean="0">
+                            <a:effectLst/>
+                            <a:latin typeface="Cambria Math" panose="02040503050406030204" pitchFamily="18" charset="0"/>
+                            <a:cs typeface="Times New Roman" panose="02020603050405020304" pitchFamily="18" charset="0"/>
+                          </a:rPr>
+                        </m:ctrlPr>
+                      </m:sSupPr>
+                      <m:e>
+                        <m:r>
+                          <a:rPr lang="en-GB" sz="1300" b="1">
+                            <a:effectLst/>
+                            <a:latin typeface="Cambria Math" panose="02040503050406030204" pitchFamily="18" charset="0"/>
+                            <a:ea typeface="Yu Gothic" panose="020B0400000000000000" pitchFamily="34" charset="-128"/>
+                            <a:cs typeface="Times New Roman" panose="02020603050405020304" pitchFamily="18" charset="0"/>
+                          </a:rPr>
+                          <m:t>(</m:t>
+                        </m:r>
+                        <m:f>
+                          <m:fPr>
+                            <m:ctrlPr>
+                              <a:rPr lang="en-GB" sz="1300" b="1" i="1">
+                                <a:effectLst/>
+                                <a:latin typeface="Cambria Math" panose="02040503050406030204" pitchFamily="18" charset="0"/>
+                                <a:cs typeface="Times New Roman" panose="02020603050405020304" pitchFamily="18" charset="0"/>
+                              </a:rPr>
+                            </m:ctrlPr>
+                          </m:fPr>
+                          <m:num>
+                            <m:r>
+                              <a:rPr lang="en-GB" sz="1300" b="1" i="1">
+                                <a:effectLst/>
+                                <a:latin typeface="Cambria Math" panose="02040503050406030204" pitchFamily="18" charset="0"/>
+                                <a:ea typeface="Yu Gothic" panose="020B0400000000000000" pitchFamily="34" charset="-128"/>
+                                <a:cs typeface="Times New Roman" panose="02020603050405020304" pitchFamily="18" charset="0"/>
+                              </a:rPr>
+                              <m:t>𝑺𝒃𝑺𝒆</m:t>
+                            </m:r>
+                          </m:num>
+                          <m:den>
+                            <m:r>
+                              <a:rPr lang="en-GB" sz="1300" b="1" i="1">
+                                <a:effectLst/>
+                                <a:latin typeface="Cambria Math" panose="02040503050406030204" pitchFamily="18" charset="0"/>
+                                <a:ea typeface="Yu Gothic" panose="020B0400000000000000" pitchFamily="34" charset="-128"/>
+                                <a:cs typeface="Times New Roman" panose="02020603050405020304" pitchFamily="18" charset="0"/>
+                              </a:rPr>
+                              <m:t>𝟐</m:t>
+                            </m:r>
+                          </m:den>
+                        </m:f>
+                        <m:r>
+                          <a:rPr lang="en-GB" sz="1300" b="1">
+                            <a:effectLst/>
+                            <a:latin typeface="Cambria Math" panose="02040503050406030204" pitchFamily="18" charset="0"/>
+                            <a:ea typeface="Yu Gothic" panose="020B0400000000000000" pitchFamily="34" charset="-128"/>
+                            <a:cs typeface="Times New Roman" panose="02020603050405020304" pitchFamily="18" charset="0"/>
+                          </a:rPr>
+                          <m:t>/</m:t>
+                        </m:r>
+                        <m:r>
+                          <a:rPr lang="en-GB" sz="1300" b="1" i="1">
+                            <a:effectLst/>
+                            <a:latin typeface="Cambria Math" panose="02040503050406030204" pitchFamily="18" charset="0"/>
+                            <a:ea typeface="Yu Gothic" panose="020B0400000000000000" pitchFamily="34" charset="-128"/>
+                            <a:cs typeface="Times New Roman" panose="02020603050405020304" pitchFamily="18" charset="0"/>
+                          </a:rPr>
+                          <m:t>𝐌𝐠𝐅</m:t>
+                        </m:r>
+                        <m:r>
+                          <a:rPr lang="en-GB" sz="1300" b="1">
+                            <a:effectLst/>
+                            <a:latin typeface="Cambria Math" panose="02040503050406030204" pitchFamily="18" charset="0"/>
+                            <a:ea typeface="Yu Gothic" panose="020B0400000000000000" pitchFamily="34" charset="-128"/>
+                            <a:cs typeface="Times New Roman" panose="02020603050405020304" pitchFamily="18" charset="0"/>
+                          </a:rPr>
+                          <m:t>/</m:t>
+                        </m:r>
+                        <m:f>
+                          <m:fPr>
+                            <m:ctrlPr>
+                              <a:rPr lang="en-GB" sz="1300" b="1" i="1">
+                                <a:effectLst/>
+                                <a:latin typeface="Cambria Math" panose="02040503050406030204" pitchFamily="18" charset="0"/>
+                                <a:cs typeface="Times New Roman" panose="02020603050405020304" pitchFamily="18" charset="0"/>
+                              </a:rPr>
+                            </m:ctrlPr>
+                          </m:fPr>
+                          <m:num>
+                            <m:r>
+                              <a:rPr lang="en-GB" sz="1300" b="1" i="1">
+                                <a:effectLst/>
+                                <a:latin typeface="Cambria Math" panose="02040503050406030204" pitchFamily="18" charset="0"/>
+                                <a:ea typeface="Yu Gothic" panose="020B0400000000000000" pitchFamily="34" charset="-128"/>
+                                <a:cs typeface="Times New Roman" panose="02020603050405020304" pitchFamily="18" charset="0"/>
+                              </a:rPr>
+                              <m:t>𝑺𝒃𝑺𝒆</m:t>
+                            </m:r>
+                          </m:num>
+                          <m:den>
+                            <m:r>
+                              <a:rPr lang="en-GB" sz="1300" b="1" i="1">
+                                <a:effectLst/>
+                                <a:latin typeface="Cambria Math" panose="02040503050406030204" pitchFamily="18" charset="0"/>
+                                <a:ea typeface="Yu Gothic" panose="020B0400000000000000" pitchFamily="34" charset="-128"/>
+                                <a:cs typeface="Times New Roman" panose="02020603050405020304" pitchFamily="18" charset="0"/>
+                              </a:rPr>
+                              <m:t>𝟐</m:t>
+                            </m:r>
+                          </m:den>
+                        </m:f>
+                        <m:r>
+                          <a:rPr lang="en-GB" sz="1300" b="1">
+                            <a:effectLst/>
+                            <a:latin typeface="Cambria Math" panose="02040503050406030204" pitchFamily="18" charset="0"/>
+                            <a:ea typeface="Yu Gothic" panose="020B0400000000000000" pitchFamily="34" charset="-128"/>
+                            <a:cs typeface="Times New Roman" panose="02020603050405020304" pitchFamily="18" charset="0"/>
+                          </a:rPr>
+                          <m:t>)</m:t>
+                        </m:r>
+                      </m:e>
+                      <m:sup>
+                        <m:r>
+                          <a:rPr lang="en-GB" sz="1300" b="1" i="1">
+                            <a:effectLst/>
+                            <a:latin typeface="Cambria Math" panose="02040503050406030204" pitchFamily="18" charset="0"/>
+                            <a:ea typeface="Yu Gothic" panose="020B0400000000000000" pitchFamily="34" charset="-128"/>
+                            <a:cs typeface="Times New Roman" panose="02020603050405020304" pitchFamily="18" charset="0"/>
+                          </a:rPr>
+                          <m:t>𝟓</m:t>
+                        </m:r>
+                      </m:sup>
+                    </m:sSup>
+                  </m:oMath>
+                </a14:m>
+                <a:endParaRPr lang="en-GB" sz="1300" b="1" dirty="0">
+                  <a:effectLst/>
+                  <a:latin typeface="Arial" panose="020B0604020202020204" pitchFamily="34" charset="0"/>
+                  <a:ea typeface="TH Sarabun PSK"/>
+                  <a:cs typeface="TH Sarabun PSK"/>
+                </a:endParaRPr>
+              </a:p>
+            </p:txBody>
+          </p:sp>
+        </mc:Choice>
+        <mc:Fallback>
+          <p:sp>
+            <p:nvSpPr>
+              <p:cNvPr id="4" name="Text Box 2">
+                <a:extLst>
+                  <a:ext uri="{FF2B5EF4-FFF2-40B4-BE49-F238E27FC236}">
+                    <a16:creationId xmlns:a16="http://schemas.microsoft.com/office/drawing/2014/main" id="{40AFA504-9F42-ED86-D381-969A7B8B6964}"/>
+                  </a:ext>
+                </a:extLst>
+              </p:cNvPr>
+              <p:cNvSpPr txBox="1">
+                <a:spLocks noRot="1" noChangeAspect="1" noMove="1" noResize="1" noEditPoints="1" noAdjustHandles="1" noChangeArrowheads="1" noChangeShapeType="1" noTextEdit="1"/>
+              </p:cNvSpPr>
+              <p:nvPr/>
+            </p:nvSpPr>
+            <p:spPr bwMode="auto">
+              <a:xfrm>
+                <a:off x="8521914" y="1661453"/>
+                <a:ext cx="3269974" cy="383375"/>
+              </a:xfrm>
+              <a:prstGeom prst="rect">
+                <a:avLst/>
+              </a:prstGeom>
+              <a:blipFill>
+                <a:blip r:embed="rId2"/>
+                <a:stretch>
+                  <a:fillRect l="-373" b="-3226"/>
+                </a:stretch>
+              </a:blipFill>
+              <a:ln w="9525">
+                <a:noFill/>
+                <a:miter lim="800000"/>
+                <a:headEnd/>
+                <a:tailEnd/>
+              </a:ln>
+            </p:spPr>
+            <p:txBody>
+              <a:bodyPr/>
+              <a:lstStyle/>
+              <a:p>
+                <a:r>
+                  <a:rPr lang="en-GB">
+                    <a:noFill/>
+                  </a:rPr>
+                  <a:t> </a:t>
+                </a:r>
+              </a:p>
+            </p:txBody>
+          </p:sp>
+        </mc:Fallback>
+      </mc:AlternateContent>
+      <p:pic>
+        <p:nvPicPr>
+          <p:cNvPr id="8" name="Picture 7">
+            <a:extLst>
+              <a:ext uri="{FF2B5EF4-FFF2-40B4-BE49-F238E27FC236}">
+                <a16:creationId xmlns:a16="http://schemas.microsoft.com/office/drawing/2014/main" id="{BE62718D-CC86-451E-CDBB-792DF46D479D}"/>
+              </a:ext>
+            </a:extLst>
+          </p:cNvPr>
+          <p:cNvPicPr>
+            <a:picLocks noChangeAspect="1"/>
+          </p:cNvPicPr>
+          <p:nvPr/>
+        </p:nvPicPr>
+        <p:blipFill>
+          <a:blip r:embed="rId3" cstate="print">
+            <a:extLst>
+              <a:ext uri="{28A0092B-C50C-407E-A947-70E740481C1C}">
+                <a14:useLocalDpi xmlns:a14="http://schemas.microsoft.com/office/drawing/2010/main" val="0"/>
+              </a:ext>
+            </a:extLst>
+          </a:blip>
+          <a:srcRect t="5407"/>
+          <a:stretch>
+            <a:fillRect/>
+          </a:stretch>
+        </p:blipFill>
+        <p:spPr>
+          <a:xfrm>
+            <a:off x="0" y="2044828"/>
+            <a:ext cx="4211700" cy="2988000"/>
+          </a:xfrm>
+          <a:prstGeom prst="rect">
+            <a:avLst/>
+          </a:prstGeom>
+        </p:spPr>
+      </p:pic>
+      <p:pic>
+        <p:nvPicPr>
+          <p:cNvPr id="9" name="Picture 8">
+            <a:extLst>
+              <a:ext uri="{FF2B5EF4-FFF2-40B4-BE49-F238E27FC236}">
+                <a16:creationId xmlns:a16="http://schemas.microsoft.com/office/drawing/2014/main" id="{F09CD10C-B0D5-8DF3-6BAA-9BF642DD9E69}"/>
+              </a:ext>
+            </a:extLst>
+          </p:cNvPr>
+          <p:cNvPicPr>
+            <a:picLocks noChangeAspect="1"/>
+          </p:cNvPicPr>
+          <p:nvPr/>
+        </p:nvPicPr>
+        <p:blipFill>
+          <a:blip r:embed="rId4" cstate="print">
+            <a:extLst>
+              <a:ext uri="{28A0092B-C50C-407E-A947-70E740481C1C}">
+                <a14:useLocalDpi xmlns:a14="http://schemas.microsoft.com/office/drawing/2010/main" val="0"/>
+              </a:ext>
+            </a:extLst>
+          </a:blip>
+          <a:srcRect t="5407"/>
+          <a:stretch>
+            <a:fillRect/>
+          </a:stretch>
+        </p:blipFill>
+        <p:spPr>
+          <a:xfrm>
+            <a:off x="3990150" y="2046826"/>
+            <a:ext cx="4211700" cy="2988000"/>
+          </a:xfrm>
+          <a:prstGeom prst="rect">
+            <a:avLst/>
+          </a:prstGeom>
+        </p:spPr>
+      </p:pic>
+      <p:pic>
+        <p:nvPicPr>
+          <p:cNvPr id="10" name="Picture 9">
+            <a:extLst>
+              <a:ext uri="{FF2B5EF4-FFF2-40B4-BE49-F238E27FC236}">
+                <a16:creationId xmlns:a16="http://schemas.microsoft.com/office/drawing/2014/main" id="{178F51E6-7DAD-FB1A-ED8D-BDEBE5AFC335}"/>
+              </a:ext>
+            </a:extLst>
+          </p:cNvPr>
+          <p:cNvPicPr>
+            <a:picLocks noChangeAspect="1"/>
+          </p:cNvPicPr>
+          <p:nvPr/>
+        </p:nvPicPr>
+        <p:blipFill>
+          <a:blip r:embed="rId5" cstate="print">
+            <a:extLst>
+              <a:ext uri="{28A0092B-C50C-407E-A947-70E740481C1C}">
+                <a14:useLocalDpi xmlns:a14="http://schemas.microsoft.com/office/drawing/2010/main" val="0"/>
+              </a:ext>
+            </a:extLst>
+          </a:blip>
+          <a:srcRect t="5407"/>
+          <a:stretch>
+            <a:fillRect/>
+          </a:stretch>
+        </p:blipFill>
+        <p:spPr>
+          <a:xfrm>
+            <a:off x="7980300" y="2044828"/>
+            <a:ext cx="4211700" cy="2988000"/>
+          </a:xfrm>
+          <a:prstGeom prst="rect">
+            <a:avLst/>
+          </a:prstGeom>
+        </p:spPr>
+      </p:pic>
+    </p:spTree>
+    <p:extLst>
+      <p:ext uri="{BB962C8B-B14F-4D97-AF65-F5344CB8AC3E}">
+        <p14:creationId xmlns:p14="http://schemas.microsoft.com/office/powerpoint/2010/main" val="1818320857"/>
+      </p:ext>
+    </p:extLst>
+  </p:cSld>
+  <p:clrMapOvr>
+    <a:masterClrMapping/>
+  </p:clrMapOvr>
+</p:sld>
+</file>
+
+<file path=ppt/slides/slide12.xml><?xml version="1.0" encoding="utf-8"?>
+<p:sld xmlns:a="http://schemas.openxmlformats.org/drawingml/2006/main" xmlns:r="http://schemas.openxmlformats.org/officeDocument/2006/relationships" xmlns:p="http://schemas.openxmlformats.org/presentationml/2006/main" show="0">
+  <p:cSld>
+    <p:spTree>
+      <p:nvGrpSpPr>
+        <p:cNvPr id="1" name=""/>
+        <p:cNvGrpSpPr/>
+        <p:nvPr/>
+      </p:nvGrpSpPr>
+      <p:grpSpPr>
+        <a:xfrm>
+          <a:off x="0" y="0"/>
+          <a:ext cx="0" cy="0"/>
+          <a:chOff x="0" y="0"/>
+          <a:chExt cx="0" cy="0"/>
+        </a:xfrm>
+      </p:grpSpPr>
+      <p:pic>
+        <p:nvPicPr>
+          <p:cNvPr id="7" name="Picture 6">
+            <a:extLst>
+              <a:ext uri="{FF2B5EF4-FFF2-40B4-BE49-F238E27FC236}">
+                <a16:creationId xmlns:a16="http://schemas.microsoft.com/office/drawing/2014/main" id="{14543072-3757-233B-84BE-B32C2482FD2F}"/>
+              </a:ext>
+            </a:extLst>
+          </p:cNvPr>
+          <p:cNvPicPr>
+            <a:picLocks noChangeAspect="1"/>
+          </p:cNvPicPr>
+          <p:nvPr/>
+        </p:nvPicPr>
+        <p:blipFill>
+          <a:blip r:embed="rId3">
+            <a:extLst>
+              <a:ext uri="{28A0092B-C50C-407E-A947-70E740481C1C}">
+                <a14:useLocalDpi xmlns:a14="http://schemas.microsoft.com/office/drawing/2010/main" val="0"/>
+              </a:ext>
+            </a:extLst>
+          </a:blip>
+          <a:srcRect l="1402" t="6666" b="2516"/>
+          <a:stretch>
+            <a:fillRect/>
+          </a:stretch>
+        </p:blipFill>
+        <p:spPr>
+          <a:xfrm>
+            <a:off x="492670" y="-2513"/>
+            <a:ext cx="5793111" cy="6860513"/>
+          </a:xfrm>
+          <a:prstGeom prst="rect">
+            <a:avLst/>
+          </a:prstGeom>
+        </p:spPr>
+      </p:pic>
+      <p:pic>
+        <p:nvPicPr>
+          <p:cNvPr id="9" name="Picture 8">
+            <a:extLst>
+              <a:ext uri="{FF2B5EF4-FFF2-40B4-BE49-F238E27FC236}">
+                <a16:creationId xmlns:a16="http://schemas.microsoft.com/office/drawing/2014/main" id="{3CEFE170-57FA-DADE-C41D-0522204CB9CB}"/>
+              </a:ext>
+            </a:extLst>
+          </p:cNvPr>
+          <p:cNvPicPr>
+            <a:picLocks noChangeAspect="1"/>
+          </p:cNvPicPr>
+          <p:nvPr/>
+        </p:nvPicPr>
+        <p:blipFill>
+          <a:blip r:embed="rId4">
+            <a:extLst>
+              <a:ext uri="{28A0092B-C50C-407E-A947-70E740481C1C}">
+                <a14:useLocalDpi xmlns:a14="http://schemas.microsoft.com/office/drawing/2010/main" val="0"/>
+              </a:ext>
+            </a:extLst>
+          </a:blip>
+          <a:srcRect t="6666" r="4529" b="2516"/>
+          <a:stretch>
+            <a:fillRect/>
+          </a:stretch>
+        </p:blipFill>
+        <p:spPr>
+          <a:xfrm>
+            <a:off x="5725067" y="3531"/>
+            <a:ext cx="5604461" cy="6854469"/>
+          </a:xfrm>
+          <a:prstGeom prst="rect">
+            <a:avLst/>
+          </a:prstGeom>
+        </p:spPr>
+      </p:pic>
+      <p:sp>
+        <p:nvSpPr>
+          <p:cNvPr id="13" name="Text Box 2">
+            <a:extLst>
+              <a:ext uri="{FF2B5EF4-FFF2-40B4-BE49-F238E27FC236}">
+                <a16:creationId xmlns:a16="http://schemas.microsoft.com/office/drawing/2014/main" id="{CB3E3DF2-12B4-3697-D3AC-8E30BBCCCFF3}"/>
+              </a:ext>
+            </a:extLst>
+          </p:cNvPr>
+          <p:cNvSpPr txBox="1">
+            <a:spLocks noChangeArrowheads="1"/>
+          </p:cNvSpPr>
+          <p:nvPr/>
+        </p:nvSpPr>
+        <p:spPr bwMode="auto">
+          <a:xfrm>
+            <a:off x="1161744" y="423234"/>
+            <a:ext cx="542519" cy="338554"/>
+          </a:xfrm>
+          <a:prstGeom prst="rect">
+            <a:avLst/>
+          </a:prstGeom>
+          <a:noFill/>
+          <a:ln w="9525">
+            <a:noFill/>
+            <a:miter lim="800000"/>
+            <a:headEnd/>
+            <a:tailEnd/>
+          </a:ln>
+        </p:spPr>
+        <p:txBody>
+          <a:bodyPr rot="0" vert="horz" wrap="square" lIns="91440" tIns="45720" rIns="91440" bIns="45720" anchor="t" anchorCtr="0">
+            <a:spAutoFit/>
+          </a:bodyPr>
+          <a:lstStyle/>
+          <a:p>
+            <a:pPr algn="just"/>
+            <a:r>
+              <a:rPr lang="en-GB" sz="1600" dirty="0">
+                <a:effectLst/>
+                <a:latin typeface="Arial" panose="020B0604020202020204" pitchFamily="34" charset="0"/>
+                <a:ea typeface="TH Sarabun PSK"/>
+                <a:cs typeface="TH Sarabun PSK"/>
+              </a:rPr>
+              <a:t>(a)</a:t>
+            </a:r>
+          </a:p>
+        </p:txBody>
+      </p:sp>
+      <p:sp>
+        <p:nvSpPr>
+          <p:cNvPr id="15" name="Text Box 2">
+            <a:extLst>
+              <a:ext uri="{FF2B5EF4-FFF2-40B4-BE49-F238E27FC236}">
+                <a16:creationId xmlns:a16="http://schemas.microsoft.com/office/drawing/2014/main" id="{CF2AFB40-0253-886C-03D1-C9E3B1D444E4}"/>
+              </a:ext>
+            </a:extLst>
+          </p:cNvPr>
+          <p:cNvSpPr txBox="1">
+            <a:spLocks noChangeArrowheads="1"/>
+          </p:cNvSpPr>
+          <p:nvPr/>
+        </p:nvSpPr>
+        <p:spPr bwMode="auto">
+          <a:xfrm>
+            <a:off x="6466039" y="423234"/>
+            <a:ext cx="542519" cy="338554"/>
+          </a:xfrm>
+          <a:prstGeom prst="rect">
+            <a:avLst/>
+          </a:prstGeom>
+          <a:noFill/>
+          <a:ln w="9525">
+            <a:noFill/>
+            <a:miter lim="800000"/>
+            <a:headEnd/>
+            <a:tailEnd/>
+          </a:ln>
+        </p:spPr>
+        <p:txBody>
+          <a:bodyPr rot="0" vert="horz" wrap="square" lIns="91440" tIns="45720" rIns="91440" bIns="45720" anchor="t" anchorCtr="0">
+            <a:spAutoFit/>
+          </a:bodyPr>
+          <a:lstStyle/>
+          <a:p>
+            <a:pPr algn="just"/>
+            <a:r>
+              <a:rPr lang="en-GB" sz="1600" dirty="0">
+                <a:effectLst/>
+                <a:latin typeface="Arial" panose="020B0604020202020204" pitchFamily="34" charset="0"/>
+                <a:ea typeface="Tahoma" panose="020B0604030504040204" pitchFamily="34" charset="0"/>
+                <a:cs typeface="Arial" panose="020B0604020202020204" pitchFamily="34" charset="0"/>
+              </a:rPr>
+              <a:t>(b)</a:t>
+            </a:r>
+          </a:p>
+        </p:txBody>
+      </p:sp>
+    </p:spTree>
+    <p:extLst>
+      <p:ext uri="{BB962C8B-B14F-4D97-AF65-F5344CB8AC3E}">
+        <p14:creationId xmlns:p14="http://schemas.microsoft.com/office/powerpoint/2010/main" val="579365150"/>
+      </p:ext>
+    </p:extLst>
+  </p:cSld>
+  <p:clrMapOvr>
+    <a:masterClrMapping/>
+  </p:clrMapOvr>
+</p:sld>
+</file>
+
+<file path=ppt/slides/slide13.xml><?xml version="1.0" encoding="utf-8"?>
 <p:sld xmlns:a="http://schemas.openxmlformats.org/drawingml/2006/main" xmlns:r="http://schemas.openxmlformats.org/officeDocument/2006/relationships" xmlns:p="http://schemas.openxmlformats.org/presentationml/2006/main" show="0">
   <p:cSld>
     <p:spTree>
@@ -4338,7 +5731,7 @@
 </p:sld>
 </file>
 
-<file path=ppt/slides/slide11.xml><?xml version="1.0" encoding="utf-8"?>
+<file path=ppt/slides/slide14.xml><?xml version="1.0" encoding="utf-8"?>
 <p:sld xmlns:a="http://schemas.openxmlformats.org/drawingml/2006/main" xmlns:r="http://schemas.openxmlformats.org/officeDocument/2006/relationships" xmlns:p="http://schemas.openxmlformats.org/presentationml/2006/main" show="0">
   <p:cSld>
     <p:spTree>
@@ -4893,7 +6286,7 @@
 </p:sld>
 </file>
 
-<file path=ppt/slides/slide12.xml><?xml version="1.0" encoding="utf-8"?>
+<file path=ppt/slides/slide15.xml><?xml version="1.0" encoding="utf-8"?>
 <p:sld xmlns:a="http://schemas.openxmlformats.org/drawingml/2006/main" xmlns:r="http://schemas.openxmlformats.org/officeDocument/2006/relationships" xmlns:p="http://schemas.openxmlformats.org/presentationml/2006/main" show="0">
   <p:cSld>
     <p:spTree>
@@ -4966,7 +6359,7 @@
 </p:sld>
 </file>
 
-<file path=ppt/slides/slide13.xml><?xml version="1.0" encoding="utf-8"?>
+<file path=ppt/slides/slide16.xml><?xml version="1.0" encoding="utf-8"?>
 <p:sld xmlns:a="http://schemas.openxmlformats.org/drawingml/2006/main" xmlns:r="http://schemas.openxmlformats.org/officeDocument/2006/relationships" xmlns:p="http://schemas.openxmlformats.org/presentationml/2006/main" show="0">
   <p:cSld>
     <p:spTree>
@@ -5514,7 +6907,7 @@
 </p:sld>
 </file>
 
-<file path=ppt/slides/slide14.xml><?xml version="1.0" encoding="utf-8"?>
+<file path=ppt/slides/slide17.xml><?xml version="1.0" encoding="utf-8"?>
 <p:sld xmlns:a="http://schemas.openxmlformats.org/drawingml/2006/main" xmlns:r="http://schemas.openxmlformats.org/officeDocument/2006/relationships" xmlns:p="http://schemas.openxmlformats.org/presentationml/2006/main" show="0">
   <p:cSld>
     <p:spTree>
@@ -5728,7 +7121,7 @@
 </p:sld>
 </file>
 
-<file path=ppt/slides/slide15.xml><?xml version="1.0" encoding="utf-8"?>
+<file path=ppt/slides/slide18.xml><?xml version="1.0" encoding="utf-8"?>
 <p:sld xmlns:a="http://schemas.openxmlformats.org/drawingml/2006/main" xmlns:r="http://schemas.openxmlformats.org/officeDocument/2006/relationships" xmlns:p="http://schemas.openxmlformats.org/presentationml/2006/main" show="0">
   <p:cSld>
     <p:spTree>
@@ -5855,7 +7248,7 @@
 </p:sld>
 </file>
 
-<file path=ppt/slides/slide16.xml><?xml version="1.0" encoding="utf-8"?>
+<file path=ppt/slides/slide19.xml><?xml version="1.0" encoding="utf-8"?>
 <p:sld xmlns:a="http://schemas.openxmlformats.org/drawingml/2006/main" xmlns:r="http://schemas.openxmlformats.org/officeDocument/2006/relationships" xmlns:p="http://schemas.openxmlformats.org/presentationml/2006/main" show="0">
   <p:cSld>
     <p:spTree>
@@ -6021,7 +7414,619 @@
 </p:sld>
 </file>
 
-<file path=ppt/slides/slide17.xml><?xml version="1.0" encoding="utf-8"?>
+<file path=ppt/slides/slide2.xml><?xml version="1.0" encoding="utf-8"?>
+<p:sld xmlns:a="http://schemas.openxmlformats.org/drawingml/2006/main" xmlns:r="http://schemas.openxmlformats.org/officeDocument/2006/relationships" xmlns:p="http://schemas.openxmlformats.org/presentationml/2006/main">
+  <p:cSld>
+    <p:spTree>
+      <p:nvGrpSpPr>
+        <p:cNvPr id="1" name=""/>
+        <p:cNvGrpSpPr/>
+        <p:nvPr/>
+      </p:nvGrpSpPr>
+      <p:grpSpPr>
+        <a:xfrm>
+          <a:off x="0" y="0"/>
+          <a:ext cx="0" cy="0"/>
+          <a:chOff x="0" y="0"/>
+          <a:chExt cx="0" cy="0"/>
+        </a:xfrm>
+      </p:grpSpPr>
+      <p:sp>
+        <p:nvSpPr>
+          <p:cNvPr id="2" name="Rectangle 1">
+            <a:extLst>
+              <a:ext uri="{FF2B5EF4-FFF2-40B4-BE49-F238E27FC236}">
+                <a16:creationId xmlns:a16="http://schemas.microsoft.com/office/drawing/2014/main" id="{34B8F0EC-0887-CF59-65E7-B34DD0AA15BE}"/>
+              </a:ext>
+            </a:extLst>
+          </p:cNvPr>
+          <p:cNvSpPr/>
+          <p:nvPr/>
+        </p:nvSpPr>
+        <p:spPr>
+          <a:xfrm>
+            <a:off x="3556236" y="3880739"/>
+            <a:ext cx="5281502" cy="1950717"/>
+          </a:xfrm>
+          <a:prstGeom prst="rect">
+            <a:avLst/>
+          </a:prstGeom>
+          <a:solidFill>
+            <a:schemeClr val="tx2">
+              <a:lumMod val="25000"/>
+              <a:lumOff val="75000"/>
+            </a:schemeClr>
+          </a:solidFill>
+          <a:ln>
+            <a:noFill/>
+          </a:ln>
+        </p:spPr>
+        <p:style>
+          <a:lnRef idx="2">
+            <a:schemeClr val="accent1">
+              <a:shade val="15000"/>
+            </a:schemeClr>
+          </a:lnRef>
+          <a:fillRef idx="1">
+            <a:schemeClr val="accent1"/>
+          </a:fillRef>
+          <a:effectRef idx="0">
+            <a:schemeClr val="accent1"/>
+          </a:effectRef>
+          <a:fontRef idx="minor">
+            <a:schemeClr val="lt1"/>
+          </a:fontRef>
+        </p:style>
+        <p:txBody>
+          <a:bodyPr rtlCol="0" anchor="t"/>
+          <a:lstStyle/>
+          <a:p>
+            <a:r>
+              <a:rPr lang="en-US" sz="2400" dirty="0">
+                <a:solidFill>
+                  <a:schemeClr val="tx1"/>
+                </a:solidFill>
+                <a:latin typeface="Arial" panose="020B0604020202020204" pitchFamily="34" charset="0"/>
+                <a:cs typeface="Arial" panose="020B0604020202020204" pitchFamily="34" charset="0"/>
+              </a:rPr>
+              <a:t>Substrate</a:t>
+            </a:r>
+            <a:endParaRPr lang="en-GB" sz="2400" dirty="0">
+              <a:solidFill>
+                <a:schemeClr val="tx1"/>
+              </a:solidFill>
+              <a:latin typeface="Arial" panose="020B0604020202020204" pitchFamily="34" charset="0"/>
+              <a:cs typeface="Arial" panose="020B0604020202020204" pitchFamily="34" charset="0"/>
+            </a:endParaRPr>
+          </a:p>
+        </p:txBody>
+      </p:sp>
+      <p:sp>
+        <p:nvSpPr>
+          <p:cNvPr id="3" name="Rectangle 2">
+            <a:extLst>
+              <a:ext uri="{FF2B5EF4-FFF2-40B4-BE49-F238E27FC236}">
+                <a16:creationId xmlns:a16="http://schemas.microsoft.com/office/drawing/2014/main" id="{C100CBF4-C87C-8EA4-40E3-75E5BD3CC923}"/>
+              </a:ext>
+            </a:extLst>
+          </p:cNvPr>
+          <p:cNvSpPr/>
+          <p:nvPr/>
+        </p:nvSpPr>
+        <p:spPr>
+          <a:xfrm>
+            <a:off x="3556237" y="2826744"/>
+            <a:ext cx="5281498" cy="1053996"/>
+          </a:xfrm>
+          <a:prstGeom prst="rect">
+            <a:avLst/>
+          </a:prstGeom>
+          <a:solidFill>
+            <a:schemeClr val="accent3">
+              <a:lumMod val="20000"/>
+              <a:lumOff val="80000"/>
+            </a:schemeClr>
+          </a:solidFill>
+          <a:ln>
+            <a:noFill/>
+          </a:ln>
+        </p:spPr>
+        <p:style>
+          <a:lnRef idx="2">
+            <a:schemeClr val="accent1">
+              <a:shade val="15000"/>
+            </a:schemeClr>
+          </a:lnRef>
+          <a:fillRef idx="1">
+            <a:schemeClr val="accent1"/>
+          </a:fillRef>
+          <a:effectRef idx="0">
+            <a:schemeClr val="accent1"/>
+          </a:effectRef>
+          <a:fontRef idx="minor">
+            <a:schemeClr val="lt1"/>
+          </a:fontRef>
+        </p:style>
+        <p:txBody>
+          <a:bodyPr rtlCol="0" anchor="t"/>
+          <a:lstStyle/>
+          <a:p>
+            <a:r>
+              <a:rPr lang="en-US" sz="2400" dirty="0">
+                <a:solidFill>
+                  <a:schemeClr val="tx1"/>
+                </a:solidFill>
+                <a:latin typeface="Arial" panose="020B0604020202020204" pitchFamily="34" charset="0"/>
+                <a:cs typeface="Arial" panose="020B0604020202020204" pitchFamily="34" charset="0"/>
+              </a:rPr>
+              <a:t>Film</a:t>
+            </a:r>
+            <a:endParaRPr lang="en-GB" sz="2400" dirty="0">
+              <a:solidFill>
+                <a:schemeClr val="tx1"/>
+              </a:solidFill>
+              <a:latin typeface="Arial" panose="020B0604020202020204" pitchFamily="34" charset="0"/>
+              <a:cs typeface="Arial" panose="020B0604020202020204" pitchFamily="34" charset="0"/>
+            </a:endParaRPr>
+          </a:p>
+        </p:txBody>
+      </p:sp>
+      <p:cxnSp>
+        <p:nvCxnSpPr>
+          <p:cNvPr id="12" name="Straight Arrow Connector 11">
+            <a:extLst>
+              <a:ext uri="{FF2B5EF4-FFF2-40B4-BE49-F238E27FC236}">
+                <a16:creationId xmlns:a16="http://schemas.microsoft.com/office/drawing/2014/main" id="{18DF0614-9416-BE65-3537-D556EF6446F9}"/>
+              </a:ext>
+            </a:extLst>
+          </p:cNvPr>
+          <p:cNvCxnSpPr>
+            <a:cxnSpLocks/>
+          </p:cNvCxnSpPr>
+          <p:nvPr/>
+        </p:nvCxnSpPr>
+        <p:spPr>
+          <a:xfrm flipV="1">
+            <a:off x="5778020" y="1699731"/>
+            <a:ext cx="2547126" cy="2193709"/>
+          </a:xfrm>
+          <a:prstGeom prst="straightConnector1">
+            <a:avLst/>
+          </a:prstGeom>
+          <a:ln w="57150">
+            <a:solidFill>
+              <a:schemeClr val="accent2"/>
+            </a:solidFill>
+            <a:prstDash val="dash"/>
+            <a:tailEnd type="triangle"/>
+          </a:ln>
+        </p:spPr>
+        <p:style>
+          <a:lnRef idx="2">
+            <a:schemeClr val="accent1"/>
+          </a:lnRef>
+          <a:fillRef idx="0">
+            <a:schemeClr val="accent1"/>
+          </a:fillRef>
+          <a:effectRef idx="1">
+            <a:schemeClr val="accent1"/>
+          </a:effectRef>
+          <a:fontRef idx="minor">
+            <a:schemeClr val="tx1"/>
+          </a:fontRef>
+        </p:style>
+      </p:cxnSp>
+      <p:cxnSp>
+        <p:nvCxnSpPr>
+          <p:cNvPr id="21" name="Straight Arrow Connector 20">
+            <a:extLst>
+              <a:ext uri="{FF2B5EF4-FFF2-40B4-BE49-F238E27FC236}">
+                <a16:creationId xmlns:a16="http://schemas.microsoft.com/office/drawing/2014/main" id="{AD091AAD-134C-0EAD-F4A2-6BC8EE5317E6}"/>
+              </a:ext>
+            </a:extLst>
+          </p:cNvPr>
+          <p:cNvCxnSpPr>
+            <a:cxnSpLocks/>
+          </p:cNvCxnSpPr>
+          <p:nvPr/>
+        </p:nvCxnSpPr>
+        <p:spPr>
+          <a:xfrm>
+            <a:off x="5778021" y="1663700"/>
+            <a:ext cx="0" cy="4584700"/>
+          </a:xfrm>
+          <a:prstGeom prst="straightConnector1">
+            <a:avLst/>
+          </a:prstGeom>
+          <a:ln w="76200">
+            <a:solidFill>
+              <a:schemeClr val="accent2"/>
+            </a:solidFill>
+            <a:tailEnd type="triangle"/>
+          </a:ln>
+        </p:spPr>
+        <p:style>
+          <a:lnRef idx="2">
+            <a:schemeClr val="accent1"/>
+          </a:lnRef>
+          <a:fillRef idx="0">
+            <a:schemeClr val="accent1"/>
+          </a:fillRef>
+          <a:effectRef idx="1">
+            <a:schemeClr val="accent1"/>
+          </a:effectRef>
+          <a:fontRef idx="minor">
+            <a:schemeClr val="tx1"/>
+          </a:fontRef>
+        </p:style>
+      </p:cxnSp>
+      <p:sp>
+        <p:nvSpPr>
+          <p:cNvPr id="47" name="TextBox 46">
+            <a:extLst>
+              <a:ext uri="{FF2B5EF4-FFF2-40B4-BE49-F238E27FC236}">
+                <a16:creationId xmlns:a16="http://schemas.microsoft.com/office/drawing/2014/main" id="{E5A4E198-88D5-A962-8272-D77462BC6181}"/>
+              </a:ext>
+            </a:extLst>
+          </p:cNvPr>
+          <p:cNvSpPr txBox="1"/>
+          <p:nvPr/>
+        </p:nvSpPr>
+        <p:spPr>
+          <a:xfrm>
+            <a:off x="6833138" y="1810366"/>
+            <a:ext cx="521297" cy="461665"/>
+          </a:xfrm>
+          <a:prstGeom prst="rect">
+            <a:avLst/>
+          </a:prstGeom>
+          <a:noFill/>
+        </p:spPr>
+        <p:txBody>
+          <a:bodyPr wrap="square" rtlCol="0">
+            <a:spAutoFit/>
+          </a:bodyPr>
+          <a:lstStyle/>
+          <a:p>
+            <a:r>
+              <a:rPr lang="en-US" sz="2400" dirty="0">
+                <a:latin typeface="Arial" panose="020B0604020202020204" pitchFamily="34" charset="0"/>
+                <a:cs typeface="Arial" panose="020B0604020202020204" pitchFamily="34" charset="0"/>
+              </a:rPr>
+              <a:t>R</a:t>
+            </a:r>
+            <a:r>
+              <a:rPr lang="en-US" sz="2400" baseline="-25000" dirty="0">
+                <a:latin typeface="Arial" panose="020B0604020202020204" pitchFamily="34" charset="0"/>
+                <a:cs typeface="Arial" panose="020B0604020202020204" pitchFamily="34" charset="0"/>
+              </a:rPr>
+              <a:t>2</a:t>
+            </a:r>
+            <a:endParaRPr lang="en-GB" sz="2400" dirty="0">
+              <a:latin typeface="Arial" panose="020B0604020202020204" pitchFamily="34" charset="0"/>
+              <a:cs typeface="Arial" panose="020B0604020202020204" pitchFamily="34" charset="0"/>
+            </a:endParaRPr>
+          </a:p>
+        </p:txBody>
+      </p:sp>
+      <p:sp>
+        <p:nvSpPr>
+          <p:cNvPr id="48" name="TextBox 47">
+            <a:extLst>
+              <a:ext uri="{FF2B5EF4-FFF2-40B4-BE49-F238E27FC236}">
+                <a16:creationId xmlns:a16="http://schemas.microsoft.com/office/drawing/2014/main" id="{6975321D-45E2-AB97-A7B5-0408E4773235}"/>
+              </a:ext>
+            </a:extLst>
+          </p:cNvPr>
+          <p:cNvSpPr txBox="1"/>
+          <p:nvPr/>
+        </p:nvSpPr>
+        <p:spPr>
+          <a:xfrm>
+            <a:off x="8070147" y="1808106"/>
+            <a:ext cx="521297" cy="461665"/>
+          </a:xfrm>
+          <a:prstGeom prst="rect">
+            <a:avLst/>
+          </a:prstGeom>
+          <a:noFill/>
+        </p:spPr>
+        <p:txBody>
+          <a:bodyPr wrap="square" rtlCol="0">
+            <a:spAutoFit/>
+          </a:bodyPr>
+          <a:lstStyle/>
+          <a:p>
+            <a:r>
+              <a:rPr lang="en-US" sz="2400" dirty="0">
+                <a:latin typeface="Arial" panose="020B0604020202020204" pitchFamily="34" charset="0"/>
+                <a:cs typeface="Arial" panose="020B0604020202020204" pitchFamily="34" charset="0"/>
+              </a:rPr>
+              <a:t>R</a:t>
+            </a:r>
+            <a:r>
+              <a:rPr lang="en-US" sz="2400" baseline="-25000" dirty="0">
+                <a:latin typeface="Arial" panose="020B0604020202020204" pitchFamily="34" charset="0"/>
+                <a:cs typeface="Arial" panose="020B0604020202020204" pitchFamily="34" charset="0"/>
+              </a:rPr>
+              <a:t>1</a:t>
+            </a:r>
+            <a:endParaRPr lang="en-GB" sz="2400" dirty="0">
+              <a:latin typeface="Arial" panose="020B0604020202020204" pitchFamily="34" charset="0"/>
+              <a:cs typeface="Arial" panose="020B0604020202020204" pitchFamily="34" charset="0"/>
+            </a:endParaRPr>
+          </a:p>
+        </p:txBody>
+      </p:sp>
+      <p:cxnSp>
+        <p:nvCxnSpPr>
+          <p:cNvPr id="54" name="Straight Arrow Connector 53">
+            <a:extLst>
+              <a:ext uri="{FF2B5EF4-FFF2-40B4-BE49-F238E27FC236}">
+                <a16:creationId xmlns:a16="http://schemas.microsoft.com/office/drawing/2014/main" id="{90E1AC66-5568-7FAE-96E5-10169FD28F2D}"/>
+              </a:ext>
+            </a:extLst>
+          </p:cNvPr>
+          <p:cNvCxnSpPr>
+            <a:cxnSpLocks/>
+          </p:cNvCxnSpPr>
+          <p:nvPr/>
+        </p:nvCxnSpPr>
+        <p:spPr>
+          <a:xfrm flipV="1">
+            <a:off x="5778020" y="1685297"/>
+            <a:ext cx="1308580" cy="1127013"/>
+          </a:xfrm>
+          <a:prstGeom prst="straightConnector1">
+            <a:avLst/>
+          </a:prstGeom>
+          <a:ln w="57150">
+            <a:solidFill>
+              <a:schemeClr val="accent2"/>
+            </a:solidFill>
+            <a:prstDash val="dash"/>
+            <a:tailEnd type="triangle"/>
+          </a:ln>
+        </p:spPr>
+        <p:style>
+          <a:lnRef idx="2">
+            <a:schemeClr val="accent1"/>
+          </a:lnRef>
+          <a:fillRef idx="0">
+            <a:schemeClr val="accent1"/>
+          </a:fillRef>
+          <a:effectRef idx="1">
+            <a:schemeClr val="accent1"/>
+          </a:effectRef>
+          <a:fontRef idx="minor">
+            <a:schemeClr val="tx1"/>
+          </a:fontRef>
+        </p:style>
+      </p:cxnSp>
+      <p:sp>
+        <p:nvSpPr>
+          <p:cNvPr id="66" name="Right Brace 65">
+            <a:extLst>
+              <a:ext uri="{FF2B5EF4-FFF2-40B4-BE49-F238E27FC236}">
+                <a16:creationId xmlns:a16="http://schemas.microsoft.com/office/drawing/2014/main" id="{72F1F781-8B83-9D86-1431-22905D416A8E}"/>
+              </a:ext>
+            </a:extLst>
+          </p:cNvPr>
+          <p:cNvSpPr/>
+          <p:nvPr/>
+        </p:nvSpPr>
+        <p:spPr>
+          <a:xfrm>
+            <a:off x="8207277" y="2838188"/>
+            <a:ext cx="213360" cy="1030700"/>
+          </a:xfrm>
+          <a:prstGeom prst="rightBrace">
+            <a:avLst>
+              <a:gd name="adj1" fmla="val 8333"/>
+              <a:gd name="adj2" fmla="val 51479"/>
+            </a:avLst>
+          </a:prstGeom>
+          <a:ln>
+            <a:solidFill>
+              <a:schemeClr val="tx1"/>
+            </a:solidFill>
+          </a:ln>
+        </p:spPr>
+        <p:style>
+          <a:lnRef idx="2">
+            <a:schemeClr val="accent1"/>
+          </a:lnRef>
+          <a:fillRef idx="0">
+            <a:schemeClr val="accent1"/>
+          </a:fillRef>
+          <a:effectRef idx="1">
+            <a:schemeClr val="accent1"/>
+          </a:effectRef>
+          <a:fontRef idx="minor">
+            <a:schemeClr val="tx1"/>
+          </a:fontRef>
+        </p:style>
+        <p:txBody>
+          <a:bodyPr rtlCol="0" anchor="ctr"/>
+          <a:lstStyle/>
+          <a:p>
+            <a:pPr algn="ctr"/>
+            <a:endParaRPr lang="en-GB"/>
+          </a:p>
+        </p:txBody>
+      </p:sp>
+      <mc:AlternateContent xmlns:mc="http://schemas.openxmlformats.org/markup-compatibility/2006" xmlns:a14="http://schemas.microsoft.com/office/drawing/2010/main">
+        <mc:Choice Requires="a14">
+          <p:sp>
+            <p:nvSpPr>
+              <p:cNvPr id="67" name="TextBox 66">
+                <a:extLst>
+                  <a:ext uri="{FF2B5EF4-FFF2-40B4-BE49-F238E27FC236}">
+                    <a16:creationId xmlns:a16="http://schemas.microsoft.com/office/drawing/2014/main" id="{DA108C06-DFC5-4089-E587-AD31D5C8FDDE}"/>
+                  </a:ext>
+                </a:extLst>
+              </p:cNvPr>
+              <p:cNvSpPr txBox="1"/>
+              <p:nvPr/>
+            </p:nvSpPr>
+            <p:spPr>
+              <a:xfrm>
+                <a:off x="8377507" y="2975136"/>
+                <a:ext cx="417102" cy="791307"/>
+              </a:xfrm>
+              <a:prstGeom prst="rect">
+                <a:avLst/>
+              </a:prstGeom>
+              <a:noFill/>
+            </p:spPr>
+            <p:txBody>
+              <a:bodyPr wrap="none" rtlCol="0">
+                <a:spAutoFit/>
+              </a:bodyPr>
+              <a:lstStyle/>
+              <a:p>
+                <a:pPr/>
+                <a14:m>
+                  <m:oMathPara xmlns:m="http://schemas.openxmlformats.org/officeDocument/2006/math">
+                    <m:oMathParaPr>
+                      <m:jc m:val="centerGroup"/>
+                    </m:oMathParaPr>
+                    <m:oMath xmlns:m="http://schemas.openxmlformats.org/officeDocument/2006/math">
+                      <m:f>
+                        <m:fPr>
+                          <m:ctrlPr>
+                            <a:rPr lang="en-GB" sz="2400" i="1" smtClean="0">
+                              <a:latin typeface="Cambria Math" panose="02040503050406030204" pitchFamily="18" charset="0"/>
+                            </a:rPr>
+                          </m:ctrlPr>
+                        </m:fPr>
+                        <m:num>
+                          <m:r>
+                            <a:rPr lang="en-GB" sz="2400" i="1" smtClean="0">
+                              <a:latin typeface="Cambria Math" panose="02040503050406030204" pitchFamily="18" charset="0"/>
+                              <a:ea typeface="Cambria Math" panose="02040503050406030204" pitchFamily="18" charset="0"/>
+                            </a:rPr>
+                            <m:t>𝜆</m:t>
+                          </m:r>
+                        </m:num>
+                        <m:den>
+                          <m:r>
+                            <a:rPr lang="en-US" sz="2400" b="0" i="1" smtClean="0">
+                              <a:latin typeface="Cambria Math" panose="02040503050406030204" pitchFamily="18" charset="0"/>
+                            </a:rPr>
+                            <m:t>4</m:t>
+                          </m:r>
+                        </m:den>
+                      </m:f>
+                    </m:oMath>
+                  </m:oMathPara>
+                </a14:m>
+                <a:endParaRPr lang="en-GB" sz="2400" dirty="0"/>
+              </a:p>
+            </p:txBody>
+          </p:sp>
+        </mc:Choice>
+        <mc:Fallback xmlns="">
+          <p:sp>
+            <p:nvSpPr>
+              <p:cNvPr id="67" name="TextBox 66">
+                <a:extLst>
+                  <a:ext uri="{FF2B5EF4-FFF2-40B4-BE49-F238E27FC236}">
+                    <a16:creationId xmlns:a16="http://schemas.microsoft.com/office/drawing/2014/main" id="{DA108C06-DFC5-4089-E587-AD31D5C8FDDE}"/>
+                  </a:ext>
+                </a:extLst>
+              </p:cNvPr>
+              <p:cNvSpPr txBox="1">
+                <a:spLocks noRot="1" noChangeAspect="1" noMove="1" noResize="1" noEditPoints="1" noAdjustHandles="1" noChangeArrowheads="1" noChangeShapeType="1" noTextEdit="1"/>
+              </p:cNvSpPr>
+              <p:nvPr/>
+            </p:nvSpPr>
+            <p:spPr>
+              <a:xfrm>
+                <a:off x="8377507" y="2975136"/>
+                <a:ext cx="417102" cy="791307"/>
+              </a:xfrm>
+              <a:prstGeom prst="rect">
+                <a:avLst/>
+              </a:prstGeom>
+              <a:blipFill>
+                <a:blip r:embed="rId3"/>
+                <a:stretch>
+                  <a:fillRect/>
+                </a:stretch>
+              </a:blipFill>
+            </p:spPr>
+            <p:txBody>
+              <a:bodyPr/>
+              <a:lstStyle/>
+              <a:p>
+                <a:r>
+                  <a:rPr lang="en-GB">
+                    <a:noFill/>
+                  </a:rPr>
+                  <a:t> </a:t>
+                </a:r>
+              </a:p>
+            </p:txBody>
+          </p:sp>
+        </mc:Fallback>
+      </mc:AlternateContent>
+      <p:sp>
+        <p:nvSpPr>
+          <p:cNvPr id="68" name="TextBox 67">
+            <a:extLst>
+              <a:ext uri="{FF2B5EF4-FFF2-40B4-BE49-F238E27FC236}">
+                <a16:creationId xmlns:a16="http://schemas.microsoft.com/office/drawing/2014/main" id="{B8A2F634-2561-D36F-7A29-B3E4BBF61D72}"/>
+              </a:ext>
+            </a:extLst>
+          </p:cNvPr>
+          <p:cNvSpPr txBox="1"/>
+          <p:nvPr/>
+        </p:nvSpPr>
+        <p:spPr>
+          <a:xfrm>
+            <a:off x="3556236" y="1693806"/>
+            <a:ext cx="561372" cy="461665"/>
+          </a:xfrm>
+          <a:prstGeom prst="rect">
+            <a:avLst/>
+          </a:prstGeom>
+          <a:noFill/>
+        </p:spPr>
+        <p:txBody>
+          <a:bodyPr wrap="none" rtlCol="0">
+            <a:spAutoFit/>
+          </a:bodyPr>
+          <a:lstStyle/>
+          <a:p>
+            <a:r>
+              <a:rPr lang="en-US" sz="2400" dirty="0">
+                <a:latin typeface="Arial" panose="020B0604020202020204" pitchFamily="34" charset="0"/>
+                <a:cs typeface="Arial" panose="020B0604020202020204" pitchFamily="34" charset="0"/>
+              </a:rPr>
+              <a:t>Air</a:t>
+            </a:r>
+            <a:endParaRPr lang="en-GB" sz="2400" dirty="0">
+              <a:latin typeface="Arial" panose="020B0604020202020204" pitchFamily="34" charset="0"/>
+              <a:cs typeface="Arial" panose="020B0604020202020204" pitchFamily="34" charset="0"/>
+            </a:endParaRPr>
+          </a:p>
+        </p:txBody>
+      </p:sp>
+    </p:spTree>
+    <p:extLst>
+      <p:ext uri="{BB962C8B-B14F-4D97-AF65-F5344CB8AC3E}">
+        <p14:creationId xmlns:p14="http://schemas.microsoft.com/office/powerpoint/2010/main" val="3648933230"/>
+      </p:ext>
+    </p:extLst>
+  </p:cSld>
+  <p:clrMapOvr>
+    <a:masterClrMapping/>
+  </p:clrMapOvr>
+</p:sld>
+</file>
+
+<file path=ppt/slides/slide20.xml><?xml version="1.0" encoding="utf-8"?>
 <p:sld xmlns:a="http://schemas.openxmlformats.org/drawingml/2006/main" xmlns:r="http://schemas.openxmlformats.org/officeDocument/2006/relationships" xmlns:p="http://schemas.openxmlformats.org/presentationml/2006/main" show="0">
   <p:cSld>
     <p:bg>
@@ -6227,7 +8232,7 @@
 </p:sld>
 </file>
 
-<file path=ppt/slides/slide18.xml><?xml version="1.0" encoding="utf-8"?>
+<file path=ppt/slides/slide21.xml><?xml version="1.0" encoding="utf-8"?>
 <p:sld xmlns:a="http://schemas.openxmlformats.org/drawingml/2006/main" xmlns:r="http://schemas.openxmlformats.org/officeDocument/2006/relationships" xmlns:p="http://schemas.openxmlformats.org/presentationml/2006/main" show="0">
   <p:cSld>
     <p:bg>
@@ -6434,7 +8439,7 @@
 </p:sld>
 </file>
 
-<file path=ppt/slides/slide19.xml><?xml version="1.0" encoding="utf-8"?>
+<file path=ppt/slides/slide22.xml><?xml version="1.0" encoding="utf-8"?>
 <p:sld xmlns:a="http://schemas.openxmlformats.org/drawingml/2006/main" xmlns:r="http://schemas.openxmlformats.org/officeDocument/2006/relationships" xmlns:p="http://schemas.openxmlformats.org/presentationml/2006/main" show="0">
   <p:cSld>
     <p:spTree>
@@ -7224,618 +9229,6 @@
 </p:sld>
 </file>
 
-<file path=ppt/slides/slide2.xml><?xml version="1.0" encoding="utf-8"?>
-<p:sld xmlns:a="http://schemas.openxmlformats.org/drawingml/2006/main" xmlns:r="http://schemas.openxmlformats.org/officeDocument/2006/relationships" xmlns:p="http://schemas.openxmlformats.org/presentationml/2006/main">
-  <p:cSld>
-    <p:spTree>
-      <p:nvGrpSpPr>
-        <p:cNvPr id="1" name=""/>
-        <p:cNvGrpSpPr/>
-        <p:nvPr/>
-      </p:nvGrpSpPr>
-      <p:grpSpPr>
-        <a:xfrm>
-          <a:off x="0" y="0"/>
-          <a:ext cx="0" cy="0"/>
-          <a:chOff x="0" y="0"/>
-          <a:chExt cx="0" cy="0"/>
-        </a:xfrm>
-      </p:grpSpPr>
-      <p:sp>
-        <p:nvSpPr>
-          <p:cNvPr id="2" name="Rectangle 1">
-            <a:extLst>
-              <a:ext uri="{FF2B5EF4-FFF2-40B4-BE49-F238E27FC236}">
-                <a16:creationId xmlns:a16="http://schemas.microsoft.com/office/drawing/2014/main" id="{34B8F0EC-0887-CF59-65E7-B34DD0AA15BE}"/>
-              </a:ext>
-            </a:extLst>
-          </p:cNvPr>
-          <p:cNvSpPr/>
-          <p:nvPr/>
-        </p:nvSpPr>
-        <p:spPr>
-          <a:xfrm>
-            <a:off x="3556236" y="3880739"/>
-            <a:ext cx="5281502" cy="1950717"/>
-          </a:xfrm>
-          <a:prstGeom prst="rect">
-            <a:avLst/>
-          </a:prstGeom>
-          <a:solidFill>
-            <a:schemeClr val="tx2">
-              <a:lumMod val="25000"/>
-              <a:lumOff val="75000"/>
-            </a:schemeClr>
-          </a:solidFill>
-          <a:ln>
-            <a:noFill/>
-          </a:ln>
-        </p:spPr>
-        <p:style>
-          <a:lnRef idx="2">
-            <a:schemeClr val="accent1">
-              <a:shade val="15000"/>
-            </a:schemeClr>
-          </a:lnRef>
-          <a:fillRef idx="1">
-            <a:schemeClr val="accent1"/>
-          </a:fillRef>
-          <a:effectRef idx="0">
-            <a:schemeClr val="accent1"/>
-          </a:effectRef>
-          <a:fontRef idx="minor">
-            <a:schemeClr val="lt1"/>
-          </a:fontRef>
-        </p:style>
-        <p:txBody>
-          <a:bodyPr rtlCol="0" anchor="t"/>
-          <a:lstStyle/>
-          <a:p>
-            <a:r>
-              <a:rPr lang="en-US" sz="2400" dirty="0">
-                <a:solidFill>
-                  <a:schemeClr val="tx1"/>
-                </a:solidFill>
-                <a:latin typeface="Arial" panose="020B0604020202020204" pitchFamily="34" charset="0"/>
-                <a:cs typeface="Arial" panose="020B0604020202020204" pitchFamily="34" charset="0"/>
-              </a:rPr>
-              <a:t>Substrate</a:t>
-            </a:r>
-            <a:endParaRPr lang="en-GB" sz="2400" dirty="0">
-              <a:solidFill>
-                <a:schemeClr val="tx1"/>
-              </a:solidFill>
-              <a:latin typeface="Arial" panose="020B0604020202020204" pitchFamily="34" charset="0"/>
-              <a:cs typeface="Arial" panose="020B0604020202020204" pitchFamily="34" charset="0"/>
-            </a:endParaRPr>
-          </a:p>
-        </p:txBody>
-      </p:sp>
-      <p:sp>
-        <p:nvSpPr>
-          <p:cNvPr id="3" name="Rectangle 2">
-            <a:extLst>
-              <a:ext uri="{FF2B5EF4-FFF2-40B4-BE49-F238E27FC236}">
-                <a16:creationId xmlns:a16="http://schemas.microsoft.com/office/drawing/2014/main" id="{C100CBF4-C87C-8EA4-40E3-75E5BD3CC923}"/>
-              </a:ext>
-            </a:extLst>
-          </p:cNvPr>
-          <p:cNvSpPr/>
-          <p:nvPr/>
-        </p:nvSpPr>
-        <p:spPr>
-          <a:xfrm>
-            <a:off x="3556237" y="2826744"/>
-            <a:ext cx="5281498" cy="1053996"/>
-          </a:xfrm>
-          <a:prstGeom prst="rect">
-            <a:avLst/>
-          </a:prstGeom>
-          <a:solidFill>
-            <a:schemeClr val="accent3">
-              <a:lumMod val="20000"/>
-              <a:lumOff val="80000"/>
-            </a:schemeClr>
-          </a:solidFill>
-          <a:ln>
-            <a:noFill/>
-          </a:ln>
-        </p:spPr>
-        <p:style>
-          <a:lnRef idx="2">
-            <a:schemeClr val="accent1">
-              <a:shade val="15000"/>
-            </a:schemeClr>
-          </a:lnRef>
-          <a:fillRef idx="1">
-            <a:schemeClr val="accent1"/>
-          </a:fillRef>
-          <a:effectRef idx="0">
-            <a:schemeClr val="accent1"/>
-          </a:effectRef>
-          <a:fontRef idx="minor">
-            <a:schemeClr val="lt1"/>
-          </a:fontRef>
-        </p:style>
-        <p:txBody>
-          <a:bodyPr rtlCol="0" anchor="t"/>
-          <a:lstStyle/>
-          <a:p>
-            <a:r>
-              <a:rPr lang="en-US" sz="2400" dirty="0">
-                <a:solidFill>
-                  <a:schemeClr val="tx1"/>
-                </a:solidFill>
-                <a:latin typeface="Arial" panose="020B0604020202020204" pitchFamily="34" charset="0"/>
-                <a:cs typeface="Arial" panose="020B0604020202020204" pitchFamily="34" charset="0"/>
-              </a:rPr>
-              <a:t>Film</a:t>
-            </a:r>
-            <a:endParaRPr lang="en-GB" sz="2400" dirty="0">
-              <a:solidFill>
-                <a:schemeClr val="tx1"/>
-              </a:solidFill>
-              <a:latin typeface="Arial" panose="020B0604020202020204" pitchFamily="34" charset="0"/>
-              <a:cs typeface="Arial" panose="020B0604020202020204" pitchFamily="34" charset="0"/>
-            </a:endParaRPr>
-          </a:p>
-        </p:txBody>
-      </p:sp>
-      <p:cxnSp>
-        <p:nvCxnSpPr>
-          <p:cNvPr id="12" name="Straight Arrow Connector 11">
-            <a:extLst>
-              <a:ext uri="{FF2B5EF4-FFF2-40B4-BE49-F238E27FC236}">
-                <a16:creationId xmlns:a16="http://schemas.microsoft.com/office/drawing/2014/main" id="{18DF0614-9416-BE65-3537-D556EF6446F9}"/>
-              </a:ext>
-            </a:extLst>
-          </p:cNvPr>
-          <p:cNvCxnSpPr>
-            <a:cxnSpLocks/>
-          </p:cNvCxnSpPr>
-          <p:nvPr/>
-        </p:nvCxnSpPr>
-        <p:spPr>
-          <a:xfrm flipV="1">
-            <a:off x="5778020" y="1699731"/>
-            <a:ext cx="2547126" cy="2193709"/>
-          </a:xfrm>
-          <a:prstGeom prst="straightConnector1">
-            <a:avLst/>
-          </a:prstGeom>
-          <a:ln w="57150">
-            <a:solidFill>
-              <a:schemeClr val="accent2"/>
-            </a:solidFill>
-            <a:prstDash val="dash"/>
-            <a:tailEnd type="triangle"/>
-          </a:ln>
-        </p:spPr>
-        <p:style>
-          <a:lnRef idx="2">
-            <a:schemeClr val="accent1"/>
-          </a:lnRef>
-          <a:fillRef idx="0">
-            <a:schemeClr val="accent1"/>
-          </a:fillRef>
-          <a:effectRef idx="1">
-            <a:schemeClr val="accent1"/>
-          </a:effectRef>
-          <a:fontRef idx="minor">
-            <a:schemeClr val="tx1"/>
-          </a:fontRef>
-        </p:style>
-      </p:cxnSp>
-      <p:cxnSp>
-        <p:nvCxnSpPr>
-          <p:cNvPr id="21" name="Straight Arrow Connector 20">
-            <a:extLst>
-              <a:ext uri="{FF2B5EF4-FFF2-40B4-BE49-F238E27FC236}">
-                <a16:creationId xmlns:a16="http://schemas.microsoft.com/office/drawing/2014/main" id="{AD091AAD-134C-0EAD-F4A2-6BC8EE5317E6}"/>
-              </a:ext>
-            </a:extLst>
-          </p:cNvPr>
-          <p:cNvCxnSpPr>
-            <a:cxnSpLocks/>
-          </p:cNvCxnSpPr>
-          <p:nvPr/>
-        </p:nvCxnSpPr>
-        <p:spPr>
-          <a:xfrm>
-            <a:off x="5778021" y="1663700"/>
-            <a:ext cx="0" cy="4584700"/>
-          </a:xfrm>
-          <a:prstGeom prst="straightConnector1">
-            <a:avLst/>
-          </a:prstGeom>
-          <a:ln w="76200">
-            <a:solidFill>
-              <a:schemeClr val="accent2"/>
-            </a:solidFill>
-            <a:tailEnd type="triangle"/>
-          </a:ln>
-        </p:spPr>
-        <p:style>
-          <a:lnRef idx="2">
-            <a:schemeClr val="accent1"/>
-          </a:lnRef>
-          <a:fillRef idx="0">
-            <a:schemeClr val="accent1"/>
-          </a:fillRef>
-          <a:effectRef idx="1">
-            <a:schemeClr val="accent1"/>
-          </a:effectRef>
-          <a:fontRef idx="minor">
-            <a:schemeClr val="tx1"/>
-          </a:fontRef>
-        </p:style>
-      </p:cxnSp>
-      <p:sp>
-        <p:nvSpPr>
-          <p:cNvPr id="47" name="TextBox 46">
-            <a:extLst>
-              <a:ext uri="{FF2B5EF4-FFF2-40B4-BE49-F238E27FC236}">
-                <a16:creationId xmlns:a16="http://schemas.microsoft.com/office/drawing/2014/main" id="{E5A4E198-88D5-A962-8272-D77462BC6181}"/>
-              </a:ext>
-            </a:extLst>
-          </p:cNvPr>
-          <p:cNvSpPr txBox="1"/>
-          <p:nvPr/>
-        </p:nvSpPr>
-        <p:spPr>
-          <a:xfrm>
-            <a:off x="6833138" y="1810366"/>
-            <a:ext cx="521297" cy="461665"/>
-          </a:xfrm>
-          <a:prstGeom prst="rect">
-            <a:avLst/>
-          </a:prstGeom>
-          <a:noFill/>
-        </p:spPr>
-        <p:txBody>
-          <a:bodyPr wrap="square" rtlCol="0">
-            <a:spAutoFit/>
-          </a:bodyPr>
-          <a:lstStyle/>
-          <a:p>
-            <a:r>
-              <a:rPr lang="en-US" sz="2400" dirty="0">
-                <a:latin typeface="Arial" panose="020B0604020202020204" pitchFamily="34" charset="0"/>
-                <a:cs typeface="Arial" panose="020B0604020202020204" pitchFamily="34" charset="0"/>
-              </a:rPr>
-              <a:t>R</a:t>
-            </a:r>
-            <a:r>
-              <a:rPr lang="en-US" sz="2400" baseline="-25000" dirty="0">
-                <a:latin typeface="Arial" panose="020B0604020202020204" pitchFamily="34" charset="0"/>
-                <a:cs typeface="Arial" panose="020B0604020202020204" pitchFamily="34" charset="0"/>
-              </a:rPr>
-              <a:t>2</a:t>
-            </a:r>
-            <a:endParaRPr lang="en-GB" sz="2400" dirty="0">
-              <a:latin typeface="Arial" panose="020B0604020202020204" pitchFamily="34" charset="0"/>
-              <a:cs typeface="Arial" panose="020B0604020202020204" pitchFamily="34" charset="0"/>
-            </a:endParaRPr>
-          </a:p>
-        </p:txBody>
-      </p:sp>
-      <p:sp>
-        <p:nvSpPr>
-          <p:cNvPr id="48" name="TextBox 47">
-            <a:extLst>
-              <a:ext uri="{FF2B5EF4-FFF2-40B4-BE49-F238E27FC236}">
-                <a16:creationId xmlns:a16="http://schemas.microsoft.com/office/drawing/2014/main" id="{6975321D-45E2-AB97-A7B5-0408E4773235}"/>
-              </a:ext>
-            </a:extLst>
-          </p:cNvPr>
-          <p:cNvSpPr txBox="1"/>
-          <p:nvPr/>
-        </p:nvSpPr>
-        <p:spPr>
-          <a:xfrm>
-            <a:off x="8070147" y="1808106"/>
-            <a:ext cx="521297" cy="461665"/>
-          </a:xfrm>
-          <a:prstGeom prst="rect">
-            <a:avLst/>
-          </a:prstGeom>
-          <a:noFill/>
-        </p:spPr>
-        <p:txBody>
-          <a:bodyPr wrap="square" rtlCol="0">
-            <a:spAutoFit/>
-          </a:bodyPr>
-          <a:lstStyle/>
-          <a:p>
-            <a:r>
-              <a:rPr lang="en-US" sz="2400" dirty="0">
-                <a:latin typeface="Arial" panose="020B0604020202020204" pitchFamily="34" charset="0"/>
-                <a:cs typeface="Arial" panose="020B0604020202020204" pitchFamily="34" charset="0"/>
-              </a:rPr>
-              <a:t>R</a:t>
-            </a:r>
-            <a:r>
-              <a:rPr lang="en-US" sz="2400" baseline="-25000" dirty="0">
-                <a:latin typeface="Arial" panose="020B0604020202020204" pitchFamily="34" charset="0"/>
-                <a:cs typeface="Arial" panose="020B0604020202020204" pitchFamily="34" charset="0"/>
-              </a:rPr>
-              <a:t>1</a:t>
-            </a:r>
-            <a:endParaRPr lang="en-GB" sz="2400" dirty="0">
-              <a:latin typeface="Arial" panose="020B0604020202020204" pitchFamily="34" charset="0"/>
-              <a:cs typeface="Arial" panose="020B0604020202020204" pitchFamily="34" charset="0"/>
-            </a:endParaRPr>
-          </a:p>
-        </p:txBody>
-      </p:sp>
-      <p:cxnSp>
-        <p:nvCxnSpPr>
-          <p:cNvPr id="54" name="Straight Arrow Connector 53">
-            <a:extLst>
-              <a:ext uri="{FF2B5EF4-FFF2-40B4-BE49-F238E27FC236}">
-                <a16:creationId xmlns:a16="http://schemas.microsoft.com/office/drawing/2014/main" id="{90E1AC66-5568-7FAE-96E5-10169FD28F2D}"/>
-              </a:ext>
-            </a:extLst>
-          </p:cNvPr>
-          <p:cNvCxnSpPr>
-            <a:cxnSpLocks/>
-          </p:cNvCxnSpPr>
-          <p:nvPr/>
-        </p:nvCxnSpPr>
-        <p:spPr>
-          <a:xfrm flipV="1">
-            <a:off x="5778020" y="1685297"/>
-            <a:ext cx="1308580" cy="1127013"/>
-          </a:xfrm>
-          <a:prstGeom prst="straightConnector1">
-            <a:avLst/>
-          </a:prstGeom>
-          <a:ln w="57150">
-            <a:solidFill>
-              <a:schemeClr val="accent2"/>
-            </a:solidFill>
-            <a:prstDash val="dash"/>
-            <a:tailEnd type="triangle"/>
-          </a:ln>
-        </p:spPr>
-        <p:style>
-          <a:lnRef idx="2">
-            <a:schemeClr val="accent1"/>
-          </a:lnRef>
-          <a:fillRef idx="0">
-            <a:schemeClr val="accent1"/>
-          </a:fillRef>
-          <a:effectRef idx="1">
-            <a:schemeClr val="accent1"/>
-          </a:effectRef>
-          <a:fontRef idx="minor">
-            <a:schemeClr val="tx1"/>
-          </a:fontRef>
-        </p:style>
-      </p:cxnSp>
-      <p:sp>
-        <p:nvSpPr>
-          <p:cNvPr id="66" name="Right Brace 65">
-            <a:extLst>
-              <a:ext uri="{FF2B5EF4-FFF2-40B4-BE49-F238E27FC236}">
-                <a16:creationId xmlns:a16="http://schemas.microsoft.com/office/drawing/2014/main" id="{72F1F781-8B83-9D86-1431-22905D416A8E}"/>
-              </a:ext>
-            </a:extLst>
-          </p:cNvPr>
-          <p:cNvSpPr/>
-          <p:nvPr/>
-        </p:nvSpPr>
-        <p:spPr>
-          <a:xfrm>
-            <a:off x="8207277" y="2838188"/>
-            <a:ext cx="213360" cy="1030700"/>
-          </a:xfrm>
-          <a:prstGeom prst="rightBrace">
-            <a:avLst>
-              <a:gd name="adj1" fmla="val 8333"/>
-              <a:gd name="adj2" fmla="val 51479"/>
-            </a:avLst>
-          </a:prstGeom>
-          <a:ln>
-            <a:solidFill>
-              <a:schemeClr val="tx1"/>
-            </a:solidFill>
-          </a:ln>
-        </p:spPr>
-        <p:style>
-          <a:lnRef idx="2">
-            <a:schemeClr val="accent1"/>
-          </a:lnRef>
-          <a:fillRef idx="0">
-            <a:schemeClr val="accent1"/>
-          </a:fillRef>
-          <a:effectRef idx="1">
-            <a:schemeClr val="accent1"/>
-          </a:effectRef>
-          <a:fontRef idx="minor">
-            <a:schemeClr val="tx1"/>
-          </a:fontRef>
-        </p:style>
-        <p:txBody>
-          <a:bodyPr rtlCol="0" anchor="ctr"/>
-          <a:lstStyle/>
-          <a:p>
-            <a:pPr algn="ctr"/>
-            <a:endParaRPr lang="en-GB"/>
-          </a:p>
-        </p:txBody>
-      </p:sp>
-      <mc:AlternateContent xmlns:mc="http://schemas.openxmlformats.org/markup-compatibility/2006" xmlns:a14="http://schemas.microsoft.com/office/drawing/2010/main">
-        <mc:Choice Requires="a14">
-          <p:sp>
-            <p:nvSpPr>
-              <p:cNvPr id="67" name="TextBox 66">
-                <a:extLst>
-                  <a:ext uri="{FF2B5EF4-FFF2-40B4-BE49-F238E27FC236}">
-                    <a16:creationId xmlns:a16="http://schemas.microsoft.com/office/drawing/2014/main" id="{DA108C06-DFC5-4089-E587-AD31D5C8FDDE}"/>
-                  </a:ext>
-                </a:extLst>
-              </p:cNvPr>
-              <p:cNvSpPr txBox="1"/>
-              <p:nvPr/>
-            </p:nvSpPr>
-            <p:spPr>
-              <a:xfrm>
-                <a:off x="8377507" y="2975136"/>
-                <a:ext cx="417102" cy="791307"/>
-              </a:xfrm>
-              <a:prstGeom prst="rect">
-                <a:avLst/>
-              </a:prstGeom>
-              <a:noFill/>
-            </p:spPr>
-            <p:txBody>
-              <a:bodyPr wrap="none" rtlCol="0">
-                <a:spAutoFit/>
-              </a:bodyPr>
-              <a:lstStyle/>
-              <a:p>
-                <a:pPr/>
-                <a14:m>
-                  <m:oMathPara xmlns:m="http://schemas.openxmlformats.org/officeDocument/2006/math">
-                    <m:oMathParaPr>
-                      <m:jc m:val="centerGroup"/>
-                    </m:oMathParaPr>
-                    <m:oMath xmlns:m="http://schemas.openxmlformats.org/officeDocument/2006/math">
-                      <m:f>
-                        <m:fPr>
-                          <m:ctrlPr>
-                            <a:rPr lang="en-GB" sz="2400" i="1" smtClean="0">
-                              <a:latin typeface="Cambria Math" panose="02040503050406030204" pitchFamily="18" charset="0"/>
-                            </a:rPr>
-                          </m:ctrlPr>
-                        </m:fPr>
-                        <m:num>
-                          <m:r>
-                            <a:rPr lang="en-GB" sz="2400" i="1" smtClean="0">
-                              <a:latin typeface="Cambria Math" panose="02040503050406030204" pitchFamily="18" charset="0"/>
-                              <a:ea typeface="Cambria Math" panose="02040503050406030204" pitchFamily="18" charset="0"/>
-                            </a:rPr>
-                            <m:t>𝜆</m:t>
-                          </m:r>
-                        </m:num>
-                        <m:den>
-                          <m:r>
-                            <a:rPr lang="en-US" sz="2400" b="0" i="1" smtClean="0">
-                              <a:latin typeface="Cambria Math" panose="02040503050406030204" pitchFamily="18" charset="0"/>
-                            </a:rPr>
-                            <m:t>4</m:t>
-                          </m:r>
-                        </m:den>
-                      </m:f>
-                    </m:oMath>
-                  </m:oMathPara>
-                </a14:m>
-                <a:endParaRPr lang="en-GB" sz="2400" dirty="0"/>
-              </a:p>
-            </p:txBody>
-          </p:sp>
-        </mc:Choice>
-        <mc:Fallback xmlns="">
-          <p:sp>
-            <p:nvSpPr>
-              <p:cNvPr id="67" name="TextBox 66">
-                <a:extLst>
-                  <a:ext uri="{FF2B5EF4-FFF2-40B4-BE49-F238E27FC236}">
-                    <a16:creationId xmlns:a16="http://schemas.microsoft.com/office/drawing/2014/main" id="{DA108C06-DFC5-4089-E587-AD31D5C8FDDE}"/>
-                  </a:ext>
-                </a:extLst>
-              </p:cNvPr>
-              <p:cNvSpPr txBox="1">
-                <a:spLocks noRot="1" noChangeAspect="1" noMove="1" noResize="1" noEditPoints="1" noAdjustHandles="1" noChangeArrowheads="1" noChangeShapeType="1" noTextEdit="1"/>
-              </p:cNvSpPr>
-              <p:nvPr/>
-            </p:nvSpPr>
-            <p:spPr>
-              <a:xfrm>
-                <a:off x="8377507" y="2975136"/>
-                <a:ext cx="417102" cy="791307"/>
-              </a:xfrm>
-              <a:prstGeom prst="rect">
-                <a:avLst/>
-              </a:prstGeom>
-              <a:blipFill>
-                <a:blip r:embed="rId3"/>
-                <a:stretch>
-                  <a:fillRect/>
-                </a:stretch>
-              </a:blipFill>
-            </p:spPr>
-            <p:txBody>
-              <a:bodyPr/>
-              <a:lstStyle/>
-              <a:p>
-                <a:r>
-                  <a:rPr lang="en-GB">
-                    <a:noFill/>
-                  </a:rPr>
-                  <a:t> </a:t>
-                </a:r>
-              </a:p>
-            </p:txBody>
-          </p:sp>
-        </mc:Fallback>
-      </mc:AlternateContent>
-      <p:sp>
-        <p:nvSpPr>
-          <p:cNvPr id="68" name="TextBox 67">
-            <a:extLst>
-              <a:ext uri="{FF2B5EF4-FFF2-40B4-BE49-F238E27FC236}">
-                <a16:creationId xmlns:a16="http://schemas.microsoft.com/office/drawing/2014/main" id="{B8A2F634-2561-D36F-7A29-B3E4BBF61D72}"/>
-              </a:ext>
-            </a:extLst>
-          </p:cNvPr>
-          <p:cNvSpPr txBox="1"/>
-          <p:nvPr/>
-        </p:nvSpPr>
-        <p:spPr>
-          <a:xfrm>
-            <a:off x="3556236" y="1693806"/>
-            <a:ext cx="561372" cy="461665"/>
-          </a:xfrm>
-          <a:prstGeom prst="rect">
-            <a:avLst/>
-          </a:prstGeom>
-          <a:noFill/>
-        </p:spPr>
-        <p:txBody>
-          <a:bodyPr wrap="none" rtlCol="0">
-            <a:spAutoFit/>
-          </a:bodyPr>
-          <a:lstStyle/>
-          <a:p>
-            <a:r>
-              <a:rPr lang="en-US" sz="2400" dirty="0">
-                <a:latin typeface="Arial" panose="020B0604020202020204" pitchFamily="34" charset="0"/>
-                <a:cs typeface="Arial" panose="020B0604020202020204" pitchFamily="34" charset="0"/>
-              </a:rPr>
-              <a:t>Air</a:t>
-            </a:r>
-            <a:endParaRPr lang="en-GB" sz="2400" dirty="0">
-              <a:latin typeface="Arial" panose="020B0604020202020204" pitchFamily="34" charset="0"/>
-              <a:cs typeface="Arial" panose="020B0604020202020204" pitchFamily="34" charset="0"/>
-            </a:endParaRPr>
-          </a:p>
-        </p:txBody>
-      </p:sp>
-    </p:spTree>
-    <p:extLst>
-      <p:ext uri="{BB962C8B-B14F-4D97-AF65-F5344CB8AC3E}">
-        <p14:creationId xmlns:p14="http://schemas.microsoft.com/office/powerpoint/2010/main" val="3648933230"/>
-      </p:ext>
-    </p:extLst>
-  </p:cSld>
-  <p:clrMapOvr>
-    <a:masterClrMapping/>
-  </p:clrMapOvr>
-</p:sld>
-</file>
-
 <file path=ppt/slides/slide3.xml><?xml version="1.0" encoding="utf-8"?>
 <p:sld xmlns:a="http://schemas.openxmlformats.org/drawingml/2006/main" xmlns:r="http://schemas.openxmlformats.org/officeDocument/2006/relationships" xmlns:p="http://schemas.openxmlformats.org/presentationml/2006/main">
   <p:cSld>
@@ -8260,14 +9653,12 @@
               </a:ext>
             </a:extLst>
           </a:blip>
-          <a:srcRect t="6666" b="2222"/>
-          <a:stretch>
-            <a:fillRect/>
-          </a:stretch>
+          <a:srcRect t="4444" b="4444"/>
+          <a:stretch/>
         </p:blipFill>
         <p:spPr>
           <a:xfrm>
-            <a:off x="533400" y="-272"/>
+            <a:off x="498553" y="-272"/>
             <a:ext cx="5857875" cy="6862082"/>
           </a:xfrm>
           <a:prstGeom prst="rect">
@@ -8297,14 +9688,12 @@
               </a:ext>
             </a:extLst>
           </a:blip>
-          <a:srcRect t="6666" b="2222"/>
-          <a:stretch>
-            <a:fillRect/>
-          </a:stretch>
+          <a:srcRect t="4444" b="4444"/>
+          <a:stretch/>
         </p:blipFill>
         <p:spPr>
           <a:xfrm>
-            <a:off x="5838825" y="-272"/>
+            <a:off x="5803978" y="-272"/>
             <a:ext cx="5854622" cy="6858272"/>
           </a:xfrm>
           <a:prstGeom prst="rect">
@@ -8328,8 +9717,8 @@
         </p:nvSpPr>
         <p:spPr bwMode="auto">
           <a:xfrm>
-            <a:off x="1265437" y="47625"/>
-            <a:ext cx="542519" cy="338554"/>
+            <a:off x="1230590" y="230021"/>
+            <a:ext cx="3237552" cy="338554"/>
           </a:xfrm>
           <a:prstGeom prst="rect">
             <a:avLst/>
@@ -8356,7 +9745,7 @@
                 <a:ea typeface="TH Sarabun PSK"/>
                 <a:cs typeface="TH Sarabun PSK"/>
               </a:rPr>
-              <a:t>(a)</a:t>
+              <a:t>(a) Amorphous phase (ON mode)</a:t>
             </a:r>
           </a:p>
         </p:txBody>
@@ -8377,8 +9766,8 @@
         </p:nvSpPr>
         <p:spPr bwMode="auto">
           <a:xfrm>
-            <a:off x="6580387" y="47625"/>
-            <a:ext cx="542519" cy="338554"/>
+            <a:off x="6545540" y="230021"/>
+            <a:ext cx="3270979" cy="338554"/>
           </a:xfrm>
           <a:prstGeom prst="rect">
             <a:avLst/>
@@ -8405,99 +9794,11 @@
                 <a:ea typeface="Tahoma" panose="020B0604030504040204" pitchFamily="34" charset="0"/>
                 <a:cs typeface="Arial" panose="020B0604020202020204" pitchFamily="34" charset="0"/>
               </a:rPr>
-              <a:t>(b)</a:t>
-            </a:r>
-          </a:p>
-        </p:txBody>
-      </p:sp>
-      <p:cxnSp>
-        <p:nvCxnSpPr>
-          <p:cNvPr id="15" name="Straight Arrow Connector 14">
-            <a:extLst>
-              <a:ext uri="{FF2B5EF4-FFF2-40B4-BE49-F238E27FC236}">
-                <a16:creationId xmlns:a16="http://schemas.microsoft.com/office/drawing/2014/main" id="{055C38ED-B050-03BC-C2EB-BB271C079317}"/>
-              </a:ext>
-            </a:extLst>
-          </p:cNvPr>
-          <p:cNvCxnSpPr>
-            <a:cxnSpLocks/>
-          </p:cNvCxnSpPr>
-          <p:nvPr/>
-        </p:nvCxnSpPr>
-        <p:spPr>
-          <a:xfrm flipH="1" flipV="1">
-            <a:off x="7829549" y="742950"/>
-            <a:ext cx="936587" cy="695325"/>
-          </a:xfrm>
-          <a:prstGeom prst="straightConnector1">
-            <a:avLst/>
-          </a:prstGeom>
-          <a:ln>
-            <a:solidFill>
-              <a:srgbClr val="FFAF24"/>
-            </a:solidFill>
-            <a:tailEnd type="triangle"/>
-          </a:ln>
-        </p:spPr>
-        <p:style>
-          <a:lnRef idx="3">
-            <a:schemeClr val="accent1"/>
-          </a:lnRef>
-          <a:fillRef idx="0">
-            <a:schemeClr val="accent1"/>
-          </a:fillRef>
-          <a:effectRef idx="2">
-            <a:schemeClr val="accent1"/>
-          </a:effectRef>
-          <a:fontRef idx="minor">
-            <a:schemeClr val="tx1"/>
-          </a:fontRef>
-        </p:style>
-      </p:cxnSp>
-      <p:cxnSp>
-        <p:nvCxnSpPr>
-          <p:cNvPr id="19" name="Straight Arrow Connector 18">
-            <a:extLst>
-              <a:ext uri="{FF2B5EF4-FFF2-40B4-BE49-F238E27FC236}">
-                <a16:creationId xmlns:a16="http://schemas.microsoft.com/office/drawing/2014/main" id="{99DF0AE7-A4B1-DEC2-B62D-5C658CD8D8D0}"/>
-              </a:ext>
-            </a:extLst>
-          </p:cNvPr>
-          <p:cNvCxnSpPr>
-            <a:cxnSpLocks/>
-          </p:cNvCxnSpPr>
-          <p:nvPr/>
-        </p:nvCxnSpPr>
-        <p:spPr>
-          <a:xfrm flipH="1">
-            <a:off x="7829549" y="5067300"/>
-            <a:ext cx="936587" cy="695325"/>
-          </a:xfrm>
-          <a:prstGeom prst="straightConnector1">
-            <a:avLst/>
-          </a:prstGeom>
-          <a:ln>
-            <a:solidFill>
-              <a:srgbClr val="1212FF"/>
-            </a:solidFill>
-            <a:tailEnd type="triangle"/>
-          </a:ln>
-        </p:spPr>
-        <p:style>
-          <a:lnRef idx="3">
-            <a:schemeClr val="accent1"/>
-          </a:lnRef>
-          <a:fillRef idx="0">
-            <a:schemeClr val="accent1"/>
-          </a:fillRef>
-          <a:effectRef idx="2">
-            <a:schemeClr val="accent1"/>
-          </a:effectRef>
-          <a:fontRef idx="minor">
-            <a:schemeClr val="tx1"/>
-          </a:fontRef>
-        </p:style>
-      </p:cxnSp>
+              <a:t>(b) Crystalline phase (OFF mode)</a:t>
+            </a:r>
+          </a:p>
+        </p:txBody>
+      </p:sp>
       <p:sp>
         <p:nvSpPr>
           <p:cNvPr id="21" name="Text Box 2">
@@ -8514,8 +9815,8 @@
         </p:nvSpPr>
         <p:spPr bwMode="auto">
           <a:xfrm>
-            <a:off x="8697666" y="1354723"/>
-            <a:ext cx="2046534" cy="338554"/>
+            <a:off x="6473056" y="5827507"/>
+            <a:ext cx="1937356" cy="307777"/>
           </a:xfrm>
           <a:prstGeom prst="rect">
             <a:avLst/>
@@ -8534,43 +9835,73 @@
           </a:bodyPr>
           <a:lstStyle/>
           <a:p>
-            <a:pPr algn="just"/>
-            <a:r>
-              <a:rPr lang="en-GB" sz="1600" dirty="0">
+            <a:pPr algn="ctr"/>
+            <a:r>
+              <a:rPr lang="en-GB" sz="1400" dirty="0">
+                <a:latin typeface="Arial" panose="020B0604020202020204" pitchFamily="34" charset="0"/>
+                <a:ea typeface="TH Sarabun PSK"/>
+                <a:cs typeface="TH Sarabun PSK"/>
+              </a:rPr>
+              <a:t>h</a:t>
+            </a:r>
+            <a:r>
+              <a:rPr lang="en-GB" sz="1400" dirty="0">
                 <a:effectLst/>
                 <a:latin typeface="Arial" panose="020B0604020202020204" pitchFamily="34" charset="0"/>
                 <a:ea typeface="TH Sarabun PSK"/>
                 <a:cs typeface="TH Sarabun PSK"/>
               </a:rPr>
-              <a:t>R</a:t>
-            </a:r>
-            <a:r>
-              <a:rPr lang="en-GB" sz="1600" baseline="-25000" dirty="0">
-                <a:effectLst/>
-                <a:latin typeface="Arial" panose="020B0604020202020204" pitchFamily="34" charset="0"/>
-                <a:ea typeface="TH Sarabun PSK"/>
-                <a:cs typeface="TH Sarabun PSK"/>
-              </a:rPr>
-              <a:t>crystalline</a:t>
-            </a:r>
-            <a:r>
-              <a:rPr lang="en-GB" sz="1600" dirty="0">
-                <a:effectLst/>
-                <a:latin typeface="Arial" panose="020B0604020202020204" pitchFamily="34" charset="0"/>
-                <a:ea typeface="TH Sarabun PSK"/>
-                <a:cs typeface="TH Sarabun PSK"/>
-              </a:rPr>
-              <a:t> = 94.1%</a:t>
-            </a:r>
-          </a:p>
-        </p:txBody>
-      </p:sp>
-      <p:sp>
-        <p:nvSpPr>
-          <p:cNvPr id="22" name="Text Box 2">
-            <a:extLst>
-              <a:ext uri="{FF2B5EF4-FFF2-40B4-BE49-F238E27FC236}">
-                <a16:creationId xmlns:a16="http://schemas.microsoft.com/office/drawing/2014/main" id="{6684020B-AC0F-791C-0F34-24D7A8D527C7}"/>
+              <a:t>igh-reflection region</a:t>
+            </a:r>
+          </a:p>
+        </p:txBody>
+      </p:sp>
+      <p:cxnSp>
+        <p:nvCxnSpPr>
+          <p:cNvPr id="3" name="Straight Arrow Connector 2">
+            <a:extLst>
+              <a:ext uri="{FF2B5EF4-FFF2-40B4-BE49-F238E27FC236}">
+                <a16:creationId xmlns:a16="http://schemas.microsoft.com/office/drawing/2014/main" id="{A2E3A126-38BB-9AB9-AAE3-F359F19B8D79}"/>
+              </a:ext>
+            </a:extLst>
+          </p:cNvPr>
+          <p:cNvCxnSpPr/>
+          <p:nvPr/>
+        </p:nvCxnSpPr>
+        <p:spPr>
+          <a:xfrm>
+            <a:off x="6545540" y="6133377"/>
+            <a:ext cx="1717455" cy="0"/>
+          </a:xfrm>
+          <a:prstGeom prst="straightConnector1">
+            <a:avLst/>
+          </a:prstGeom>
+          <a:ln>
+            <a:headEnd type="triangle"/>
+            <a:tailEnd type="triangle"/>
+          </a:ln>
+        </p:spPr>
+        <p:style>
+          <a:lnRef idx="2">
+            <a:schemeClr val="dk1"/>
+          </a:lnRef>
+          <a:fillRef idx="0">
+            <a:schemeClr val="dk1"/>
+          </a:fillRef>
+          <a:effectRef idx="1">
+            <a:schemeClr val="dk1"/>
+          </a:effectRef>
+          <a:fontRef idx="minor">
+            <a:schemeClr val="tx1"/>
+          </a:fontRef>
+        </p:style>
+      </p:cxnSp>
+      <p:sp>
+        <p:nvSpPr>
+          <p:cNvPr id="4" name="Text Box 2">
+            <a:extLst>
+              <a:ext uri="{FF2B5EF4-FFF2-40B4-BE49-F238E27FC236}">
+                <a16:creationId xmlns:a16="http://schemas.microsoft.com/office/drawing/2014/main" id="{75FFEA3B-EA8D-2D2D-2206-2AA88F8D6963}"/>
               </a:ext>
             </a:extLst>
           </p:cNvPr>
@@ -8581,8 +9912,8 @@
         </p:nvSpPr>
         <p:spPr bwMode="auto">
           <a:xfrm>
-            <a:off x="8716715" y="4829711"/>
-            <a:ext cx="2179885" cy="338554"/>
+            <a:off x="1192293" y="6085484"/>
+            <a:ext cx="1708829" cy="307777"/>
           </a:xfrm>
           <a:prstGeom prst="rect">
             <a:avLst/>
@@ -8603,31 +9934,261 @@
           <a:p>
             <a:pPr algn="just"/>
             <a:r>
-              <a:rPr lang="en-GB" sz="1600" dirty="0">
+              <a:rPr lang="en-GB" sz="1400" dirty="0">
+                <a:latin typeface="Arial" panose="020B0604020202020204" pitchFamily="34" charset="0"/>
+                <a:ea typeface="TH Sarabun PSK"/>
+                <a:cs typeface="TH Sarabun PSK"/>
+              </a:rPr>
+              <a:t>h</a:t>
+            </a:r>
+            <a:r>
+              <a:rPr lang="en-GB" sz="1400" dirty="0">
                 <a:effectLst/>
                 <a:latin typeface="Arial" panose="020B0604020202020204" pitchFamily="34" charset="0"/>
                 <a:ea typeface="TH Sarabun PSK"/>
                 <a:cs typeface="TH Sarabun PSK"/>
               </a:rPr>
-              <a:t>R</a:t>
-            </a:r>
-            <a:r>
-              <a:rPr lang="en-GB" sz="1600" baseline="-25000" dirty="0">
+              <a:t>igh-reflection</a:t>
+            </a:r>
+          </a:p>
+        </p:txBody>
+      </p:sp>
+      <p:cxnSp>
+        <p:nvCxnSpPr>
+          <p:cNvPr id="6" name="Straight Arrow Connector 5">
+            <a:extLst>
+              <a:ext uri="{FF2B5EF4-FFF2-40B4-BE49-F238E27FC236}">
+                <a16:creationId xmlns:a16="http://schemas.microsoft.com/office/drawing/2014/main" id="{A3CC17FB-9533-68FE-38EB-BA2D224C0A70}"/>
+              </a:ext>
+            </a:extLst>
+          </p:cNvPr>
+          <p:cNvCxnSpPr>
+            <a:cxnSpLocks/>
+          </p:cNvCxnSpPr>
+          <p:nvPr/>
+        </p:nvCxnSpPr>
+        <p:spPr>
+          <a:xfrm>
+            <a:off x="1233731" y="6133377"/>
+            <a:ext cx="741377" cy="0"/>
+          </a:xfrm>
+          <a:prstGeom prst="straightConnector1">
+            <a:avLst/>
+          </a:prstGeom>
+          <a:ln>
+            <a:headEnd type="triangle"/>
+            <a:tailEnd type="triangle"/>
+          </a:ln>
+        </p:spPr>
+        <p:style>
+          <a:lnRef idx="2">
+            <a:schemeClr val="dk1"/>
+          </a:lnRef>
+          <a:fillRef idx="0">
+            <a:schemeClr val="dk1"/>
+          </a:fillRef>
+          <a:effectRef idx="1">
+            <a:schemeClr val="dk1"/>
+          </a:effectRef>
+          <a:fontRef idx="minor">
+            <a:schemeClr val="tx1"/>
+          </a:fontRef>
+        </p:style>
+      </p:cxnSp>
+      <p:sp>
+        <p:nvSpPr>
+          <p:cNvPr id="11" name="Text Box 2">
+            <a:extLst>
+              <a:ext uri="{FF2B5EF4-FFF2-40B4-BE49-F238E27FC236}">
+                <a16:creationId xmlns:a16="http://schemas.microsoft.com/office/drawing/2014/main" id="{3227A217-ECEE-4FD5-D325-E7116B3796D5}"/>
+              </a:ext>
+            </a:extLst>
+          </p:cNvPr>
+          <p:cNvSpPr txBox="1">
+            <a:spLocks noChangeArrowheads="1"/>
+          </p:cNvSpPr>
+          <p:nvPr/>
+        </p:nvSpPr>
+        <p:spPr bwMode="auto">
+          <a:xfrm>
+            <a:off x="8784162" y="6089294"/>
+            <a:ext cx="1736142" cy="307777"/>
+          </a:xfrm>
+          <a:prstGeom prst="rect">
+            <a:avLst/>
+          </a:prstGeom>
+          <a:noFill/>
+          <a:ln w="9525">
+            <a:noFill/>
+            <a:miter lim="800000"/>
+            <a:headEnd/>
+            <a:tailEnd/>
+          </a:ln>
+        </p:spPr>
+        <p:txBody>
+          <a:bodyPr rot="0" vert="horz" wrap="square" lIns="91440" tIns="45720" rIns="91440" bIns="45720" anchor="t" anchorCtr="0">
+            <a:spAutoFit/>
+          </a:bodyPr>
+          <a:lstStyle/>
+          <a:p>
+            <a:pPr algn="just"/>
+            <a:r>
+              <a:rPr lang="en-GB" sz="1400" dirty="0">
+                <a:latin typeface="Arial" panose="020B0604020202020204" pitchFamily="34" charset="0"/>
+                <a:ea typeface="TH Sarabun PSK"/>
+                <a:cs typeface="TH Sarabun PSK"/>
+              </a:rPr>
+              <a:t>anti</a:t>
+            </a:r>
+            <a:r>
+              <a:rPr lang="en-GB" sz="1400" dirty="0">
                 <a:effectLst/>
                 <a:latin typeface="Arial" panose="020B0604020202020204" pitchFamily="34" charset="0"/>
                 <a:ea typeface="TH Sarabun PSK"/>
                 <a:cs typeface="TH Sarabun PSK"/>
               </a:rPr>
-              <a:t>amorphous</a:t>
-            </a:r>
-            <a:r>
-              <a:rPr lang="en-GB" sz="1600" dirty="0">
+              <a:t>reflection region</a:t>
+            </a:r>
+          </a:p>
+        </p:txBody>
+      </p:sp>
+      <p:cxnSp>
+        <p:nvCxnSpPr>
+          <p:cNvPr id="12" name="Straight Arrow Connector 11">
+            <a:extLst>
+              <a:ext uri="{FF2B5EF4-FFF2-40B4-BE49-F238E27FC236}">
+                <a16:creationId xmlns:a16="http://schemas.microsoft.com/office/drawing/2014/main" id="{94FF6EB6-DF3F-F193-C2AA-E21A81C9D5C8}"/>
+              </a:ext>
+            </a:extLst>
+          </p:cNvPr>
+          <p:cNvCxnSpPr>
+            <a:cxnSpLocks/>
+          </p:cNvCxnSpPr>
+          <p:nvPr/>
+        </p:nvCxnSpPr>
+        <p:spPr>
+          <a:xfrm>
+            <a:off x="8297499" y="6133377"/>
+            <a:ext cx="2772000" cy="0"/>
+          </a:xfrm>
+          <a:prstGeom prst="straightConnector1">
+            <a:avLst/>
+          </a:prstGeom>
+          <a:ln>
+            <a:headEnd type="triangle"/>
+            <a:tailEnd type="triangle"/>
+          </a:ln>
+        </p:spPr>
+        <p:style>
+          <a:lnRef idx="2">
+            <a:schemeClr val="dk1"/>
+          </a:lnRef>
+          <a:fillRef idx="0">
+            <a:schemeClr val="dk1"/>
+          </a:fillRef>
+          <a:effectRef idx="1">
+            <a:schemeClr val="dk1"/>
+          </a:effectRef>
+          <a:fontRef idx="minor">
+            <a:schemeClr val="tx1"/>
+          </a:fontRef>
+        </p:style>
+      </p:cxnSp>
+      <p:cxnSp>
+        <p:nvCxnSpPr>
+          <p:cNvPr id="16" name="Straight Arrow Connector 15">
+            <a:extLst>
+              <a:ext uri="{FF2B5EF4-FFF2-40B4-BE49-F238E27FC236}">
+                <a16:creationId xmlns:a16="http://schemas.microsoft.com/office/drawing/2014/main" id="{89395275-0FC4-C799-D2EB-9274D6ADE9A2}"/>
+              </a:ext>
+            </a:extLst>
+          </p:cNvPr>
+          <p:cNvCxnSpPr>
+            <a:cxnSpLocks/>
+          </p:cNvCxnSpPr>
+          <p:nvPr/>
+        </p:nvCxnSpPr>
+        <p:spPr>
+          <a:xfrm>
+            <a:off x="1992361" y="6133377"/>
+            <a:ext cx="3785739" cy="0"/>
+          </a:xfrm>
+          <a:prstGeom prst="straightConnector1">
+            <a:avLst/>
+          </a:prstGeom>
+          <a:ln>
+            <a:headEnd type="triangle"/>
+            <a:tailEnd type="triangle"/>
+          </a:ln>
+        </p:spPr>
+        <p:style>
+          <a:lnRef idx="2">
+            <a:schemeClr val="dk1"/>
+          </a:lnRef>
+          <a:fillRef idx="0">
+            <a:schemeClr val="dk1"/>
+          </a:fillRef>
+          <a:effectRef idx="1">
+            <a:schemeClr val="dk1"/>
+          </a:effectRef>
+          <a:fontRef idx="minor">
+            <a:schemeClr val="tx1"/>
+          </a:fontRef>
+        </p:style>
+      </p:cxnSp>
+      <p:sp>
+        <p:nvSpPr>
+          <p:cNvPr id="18" name="Text Box 2">
+            <a:extLst>
+              <a:ext uri="{FF2B5EF4-FFF2-40B4-BE49-F238E27FC236}">
+                <a16:creationId xmlns:a16="http://schemas.microsoft.com/office/drawing/2014/main" id="{537086FB-D8A1-AAD6-7928-1D37D1B7FB4E}"/>
+              </a:ext>
+            </a:extLst>
+          </p:cNvPr>
+          <p:cNvSpPr txBox="1">
+            <a:spLocks noChangeArrowheads="1"/>
+          </p:cNvSpPr>
+          <p:nvPr/>
+        </p:nvSpPr>
+        <p:spPr bwMode="auto">
+          <a:xfrm>
+            <a:off x="3304420" y="6085484"/>
+            <a:ext cx="1910458" cy="307777"/>
+          </a:xfrm>
+          <a:prstGeom prst="rect">
+            <a:avLst/>
+          </a:prstGeom>
+          <a:noFill/>
+          <a:ln w="9525">
+            <a:noFill/>
+            <a:miter lim="800000"/>
+            <a:headEnd/>
+            <a:tailEnd/>
+          </a:ln>
+        </p:spPr>
+        <p:txBody>
+          <a:bodyPr rot="0" vert="horz" wrap="square" lIns="91440" tIns="45720" rIns="91440" bIns="45720" anchor="t" anchorCtr="0">
+            <a:spAutoFit/>
+          </a:bodyPr>
+          <a:lstStyle/>
+          <a:p>
+            <a:pPr algn="just"/>
+            <a:r>
+              <a:rPr lang="en-GB" sz="1400" dirty="0">
+                <a:latin typeface="Arial" panose="020B0604020202020204" pitchFamily="34" charset="0"/>
+                <a:ea typeface="TH Sarabun PSK"/>
+                <a:cs typeface="TH Sarabun PSK"/>
+              </a:rPr>
+              <a:t>anti</a:t>
+            </a:r>
+            <a:r>
+              <a:rPr lang="en-GB" sz="1400" dirty="0">
                 <a:effectLst/>
                 <a:latin typeface="Arial" panose="020B0604020202020204" pitchFamily="34" charset="0"/>
                 <a:ea typeface="TH Sarabun PSK"/>
                 <a:cs typeface="TH Sarabun PSK"/>
               </a:rPr>
-              <a:t> = 6.5%</a:t>
+              <a:t>reflection region</a:t>
             </a:r>
           </a:p>
         </p:txBody>
@@ -8664,10 +10225,10 @@
       </p:grpSpPr>
       <p:pic>
         <p:nvPicPr>
-          <p:cNvPr id="7" name="Picture 6">
-            <a:extLst>
-              <a:ext uri="{FF2B5EF4-FFF2-40B4-BE49-F238E27FC236}">
-                <a16:creationId xmlns:a16="http://schemas.microsoft.com/office/drawing/2014/main" id="{14543072-3757-233B-84BE-B32C2482FD2F}"/>
+          <p:cNvPr id="3" name="Picture 2">
+            <a:extLst>
+              <a:ext uri="{FF2B5EF4-FFF2-40B4-BE49-F238E27FC236}">
+                <a16:creationId xmlns:a16="http://schemas.microsoft.com/office/drawing/2014/main" id="{9709722C-E19A-A09B-6BF9-91D6A9A69573}"/>
               </a:ext>
             </a:extLst>
           </p:cNvPr>
@@ -8677,167 +10238,32 @@
           <p:nvPr/>
         </p:nvPicPr>
         <p:blipFill>
-          <a:blip r:embed="rId3">
+          <a:blip r:embed="rId2">
             <a:extLst>
               <a:ext uri="{28A0092B-C50C-407E-A947-70E740481C1C}">
                 <a14:useLocalDpi xmlns:a14="http://schemas.microsoft.com/office/drawing/2010/main" val="0"/>
               </a:ext>
             </a:extLst>
           </a:blip>
-          <a:srcRect l="1402" t="6666" b="2516"/>
+          <a:srcRect l="3785" t="2647" r="3785" b="2647"/>
           <a:stretch>
             <a:fillRect/>
           </a:stretch>
         </p:blipFill>
         <p:spPr>
           <a:xfrm>
-            <a:off x="492670" y="-2513"/>
-            <a:ext cx="5793111" cy="6860513"/>
+            <a:off x="911281" y="0"/>
+            <a:ext cx="10369966" cy="6857634"/>
           </a:xfrm>
           <a:prstGeom prst="rect">
             <a:avLst/>
           </a:prstGeom>
         </p:spPr>
       </p:pic>
-      <p:pic>
-        <p:nvPicPr>
-          <p:cNvPr id="9" name="Picture 8">
-            <a:extLst>
-              <a:ext uri="{FF2B5EF4-FFF2-40B4-BE49-F238E27FC236}">
-                <a16:creationId xmlns:a16="http://schemas.microsoft.com/office/drawing/2014/main" id="{3CEFE170-57FA-DADE-C41D-0522204CB9CB}"/>
-              </a:ext>
-            </a:extLst>
-          </p:cNvPr>
-          <p:cNvPicPr>
-            <a:picLocks noChangeAspect="1"/>
-          </p:cNvPicPr>
-          <p:nvPr/>
-        </p:nvPicPr>
-        <p:blipFill>
-          <a:blip r:embed="rId4">
-            <a:extLst>
-              <a:ext uri="{28A0092B-C50C-407E-A947-70E740481C1C}">
-                <a14:useLocalDpi xmlns:a14="http://schemas.microsoft.com/office/drawing/2010/main" val="0"/>
-              </a:ext>
-            </a:extLst>
-          </a:blip>
-          <a:srcRect t="6666" r="4529" b="2516"/>
-          <a:stretch>
-            <a:fillRect/>
-          </a:stretch>
-        </p:blipFill>
-        <p:spPr>
-          <a:xfrm>
-            <a:off x="5725067" y="3531"/>
-            <a:ext cx="5604461" cy="6854469"/>
-          </a:xfrm>
-          <a:prstGeom prst="rect">
-            <a:avLst/>
-          </a:prstGeom>
-        </p:spPr>
-      </p:pic>
-      <p:sp>
-        <p:nvSpPr>
-          <p:cNvPr id="13" name="Text Box 2">
-            <a:extLst>
-              <a:ext uri="{FF2B5EF4-FFF2-40B4-BE49-F238E27FC236}">
-                <a16:creationId xmlns:a16="http://schemas.microsoft.com/office/drawing/2014/main" id="{CB3E3DF2-12B4-3697-D3AC-8E30BBCCCFF3}"/>
-              </a:ext>
-            </a:extLst>
-          </p:cNvPr>
-          <p:cNvSpPr txBox="1">
-            <a:spLocks noChangeArrowheads="1"/>
-          </p:cNvSpPr>
-          <p:nvPr/>
-        </p:nvSpPr>
-        <p:spPr bwMode="auto">
-          <a:xfrm>
-            <a:off x="1161744" y="423234"/>
-            <a:ext cx="542519" cy="338554"/>
-          </a:xfrm>
-          <a:prstGeom prst="rect">
-            <a:avLst/>
-          </a:prstGeom>
-          <a:noFill/>
-          <a:ln w="9525">
-            <a:noFill/>
-            <a:miter lim="800000"/>
-            <a:headEnd/>
-            <a:tailEnd/>
-          </a:ln>
-        </p:spPr>
-        <p:txBody>
-          <a:bodyPr rot="0" vert="horz" wrap="square" lIns="91440" tIns="45720" rIns="91440" bIns="45720" anchor="t" anchorCtr="0">
-            <a:spAutoFit/>
-          </a:bodyPr>
-          <a:lstStyle/>
-          <a:p>
-            <a:pPr algn="just"/>
-            <a:r>
-              <a:rPr lang="en-GB" sz="1600" dirty="0">
-                <a:effectLst/>
-                <a:latin typeface="Arial" panose="020B0604020202020204" pitchFamily="34" charset="0"/>
-                <a:ea typeface="TH Sarabun PSK"/>
-                <a:cs typeface="TH Sarabun PSK"/>
-              </a:rPr>
-              <a:t>(a)</a:t>
-            </a:r>
-          </a:p>
-        </p:txBody>
-      </p:sp>
-      <p:sp>
-        <p:nvSpPr>
-          <p:cNvPr id="15" name="Text Box 2">
-            <a:extLst>
-              <a:ext uri="{FF2B5EF4-FFF2-40B4-BE49-F238E27FC236}">
-                <a16:creationId xmlns:a16="http://schemas.microsoft.com/office/drawing/2014/main" id="{CF2AFB40-0253-886C-03D1-C9E3B1D444E4}"/>
-              </a:ext>
-            </a:extLst>
-          </p:cNvPr>
-          <p:cNvSpPr txBox="1">
-            <a:spLocks noChangeArrowheads="1"/>
-          </p:cNvSpPr>
-          <p:nvPr/>
-        </p:nvSpPr>
-        <p:spPr bwMode="auto">
-          <a:xfrm>
-            <a:off x="6466039" y="423234"/>
-            <a:ext cx="542519" cy="338554"/>
-          </a:xfrm>
-          <a:prstGeom prst="rect">
-            <a:avLst/>
-          </a:prstGeom>
-          <a:noFill/>
-          <a:ln w="9525">
-            <a:noFill/>
-            <a:miter lim="800000"/>
-            <a:headEnd/>
-            <a:tailEnd/>
-          </a:ln>
-        </p:spPr>
-        <p:txBody>
-          <a:bodyPr rot="0" vert="horz" wrap="square" lIns="91440" tIns="45720" rIns="91440" bIns="45720" anchor="t" anchorCtr="0">
-            <a:spAutoFit/>
-          </a:bodyPr>
-          <a:lstStyle/>
-          <a:p>
-            <a:pPr algn="just"/>
-            <a:r>
-              <a:rPr lang="en-GB" sz="1600" dirty="0">
-                <a:effectLst/>
-                <a:latin typeface="Arial" panose="020B0604020202020204" pitchFamily="34" charset="0"/>
-                <a:ea typeface="Tahoma" panose="020B0604030504040204" pitchFamily="34" charset="0"/>
-                <a:cs typeface="Arial" panose="020B0604020202020204" pitchFamily="34" charset="0"/>
-              </a:rPr>
-              <a:t>(b)</a:t>
-            </a:r>
-          </a:p>
-        </p:txBody>
-      </p:sp>
     </p:spTree>
     <p:extLst>
       <p:ext uri="{BB962C8B-B14F-4D97-AF65-F5344CB8AC3E}">
-        <p14:creationId xmlns:p14="http://schemas.microsoft.com/office/powerpoint/2010/main" val="579365150"/>
+        <p14:creationId xmlns:p14="http://schemas.microsoft.com/office/powerpoint/2010/main" val="3768456690"/>
       </p:ext>
     </p:extLst>
   </p:cSld>
@@ -8866,10 +10292,10 @@
       </p:grpSpPr>
       <p:pic>
         <p:nvPicPr>
-          <p:cNvPr id="3" name="Picture 2">
-            <a:extLst>
-              <a:ext uri="{FF2B5EF4-FFF2-40B4-BE49-F238E27FC236}">
-                <a16:creationId xmlns:a16="http://schemas.microsoft.com/office/drawing/2014/main" id="{9709722C-E19A-A09B-6BF9-91D6A9A69573}"/>
+          <p:cNvPr id="37" name="Picture 36">
+            <a:extLst>
+              <a:ext uri="{FF2B5EF4-FFF2-40B4-BE49-F238E27FC236}">
+                <a16:creationId xmlns:a16="http://schemas.microsoft.com/office/drawing/2014/main" id="{9614A0A1-CA66-2C01-FFE1-CEE8EB4BC42C}"/>
               </a:ext>
             </a:extLst>
           </p:cNvPr>
@@ -8886,25 +10312,566 @@
               </a:ext>
             </a:extLst>
           </a:blip>
-          <a:srcRect l="6631" t="2893" r="6631" b="2893"/>
           <a:stretch>
             <a:fillRect/>
           </a:stretch>
         </p:blipFill>
         <p:spPr>
           <a:xfrm>
-            <a:off x="1185221" y="-368"/>
-            <a:ext cx="9822086" cy="6858367"/>
+            <a:off x="2803585" y="3191771"/>
+            <a:ext cx="2983490" cy="3835916"/>
           </a:xfrm>
           <a:prstGeom prst="rect">
             <a:avLst/>
           </a:prstGeom>
         </p:spPr>
       </p:pic>
+      <p:pic>
+        <p:nvPicPr>
+          <p:cNvPr id="33" name="Picture 32">
+            <a:extLst>
+              <a:ext uri="{FF2B5EF4-FFF2-40B4-BE49-F238E27FC236}">
+                <a16:creationId xmlns:a16="http://schemas.microsoft.com/office/drawing/2014/main" id="{0E966266-5458-95CE-5548-1BAE870540FB}"/>
+              </a:ext>
+            </a:extLst>
+          </p:cNvPr>
+          <p:cNvPicPr>
+            <a:picLocks noChangeAspect="1"/>
+          </p:cNvPicPr>
+          <p:nvPr/>
+        </p:nvPicPr>
+        <p:blipFill>
+          <a:blip r:embed="rId3">
+            <a:extLst>
+              <a:ext uri="{28A0092B-C50C-407E-A947-70E740481C1C}">
+                <a14:useLocalDpi xmlns:a14="http://schemas.microsoft.com/office/drawing/2010/main" val="0"/>
+              </a:ext>
+            </a:extLst>
+          </a:blip>
+          <a:srcRect b="3142"/>
+          <a:stretch>
+            <a:fillRect/>
+          </a:stretch>
+        </p:blipFill>
+        <p:spPr>
+          <a:xfrm>
+            <a:off x="2803585" y="-77634"/>
+            <a:ext cx="2983490" cy="3715391"/>
+          </a:xfrm>
+          <a:prstGeom prst="rect">
+            <a:avLst/>
+          </a:prstGeom>
+          <a:ln>
+            <a:noFill/>
+          </a:ln>
+        </p:spPr>
+      </p:pic>
+      <p:pic>
+        <p:nvPicPr>
+          <p:cNvPr id="35" name="Picture 34">
+            <a:extLst>
+              <a:ext uri="{FF2B5EF4-FFF2-40B4-BE49-F238E27FC236}">
+                <a16:creationId xmlns:a16="http://schemas.microsoft.com/office/drawing/2014/main" id="{EF79C04B-E8EF-49A3-2060-5154867773FE}"/>
+              </a:ext>
+            </a:extLst>
+          </p:cNvPr>
+          <p:cNvPicPr>
+            <a:picLocks noChangeAspect="1"/>
+          </p:cNvPicPr>
+          <p:nvPr/>
+        </p:nvPicPr>
+        <p:blipFill>
+          <a:blip r:embed="rId4">
+            <a:extLst>
+              <a:ext uri="{28A0092B-C50C-407E-A947-70E740481C1C}">
+                <a14:useLocalDpi xmlns:a14="http://schemas.microsoft.com/office/drawing/2010/main" val="0"/>
+              </a:ext>
+            </a:extLst>
+          </a:blip>
+          <a:stretch>
+            <a:fillRect/>
+          </a:stretch>
+        </p:blipFill>
+        <p:spPr>
+          <a:xfrm>
+            <a:off x="5135593" y="3191771"/>
+            <a:ext cx="2983490" cy="3835916"/>
+          </a:xfrm>
+          <a:prstGeom prst="rect">
+            <a:avLst/>
+          </a:prstGeom>
+        </p:spPr>
+      </p:pic>
+      <p:pic>
+        <p:nvPicPr>
+          <p:cNvPr id="31" name="Picture 30">
+            <a:extLst>
+              <a:ext uri="{FF2B5EF4-FFF2-40B4-BE49-F238E27FC236}">
+                <a16:creationId xmlns:a16="http://schemas.microsoft.com/office/drawing/2014/main" id="{53619BE8-09FF-7B43-8338-BC0B36E7D23E}"/>
+              </a:ext>
+            </a:extLst>
+          </p:cNvPr>
+          <p:cNvPicPr>
+            <a:picLocks noChangeAspect="1"/>
+          </p:cNvPicPr>
+          <p:nvPr/>
+        </p:nvPicPr>
+        <p:blipFill>
+          <a:blip r:embed="rId5">
+            <a:extLst>
+              <a:ext uri="{28A0092B-C50C-407E-A947-70E740481C1C}">
+                <a14:useLocalDpi xmlns:a14="http://schemas.microsoft.com/office/drawing/2010/main" val="0"/>
+              </a:ext>
+            </a:extLst>
+          </a:blip>
+          <a:srcRect b="3142"/>
+          <a:stretch>
+            <a:fillRect/>
+          </a:stretch>
+        </p:blipFill>
+        <p:spPr>
+          <a:xfrm>
+            <a:off x="5135593" y="-77634"/>
+            <a:ext cx="2983490" cy="3715391"/>
+          </a:xfrm>
+          <a:prstGeom prst="rect">
+            <a:avLst/>
+          </a:prstGeom>
+          <a:ln>
+            <a:noFill/>
+          </a:ln>
+        </p:spPr>
+      </p:pic>
+      <p:sp>
+        <p:nvSpPr>
+          <p:cNvPr id="38" name="Text Box 2">
+            <a:extLst>
+              <a:ext uri="{FF2B5EF4-FFF2-40B4-BE49-F238E27FC236}">
+                <a16:creationId xmlns:a16="http://schemas.microsoft.com/office/drawing/2014/main" id="{D15F8736-AA4F-97B1-C0F4-CE0BC4F44C27}"/>
+              </a:ext>
+            </a:extLst>
+          </p:cNvPr>
+          <p:cNvSpPr txBox="1">
+            <a:spLocks noChangeArrowheads="1"/>
+          </p:cNvSpPr>
+          <p:nvPr/>
+        </p:nvSpPr>
+        <p:spPr bwMode="auto">
+          <a:xfrm>
+            <a:off x="3179280" y="384984"/>
+            <a:ext cx="494989" cy="276999"/>
+          </a:xfrm>
+          <a:prstGeom prst="rect">
+            <a:avLst/>
+          </a:prstGeom>
+          <a:noFill/>
+          <a:ln w="9525">
+            <a:noFill/>
+            <a:miter lim="800000"/>
+            <a:headEnd/>
+            <a:tailEnd/>
+          </a:ln>
+        </p:spPr>
+        <p:txBody>
+          <a:bodyPr rot="0" vert="horz" wrap="square" lIns="91440" tIns="45720" rIns="91440" bIns="45720" anchor="t" anchorCtr="0">
+            <a:spAutoFit/>
+          </a:bodyPr>
+          <a:lstStyle/>
+          <a:p>
+            <a:pPr algn="just"/>
+            <a:r>
+              <a:rPr lang="en-GB" sz="1200" dirty="0">
+                <a:solidFill>
+                  <a:schemeClr val="bg1"/>
+                </a:solidFill>
+                <a:effectLst/>
+                <a:latin typeface="Arial" panose="020B0604020202020204" pitchFamily="34" charset="0"/>
+                <a:ea typeface="TH Sarabun PSK"/>
+                <a:cs typeface="TH Sarabun PSK"/>
+              </a:rPr>
+              <a:t>(a)</a:t>
+            </a:r>
+          </a:p>
+        </p:txBody>
+      </p:sp>
+      <p:sp>
+        <p:nvSpPr>
+          <p:cNvPr id="39" name="Text Box 2">
+            <a:extLst>
+              <a:ext uri="{FF2B5EF4-FFF2-40B4-BE49-F238E27FC236}">
+                <a16:creationId xmlns:a16="http://schemas.microsoft.com/office/drawing/2014/main" id="{3BD119CD-5434-EAF2-8376-4C624588E246}"/>
+              </a:ext>
+            </a:extLst>
+          </p:cNvPr>
+          <p:cNvSpPr txBox="1">
+            <a:spLocks noChangeArrowheads="1"/>
+          </p:cNvSpPr>
+          <p:nvPr/>
+        </p:nvSpPr>
+        <p:spPr bwMode="auto">
+          <a:xfrm>
+            <a:off x="5515770" y="384983"/>
+            <a:ext cx="494989" cy="276999"/>
+          </a:xfrm>
+          <a:prstGeom prst="rect">
+            <a:avLst/>
+          </a:prstGeom>
+          <a:noFill/>
+          <a:ln w="9525">
+            <a:noFill/>
+            <a:miter lim="800000"/>
+            <a:headEnd/>
+            <a:tailEnd/>
+          </a:ln>
+        </p:spPr>
+        <p:txBody>
+          <a:bodyPr rot="0" vert="horz" wrap="square" lIns="91440" tIns="45720" rIns="91440" bIns="45720" anchor="t" anchorCtr="0">
+            <a:spAutoFit/>
+          </a:bodyPr>
+          <a:lstStyle/>
+          <a:p>
+            <a:pPr algn="just"/>
+            <a:r>
+              <a:rPr lang="en-GB" sz="1200" dirty="0">
+                <a:solidFill>
+                  <a:schemeClr val="bg1"/>
+                </a:solidFill>
+                <a:effectLst/>
+                <a:latin typeface="Arial" panose="020B0604020202020204" pitchFamily="34" charset="0"/>
+                <a:ea typeface="TH Sarabun PSK"/>
+                <a:cs typeface="TH Sarabun PSK"/>
+              </a:rPr>
+              <a:t>(b)</a:t>
+            </a:r>
+          </a:p>
+        </p:txBody>
+      </p:sp>
+      <p:sp>
+        <p:nvSpPr>
+          <p:cNvPr id="40" name="Text Box 2">
+            <a:extLst>
+              <a:ext uri="{FF2B5EF4-FFF2-40B4-BE49-F238E27FC236}">
+                <a16:creationId xmlns:a16="http://schemas.microsoft.com/office/drawing/2014/main" id="{13B330B2-991D-405D-66E3-DC06DE1DEFD7}"/>
+              </a:ext>
+            </a:extLst>
+          </p:cNvPr>
+          <p:cNvSpPr txBox="1">
+            <a:spLocks noChangeArrowheads="1"/>
+          </p:cNvSpPr>
+          <p:nvPr/>
+        </p:nvSpPr>
+        <p:spPr bwMode="auto">
+          <a:xfrm>
+            <a:off x="5515770" y="3637757"/>
+            <a:ext cx="494989" cy="276999"/>
+          </a:xfrm>
+          <a:prstGeom prst="rect">
+            <a:avLst/>
+          </a:prstGeom>
+          <a:noFill/>
+          <a:ln w="9525">
+            <a:noFill/>
+            <a:miter lim="800000"/>
+            <a:headEnd/>
+            <a:tailEnd/>
+          </a:ln>
+        </p:spPr>
+        <p:txBody>
+          <a:bodyPr rot="0" vert="horz" wrap="square" lIns="91440" tIns="45720" rIns="91440" bIns="45720" anchor="t" anchorCtr="0">
+            <a:spAutoFit/>
+          </a:bodyPr>
+          <a:lstStyle/>
+          <a:p>
+            <a:pPr algn="just"/>
+            <a:r>
+              <a:rPr lang="en-GB" sz="1200" dirty="0">
+                <a:solidFill>
+                  <a:schemeClr val="bg1"/>
+                </a:solidFill>
+                <a:effectLst/>
+                <a:latin typeface="Arial" panose="020B0604020202020204" pitchFamily="34" charset="0"/>
+                <a:ea typeface="TH Sarabun PSK"/>
+                <a:cs typeface="TH Sarabun PSK"/>
+              </a:rPr>
+              <a:t>(</a:t>
+            </a:r>
+            <a:r>
+              <a:rPr lang="en-GB" sz="1200" dirty="0">
+                <a:solidFill>
+                  <a:schemeClr val="bg1"/>
+                </a:solidFill>
+                <a:latin typeface="Arial" panose="020B0604020202020204" pitchFamily="34" charset="0"/>
+                <a:ea typeface="TH Sarabun PSK"/>
+                <a:cs typeface="TH Sarabun PSK"/>
+              </a:rPr>
+              <a:t>d</a:t>
+            </a:r>
+            <a:r>
+              <a:rPr lang="en-GB" sz="1200" dirty="0">
+                <a:solidFill>
+                  <a:schemeClr val="bg1"/>
+                </a:solidFill>
+                <a:effectLst/>
+                <a:latin typeface="Arial" panose="020B0604020202020204" pitchFamily="34" charset="0"/>
+                <a:ea typeface="TH Sarabun PSK"/>
+                <a:cs typeface="TH Sarabun PSK"/>
+              </a:rPr>
+              <a:t>)</a:t>
+            </a:r>
+          </a:p>
+        </p:txBody>
+      </p:sp>
+      <p:sp>
+        <p:nvSpPr>
+          <p:cNvPr id="41" name="Text Box 2">
+            <a:extLst>
+              <a:ext uri="{FF2B5EF4-FFF2-40B4-BE49-F238E27FC236}">
+                <a16:creationId xmlns:a16="http://schemas.microsoft.com/office/drawing/2014/main" id="{7C05AD5F-B900-E0A1-AC91-8542E05BE10D}"/>
+              </a:ext>
+            </a:extLst>
+          </p:cNvPr>
+          <p:cNvSpPr txBox="1">
+            <a:spLocks noChangeArrowheads="1"/>
+          </p:cNvSpPr>
+          <p:nvPr/>
+        </p:nvSpPr>
+        <p:spPr bwMode="auto">
+          <a:xfrm>
+            <a:off x="3179279" y="3637757"/>
+            <a:ext cx="494989" cy="276999"/>
+          </a:xfrm>
+          <a:prstGeom prst="rect">
+            <a:avLst/>
+          </a:prstGeom>
+          <a:noFill/>
+          <a:ln w="9525">
+            <a:noFill/>
+            <a:miter lim="800000"/>
+            <a:headEnd/>
+            <a:tailEnd/>
+          </a:ln>
+        </p:spPr>
+        <p:txBody>
+          <a:bodyPr rot="0" vert="horz" wrap="square" lIns="91440" tIns="45720" rIns="91440" bIns="45720" anchor="t" anchorCtr="0">
+            <a:spAutoFit/>
+          </a:bodyPr>
+          <a:lstStyle/>
+          <a:p>
+            <a:pPr algn="just"/>
+            <a:r>
+              <a:rPr lang="en-GB" sz="1200" dirty="0">
+                <a:solidFill>
+                  <a:schemeClr val="bg1"/>
+                </a:solidFill>
+                <a:effectLst/>
+                <a:latin typeface="Arial" panose="020B0604020202020204" pitchFamily="34" charset="0"/>
+                <a:ea typeface="TH Sarabun PSK"/>
+                <a:cs typeface="TH Sarabun PSK"/>
+              </a:rPr>
+              <a:t>(c)</a:t>
+            </a:r>
+          </a:p>
+        </p:txBody>
+      </p:sp>
+      <p:sp>
+        <p:nvSpPr>
+          <p:cNvPr id="42" name="Text Box 2">
+            <a:extLst>
+              <a:ext uri="{FF2B5EF4-FFF2-40B4-BE49-F238E27FC236}">
+                <a16:creationId xmlns:a16="http://schemas.microsoft.com/office/drawing/2014/main" id="{0BE1C4CC-5C77-06E3-24BD-7B2B22CBBF66}"/>
+              </a:ext>
+            </a:extLst>
+          </p:cNvPr>
+          <p:cNvSpPr txBox="1">
+            <a:spLocks noChangeArrowheads="1"/>
+          </p:cNvSpPr>
+          <p:nvPr/>
+        </p:nvSpPr>
+        <p:spPr bwMode="auto">
+          <a:xfrm>
+            <a:off x="3179279" y="46429"/>
+            <a:ext cx="1858547" cy="307777"/>
+          </a:xfrm>
+          <a:prstGeom prst="rect">
+            <a:avLst/>
+          </a:prstGeom>
+          <a:noFill/>
+          <a:ln w="9525">
+            <a:noFill/>
+            <a:miter lim="800000"/>
+            <a:headEnd/>
+            <a:tailEnd/>
+          </a:ln>
+        </p:spPr>
+        <p:txBody>
+          <a:bodyPr rot="0" vert="horz" wrap="square" lIns="91440" tIns="45720" rIns="91440" bIns="45720" anchor="t" anchorCtr="0">
+            <a:spAutoFit/>
+          </a:bodyPr>
+          <a:lstStyle/>
+          <a:p>
+            <a:pPr algn="ctr"/>
+            <a:r>
+              <a:rPr lang="en-GB" sz="1400" b="1" dirty="0">
+                <a:effectLst/>
+                <a:latin typeface="Arial" panose="020B0604020202020204" pitchFamily="34" charset="0"/>
+                <a:ea typeface="TH Sarabun PSK"/>
+                <a:cs typeface="TH Sarabun PSK"/>
+              </a:rPr>
+              <a:t>TE</a:t>
+            </a:r>
+          </a:p>
+        </p:txBody>
+      </p:sp>
+      <p:sp>
+        <p:nvSpPr>
+          <p:cNvPr id="43" name="Text Box 2">
+            <a:extLst>
+              <a:ext uri="{FF2B5EF4-FFF2-40B4-BE49-F238E27FC236}">
+                <a16:creationId xmlns:a16="http://schemas.microsoft.com/office/drawing/2014/main" id="{146D3C36-9575-442F-9B8C-59B8B061D83E}"/>
+              </a:ext>
+            </a:extLst>
+          </p:cNvPr>
+          <p:cNvSpPr txBox="1">
+            <a:spLocks noChangeArrowheads="1"/>
+          </p:cNvSpPr>
+          <p:nvPr/>
+        </p:nvSpPr>
+        <p:spPr bwMode="auto">
+          <a:xfrm>
+            <a:off x="5511287" y="46428"/>
+            <a:ext cx="1858547" cy="307777"/>
+          </a:xfrm>
+          <a:prstGeom prst="rect">
+            <a:avLst/>
+          </a:prstGeom>
+          <a:noFill/>
+          <a:ln w="9525">
+            <a:noFill/>
+            <a:miter lim="800000"/>
+            <a:headEnd/>
+            <a:tailEnd/>
+          </a:ln>
+        </p:spPr>
+        <p:txBody>
+          <a:bodyPr rot="0" vert="horz" wrap="square" lIns="91440" tIns="45720" rIns="91440" bIns="45720" anchor="t" anchorCtr="0">
+            <a:spAutoFit/>
+          </a:bodyPr>
+          <a:lstStyle/>
+          <a:p>
+            <a:pPr algn="ctr"/>
+            <a:r>
+              <a:rPr lang="en-GB" sz="1400" b="1" dirty="0">
+                <a:effectLst/>
+                <a:latin typeface="Arial" panose="020B0604020202020204" pitchFamily="34" charset="0"/>
+                <a:ea typeface="TH Sarabun PSK"/>
+                <a:cs typeface="TH Sarabun PSK"/>
+              </a:rPr>
+              <a:t>TM</a:t>
+            </a:r>
+          </a:p>
+        </p:txBody>
+      </p:sp>
+      <p:sp>
+        <p:nvSpPr>
+          <p:cNvPr id="44" name="Text Box 2">
+            <a:extLst>
+              <a:ext uri="{FF2B5EF4-FFF2-40B4-BE49-F238E27FC236}">
+                <a16:creationId xmlns:a16="http://schemas.microsoft.com/office/drawing/2014/main" id="{F5BFDB22-66FC-E811-C927-50E0C715FA98}"/>
+              </a:ext>
+            </a:extLst>
+          </p:cNvPr>
+          <p:cNvSpPr txBox="1">
+            <a:spLocks noChangeArrowheads="1"/>
+          </p:cNvSpPr>
+          <p:nvPr/>
+        </p:nvSpPr>
+        <p:spPr bwMode="auto">
+          <a:xfrm rot="16200000">
+            <a:off x="1166505" y="1714285"/>
+            <a:ext cx="2966383" cy="307777"/>
+          </a:xfrm>
+          <a:prstGeom prst="rect">
+            <a:avLst/>
+          </a:prstGeom>
+          <a:noFill/>
+          <a:ln w="9525">
+            <a:noFill/>
+            <a:miter lim="800000"/>
+            <a:headEnd/>
+            <a:tailEnd/>
+          </a:ln>
+        </p:spPr>
+        <p:txBody>
+          <a:bodyPr rot="0" vert="horz" wrap="square" lIns="91440" tIns="45720" rIns="91440" bIns="45720" anchor="t" anchorCtr="0">
+            <a:spAutoFit/>
+          </a:bodyPr>
+          <a:lstStyle/>
+          <a:p>
+            <a:pPr algn="ctr"/>
+            <a:r>
+              <a:rPr lang="en-GB" sz="1400" b="1" dirty="0">
+                <a:effectLst/>
+                <a:latin typeface="Arial" panose="020B0604020202020204" pitchFamily="34" charset="0"/>
+                <a:ea typeface="TH Sarabun PSK"/>
+                <a:cs typeface="TH Sarabun PSK"/>
+              </a:rPr>
+              <a:t>4-unit-cells edge-filter design</a:t>
+            </a:r>
+          </a:p>
+        </p:txBody>
+      </p:sp>
+      <p:sp>
+        <p:nvSpPr>
+          <p:cNvPr id="45" name="Text Box 2">
+            <a:extLst>
+              <a:ext uri="{FF2B5EF4-FFF2-40B4-BE49-F238E27FC236}">
+                <a16:creationId xmlns:a16="http://schemas.microsoft.com/office/drawing/2014/main" id="{D2850973-ADE9-27E7-FD3B-0F696C6E1639}"/>
+              </a:ext>
+            </a:extLst>
+          </p:cNvPr>
+          <p:cNvSpPr txBox="1">
+            <a:spLocks noChangeArrowheads="1"/>
+          </p:cNvSpPr>
+          <p:nvPr/>
+        </p:nvSpPr>
+        <p:spPr bwMode="auto">
+          <a:xfrm rot="16200000">
+            <a:off x="1309700" y="4823865"/>
+            <a:ext cx="2679994" cy="307777"/>
+          </a:xfrm>
+          <a:prstGeom prst="rect">
+            <a:avLst/>
+          </a:prstGeom>
+          <a:noFill/>
+          <a:ln w="9525">
+            <a:noFill/>
+            <a:miter lim="800000"/>
+            <a:headEnd/>
+            <a:tailEnd/>
+          </a:ln>
+        </p:spPr>
+        <p:txBody>
+          <a:bodyPr rot="0" vert="horz" wrap="square" lIns="91440" tIns="45720" rIns="91440" bIns="45720" anchor="t" anchorCtr="0">
+            <a:spAutoFit/>
+          </a:bodyPr>
+          <a:lstStyle/>
+          <a:p>
+            <a:pPr algn="ctr"/>
+            <a:r>
+              <a:rPr lang="en-GB" sz="1400" b="1" dirty="0">
+                <a:latin typeface="Arial" panose="020B0604020202020204" pitchFamily="34" charset="0"/>
+                <a:ea typeface="TH Sarabun PSK"/>
+                <a:cs typeface="TH Sarabun PSK"/>
+              </a:rPr>
+              <a:t>5-unit-cells edge-filter design</a:t>
+            </a:r>
+          </a:p>
+        </p:txBody>
+      </p:sp>
     </p:spTree>
     <p:extLst>
       <p:ext uri="{BB962C8B-B14F-4D97-AF65-F5344CB8AC3E}">
-        <p14:creationId xmlns:p14="http://schemas.microsoft.com/office/powerpoint/2010/main" val="3768456690"/>
+        <p14:creationId xmlns:p14="http://schemas.microsoft.com/office/powerpoint/2010/main" val="2583949549"/>
       </p:ext>
     </p:extLst>
   </p:cSld>
@@ -8931,230 +10898,574 @@
           <a:chExt cx="0" cy="0"/>
         </a:xfrm>
       </p:grpSpPr>
-      <p:grpSp>
-        <p:nvGrpSpPr>
-          <p:cNvPr id="13" name="Group 12">
-            <a:extLst>
-              <a:ext uri="{FF2B5EF4-FFF2-40B4-BE49-F238E27FC236}">
-                <a16:creationId xmlns:a16="http://schemas.microsoft.com/office/drawing/2014/main" id="{ADE26A5F-5E3E-8604-7225-5B652066903C}"/>
-              </a:ext>
-            </a:extLst>
-          </p:cNvPr>
-          <p:cNvGrpSpPr/>
+      <p:pic>
+        <p:nvPicPr>
+          <p:cNvPr id="2" name="Picture 1">
+            <a:extLst>
+              <a:ext uri="{FF2B5EF4-FFF2-40B4-BE49-F238E27FC236}">
+                <a16:creationId xmlns:a16="http://schemas.microsoft.com/office/drawing/2014/main" id="{EE040C26-0105-1F59-EEAB-03FB983CEACD}"/>
+              </a:ext>
+            </a:extLst>
+          </p:cNvPr>
+          <p:cNvPicPr>
+            <a:picLocks noChangeAspect="1"/>
+          </p:cNvPicPr>
           <p:nvPr/>
-        </p:nvGrpSpPr>
-        <p:grpSpPr>
+        </p:nvPicPr>
+        <p:blipFill>
+          <a:blip r:embed="rId2" cstate="print">
+            <a:extLst>
+              <a:ext uri="{28A0092B-C50C-407E-A947-70E740481C1C}">
+                <a14:useLocalDpi xmlns:a14="http://schemas.microsoft.com/office/drawing/2010/main" val="0"/>
+              </a:ext>
+            </a:extLst>
+          </a:blip>
+          <a:srcRect t="5518"/>
+          <a:stretch>
+            <a:fillRect/>
+          </a:stretch>
+        </p:blipFill>
+        <p:spPr>
           <a:xfrm>
-            <a:off x="762000" y="2696"/>
-            <a:ext cx="10309379" cy="6855304"/>
-            <a:chOff x="762000" y="2696"/>
-            <a:chExt cx="10309379" cy="6855304"/>
-          </a:xfrm>
-        </p:grpSpPr>
-        <p:grpSp>
-          <p:nvGrpSpPr>
-            <p:cNvPr id="10" name="Group 9">
-              <a:extLst>
-                <a:ext uri="{FF2B5EF4-FFF2-40B4-BE49-F238E27FC236}">
-                  <a16:creationId xmlns:a16="http://schemas.microsoft.com/office/drawing/2014/main" id="{6FC60193-82F5-FCC9-BF33-4AFB0B5FF3B8}"/>
-                </a:ext>
-              </a:extLst>
-            </p:cNvPr>
-            <p:cNvGrpSpPr/>
-            <p:nvPr/>
-          </p:nvGrpSpPr>
-          <p:grpSpPr>
-            <a:xfrm>
-              <a:off x="762000" y="2696"/>
-              <a:ext cx="10309379" cy="6855304"/>
-              <a:chOff x="762000" y="2696"/>
-              <a:chExt cx="10309379" cy="6855304"/>
-            </a:xfrm>
-          </p:grpSpPr>
-          <p:pic>
-            <p:nvPicPr>
-              <p:cNvPr id="7" name="Picture 6">
+            <a:off x="1" y="1987826"/>
+            <a:ext cx="4216735" cy="2988000"/>
+          </a:xfrm>
+          <a:prstGeom prst="rect">
+            <a:avLst/>
+          </a:prstGeom>
+        </p:spPr>
+      </p:pic>
+      <p:pic>
+        <p:nvPicPr>
+          <p:cNvPr id="3" name="Picture 2">
+            <a:extLst>
+              <a:ext uri="{FF2B5EF4-FFF2-40B4-BE49-F238E27FC236}">
+                <a16:creationId xmlns:a16="http://schemas.microsoft.com/office/drawing/2014/main" id="{E9F01624-A124-B643-3B03-F651A4EB0807}"/>
+              </a:ext>
+            </a:extLst>
+          </p:cNvPr>
+          <p:cNvPicPr>
+            <a:picLocks noChangeAspect="1"/>
+          </p:cNvPicPr>
+          <p:nvPr/>
+        </p:nvPicPr>
+        <p:blipFill>
+          <a:blip r:embed="rId3" cstate="print">
+            <a:extLst>
+              <a:ext uri="{28A0092B-C50C-407E-A947-70E740481C1C}">
+                <a14:useLocalDpi xmlns:a14="http://schemas.microsoft.com/office/drawing/2010/main" val="0"/>
+              </a:ext>
+            </a:extLst>
+          </a:blip>
+          <a:srcRect t="5520"/>
+          <a:stretch>
+            <a:fillRect/>
+          </a:stretch>
+        </p:blipFill>
+        <p:spPr>
+          <a:xfrm>
+            <a:off x="3987632" y="1987826"/>
+            <a:ext cx="4216735" cy="2988000"/>
+          </a:xfrm>
+          <a:prstGeom prst="rect">
+            <a:avLst/>
+          </a:prstGeom>
+        </p:spPr>
+      </p:pic>
+      <p:pic>
+        <p:nvPicPr>
+          <p:cNvPr id="4" name="Picture 3">
+            <a:extLst>
+              <a:ext uri="{FF2B5EF4-FFF2-40B4-BE49-F238E27FC236}">
+                <a16:creationId xmlns:a16="http://schemas.microsoft.com/office/drawing/2014/main" id="{E2EDB843-9DA9-1EB4-5F44-81B183FA0991}"/>
+              </a:ext>
+            </a:extLst>
+          </p:cNvPr>
+          <p:cNvPicPr>
+            <a:picLocks noChangeAspect="1"/>
+          </p:cNvPicPr>
+          <p:nvPr/>
+        </p:nvPicPr>
+        <p:blipFill>
+          <a:blip r:embed="rId4" cstate="print">
+            <a:extLst>
+              <a:ext uri="{28A0092B-C50C-407E-A947-70E740481C1C}">
+                <a14:useLocalDpi xmlns:a14="http://schemas.microsoft.com/office/drawing/2010/main" val="0"/>
+              </a:ext>
+            </a:extLst>
+          </a:blip>
+          <a:srcRect t="5520"/>
+          <a:stretch>
+            <a:fillRect/>
+          </a:stretch>
+        </p:blipFill>
+        <p:spPr>
+          <a:xfrm>
+            <a:off x="7975263" y="1987826"/>
+            <a:ext cx="4216735" cy="2988000"/>
+          </a:xfrm>
+          <a:prstGeom prst="rect">
+            <a:avLst/>
+          </a:prstGeom>
+        </p:spPr>
+      </p:pic>
+      <p:sp>
+        <p:nvSpPr>
+          <p:cNvPr id="5" name="Text Box 2">
+            <a:extLst>
+              <a:ext uri="{FF2B5EF4-FFF2-40B4-BE49-F238E27FC236}">
+                <a16:creationId xmlns:a16="http://schemas.microsoft.com/office/drawing/2014/main" id="{92241068-DABA-E9C3-A73B-E04AA20B0876}"/>
+              </a:ext>
+            </a:extLst>
+          </p:cNvPr>
+          <p:cNvSpPr txBox="1">
+            <a:spLocks noChangeArrowheads="1"/>
+          </p:cNvSpPr>
+          <p:nvPr/>
+        </p:nvSpPr>
+        <p:spPr bwMode="auto">
+          <a:xfrm>
+            <a:off x="546652" y="1711048"/>
+            <a:ext cx="3269974" cy="307777"/>
+          </a:xfrm>
+          <a:prstGeom prst="rect">
+            <a:avLst/>
+          </a:prstGeom>
+          <a:noFill/>
+          <a:ln w="9525">
+            <a:noFill/>
+            <a:miter lim="800000"/>
+            <a:headEnd/>
+            <a:tailEnd/>
+          </a:ln>
+        </p:spPr>
+        <p:txBody>
+          <a:bodyPr rot="0" vert="horz" wrap="square" lIns="91440" tIns="45720" rIns="91440" bIns="45720" anchor="t" anchorCtr="0">
+            <a:spAutoFit/>
+          </a:bodyPr>
+          <a:lstStyle/>
+          <a:p>
+            <a:pPr algn="just"/>
+            <a:r>
+              <a:rPr lang="en-GB" sz="1400" b="1" dirty="0">
+                <a:effectLst/>
+                <a:latin typeface="Arial" panose="020B0604020202020204" pitchFamily="34" charset="0"/>
+                <a:ea typeface="TH Sarabun PSK"/>
+                <a:cs typeface="TH Sarabun PSK"/>
+              </a:rPr>
+              <a:t>(a) Single-layer design (Sb</a:t>
+            </a:r>
+            <a:r>
+              <a:rPr lang="en-GB" sz="1400" b="1" baseline="-25000" dirty="0">
+                <a:effectLst/>
+                <a:latin typeface="Arial" panose="020B0604020202020204" pitchFamily="34" charset="0"/>
+                <a:ea typeface="TH Sarabun PSK"/>
+                <a:cs typeface="TH Sarabun PSK"/>
+              </a:rPr>
+              <a:t>2</a:t>
+            </a:r>
+            <a:r>
+              <a:rPr lang="en-GB" sz="1400" b="1" dirty="0">
+                <a:effectLst/>
+                <a:latin typeface="Arial" panose="020B0604020202020204" pitchFamily="34" charset="0"/>
+                <a:ea typeface="TH Sarabun PSK"/>
+                <a:cs typeface="TH Sarabun PSK"/>
+              </a:rPr>
+              <a:t>Se</a:t>
+            </a:r>
+            <a:r>
+              <a:rPr lang="en-GB" sz="1400" b="1" baseline="-25000" dirty="0">
+                <a:effectLst/>
+                <a:latin typeface="Arial" panose="020B0604020202020204" pitchFamily="34" charset="0"/>
+                <a:ea typeface="TH Sarabun PSK"/>
+                <a:cs typeface="TH Sarabun PSK"/>
+              </a:rPr>
+              <a:t>3</a:t>
+            </a:r>
+            <a:r>
+              <a:rPr lang="en-GB" sz="1400" b="1" dirty="0">
+                <a:effectLst/>
+                <a:latin typeface="Arial" panose="020B0604020202020204" pitchFamily="34" charset="0"/>
+                <a:ea typeface="TH Sarabun PSK"/>
+                <a:cs typeface="TH Sarabun PSK"/>
+              </a:rPr>
+              <a:t>)</a:t>
+            </a:r>
+          </a:p>
+        </p:txBody>
+      </p:sp>
+      <p:sp>
+        <p:nvSpPr>
+          <p:cNvPr id="6" name="Text Box 2">
+            <a:extLst>
+              <a:ext uri="{FF2B5EF4-FFF2-40B4-BE49-F238E27FC236}">
+                <a16:creationId xmlns:a16="http://schemas.microsoft.com/office/drawing/2014/main" id="{99A1AE28-3884-7973-041D-319FBD78F4C7}"/>
+              </a:ext>
+            </a:extLst>
+          </p:cNvPr>
+          <p:cNvSpPr txBox="1">
+            <a:spLocks noChangeArrowheads="1"/>
+          </p:cNvSpPr>
+          <p:nvPr/>
+        </p:nvSpPr>
+        <p:spPr bwMode="auto">
+          <a:xfrm>
+            <a:off x="4534283" y="1705439"/>
+            <a:ext cx="3269974" cy="307777"/>
+          </a:xfrm>
+          <a:prstGeom prst="rect">
+            <a:avLst/>
+          </a:prstGeom>
+          <a:noFill/>
+          <a:ln w="9525">
+            <a:noFill/>
+            <a:miter lim="800000"/>
+            <a:headEnd/>
+            <a:tailEnd/>
+          </a:ln>
+        </p:spPr>
+        <p:txBody>
+          <a:bodyPr rot="0" vert="horz" wrap="square" lIns="91440" tIns="45720" rIns="91440" bIns="45720" anchor="t" anchorCtr="0">
+            <a:spAutoFit/>
+          </a:bodyPr>
+          <a:lstStyle/>
+          <a:p>
+            <a:pPr algn="just"/>
+            <a:r>
+              <a:rPr lang="en-GB" sz="1400" b="1" dirty="0">
+                <a:effectLst/>
+                <a:latin typeface="Arial" panose="020B0604020202020204" pitchFamily="34" charset="0"/>
+                <a:ea typeface="TH Sarabun PSK"/>
+                <a:cs typeface="TH Sarabun PSK"/>
+              </a:rPr>
+              <a:t>(b) Two-layers design (Sb</a:t>
+            </a:r>
+            <a:r>
+              <a:rPr lang="en-GB" sz="1400" b="1" baseline="-25000" dirty="0">
+                <a:effectLst/>
+                <a:latin typeface="Arial" panose="020B0604020202020204" pitchFamily="34" charset="0"/>
+                <a:ea typeface="TH Sarabun PSK"/>
+                <a:cs typeface="TH Sarabun PSK"/>
+              </a:rPr>
+              <a:t>2</a:t>
+            </a:r>
+            <a:r>
+              <a:rPr lang="en-GB" sz="1400" b="1" dirty="0">
+                <a:effectLst/>
+                <a:latin typeface="Arial" panose="020B0604020202020204" pitchFamily="34" charset="0"/>
+                <a:ea typeface="TH Sarabun PSK"/>
+                <a:cs typeface="TH Sarabun PSK"/>
+              </a:rPr>
+              <a:t>Se</a:t>
+            </a:r>
+            <a:r>
+              <a:rPr lang="en-GB" sz="1400" b="1" baseline="-25000" dirty="0">
+                <a:effectLst/>
+                <a:latin typeface="Arial" panose="020B0604020202020204" pitchFamily="34" charset="0"/>
+                <a:ea typeface="TH Sarabun PSK"/>
+                <a:cs typeface="TH Sarabun PSK"/>
+              </a:rPr>
+              <a:t>3</a:t>
+            </a:r>
+            <a:r>
+              <a:rPr lang="en-GB" sz="1400" b="1" dirty="0">
+                <a:effectLst/>
+                <a:latin typeface="Arial" panose="020B0604020202020204" pitchFamily="34" charset="0"/>
+                <a:ea typeface="TH Sarabun PSK"/>
+                <a:cs typeface="TH Sarabun PSK"/>
+              </a:rPr>
+              <a:t>/TiO</a:t>
+            </a:r>
+            <a:r>
+              <a:rPr lang="en-GB" sz="1400" b="1" baseline="-25000" dirty="0">
+                <a:effectLst/>
+                <a:latin typeface="Arial" panose="020B0604020202020204" pitchFamily="34" charset="0"/>
+                <a:ea typeface="TH Sarabun PSK"/>
+                <a:cs typeface="TH Sarabun PSK"/>
+              </a:rPr>
+              <a:t>2</a:t>
+            </a:r>
+            <a:r>
+              <a:rPr lang="en-GB" sz="1400" b="1" dirty="0">
+                <a:effectLst/>
+                <a:latin typeface="Arial" panose="020B0604020202020204" pitchFamily="34" charset="0"/>
+                <a:ea typeface="TH Sarabun PSK"/>
+                <a:cs typeface="TH Sarabun PSK"/>
+              </a:rPr>
+              <a:t>)</a:t>
+            </a:r>
+          </a:p>
+        </p:txBody>
+      </p:sp>
+      <mc:AlternateContent xmlns:mc="http://schemas.openxmlformats.org/markup-compatibility/2006">
+        <mc:Choice xmlns:a14="http://schemas.microsoft.com/office/drawing/2010/main" Requires="a14">
+          <p:sp>
+            <p:nvSpPr>
+              <p:cNvPr id="7" name="Text Box 2">
                 <a:extLst>
                   <a:ext uri="{FF2B5EF4-FFF2-40B4-BE49-F238E27FC236}">
-                    <a16:creationId xmlns:a16="http://schemas.microsoft.com/office/drawing/2014/main" id="{3B060087-7AC2-1476-01A9-750C240A2AC7}"/>
+                    <a16:creationId xmlns:a16="http://schemas.microsoft.com/office/drawing/2014/main" id="{DB388C99-BEAA-7F8E-F94E-5B16D89194D0}"/>
                   </a:ext>
                 </a:extLst>
               </p:cNvPr>
-              <p:cNvPicPr>
-                <a:picLocks noChangeAspect="1"/>
-              </p:cNvPicPr>
+              <p:cNvSpPr txBox="1">
+                <a:spLocks noChangeArrowheads="1"/>
+              </p:cNvSpPr>
               <p:nvPr/>
-            </p:nvPicPr>
-            <p:blipFill>
-              <a:blip r:embed="rId2">
-                <a:extLst>
-                  <a:ext uri="{28A0092B-C50C-407E-A947-70E740481C1C}">
-                    <a14:useLocalDpi xmlns:a14="http://schemas.microsoft.com/office/drawing/2010/main" val="0"/>
-                  </a:ext>
-                </a:extLst>
-              </a:blip>
-              <a:srcRect t="3522" r="21695" b="3522"/>
-              <a:stretch>
-                <a:fillRect/>
-              </a:stretch>
-            </p:blipFill>
-            <p:spPr>
+            </p:nvSpPr>
+            <p:spPr bwMode="auto">
               <a:xfrm>
-                <a:off x="762000" y="2696"/>
-                <a:ext cx="4491488" cy="6855304"/>
+                <a:off x="8521914" y="1661453"/>
+                <a:ext cx="3269974" cy="383375"/>
               </a:xfrm>
               <a:prstGeom prst="rect">
                 <a:avLst/>
               </a:prstGeom>
+              <a:noFill/>
+              <a:ln w="9525">
+                <a:noFill/>
+                <a:miter lim="800000"/>
+                <a:headEnd/>
+                <a:tailEnd/>
+              </a:ln>
             </p:spPr>
-          </p:pic>
-          <p:pic>
-            <p:nvPicPr>
-              <p:cNvPr id="9" name="Picture 8">
+            <p:txBody>
+              <a:bodyPr rot="0" vert="horz" wrap="square" lIns="91440" tIns="45720" rIns="91440" bIns="45720" anchor="t" anchorCtr="0">
+                <a:spAutoFit/>
+              </a:bodyPr>
+              <a:lstStyle/>
+              <a:p>
+                <a:pPr algn="just"/>
+                <a:r>
+                  <a:rPr lang="en-GB" sz="1300" b="1" dirty="0">
+                    <a:effectLst/>
+                    <a:latin typeface="Arial" panose="020B0604020202020204" pitchFamily="34" charset="0"/>
+                    <a:ea typeface="TH Sarabun PSK"/>
+                    <a:cs typeface="TH Sarabun PSK"/>
+                  </a:rPr>
+                  <a:t>(</a:t>
+                </a:r>
+                <a:r>
+                  <a:rPr lang="en-GB" sz="1300" b="1" dirty="0">
+                    <a:latin typeface="Arial" panose="020B0604020202020204" pitchFamily="34" charset="0"/>
+                    <a:ea typeface="TH Sarabun PSK"/>
+                    <a:cs typeface="TH Sarabun PSK"/>
+                  </a:rPr>
+                  <a:t>c</a:t>
+                </a:r>
+                <a:r>
+                  <a:rPr lang="en-GB" sz="1300" b="1" dirty="0">
+                    <a:effectLst/>
+                    <a:latin typeface="Arial" panose="020B0604020202020204" pitchFamily="34" charset="0"/>
+                    <a:ea typeface="TH Sarabun PSK"/>
+                    <a:cs typeface="TH Sarabun PSK"/>
+                  </a:rPr>
+                  <a:t>) Edge-filter design </a:t>
+                </a:r>
+                <a14:m>
+                  <m:oMath xmlns:m="http://schemas.openxmlformats.org/officeDocument/2006/math">
+                    <m:sSup>
+                      <m:sSupPr>
+                        <m:ctrlPr>
+                          <a:rPr lang="en-GB" sz="1300" b="1" i="1" smtClean="0">
+                            <a:effectLst/>
+                            <a:latin typeface="Cambria Math" panose="02040503050406030204" pitchFamily="18" charset="0"/>
+                            <a:cs typeface="Times New Roman" panose="02020603050405020304" pitchFamily="18" charset="0"/>
+                          </a:rPr>
+                        </m:ctrlPr>
+                      </m:sSupPr>
+                      <m:e>
+                        <m:r>
+                          <a:rPr lang="en-GB" sz="1300" b="1">
+                            <a:effectLst/>
+                            <a:latin typeface="Cambria Math" panose="02040503050406030204" pitchFamily="18" charset="0"/>
+                            <a:ea typeface="Yu Gothic" panose="020B0400000000000000" pitchFamily="34" charset="-128"/>
+                            <a:cs typeface="Times New Roman" panose="02020603050405020304" pitchFamily="18" charset="0"/>
+                          </a:rPr>
+                          <m:t>(</m:t>
+                        </m:r>
+                        <m:f>
+                          <m:fPr>
+                            <m:ctrlPr>
+                              <a:rPr lang="en-GB" sz="1300" b="1" i="1">
+                                <a:effectLst/>
+                                <a:latin typeface="Cambria Math" panose="02040503050406030204" pitchFamily="18" charset="0"/>
+                                <a:cs typeface="Times New Roman" panose="02020603050405020304" pitchFamily="18" charset="0"/>
+                              </a:rPr>
+                            </m:ctrlPr>
+                          </m:fPr>
+                          <m:num>
+                            <m:r>
+                              <a:rPr lang="en-GB" sz="1300" b="1" i="1">
+                                <a:effectLst/>
+                                <a:latin typeface="Cambria Math" panose="02040503050406030204" pitchFamily="18" charset="0"/>
+                                <a:ea typeface="Yu Gothic" panose="020B0400000000000000" pitchFamily="34" charset="-128"/>
+                                <a:cs typeface="Times New Roman" panose="02020603050405020304" pitchFamily="18" charset="0"/>
+                              </a:rPr>
+                              <m:t>𝑺𝒃𝑺𝒆</m:t>
+                            </m:r>
+                          </m:num>
+                          <m:den>
+                            <m:r>
+                              <a:rPr lang="en-GB" sz="1300" b="1" i="1">
+                                <a:effectLst/>
+                                <a:latin typeface="Cambria Math" panose="02040503050406030204" pitchFamily="18" charset="0"/>
+                                <a:ea typeface="Yu Gothic" panose="020B0400000000000000" pitchFamily="34" charset="-128"/>
+                                <a:cs typeface="Times New Roman" panose="02020603050405020304" pitchFamily="18" charset="0"/>
+                              </a:rPr>
+                              <m:t>𝟐</m:t>
+                            </m:r>
+                          </m:den>
+                        </m:f>
+                        <m:r>
+                          <a:rPr lang="en-GB" sz="1300" b="1">
+                            <a:effectLst/>
+                            <a:latin typeface="Cambria Math" panose="02040503050406030204" pitchFamily="18" charset="0"/>
+                            <a:ea typeface="Yu Gothic" panose="020B0400000000000000" pitchFamily="34" charset="-128"/>
+                            <a:cs typeface="Times New Roman" panose="02020603050405020304" pitchFamily="18" charset="0"/>
+                          </a:rPr>
+                          <m:t>/</m:t>
+                        </m:r>
+                        <m:r>
+                          <a:rPr lang="en-GB" sz="1300" b="1" i="1">
+                            <a:effectLst/>
+                            <a:latin typeface="Cambria Math" panose="02040503050406030204" pitchFamily="18" charset="0"/>
+                            <a:ea typeface="Yu Gothic" panose="020B0400000000000000" pitchFamily="34" charset="-128"/>
+                            <a:cs typeface="Times New Roman" panose="02020603050405020304" pitchFamily="18" charset="0"/>
+                          </a:rPr>
+                          <m:t>𝐌𝐠𝐅</m:t>
+                        </m:r>
+                        <m:r>
+                          <a:rPr lang="en-GB" sz="1300" b="1">
+                            <a:effectLst/>
+                            <a:latin typeface="Cambria Math" panose="02040503050406030204" pitchFamily="18" charset="0"/>
+                            <a:ea typeface="Yu Gothic" panose="020B0400000000000000" pitchFamily="34" charset="-128"/>
+                            <a:cs typeface="Times New Roman" panose="02020603050405020304" pitchFamily="18" charset="0"/>
+                          </a:rPr>
+                          <m:t>/</m:t>
+                        </m:r>
+                        <m:f>
+                          <m:fPr>
+                            <m:ctrlPr>
+                              <a:rPr lang="en-GB" sz="1300" b="1" i="1">
+                                <a:effectLst/>
+                                <a:latin typeface="Cambria Math" panose="02040503050406030204" pitchFamily="18" charset="0"/>
+                                <a:cs typeface="Times New Roman" panose="02020603050405020304" pitchFamily="18" charset="0"/>
+                              </a:rPr>
+                            </m:ctrlPr>
+                          </m:fPr>
+                          <m:num>
+                            <m:r>
+                              <a:rPr lang="en-GB" sz="1300" b="1" i="1">
+                                <a:effectLst/>
+                                <a:latin typeface="Cambria Math" panose="02040503050406030204" pitchFamily="18" charset="0"/>
+                                <a:ea typeface="Yu Gothic" panose="020B0400000000000000" pitchFamily="34" charset="-128"/>
+                                <a:cs typeface="Times New Roman" panose="02020603050405020304" pitchFamily="18" charset="0"/>
+                              </a:rPr>
+                              <m:t>𝑺𝒃𝑺𝒆</m:t>
+                            </m:r>
+                          </m:num>
+                          <m:den>
+                            <m:r>
+                              <a:rPr lang="en-GB" sz="1300" b="1" i="1">
+                                <a:effectLst/>
+                                <a:latin typeface="Cambria Math" panose="02040503050406030204" pitchFamily="18" charset="0"/>
+                                <a:ea typeface="Yu Gothic" panose="020B0400000000000000" pitchFamily="34" charset="-128"/>
+                                <a:cs typeface="Times New Roman" panose="02020603050405020304" pitchFamily="18" charset="0"/>
+                              </a:rPr>
+                              <m:t>𝟐</m:t>
+                            </m:r>
+                          </m:den>
+                        </m:f>
+                        <m:r>
+                          <a:rPr lang="en-GB" sz="1300" b="1">
+                            <a:effectLst/>
+                            <a:latin typeface="Cambria Math" panose="02040503050406030204" pitchFamily="18" charset="0"/>
+                            <a:ea typeface="Yu Gothic" panose="020B0400000000000000" pitchFamily="34" charset="-128"/>
+                            <a:cs typeface="Times New Roman" panose="02020603050405020304" pitchFamily="18" charset="0"/>
+                          </a:rPr>
+                          <m:t>)</m:t>
+                        </m:r>
+                      </m:e>
+                      <m:sup>
+                        <m:r>
+                          <a:rPr lang="en-GB" sz="1300" b="1" i="1">
+                            <a:effectLst/>
+                            <a:latin typeface="Cambria Math" panose="02040503050406030204" pitchFamily="18" charset="0"/>
+                            <a:ea typeface="Yu Gothic" panose="020B0400000000000000" pitchFamily="34" charset="-128"/>
+                            <a:cs typeface="Times New Roman" panose="02020603050405020304" pitchFamily="18" charset="0"/>
+                          </a:rPr>
+                          <m:t>𝟓</m:t>
+                        </m:r>
+                      </m:sup>
+                    </m:sSup>
+                  </m:oMath>
+                </a14:m>
+                <a:endParaRPr lang="en-GB" sz="1300" b="1" dirty="0">
+                  <a:effectLst/>
+                  <a:latin typeface="Arial" panose="020B0604020202020204" pitchFamily="34" charset="0"/>
+                  <a:ea typeface="TH Sarabun PSK"/>
+                  <a:cs typeface="TH Sarabun PSK"/>
+                </a:endParaRPr>
+              </a:p>
+            </p:txBody>
+          </p:sp>
+        </mc:Choice>
+        <mc:Fallback>
+          <p:sp>
+            <p:nvSpPr>
+              <p:cNvPr id="7" name="Text Box 2">
                 <a:extLst>
                   <a:ext uri="{FF2B5EF4-FFF2-40B4-BE49-F238E27FC236}">
-                    <a16:creationId xmlns:a16="http://schemas.microsoft.com/office/drawing/2014/main" id="{4C0CC04C-FE56-0C89-9BFB-FB71976BEC55}"/>
+                    <a16:creationId xmlns:a16="http://schemas.microsoft.com/office/drawing/2014/main" id="{DB388C99-BEAA-7F8E-F94E-5B16D89194D0}"/>
                   </a:ext>
                 </a:extLst>
               </p:cNvPr>
-              <p:cNvPicPr>
-                <a:picLocks noChangeAspect="1"/>
-              </p:cNvPicPr>
+              <p:cNvSpPr txBox="1">
+                <a:spLocks noRot="1" noChangeAspect="1" noMove="1" noResize="1" noEditPoints="1" noAdjustHandles="1" noChangeArrowheads="1" noChangeShapeType="1" noTextEdit="1"/>
+              </p:cNvSpPr>
               <p:nvPr/>
-            </p:nvPicPr>
-            <p:blipFill>
-              <a:blip r:embed="rId3">
-                <a:extLst>
-                  <a:ext uri="{28A0092B-C50C-407E-A947-70E740481C1C}">
-                    <a14:useLocalDpi xmlns:a14="http://schemas.microsoft.com/office/drawing/2010/main" val="0"/>
-                  </a:ext>
-                </a:extLst>
-              </a:blip>
-              <a:srcRect t="3522" b="3522"/>
-              <a:stretch>
-                <a:fillRect/>
-              </a:stretch>
-            </p:blipFill>
-            <p:spPr>
+            </p:nvSpPr>
+            <p:spPr bwMode="auto">
               <a:xfrm>
-                <a:off x="5335434" y="2696"/>
-                <a:ext cx="5735945" cy="6855304"/>
+                <a:off x="8521914" y="1661453"/>
+                <a:ext cx="3269974" cy="383375"/>
               </a:xfrm>
               <a:prstGeom prst="rect">
                 <a:avLst/>
               </a:prstGeom>
+              <a:blipFill>
+                <a:blip r:embed="rId5"/>
+                <a:stretch>
+                  <a:fillRect l="-373" b="-3226"/>
+                </a:stretch>
+              </a:blipFill>
+              <a:ln w="9525">
+                <a:noFill/>
+                <a:miter lim="800000"/>
+                <a:headEnd/>
+                <a:tailEnd/>
+              </a:ln>
             </p:spPr>
-          </p:pic>
-        </p:grpSp>
-        <p:sp>
-          <p:nvSpPr>
-            <p:cNvPr id="11" name="Text Box 2">
-              <a:extLst>
-                <a:ext uri="{FF2B5EF4-FFF2-40B4-BE49-F238E27FC236}">
-                  <a16:creationId xmlns:a16="http://schemas.microsoft.com/office/drawing/2014/main" id="{F6FAD176-E24B-16DF-0271-15328C30CB3E}"/>
-                </a:ext>
-              </a:extLst>
-            </p:cNvPr>
-            <p:cNvSpPr txBox="1">
-              <a:spLocks noChangeArrowheads="1"/>
-            </p:cNvSpPr>
-            <p:nvPr/>
-          </p:nvSpPr>
-          <p:spPr bwMode="auto">
-            <a:xfrm>
-              <a:off x="1488101" y="627555"/>
-              <a:ext cx="542519" cy="338554"/>
-            </a:xfrm>
-            <a:prstGeom prst="rect">
-              <a:avLst/>
-            </a:prstGeom>
-            <a:noFill/>
-            <a:ln w="9525">
-              <a:noFill/>
-              <a:miter lim="800000"/>
-              <a:headEnd/>
-              <a:tailEnd/>
-            </a:ln>
-          </p:spPr>
-          <p:txBody>
-            <a:bodyPr rot="0" vert="horz" wrap="square" lIns="91440" tIns="45720" rIns="91440" bIns="45720" anchor="t" anchorCtr="0">
-              <a:spAutoFit/>
-            </a:bodyPr>
-            <a:lstStyle/>
-            <a:p>
-              <a:pPr algn="just"/>
-              <a:r>
-                <a:rPr lang="en-GB" sz="1600" dirty="0">
-                  <a:solidFill>
-                    <a:schemeClr val="bg1"/>
-                  </a:solidFill>
-                  <a:effectLst/>
-                  <a:latin typeface="Arial" panose="020B0604020202020204" pitchFamily="34" charset="0"/>
-                  <a:ea typeface="TH Sarabun PSK"/>
-                  <a:cs typeface="TH Sarabun PSK"/>
-                </a:rPr>
-                <a:t>(a)</a:t>
-              </a:r>
-            </a:p>
-          </p:txBody>
-        </p:sp>
-        <p:sp>
-          <p:nvSpPr>
-            <p:cNvPr id="12" name="Text Box 2">
-              <a:extLst>
-                <a:ext uri="{FF2B5EF4-FFF2-40B4-BE49-F238E27FC236}">
-                  <a16:creationId xmlns:a16="http://schemas.microsoft.com/office/drawing/2014/main" id="{C3D11458-92C6-EFB0-D20E-9F6CFCE6F8D3}"/>
-                </a:ext>
-              </a:extLst>
-            </p:cNvPr>
-            <p:cNvSpPr txBox="1">
-              <a:spLocks noChangeArrowheads="1"/>
-            </p:cNvSpPr>
-            <p:nvPr/>
-          </p:nvSpPr>
-          <p:spPr bwMode="auto">
-            <a:xfrm>
-              <a:off x="6052868" y="627555"/>
-              <a:ext cx="542519" cy="338554"/>
-            </a:xfrm>
-            <a:prstGeom prst="rect">
-              <a:avLst/>
-            </a:prstGeom>
-            <a:noFill/>
-            <a:ln w="9525">
-              <a:noFill/>
-              <a:miter lim="800000"/>
-              <a:headEnd/>
-              <a:tailEnd/>
-            </a:ln>
-          </p:spPr>
-          <p:txBody>
-            <a:bodyPr rot="0" vert="horz" wrap="square" lIns="91440" tIns="45720" rIns="91440" bIns="45720" anchor="t" anchorCtr="0">
-              <a:spAutoFit/>
-            </a:bodyPr>
-            <a:lstStyle/>
-            <a:p>
-              <a:pPr algn="just"/>
-              <a:r>
-                <a:rPr lang="en-GB" sz="1600" dirty="0">
-                  <a:solidFill>
-                    <a:schemeClr val="bg1"/>
-                  </a:solidFill>
-                  <a:effectLst/>
-                  <a:latin typeface="Arial" panose="020B0604020202020204" pitchFamily="34" charset="0"/>
-                  <a:ea typeface="Tahoma" panose="020B0604030504040204" pitchFamily="34" charset="0"/>
-                  <a:cs typeface="Arial" panose="020B0604020202020204" pitchFamily="34" charset="0"/>
-                </a:rPr>
-                <a:t>(b)</a:t>
-              </a:r>
-            </a:p>
-          </p:txBody>
-        </p:sp>
-      </p:grpSp>
+            <p:txBody>
+              <a:bodyPr/>
+              <a:lstStyle/>
+              <a:p>
+                <a:r>
+                  <a:rPr lang="en-GB">
+                    <a:noFill/>
+                  </a:rPr>
+                  <a:t> </a:t>
+                </a:r>
+              </a:p>
+            </p:txBody>
+          </p:sp>
+        </mc:Fallback>
+      </mc:AlternateContent>
     </p:spTree>
     <p:extLst>
       <p:ext uri="{BB962C8B-B14F-4D97-AF65-F5344CB8AC3E}">
-        <p14:creationId xmlns:p14="http://schemas.microsoft.com/office/powerpoint/2010/main" val="2583949549"/>
+        <p14:creationId xmlns:p14="http://schemas.microsoft.com/office/powerpoint/2010/main" val="4124847423"/>
       </p:ext>
     </p:extLst>
   </p:cSld>

</xml_diff>

<commit_message>
Change style to Opt. Express
</commit_message>
<xml_diff>
--- a/figs/figures.pptx
+++ b/figs/figures.pptx
@@ -10,7 +10,7 @@
   <p:sldIdLst>
     <p:sldId id="267" r:id="rId2"/>
     <p:sldId id="268" r:id="rId3"/>
-    <p:sldId id="269" r:id="rId4"/>
+    <p:sldId id="281" r:id="rId4"/>
     <p:sldId id="270" r:id="rId5"/>
     <p:sldId id="271" r:id="rId6"/>
     <p:sldId id="272" r:id="rId7"/>
@@ -220,7 +220,7 @@
           <a:p>
             <a:fld id="{2DD6ECBE-534E-4AEE-8ADA-897E2D67A90F}" type="datetimeFigureOut">
               <a:rPr lang="en-GB" smtClean="0"/>
-              <a:t>18/06/2026</a:t>
+              <a:t>26/06/2026</a:t>
             </a:fld>
             <a:endParaRPr lang="en-GB"/>
           </a:p>
@@ -584,6 +584,121 @@
   <p:cSld>
     <p:spTree>
       <p:nvGrpSpPr>
+        <p:cNvPr id="1" name="">
+          <a:extLst>
+            <a:ext uri="{FF2B5EF4-FFF2-40B4-BE49-F238E27FC236}">
+              <a16:creationId xmlns:a16="http://schemas.microsoft.com/office/drawing/2014/main" id="{D25D9F61-14A3-280F-54A5-E11E9055F4AA}"/>
+            </a:ext>
+          </a:extLst>
+        </p:cNvPr>
+        <p:cNvGrpSpPr/>
+        <p:nvPr/>
+      </p:nvGrpSpPr>
+      <p:grpSpPr>
+        <a:xfrm>
+          <a:off x="0" y="0"/>
+          <a:ext cx="0" cy="0"/>
+          <a:chOff x="0" y="0"/>
+          <a:chExt cx="0" cy="0"/>
+        </a:xfrm>
+      </p:grpSpPr>
+      <p:sp>
+        <p:nvSpPr>
+          <p:cNvPr id="2" name="Slide Image Placeholder 1">
+            <a:extLst>
+              <a:ext uri="{FF2B5EF4-FFF2-40B4-BE49-F238E27FC236}">
+                <a16:creationId xmlns:a16="http://schemas.microsoft.com/office/drawing/2014/main" id="{7418C2B2-CD46-2941-A011-B19176DC4765}"/>
+              </a:ext>
+            </a:extLst>
+          </p:cNvPr>
+          <p:cNvSpPr>
+            <a:spLocks noGrp="1" noRot="1" noChangeAspect="1"/>
+          </p:cNvSpPr>
+          <p:nvPr>
+            <p:ph type="sldImg"/>
+          </p:nvPr>
+        </p:nvSpPr>
+        <p:spPr/>
+        <p:txBody>
+          <a:bodyPr/>
+          <a:lstStyle/>
+          <a:p>
+            <a:endParaRPr lang="en-GB"/>
+          </a:p>
+        </p:txBody>
+      </p:sp>
+      <p:sp>
+        <p:nvSpPr>
+          <p:cNvPr id="3" name="Notes Placeholder 2">
+            <a:extLst>
+              <a:ext uri="{FF2B5EF4-FFF2-40B4-BE49-F238E27FC236}">
+                <a16:creationId xmlns:a16="http://schemas.microsoft.com/office/drawing/2014/main" id="{3190AA5A-47CF-1A13-D8CE-02D123F2A772}"/>
+              </a:ext>
+            </a:extLst>
+          </p:cNvPr>
+          <p:cNvSpPr>
+            <a:spLocks noGrp="1"/>
+          </p:cNvSpPr>
+          <p:nvPr>
+            <p:ph type="body" idx="1"/>
+          </p:nvPr>
+        </p:nvSpPr>
+        <p:spPr/>
+        <p:txBody>
+          <a:bodyPr/>
+          <a:lstStyle/>
+          <a:p>
+            <a:endParaRPr lang="en-GB" dirty="0"/>
+          </a:p>
+        </p:txBody>
+      </p:sp>
+      <p:sp>
+        <p:nvSpPr>
+          <p:cNvPr id="4" name="Slide Number Placeholder 3">
+            <a:extLst>
+              <a:ext uri="{FF2B5EF4-FFF2-40B4-BE49-F238E27FC236}">
+                <a16:creationId xmlns:a16="http://schemas.microsoft.com/office/drawing/2014/main" id="{75291655-BA5E-BAA2-8605-EF7DA94A7EF5}"/>
+              </a:ext>
+            </a:extLst>
+          </p:cNvPr>
+          <p:cNvSpPr>
+            <a:spLocks noGrp="1"/>
+          </p:cNvSpPr>
+          <p:nvPr>
+            <p:ph type="sldNum" sz="quarter" idx="5"/>
+          </p:nvPr>
+        </p:nvSpPr>
+        <p:spPr/>
+        <p:txBody>
+          <a:bodyPr/>
+          <a:lstStyle/>
+          <a:p>
+            <a:fld id="{03090B90-D4C3-44FA-A94E-B53CE27CF914}" type="slidenum">
+              <a:rPr lang="en-GB" smtClean="0"/>
+              <a:t>3</a:t>
+            </a:fld>
+            <a:endParaRPr lang="en-GB"/>
+          </a:p>
+        </p:txBody>
+      </p:sp>
+    </p:spTree>
+    <p:extLst>
+      <p:ext uri="{BB962C8B-B14F-4D97-AF65-F5344CB8AC3E}">
+        <p14:creationId xmlns:p14="http://schemas.microsoft.com/office/powerpoint/2010/main" val="2197193189"/>
+      </p:ext>
+    </p:extLst>
+  </p:cSld>
+  <p:clrMapOvr>
+    <a:masterClrMapping/>
+  </p:clrMapOvr>
+</p:notes>
+</file>
+
+<file path=ppt/notesSlides/notesSlide3.xml><?xml version="1.0" encoding="utf-8"?>
+<p:notes xmlns:a="http://schemas.openxmlformats.org/drawingml/2006/main" xmlns:r="http://schemas.openxmlformats.org/officeDocument/2006/relationships" xmlns:p="http://schemas.openxmlformats.org/presentationml/2006/main">
+  <p:cSld>
+    <p:spTree>
+      <p:nvGrpSpPr>
         <p:cNvPr id="1" name=""/>
         <p:cNvGrpSpPr/>
         <p:nvPr/>
@@ -670,7 +785,7 @@
 </p:notes>
 </file>
 
-<file path=ppt/notesSlides/notesSlide3.xml><?xml version="1.0" encoding="utf-8"?>
+<file path=ppt/notesSlides/notesSlide4.xml><?xml version="1.0" encoding="utf-8"?>
 <p:notes xmlns:a="http://schemas.openxmlformats.org/drawingml/2006/main" xmlns:r="http://schemas.openxmlformats.org/officeDocument/2006/relationships" xmlns:p="http://schemas.openxmlformats.org/presentationml/2006/main">
   <p:cSld>
     <p:spTree>
@@ -903,7 +1018,7 @@
           <a:p>
             <a:fld id="{6DA190FC-D844-4E0A-A0A2-219D558319DC}" type="datetimeFigureOut">
               <a:rPr lang="en-GB" smtClean="0"/>
-              <a:t>18/06/2026</a:t>
+              <a:t>26/06/2026</a:t>
             </a:fld>
             <a:endParaRPr lang="en-GB"/>
           </a:p>
@@ -1103,7 +1218,7 @@
           <a:p>
             <a:fld id="{6DA190FC-D844-4E0A-A0A2-219D558319DC}" type="datetimeFigureOut">
               <a:rPr lang="en-GB" smtClean="0"/>
-              <a:t>18/06/2026</a:t>
+              <a:t>26/06/2026</a:t>
             </a:fld>
             <a:endParaRPr lang="en-GB"/>
           </a:p>
@@ -1313,7 +1428,7 @@
           <a:p>
             <a:fld id="{6DA190FC-D844-4E0A-A0A2-219D558319DC}" type="datetimeFigureOut">
               <a:rPr lang="en-GB" smtClean="0"/>
-              <a:t>18/06/2026</a:t>
+              <a:t>26/06/2026</a:t>
             </a:fld>
             <a:endParaRPr lang="en-GB"/>
           </a:p>
@@ -1513,7 +1628,7 @@
           <a:p>
             <a:fld id="{6DA190FC-D844-4E0A-A0A2-219D558319DC}" type="datetimeFigureOut">
               <a:rPr lang="en-GB" smtClean="0"/>
-              <a:t>18/06/2026</a:t>
+              <a:t>26/06/2026</a:t>
             </a:fld>
             <a:endParaRPr lang="en-GB"/>
           </a:p>
@@ -1789,7 +1904,7 @@
           <a:p>
             <a:fld id="{6DA190FC-D844-4E0A-A0A2-219D558319DC}" type="datetimeFigureOut">
               <a:rPr lang="en-GB" smtClean="0"/>
-              <a:t>18/06/2026</a:t>
+              <a:t>26/06/2026</a:t>
             </a:fld>
             <a:endParaRPr lang="en-GB"/>
           </a:p>
@@ -2057,7 +2172,7 @@
           <a:p>
             <a:fld id="{6DA190FC-D844-4E0A-A0A2-219D558319DC}" type="datetimeFigureOut">
               <a:rPr lang="en-GB" smtClean="0"/>
-              <a:t>18/06/2026</a:t>
+              <a:t>26/06/2026</a:t>
             </a:fld>
             <a:endParaRPr lang="en-GB"/>
           </a:p>
@@ -2472,7 +2587,7 @@
           <a:p>
             <a:fld id="{6DA190FC-D844-4E0A-A0A2-219D558319DC}" type="datetimeFigureOut">
               <a:rPr lang="en-GB" smtClean="0"/>
-              <a:t>18/06/2026</a:t>
+              <a:t>26/06/2026</a:t>
             </a:fld>
             <a:endParaRPr lang="en-GB"/>
           </a:p>
@@ -2614,7 +2729,7 @@
           <a:p>
             <a:fld id="{6DA190FC-D844-4E0A-A0A2-219D558319DC}" type="datetimeFigureOut">
               <a:rPr lang="en-GB" smtClean="0"/>
-              <a:t>18/06/2026</a:t>
+              <a:t>26/06/2026</a:t>
             </a:fld>
             <a:endParaRPr lang="en-GB"/>
           </a:p>
@@ -2727,7 +2842,7 @@
           <a:p>
             <a:fld id="{6DA190FC-D844-4E0A-A0A2-219D558319DC}" type="datetimeFigureOut">
               <a:rPr lang="en-GB" smtClean="0"/>
-              <a:t>18/06/2026</a:t>
+              <a:t>26/06/2026</a:t>
             </a:fld>
             <a:endParaRPr lang="en-GB"/>
           </a:p>
@@ -3040,7 +3155,7 @@
           <a:p>
             <a:fld id="{6DA190FC-D844-4E0A-A0A2-219D558319DC}" type="datetimeFigureOut">
               <a:rPr lang="en-GB" smtClean="0"/>
-              <a:t>18/06/2026</a:t>
+              <a:t>26/06/2026</a:t>
             </a:fld>
             <a:endParaRPr lang="en-GB"/>
           </a:p>
@@ -3329,7 +3444,7 @@
           <a:p>
             <a:fld id="{6DA190FC-D844-4E0A-A0A2-219D558319DC}" type="datetimeFigureOut">
               <a:rPr lang="en-GB" smtClean="0"/>
-              <a:t>18/06/2026</a:t>
+              <a:t>26/06/2026</a:t>
             </a:fld>
             <a:endParaRPr lang="en-GB"/>
           </a:p>
@@ -3572,7 +3687,7 @@
           <a:p>
             <a:fld id="{6DA190FC-D844-4E0A-A0A2-219D558319DC}" type="datetimeFigureOut">
               <a:rPr lang="en-GB" smtClean="0"/>
-              <a:t>18/06/2026</a:t>
+              <a:t>26/06/2026</a:t>
             </a:fld>
             <a:endParaRPr lang="en-GB"/>
           </a:p>
@@ -4011,13 +4126,15 @@
               </a:ext>
             </a:extLst>
           </a:blip>
-          <a:srcRect/>
-          <a:stretch/>
+          <a:srcRect t="2390" b="2516"/>
+          <a:stretch>
+            <a:fillRect/>
+          </a:stretch>
         </p:blipFill>
         <p:spPr>
           <a:xfrm>
-            <a:off x="0" y="0"/>
-            <a:ext cx="12192000" cy="6857999"/>
+            <a:off x="0" y="163903"/>
+            <a:ext cx="12192000" cy="6521570"/>
           </a:xfrm>
           <a:prstGeom prst="rect">
             <a:avLst/>
@@ -5366,15 +5483,15 @@
               </a:ext>
             </a:extLst>
           </a:blip>
-          <a:srcRect l="6149" t="3623" r="6149" b="3623"/>
+          <a:srcRect l="7447" t="11161" r="7447" b="4859"/>
           <a:stretch>
             <a:fillRect/>
           </a:stretch>
         </p:blipFill>
         <p:spPr>
           <a:xfrm>
-            <a:off x="1052513" y="0"/>
-            <a:ext cx="10086974" cy="6858000"/>
+            <a:off x="1201783" y="557349"/>
+            <a:ext cx="9788434" cy="6209212"/>
           </a:xfrm>
           <a:prstGeom prst="rect">
             <a:avLst/>
@@ -5433,15 +5550,15 @@
               </a:ext>
             </a:extLst>
           </a:blip>
-          <a:srcRect t="6388" b="3055"/>
+          <a:srcRect t="9904" b="3056"/>
           <a:stretch>
             <a:fillRect/>
           </a:stretch>
         </p:blipFill>
         <p:spPr>
           <a:xfrm>
-            <a:off x="762000" y="438150"/>
-            <a:ext cx="5334000" cy="6210300"/>
+            <a:off x="762000" y="679268"/>
+            <a:ext cx="5334000" cy="5969181"/>
           </a:xfrm>
           <a:prstGeom prst="rect">
             <a:avLst/>
@@ -5470,21 +5587,119 @@
               </a:ext>
             </a:extLst>
           </a:blip>
-          <a:srcRect t="6388" b="3055"/>
+          <a:srcRect t="9904" b="3056"/>
           <a:stretch>
             <a:fillRect/>
           </a:stretch>
         </p:blipFill>
         <p:spPr>
           <a:xfrm>
-            <a:off x="5828580" y="438150"/>
-            <a:ext cx="5334000" cy="6210300"/>
+            <a:off x="5776326" y="679268"/>
+            <a:ext cx="5334000" cy="5969182"/>
           </a:xfrm>
           <a:prstGeom prst="rect">
             <a:avLst/>
           </a:prstGeom>
         </p:spPr>
       </p:pic>
+      <p:sp>
+        <p:nvSpPr>
+          <p:cNvPr id="2" name="Text Box 2">
+            <a:extLst>
+              <a:ext uri="{FF2B5EF4-FFF2-40B4-BE49-F238E27FC236}">
+                <a16:creationId xmlns:a16="http://schemas.microsoft.com/office/drawing/2014/main" id="{0A13FD40-2D86-7920-8DBB-8399B2B1796E}"/>
+              </a:ext>
+            </a:extLst>
+          </p:cNvPr>
+          <p:cNvSpPr txBox="1">
+            <a:spLocks noChangeArrowheads="1"/>
+          </p:cNvSpPr>
+          <p:nvPr/>
+        </p:nvSpPr>
+        <p:spPr bwMode="auto">
+          <a:xfrm>
+            <a:off x="1445914" y="824029"/>
+            <a:ext cx="542519" cy="338554"/>
+          </a:xfrm>
+          <a:prstGeom prst="rect">
+            <a:avLst/>
+          </a:prstGeom>
+          <a:noFill/>
+          <a:ln w="9525">
+            <a:noFill/>
+            <a:miter lim="800000"/>
+            <a:headEnd/>
+            <a:tailEnd/>
+          </a:ln>
+        </p:spPr>
+        <p:txBody>
+          <a:bodyPr rot="0" vert="horz" wrap="square" lIns="91440" tIns="45720" rIns="91440" bIns="45720" anchor="t" anchorCtr="0">
+            <a:spAutoFit/>
+          </a:bodyPr>
+          <a:lstStyle/>
+          <a:p>
+            <a:pPr algn="just"/>
+            <a:r>
+              <a:rPr lang="en-GB" sz="1600" dirty="0">
+                <a:effectLst/>
+                <a:latin typeface="Arial" panose="020B0604020202020204" pitchFamily="34" charset="0"/>
+                <a:ea typeface="TH Sarabun PSK"/>
+                <a:cs typeface="TH Sarabun PSK"/>
+              </a:rPr>
+              <a:t>(a)</a:t>
+            </a:r>
+          </a:p>
+        </p:txBody>
+      </p:sp>
+      <p:sp>
+        <p:nvSpPr>
+          <p:cNvPr id="3" name="Text Box 2">
+            <a:extLst>
+              <a:ext uri="{FF2B5EF4-FFF2-40B4-BE49-F238E27FC236}">
+                <a16:creationId xmlns:a16="http://schemas.microsoft.com/office/drawing/2014/main" id="{49A0FFF7-F999-E196-A332-CDBE76F16A06}"/>
+              </a:ext>
+            </a:extLst>
+          </p:cNvPr>
+          <p:cNvSpPr txBox="1">
+            <a:spLocks noChangeArrowheads="1"/>
+          </p:cNvSpPr>
+          <p:nvPr/>
+        </p:nvSpPr>
+        <p:spPr bwMode="auto">
+          <a:xfrm>
+            <a:off x="6449469" y="826525"/>
+            <a:ext cx="542519" cy="338554"/>
+          </a:xfrm>
+          <a:prstGeom prst="rect">
+            <a:avLst/>
+          </a:prstGeom>
+          <a:noFill/>
+          <a:ln w="9525">
+            <a:noFill/>
+            <a:miter lim="800000"/>
+            <a:headEnd/>
+            <a:tailEnd/>
+          </a:ln>
+        </p:spPr>
+        <p:txBody>
+          <a:bodyPr rot="0" vert="horz" wrap="square" lIns="91440" tIns="45720" rIns="91440" bIns="45720" anchor="t" anchorCtr="0">
+            <a:spAutoFit/>
+          </a:bodyPr>
+          <a:lstStyle/>
+          <a:p>
+            <a:pPr algn="just"/>
+            <a:r>
+              <a:rPr lang="en-GB" sz="1600" dirty="0">
+                <a:effectLst/>
+                <a:latin typeface="Arial" panose="020B0604020202020204" pitchFamily="34" charset="0"/>
+                <a:ea typeface="Tahoma" panose="020B0604030504040204" pitchFamily="34" charset="0"/>
+                <a:cs typeface="Arial" panose="020B0604020202020204" pitchFamily="34" charset="0"/>
+              </a:rPr>
+              <a:t>(b)</a:t>
+            </a:r>
+          </a:p>
+        </p:txBody>
+      </p:sp>
     </p:spTree>
     <p:extLst>
       <p:ext uri="{BB962C8B-B14F-4D97-AF65-F5344CB8AC3E}">
@@ -7311,438 +7526,771 @@
           <a:chExt cx="0" cy="0"/>
         </a:xfrm>
       </p:grpSpPr>
-      <p:sp>
-        <p:nvSpPr>
-          <p:cNvPr id="2" name="Rectangle 1">
-            <a:extLst>
-              <a:ext uri="{FF2B5EF4-FFF2-40B4-BE49-F238E27FC236}">
-                <a16:creationId xmlns:a16="http://schemas.microsoft.com/office/drawing/2014/main" id="{34B8F0EC-0887-CF59-65E7-B34DD0AA15BE}"/>
-              </a:ext>
-            </a:extLst>
-          </p:cNvPr>
-          <p:cNvSpPr/>
+      <p:pic>
+        <p:nvPicPr>
+          <p:cNvPr id="15" name="Picture 14">
+            <a:extLst>
+              <a:ext uri="{FF2B5EF4-FFF2-40B4-BE49-F238E27FC236}">
+                <a16:creationId xmlns:a16="http://schemas.microsoft.com/office/drawing/2014/main" id="{95D1B0FB-4C6A-A250-B447-7194D3048347}"/>
+              </a:ext>
+            </a:extLst>
+          </p:cNvPr>
+          <p:cNvPicPr>
+            <a:picLocks noChangeAspect="1"/>
+          </p:cNvPicPr>
           <p:nvPr/>
-        </p:nvSpPr>
+        </p:nvPicPr>
+        <p:blipFill>
+          <a:blip r:embed="rId3">
+            <a:extLst>
+              <a:ext uri="{28A0092B-C50C-407E-A947-70E740481C1C}">
+                <a14:useLocalDpi xmlns:a14="http://schemas.microsoft.com/office/drawing/2010/main" val="0"/>
+              </a:ext>
+            </a:extLst>
+          </a:blip>
+          <a:srcRect l="7646" t="10289" r="7646" b="4783"/>
+          <a:stretch>
+            <a:fillRect/>
+          </a:stretch>
+        </p:blipFill>
         <p:spPr>
           <a:xfrm>
-            <a:off x="3556236" y="3880739"/>
-            <a:ext cx="5281502" cy="1950717"/>
+            <a:off x="773596" y="-3726"/>
+            <a:ext cx="10644809" cy="6860909"/>
           </a:xfrm>
           <a:prstGeom prst="rect">
             <a:avLst/>
           </a:prstGeom>
-          <a:solidFill>
-            <a:schemeClr val="tx2">
-              <a:lumMod val="25000"/>
-              <a:lumOff val="75000"/>
-            </a:schemeClr>
-          </a:solidFill>
-          <a:ln>
-            <a:noFill/>
-          </a:ln>
         </p:spPr>
-        <p:style>
-          <a:lnRef idx="2">
-            <a:schemeClr val="accent1">
-              <a:shade val="15000"/>
-            </a:schemeClr>
-          </a:lnRef>
-          <a:fillRef idx="1">
-            <a:schemeClr val="accent1"/>
-          </a:fillRef>
-          <a:effectRef idx="0">
-            <a:schemeClr val="accent1"/>
-          </a:effectRef>
-          <a:fontRef idx="minor">
-            <a:schemeClr val="lt1"/>
-          </a:fontRef>
-        </p:style>
-        <p:txBody>
-          <a:bodyPr rtlCol="0" anchor="t"/>
-          <a:lstStyle/>
-          <a:p>
-            <a:r>
-              <a:rPr lang="en-US" sz="2400" dirty="0">
+      </p:pic>
+      <p:grpSp>
+        <p:nvGrpSpPr>
+          <p:cNvPr id="17" name="Group 16">
+            <a:extLst>
+              <a:ext uri="{FF2B5EF4-FFF2-40B4-BE49-F238E27FC236}">
+                <a16:creationId xmlns:a16="http://schemas.microsoft.com/office/drawing/2014/main" id="{23D8035A-B448-2C17-6385-F156001662E3}"/>
+              </a:ext>
+            </a:extLst>
+          </p:cNvPr>
+          <p:cNvGrpSpPr/>
+          <p:nvPr/>
+        </p:nvGrpSpPr>
+        <p:grpSpPr>
+          <a:xfrm>
+            <a:off x="7686031" y="209005"/>
+            <a:ext cx="3436452" cy="2664824"/>
+            <a:chOff x="7550331" y="156754"/>
+            <a:chExt cx="3637283" cy="2820560"/>
+          </a:xfrm>
+        </p:grpSpPr>
+        <p:sp>
+          <p:nvSpPr>
+            <p:cNvPr id="16" name="Rectangle 15">
+              <a:extLst>
+                <a:ext uri="{FF2B5EF4-FFF2-40B4-BE49-F238E27FC236}">
+                  <a16:creationId xmlns:a16="http://schemas.microsoft.com/office/drawing/2014/main" id="{68CD9EE2-039A-6260-1B43-D0467B554397}"/>
+                </a:ext>
+              </a:extLst>
+            </p:cNvPr>
+            <p:cNvSpPr/>
+            <p:nvPr/>
+          </p:nvSpPr>
+          <p:spPr>
+            <a:xfrm>
+              <a:off x="7550331" y="156754"/>
+              <a:ext cx="3561806" cy="2820560"/>
+            </a:xfrm>
+            <a:prstGeom prst="rect">
+              <a:avLst/>
+            </a:prstGeom>
+            <a:solidFill>
+              <a:schemeClr val="tx2">
+                <a:lumMod val="10000"/>
+                <a:lumOff val="90000"/>
+              </a:schemeClr>
+            </a:solidFill>
+            <a:ln>
+              <a:noFill/>
+            </a:ln>
+          </p:spPr>
+          <p:style>
+            <a:lnRef idx="2">
+              <a:schemeClr val="accent1">
+                <a:shade val="15000"/>
+              </a:schemeClr>
+            </a:lnRef>
+            <a:fillRef idx="1">
+              <a:schemeClr val="accent1"/>
+            </a:fillRef>
+            <a:effectRef idx="0">
+              <a:schemeClr val="accent1"/>
+            </a:effectRef>
+            <a:fontRef idx="minor">
+              <a:schemeClr val="lt1"/>
+            </a:fontRef>
+          </p:style>
+          <p:txBody>
+            <a:bodyPr rtlCol="0" anchor="ctr"/>
+            <a:lstStyle/>
+            <a:p>
+              <a:pPr algn="ctr"/>
+              <a:endParaRPr lang="en-GB"/>
+            </a:p>
+          </p:txBody>
+        </p:sp>
+        <p:grpSp>
+          <p:nvGrpSpPr>
+            <p:cNvPr id="13" name="Group 12">
+              <a:extLst>
+                <a:ext uri="{FF2B5EF4-FFF2-40B4-BE49-F238E27FC236}">
+                  <a16:creationId xmlns:a16="http://schemas.microsoft.com/office/drawing/2014/main" id="{4931ABE6-B3AC-F519-0AE7-566D3AA44722}"/>
+                </a:ext>
+              </a:extLst>
+            </p:cNvPr>
+            <p:cNvGrpSpPr/>
+            <p:nvPr/>
+          </p:nvGrpSpPr>
+          <p:grpSpPr>
+            <a:xfrm>
+              <a:off x="7627796" y="213409"/>
+              <a:ext cx="3559818" cy="2686545"/>
+              <a:chOff x="7955140" y="160927"/>
+              <a:chExt cx="3654840" cy="2758256"/>
+            </a:xfrm>
+          </p:grpSpPr>
+          <p:grpSp>
+            <p:nvGrpSpPr>
+              <p:cNvPr id="6" name="Group 5">
+                <a:extLst>
+                  <a:ext uri="{FF2B5EF4-FFF2-40B4-BE49-F238E27FC236}">
+                    <a16:creationId xmlns:a16="http://schemas.microsoft.com/office/drawing/2014/main" id="{DDFE5320-B33B-51DD-1AA6-59E6DB5CAE80}"/>
+                  </a:ext>
+                </a:extLst>
+              </p:cNvPr>
+              <p:cNvGrpSpPr/>
+              <p:nvPr/>
+            </p:nvGrpSpPr>
+            <p:grpSpPr>
+              <a:xfrm>
+                <a:off x="7955140" y="169814"/>
+                <a:ext cx="3654840" cy="2749369"/>
+                <a:chOff x="3556236" y="1663700"/>
+                <a:chExt cx="5660489" cy="4258129"/>
+              </a:xfrm>
+              <a:effectLst/>
+            </p:grpSpPr>
+            <p:sp>
+              <p:nvSpPr>
+                <p:cNvPr id="2" name="Rectangle 1">
+                  <a:extLst>
+                    <a:ext uri="{FF2B5EF4-FFF2-40B4-BE49-F238E27FC236}">
+                      <a16:creationId xmlns:a16="http://schemas.microsoft.com/office/drawing/2014/main" id="{34B8F0EC-0887-CF59-65E7-B34DD0AA15BE}"/>
+                    </a:ext>
+                  </a:extLst>
+                </p:cNvPr>
+                <p:cNvSpPr/>
+                <p:nvPr/>
+              </p:nvSpPr>
+              <p:spPr>
+                <a:xfrm>
+                  <a:off x="3556236" y="3880739"/>
+                  <a:ext cx="5281502" cy="1570827"/>
+                </a:xfrm>
+                <a:prstGeom prst="rect">
+                  <a:avLst/>
+                </a:prstGeom>
                 <a:solidFill>
+                  <a:schemeClr val="accent1">
+                    <a:lumMod val="60000"/>
+                    <a:lumOff val="40000"/>
+                  </a:schemeClr>
+                </a:solidFill>
+                <a:ln>
+                  <a:noFill/>
+                </a:ln>
+              </p:spPr>
+              <p:style>
+                <a:lnRef idx="2">
+                  <a:schemeClr val="accent1">
+                    <a:shade val="15000"/>
+                  </a:schemeClr>
+                </a:lnRef>
+                <a:fillRef idx="1">
+                  <a:schemeClr val="accent1"/>
+                </a:fillRef>
+                <a:effectRef idx="0">
+                  <a:schemeClr val="accent1"/>
+                </a:effectRef>
+                <a:fontRef idx="minor">
+                  <a:schemeClr val="lt1"/>
+                </a:fontRef>
+              </p:style>
+              <p:txBody>
+                <a:bodyPr rtlCol="0" anchor="t"/>
+                <a:lstStyle/>
+                <a:p>
+                  <a:r>
+                    <a:rPr lang="en-US" sz="1600" dirty="0">
+                      <a:solidFill>
+                        <a:schemeClr val="tx1"/>
+                      </a:solidFill>
+                      <a:latin typeface="Arial" panose="020B0604020202020204" pitchFamily="34" charset="0"/>
+                      <a:cs typeface="Arial" panose="020B0604020202020204" pitchFamily="34" charset="0"/>
+                    </a:rPr>
+                    <a:t>SiO</a:t>
+                  </a:r>
+                  <a:r>
+                    <a:rPr lang="en-US" sz="1600" baseline="-25000" dirty="0">
+                      <a:solidFill>
+                        <a:schemeClr val="tx1"/>
+                      </a:solidFill>
+                      <a:latin typeface="Arial" panose="020B0604020202020204" pitchFamily="34" charset="0"/>
+                      <a:cs typeface="Arial" panose="020B0604020202020204" pitchFamily="34" charset="0"/>
+                    </a:rPr>
+                    <a:t>2 </a:t>
+                  </a:r>
+                  <a:r>
+                    <a:rPr lang="en-US" sz="1600" dirty="0">
+                      <a:solidFill>
+                        <a:schemeClr val="tx1"/>
+                      </a:solidFill>
+                      <a:latin typeface="Arial" panose="020B0604020202020204" pitchFamily="34" charset="0"/>
+                      <a:cs typeface="Arial" panose="020B0604020202020204" pitchFamily="34" charset="0"/>
+                    </a:rPr>
+                    <a:t>substrate</a:t>
+                  </a:r>
+                  <a:endParaRPr lang="en-GB" sz="1600" dirty="0">
+                    <a:solidFill>
+                      <a:schemeClr val="tx1"/>
+                    </a:solidFill>
+                    <a:latin typeface="Arial" panose="020B0604020202020204" pitchFamily="34" charset="0"/>
+                    <a:cs typeface="Arial" panose="020B0604020202020204" pitchFamily="34" charset="0"/>
+                  </a:endParaRPr>
+                </a:p>
+              </p:txBody>
+            </p:sp>
+            <p:sp>
+              <p:nvSpPr>
+                <p:cNvPr id="3" name="Rectangle 2">
+                  <a:extLst>
+                    <a:ext uri="{FF2B5EF4-FFF2-40B4-BE49-F238E27FC236}">
+                      <a16:creationId xmlns:a16="http://schemas.microsoft.com/office/drawing/2014/main" id="{C100CBF4-C87C-8EA4-40E3-75E5BD3CC923}"/>
+                    </a:ext>
+                  </a:extLst>
+                </p:cNvPr>
+                <p:cNvSpPr/>
+                <p:nvPr/>
+              </p:nvSpPr>
+              <p:spPr>
+                <a:xfrm>
+                  <a:off x="3556237" y="2826744"/>
+                  <a:ext cx="5281498" cy="1053996"/>
+                </a:xfrm>
+                <a:prstGeom prst="rect">
+                  <a:avLst/>
+                </a:prstGeom>
+                <a:solidFill>
+                  <a:schemeClr val="accent3">
+                    <a:lumMod val="20000"/>
+                    <a:lumOff val="80000"/>
+                  </a:schemeClr>
+                </a:solidFill>
+                <a:ln>
+                  <a:noFill/>
+                </a:ln>
+              </p:spPr>
+              <p:style>
+                <a:lnRef idx="2">
+                  <a:schemeClr val="accent1">
+                    <a:shade val="15000"/>
+                  </a:schemeClr>
+                </a:lnRef>
+                <a:fillRef idx="1">
+                  <a:schemeClr val="accent1"/>
+                </a:fillRef>
+                <a:effectRef idx="0">
+                  <a:schemeClr val="accent1"/>
+                </a:effectRef>
+                <a:fontRef idx="minor">
+                  <a:schemeClr val="lt1"/>
+                </a:fontRef>
+              </p:style>
+              <p:txBody>
+                <a:bodyPr rtlCol="0" anchor="t"/>
+                <a:lstStyle/>
+                <a:p>
+                  <a:r>
+                    <a:rPr lang="en-US" sz="1600" dirty="0">
+                      <a:solidFill>
+                        <a:schemeClr val="tx1"/>
+                      </a:solidFill>
+                      <a:latin typeface="Arial" panose="020B0604020202020204" pitchFamily="34" charset="0"/>
+                      <a:cs typeface="Arial" panose="020B0604020202020204" pitchFamily="34" charset="0"/>
+                    </a:rPr>
+                    <a:t>Film</a:t>
+                  </a:r>
+                  <a:endParaRPr lang="en-GB" sz="1600" dirty="0">
+                    <a:solidFill>
+                      <a:schemeClr val="tx1"/>
+                    </a:solidFill>
+                    <a:latin typeface="Arial" panose="020B0604020202020204" pitchFamily="34" charset="0"/>
+                    <a:cs typeface="Arial" panose="020B0604020202020204" pitchFamily="34" charset="0"/>
+                  </a:endParaRPr>
+                </a:p>
+              </p:txBody>
+            </p:sp>
+            <p:cxnSp>
+              <p:nvCxnSpPr>
+                <p:cNvPr id="12" name="Straight Arrow Connector 11">
+                  <a:extLst>
+                    <a:ext uri="{FF2B5EF4-FFF2-40B4-BE49-F238E27FC236}">
+                      <a16:creationId xmlns:a16="http://schemas.microsoft.com/office/drawing/2014/main" id="{18DF0614-9416-BE65-3537-D556EF6446F9}"/>
+                    </a:ext>
+                  </a:extLst>
+                </p:cNvPr>
+                <p:cNvCxnSpPr>
+                  <a:cxnSpLocks/>
+                </p:cNvCxnSpPr>
+                <p:nvPr/>
+              </p:nvCxnSpPr>
+              <p:spPr>
+                <a:xfrm flipV="1">
+                  <a:off x="5968551" y="1699730"/>
+                  <a:ext cx="2547126" cy="2193708"/>
+                </a:xfrm>
+                <a:prstGeom prst="straightConnector1">
+                  <a:avLst/>
+                </a:prstGeom>
+                <a:ln w="57150">
+                  <a:solidFill>
+                    <a:schemeClr val="accent2"/>
+                  </a:solidFill>
+                  <a:prstDash val="dash"/>
+                  <a:tailEnd type="triangle"/>
+                </a:ln>
+              </p:spPr>
+              <p:style>
+                <a:lnRef idx="2">
+                  <a:schemeClr val="accent1"/>
+                </a:lnRef>
+                <a:fillRef idx="0">
+                  <a:schemeClr val="accent1"/>
+                </a:fillRef>
+                <a:effectRef idx="1">
+                  <a:schemeClr val="accent1"/>
+                </a:effectRef>
+                <a:fontRef idx="minor">
                   <a:schemeClr val="tx1"/>
-                </a:solidFill>
-                <a:latin typeface="Arial" panose="020B0604020202020204" pitchFamily="34" charset="0"/>
-                <a:cs typeface="Arial" panose="020B0604020202020204" pitchFamily="34" charset="0"/>
-              </a:rPr>
-              <a:t>Substrate</a:t>
-            </a:r>
-            <a:endParaRPr lang="en-GB" sz="2400" dirty="0">
-              <a:solidFill>
-                <a:schemeClr val="tx1"/>
-              </a:solidFill>
-              <a:latin typeface="Arial" panose="020B0604020202020204" pitchFamily="34" charset="0"/>
-              <a:cs typeface="Arial" panose="020B0604020202020204" pitchFamily="34" charset="0"/>
-            </a:endParaRPr>
-          </a:p>
-        </p:txBody>
-      </p:sp>
-      <p:sp>
-        <p:nvSpPr>
-          <p:cNvPr id="3" name="Rectangle 2">
-            <a:extLst>
-              <a:ext uri="{FF2B5EF4-FFF2-40B4-BE49-F238E27FC236}">
-                <a16:creationId xmlns:a16="http://schemas.microsoft.com/office/drawing/2014/main" id="{C100CBF4-C87C-8EA4-40E3-75E5BD3CC923}"/>
-              </a:ext>
-            </a:extLst>
-          </p:cNvPr>
-          <p:cNvSpPr/>
-          <p:nvPr/>
-        </p:nvSpPr>
-        <p:spPr>
-          <a:xfrm>
-            <a:off x="3556237" y="2826744"/>
-            <a:ext cx="5281498" cy="1053996"/>
-          </a:xfrm>
-          <a:prstGeom prst="rect">
-            <a:avLst/>
-          </a:prstGeom>
-          <a:solidFill>
-            <a:schemeClr val="accent3">
-              <a:lumMod val="20000"/>
-              <a:lumOff val="80000"/>
-            </a:schemeClr>
-          </a:solidFill>
-          <a:ln>
-            <a:noFill/>
-          </a:ln>
-        </p:spPr>
-        <p:style>
-          <a:lnRef idx="2">
-            <a:schemeClr val="accent1">
-              <a:shade val="15000"/>
-            </a:schemeClr>
-          </a:lnRef>
-          <a:fillRef idx="1">
-            <a:schemeClr val="accent1"/>
-          </a:fillRef>
-          <a:effectRef idx="0">
-            <a:schemeClr val="accent1"/>
-          </a:effectRef>
-          <a:fontRef idx="minor">
-            <a:schemeClr val="lt1"/>
-          </a:fontRef>
-        </p:style>
-        <p:txBody>
-          <a:bodyPr rtlCol="0" anchor="t"/>
-          <a:lstStyle/>
-          <a:p>
-            <a:r>
-              <a:rPr lang="en-US" sz="2400" dirty="0">
-                <a:solidFill>
+                </a:fontRef>
+              </p:style>
+            </p:cxnSp>
+            <p:cxnSp>
+              <p:nvCxnSpPr>
+                <p:cNvPr id="21" name="Straight Arrow Connector 20">
+                  <a:extLst>
+                    <a:ext uri="{FF2B5EF4-FFF2-40B4-BE49-F238E27FC236}">
+                      <a16:creationId xmlns:a16="http://schemas.microsoft.com/office/drawing/2014/main" id="{AD091AAD-134C-0EAD-F4A2-6BC8EE5317E6}"/>
+                    </a:ext>
+                  </a:extLst>
+                </p:cNvPr>
+                <p:cNvCxnSpPr>
+                  <a:cxnSpLocks/>
+                </p:cNvCxnSpPr>
+                <p:nvPr/>
+              </p:nvCxnSpPr>
+              <p:spPr>
+                <a:xfrm>
+                  <a:off x="5968552" y="1663700"/>
+                  <a:ext cx="0" cy="4258129"/>
+                </a:xfrm>
+                <a:prstGeom prst="straightConnector1">
+                  <a:avLst/>
+                </a:prstGeom>
+                <a:ln w="57150">
+                  <a:solidFill>
+                    <a:schemeClr val="accent2"/>
+                  </a:solidFill>
+                  <a:tailEnd type="triangle"/>
+                </a:ln>
+              </p:spPr>
+              <p:style>
+                <a:lnRef idx="2">
+                  <a:schemeClr val="accent1"/>
+                </a:lnRef>
+                <a:fillRef idx="0">
+                  <a:schemeClr val="accent1"/>
+                </a:fillRef>
+                <a:effectRef idx="1">
+                  <a:schemeClr val="accent1"/>
+                </a:effectRef>
+                <a:fontRef idx="minor">
                   <a:schemeClr val="tx1"/>
-                </a:solidFill>
-                <a:latin typeface="Arial" panose="020B0604020202020204" pitchFamily="34" charset="0"/>
-                <a:cs typeface="Arial" panose="020B0604020202020204" pitchFamily="34" charset="0"/>
-              </a:rPr>
-              <a:t>Film</a:t>
-            </a:r>
-            <a:endParaRPr lang="en-GB" sz="2400" dirty="0">
-              <a:solidFill>
-                <a:schemeClr val="tx1"/>
-              </a:solidFill>
-              <a:latin typeface="Arial" panose="020B0604020202020204" pitchFamily="34" charset="0"/>
-              <a:cs typeface="Arial" panose="020B0604020202020204" pitchFamily="34" charset="0"/>
-            </a:endParaRPr>
-          </a:p>
-        </p:txBody>
-      </p:sp>
-      <p:cxnSp>
-        <p:nvCxnSpPr>
-          <p:cNvPr id="12" name="Straight Arrow Connector 11">
-            <a:extLst>
-              <a:ext uri="{FF2B5EF4-FFF2-40B4-BE49-F238E27FC236}">
-                <a16:creationId xmlns:a16="http://schemas.microsoft.com/office/drawing/2014/main" id="{18DF0614-9416-BE65-3537-D556EF6446F9}"/>
-              </a:ext>
-            </a:extLst>
-          </p:cNvPr>
-          <p:cNvCxnSpPr>
-            <a:cxnSpLocks/>
-          </p:cNvCxnSpPr>
-          <p:nvPr/>
-        </p:nvCxnSpPr>
-        <p:spPr>
-          <a:xfrm flipV="1">
-            <a:off x="5778020" y="1699731"/>
-            <a:ext cx="2547126" cy="2193709"/>
-          </a:xfrm>
-          <a:prstGeom prst="straightConnector1">
-            <a:avLst/>
-          </a:prstGeom>
-          <a:ln w="57150">
-            <a:solidFill>
-              <a:schemeClr val="accent2"/>
-            </a:solidFill>
-            <a:prstDash val="dash"/>
-            <a:tailEnd type="triangle"/>
-          </a:ln>
-        </p:spPr>
-        <p:style>
-          <a:lnRef idx="2">
-            <a:schemeClr val="accent1"/>
-          </a:lnRef>
-          <a:fillRef idx="0">
-            <a:schemeClr val="accent1"/>
-          </a:fillRef>
-          <a:effectRef idx="1">
-            <a:schemeClr val="accent1"/>
-          </a:effectRef>
-          <a:fontRef idx="minor">
-            <a:schemeClr val="tx1"/>
-          </a:fontRef>
-        </p:style>
-      </p:cxnSp>
-      <p:cxnSp>
-        <p:nvCxnSpPr>
-          <p:cNvPr id="21" name="Straight Arrow Connector 20">
-            <a:extLst>
-              <a:ext uri="{FF2B5EF4-FFF2-40B4-BE49-F238E27FC236}">
-                <a16:creationId xmlns:a16="http://schemas.microsoft.com/office/drawing/2014/main" id="{AD091AAD-134C-0EAD-F4A2-6BC8EE5317E6}"/>
-              </a:ext>
-            </a:extLst>
-          </p:cNvPr>
-          <p:cNvCxnSpPr>
-            <a:cxnSpLocks/>
-          </p:cNvCxnSpPr>
-          <p:nvPr/>
-        </p:nvCxnSpPr>
-        <p:spPr>
-          <a:xfrm>
-            <a:off x="5778021" y="1663700"/>
-            <a:ext cx="0" cy="4584700"/>
-          </a:xfrm>
-          <a:prstGeom prst="straightConnector1">
-            <a:avLst/>
-          </a:prstGeom>
-          <a:ln w="76200">
-            <a:solidFill>
-              <a:schemeClr val="accent2"/>
-            </a:solidFill>
-            <a:tailEnd type="triangle"/>
-          </a:ln>
-        </p:spPr>
-        <p:style>
-          <a:lnRef idx="2">
-            <a:schemeClr val="accent1"/>
-          </a:lnRef>
-          <a:fillRef idx="0">
-            <a:schemeClr val="accent1"/>
-          </a:fillRef>
-          <a:effectRef idx="1">
-            <a:schemeClr val="accent1"/>
-          </a:effectRef>
-          <a:fontRef idx="minor">
-            <a:schemeClr val="tx1"/>
-          </a:fontRef>
-        </p:style>
-      </p:cxnSp>
-      <p:sp>
-        <p:nvSpPr>
-          <p:cNvPr id="47" name="TextBox 46">
-            <a:extLst>
-              <a:ext uri="{FF2B5EF4-FFF2-40B4-BE49-F238E27FC236}">
-                <a16:creationId xmlns:a16="http://schemas.microsoft.com/office/drawing/2014/main" id="{E5A4E198-88D5-A962-8272-D77462BC6181}"/>
-              </a:ext>
-            </a:extLst>
-          </p:cNvPr>
-          <p:cNvSpPr txBox="1"/>
-          <p:nvPr/>
-        </p:nvSpPr>
-        <p:spPr>
-          <a:xfrm>
-            <a:off x="6833138" y="1810366"/>
-            <a:ext cx="521297" cy="461665"/>
-          </a:xfrm>
-          <a:prstGeom prst="rect">
-            <a:avLst/>
-          </a:prstGeom>
-          <a:noFill/>
-        </p:spPr>
-        <p:txBody>
-          <a:bodyPr wrap="square" rtlCol="0">
-            <a:spAutoFit/>
-          </a:bodyPr>
-          <a:lstStyle/>
-          <a:p>
-            <a:r>
-              <a:rPr lang="en-US" sz="2400" dirty="0">
-                <a:latin typeface="Arial" panose="020B0604020202020204" pitchFamily="34" charset="0"/>
-                <a:cs typeface="Arial" panose="020B0604020202020204" pitchFamily="34" charset="0"/>
-              </a:rPr>
-              <a:t>R</a:t>
-            </a:r>
-            <a:r>
-              <a:rPr lang="en-US" sz="2400" baseline="-25000" dirty="0">
-                <a:latin typeface="Arial" panose="020B0604020202020204" pitchFamily="34" charset="0"/>
-                <a:cs typeface="Arial" panose="020B0604020202020204" pitchFamily="34" charset="0"/>
-              </a:rPr>
-              <a:t>2</a:t>
-            </a:r>
-            <a:endParaRPr lang="en-GB" sz="2400" dirty="0">
-              <a:latin typeface="Arial" panose="020B0604020202020204" pitchFamily="34" charset="0"/>
-              <a:cs typeface="Arial" panose="020B0604020202020204" pitchFamily="34" charset="0"/>
-            </a:endParaRPr>
-          </a:p>
-        </p:txBody>
-      </p:sp>
-      <p:sp>
-        <p:nvSpPr>
-          <p:cNvPr id="48" name="TextBox 47">
-            <a:extLst>
-              <a:ext uri="{FF2B5EF4-FFF2-40B4-BE49-F238E27FC236}">
-                <a16:creationId xmlns:a16="http://schemas.microsoft.com/office/drawing/2014/main" id="{6975321D-45E2-AB97-A7B5-0408E4773235}"/>
-              </a:ext>
-            </a:extLst>
-          </p:cNvPr>
-          <p:cNvSpPr txBox="1"/>
-          <p:nvPr/>
-        </p:nvSpPr>
-        <p:spPr>
-          <a:xfrm>
-            <a:off x="8070147" y="1808106"/>
-            <a:ext cx="521297" cy="461665"/>
-          </a:xfrm>
-          <a:prstGeom prst="rect">
-            <a:avLst/>
-          </a:prstGeom>
-          <a:noFill/>
-        </p:spPr>
-        <p:txBody>
-          <a:bodyPr wrap="square" rtlCol="0">
-            <a:spAutoFit/>
-          </a:bodyPr>
-          <a:lstStyle/>
-          <a:p>
-            <a:r>
-              <a:rPr lang="en-US" sz="2400" dirty="0">
-                <a:latin typeface="Arial" panose="020B0604020202020204" pitchFamily="34" charset="0"/>
-                <a:cs typeface="Arial" panose="020B0604020202020204" pitchFamily="34" charset="0"/>
-              </a:rPr>
-              <a:t>R</a:t>
-            </a:r>
-            <a:r>
-              <a:rPr lang="en-US" sz="2400" baseline="-25000" dirty="0">
-                <a:latin typeface="Arial" panose="020B0604020202020204" pitchFamily="34" charset="0"/>
-                <a:cs typeface="Arial" panose="020B0604020202020204" pitchFamily="34" charset="0"/>
-              </a:rPr>
-              <a:t>1</a:t>
-            </a:r>
-            <a:endParaRPr lang="en-GB" sz="2400" dirty="0">
-              <a:latin typeface="Arial" panose="020B0604020202020204" pitchFamily="34" charset="0"/>
-              <a:cs typeface="Arial" panose="020B0604020202020204" pitchFamily="34" charset="0"/>
-            </a:endParaRPr>
-          </a:p>
-        </p:txBody>
-      </p:sp>
-      <p:cxnSp>
-        <p:nvCxnSpPr>
-          <p:cNvPr id="54" name="Straight Arrow Connector 53">
-            <a:extLst>
-              <a:ext uri="{FF2B5EF4-FFF2-40B4-BE49-F238E27FC236}">
-                <a16:creationId xmlns:a16="http://schemas.microsoft.com/office/drawing/2014/main" id="{90E1AC66-5568-7FAE-96E5-10169FD28F2D}"/>
-              </a:ext>
-            </a:extLst>
-          </p:cNvPr>
-          <p:cNvCxnSpPr>
-            <a:cxnSpLocks/>
-          </p:cNvCxnSpPr>
-          <p:nvPr/>
-        </p:nvCxnSpPr>
-        <p:spPr>
-          <a:xfrm flipV="1">
-            <a:off x="5778020" y="1685297"/>
-            <a:ext cx="1308580" cy="1127013"/>
-          </a:xfrm>
-          <a:prstGeom prst="straightConnector1">
-            <a:avLst/>
-          </a:prstGeom>
-          <a:ln w="57150">
-            <a:solidFill>
-              <a:schemeClr val="accent2"/>
-            </a:solidFill>
-            <a:prstDash val="dash"/>
-            <a:tailEnd type="triangle"/>
-          </a:ln>
-        </p:spPr>
-        <p:style>
-          <a:lnRef idx="2">
-            <a:schemeClr val="accent1"/>
-          </a:lnRef>
-          <a:fillRef idx="0">
-            <a:schemeClr val="accent1"/>
-          </a:fillRef>
-          <a:effectRef idx="1">
-            <a:schemeClr val="accent1"/>
-          </a:effectRef>
-          <a:fontRef idx="minor">
-            <a:schemeClr val="tx1"/>
-          </a:fontRef>
-        </p:style>
-      </p:cxnSp>
-      <p:sp>
-        <p:nvSpPr>
-          <p:cNvPr id="66" name="Right Brace 65">
-            <a:extLst>
-              <a:ext uri="{FF2B5EF4-FFF2-40B4-BE49-F238E27FC236}">
-                <a16:creationId xmlns:a16="http://schemas.microsoft.com/office/drawing/2014/main" id="{72F1F781-8B83-9D86-1431-22905D416A8E}"/>
-              </a:ext>
-            </a:extLst>
-          </p:cNvPr>
-          <p:cNvSpPr/>
-          <p:nvPr/>
-        </p:nvSpPr>
-        <p:spPr>
-          <a:xfrm>
-            <a:off x="8207277" y="2838188"/>
-            <a:ext cx="213360" cy="1030700"/>
-          </a:xfrm>
-          <a:prstGeom prst="rightBrace">
-            <a:avLst>
-              <a:gd name="adj1" fmla="val 8333"/>
-              <a:gd name="adj2" fmla="val 51479"/>
-            </a:avLst>
-          </a:prstGeom>
-          <a:ln>
-            <a:solidFill>
-              <a:schemeClr val="tx1"/>
-            </a:solidFill>
-          </a:ln>
-        </p:spPr>
-        <p:style>
-          <a:lnRef idx="2">
-            <a:schemeClr val="accent1"/>
-          </a:lnRef>
-          <a:fillRef idx="0">
-            <a:schemeClr val="accent1"/>
-          </a:fillRef>
-          <a:effectRef idx="1">
-            <a:schemeClr val="accent1"/>
-          </a:effectRef>
-          <a:fontRef idx="minor">
-            <a:schemeClr val="tx1"/>
-          </a:fontRef>
-        </p:style>
-        <p:txBody>
-          <a:bodyPr rtlCol="0" anchor="ctr"/>
-          <a:lstStyle/>
-          <a:p>
-            <a:pPr algn="ctr"/>
-            <a:endParaRPr lang="en-GB"/>
-          </a:p>
-        </p:txBody>
-      </p:sp>
-      <mc:AlternateContent xmlns:mc="http://schemas.openxmlformats.org/markup-compatibility/2006" xmlns:a14="http://schemas.microsoft.com/office/drawing/2010/main">
-        <mc:Choice Requires="a14">
+                </a:fontRef>
+              </p:style>
+            </p:cxnSp>
+            <p:sp>
+              <p:nvSpPr>
+                <p:cNvPr id="47" name="TextBox 46">
+                  <a:extLst>
+                    <a:ext uri="{FF2B5EF4-FFF2-40B4-BE49-F238E27FC236}">
+                      <a16:creationId xmlns:a16="http://schemas.microsoft.com/office/drawing/2014/main" id="{E5A4E198-88D5-A962-8272-D77462BC6181}"/>
+                    </a:ext>
+                  </a:extLst>
+                </p:cNvPr>
+                <p:cNvSpPr txBox="1"/>
+                <p:nvPr/>
+              </p:nvSpPr>
+              <p:spPr>
+                <a:xfrm>
+                  <a:off x="7225865" y="1665960"/>
+                  <a:ext cx="753850" cy="569798"/>
+                </a:xfrm>
+                <a:prstGeom prst="rect">
+                  <a:avLst/>
+                </a:prstGeom>
+                <a:noFill/>
+              </p:spPr>
+              <p:txBody>
+                <a:bodyPr wrap="square" rtlCol="0">
+                  <a:spAutoFit/>
+                </a:bodyPr>
+                <a:lstStyle/>
+                <a:p>
+                  <a:r>
+                    <a:rPr lang="en-US" sz="1600" dirty="0">
+                      <a:latin typeface="Arial" panose="020B0604020202020204" pitchFamily="34" charset="0"/>
+                      <a:cs typeface="Arial" panose="020B0604020202020204" pitchFamily="34" charset="0"/>
+                    </a:rPr>
+                    <a:t>R</a:t>
+                  </a:r>
+                  <a:r>
+                    <a:rPr lang="en-US" sz="1600" baseline="-25000" dirty="0">
+                      <a:latin typeface="Arial" panose="020B0604020202020204" pitchFamily="34" charset="0"/>
+                      <a:cs typeface="Arial" panose="020B0604020202020204" pitchFamily="34" charset="0"/>
+                    </a:rPr>
+                    <a:t>2</a:t>
+                  </a:r>
+                  <a:endParaRPr lang="en-GB" sz="1600" dirty="0">
+                    <a:latin typeface="Arial" panose="020B0604020202020204" pitchFamily="34" charset="0"/>
+                    <a:cs typeface="Arial" panose="020B0604020202020204" pitchFamily="34" charset="0"/>
+                  </a:endParaRPr>
+                </a:p>
+              </p:txBody>
+            </p:sp>
+            <p:sp>
+              <p:nvSpPr>
+                <p:cNvPr id="48" name="TextBox 47">
+                  <a:extLst>
+                    <a:ext uri="{FF2B5EF4-FFF2-40B4-BE49-F238E27FC236}">
+                      <a16:creationId xmlns:a16="http://schemas.microsoft.com/office/drawing/2014/main" id="{6975321D-45E2-AB97-A7B5-0408E4773235}"/>
+                    </a:ext>
+                  </a:extLst>
+                </p:cNvPr>
+                <p:cNvSpPr txBox="1"/>
+                <p:nvPr/>
+              </p:nvSpPr>
+              <p:spPr>
+                <a:xfrm>
+                  <a:off x="8462875" y="1663700"/>
+                  <a:ext cx="753850" cy="569798"/>
+                </a:xfrm>
+                <a:prstGeom prst="rect">
+                  <a:avLst/>
+                </a:prstGeom>
+                <a:noFill/>
+              </p:spPr>
+              <p:txBody>
+                <a:bodyPr wrap="square" rtlCol="0">
+                  <a:spAutoFit/>
+                </a:bodyPr>
+                <a:lstStyle/>
+                <a:p>
+                  <a:r>
+                    <a:rPr lang="en-US" sz="1600" dirty="0">
+                      <a:latin typeface="Arial" panose="020B0604020202020204" pitchFamily="34" charset="0"/>
+                      <a:cs typeface="Arial" panose="020B0604020202020204" pitchFamily="34" charset="0"/>
+                    </a:rPr>
+                    <a:t>R</a:t>
+                  </a:r>
+                  <a:r>
+                    <a:rPr lang="en-US" sz="1600" baseline="-25000" dirty="0">
+                      <a:latin typeface="Arial" panose="020B0604020202020204" pitchFamily="34" charset="0"/>
+                      <a:cs typeface="Arial" panose="020B0604020202020204" pitchFamily="34" charset="0"/>
+                    </a:rPr>
+                    <a:t>1</a:t>
+                  </a:r>
+                  <a:endParaRPr lang="en-GB" sz="1600" dirty="0">
+                    <a:latin typeface="Arial" panose="020B0604020202020204" pitchFamily="34" charset="0"/>
+                    <a:cs typeface="Arial" panose="020B0604020202020204" pitchFamily="34" charset="0"/>
+                  </a:endParaRPr>
+                </a:p>
+              </p:txBody>
+            </p:sp>
+            <p:cxnSp>
+              <p:nvCxnSpPr>
+                <p:cNvPr id="54" name="Straight Arrow Connector 53">
+                  <a:extLst>
+                    <a:ext uri="{FF2B5EF4-FFF2-40B4-BE49-F238E27FC236}">
+                      <a16:creationId xmlns:a16="http://schemas.microsoft.com/office/drawing/2014/main" id="{90E1AC66-5568-7FAE-96E5-10169FD28F2D}"/>
+                    </a:ext>
+                  </a:extLst>
+                </p:cNvPr>
+                <p:cNvCxnSpPr>
+                  <a:cxnSpLocks/>
+                </p:cNvCxnSpPr>
+                <p:nvPr/>
+              </p:nvCxnSpPr>
+              <p:spPr>
+                <a:xfrm flipV="1">
+                  <a:off x="5968551" y="1685297"/>
+                  <a:ext cx="1308579" cy="1127012"/>
+                </a:xfrm>
+                <a:prstGeom prst="straightConnector1">
+                  <a:avLst/>
+                </a:prstGeom>
+                <a:ln w="57150">
+                  <a:solidFill>
+                    <a:schemeClr val="accent2"/>
+                  </a:solidFill>
+                  <a:prstDash val="dash"/>
+                  <a:tailEnd type="triangle"/>
+                </a:ln>
+              </p:spPr>
+              <p:style>
+                <a:lnRef idx="2">
+                  <a:schemeClr val="accent1"/>
+                </a:lnRef>
+                <a:fillRef idx="0">
+                  <a:schemeClr val="accent1"/>
+                </a:fillRef>
+                <a:effectRef idx="1">
+                  <a:schemeClr val="accent1"/>
+                </a:effectRef>
+                <a:fontRef idx="minor">
+                  <a:schemeClr val="tx1"/>
+                </a:fontRef>
+              </p:style>
+            </p:cxnSp>
+            <p:sp>
+              <p:nvSpPr>
+                <p:cNvPr id="66" name="Right Brace 65">
+                  <a:extLst>
+                    <a:ext uri="{FF2B5EF4-FFF2-40B4-BE49-F238E27FC236}">
+                      <a16:creationId xmlns:a16="http://schemas.microsoft.com/office/drawing/2014/main" id="{72F1F781-8B83-9D86-1431-22905D416A8E}"/>
+                    </a:ext>
+                  </a:extLst>
+                </p:cNvPr>
+                <p:cNvSpPr/>
+                <p:nvPr/>
+              </p:nvSpPr>
+              <p:spPr>
+                <a:xfrm>
+                  <a:off x="7645641" y="2838189"/>
+                  <a:ext cx="213360" cy="1030700"/>
+                </a:xfrm>
+                <a:prstGeom prst="rightBrace">
+                  <a:avLst>
+                    <a:gd name="adj1" fmla="val 8333"/>
+                    <a:gd name="adj2" fmla="val 51479"/>
+                  </a:avLst>
+                </a:prstGeom>
+                <a:ln>
+                  <a:solidFill>
+                    <a:schemeClr val="tx1"/>
+                  </a:solidFill>
+                </a:ln>
+              </p:spPr>
+              <p:style>
+                <a:lnRef idx="2">
+                  <a:schemeClr val="accent1"/>
+                </a:lnRef>
+                <a:fillRef idx="0">
+                  <a:schemeClr val="accent1"/>
+                </a:fillRef>
+                <a:effectRef idx="1">
+                  <a:schemeClr val="accent1"/>
+                </a:effectRef>
+                <a:fontRef idx="minor">
+                  <a:schemeClr val="tx1"/>
+                </a:fontRef>
+              </p:style>
+              <p:txBody>
+                <a:bodyPr rtlCol="0" anchor="ctr"/>
+                <a:lstStyle/>
+                <a:p>
+                  <a:pPr algn="ctr"/>
+                  <a:endParaRPr lang="en-GB"/>
+                </a:p>
+              </p:txBody>
+            </p:sp>
+            <mc:AlternateContent xmlns:mc="http://schemas.openxmlformats.org/markup-compatibility/2006">
+              <mc:Choice xmlns:a14="http://schemas.microsoft.com/office/drawing/2010/main" Requires="a14">
+                <p:sp>
+                  <p:nvSpPr>
+                    <p:cNvPr id="67" name="TextBox 66">
+                      <a:extLst>
+                        <a:ext uri="{FF2B5EF4-FFF2-40B4-BE49-F238E27FC236}">
+                          <a16:creationId xmlns:a16="http://schemas.microsoft.com/office/drawing/2014/main" id="{DA108C06-DFC5-4089-E587-AD31D5C8FDDE}"/>
+                        </a:ext>
+                      </a:extLst>
+                    </p:cNvPr>
+                    <p:cNvSpPr txBox="1"/>
+                    <p:nvPr/>
+                  </p:nvSpPr>
+                  <p:spPr>
+                    <a:xfrm>
+                      <a:off x="7759927" y="2963721"/>
+                      <a:ext cx="1094861" cy="701305"/>
+                    </a:xfrm>
+                    <a:prstGeom prst="rect">
+                      <a:avLst/>
+                    </a:prstGeom>
+                    <a:noFill/>
+                  </p:spPr>
+                  <p:txBody>
+                    <a:bodyPr wrap="none" rtlCol="0">
+                      <a:spAutoFit/>
+                    </a:bodyPr>
+                    <a:lstStyle/>
+                    <a:p>
+                      <a:pPr/>
+                      <a:r>
+                        <a:rPr lang="en-GB" sz="1600" i="1" dirty="0"/>
+                        <a:t>OT</a:t>
+                      </a:r>
+                      <a:r>
+                        <a:rPr lang="en-GB" sz="1600" dirty="0"/>
+                        <a:t> = </a:t>
+                      </a:r>
+                      <a14:m>
+                        <m:oMath xmlns:m="http://schemas.openxmlformats.org/officeDocument/2006/math">
+                          <m:f>
+                            <m:fPr>
+                              <m:ctrlPr>
+                                <a:rPr lang="en-GB" sz="1600" i="1" smtClean="0">
+                                  <a:latin typeface="Cambria Math" panose="02040503050406030204" pitchFamily="18" charset="0"/>
+                                </a:rPr>
+                              </m:ctrlPr>
+                            </m:fPr>
+                            <m:num>
+                              <m:r>
+                                <a:rPr lang="en-GB" sz="1600" i="1" smtClean="0">
+                                  <a:latin typeface="Cambria Math" panose="02040503050406030204" pitchFamily="18" charset="0"/>
+                                  <a:ea typeface="Cambria Math" panose="02040503050406030204" pitchFamily="18" charset="0"/>
+                                </a:rPr>
+                                <m:t>𝜆</m:t>
+                              </m:r>
+                            </m:num>
+                            <m:den>
+                              <m:r>
+                                <a:rPr lang="en-US" sz="1600" b="0" i="1" smtClean="0">
+                                  <a:latin typeface="Cambria Math" panose="02040503050406030204" pitchFamily="18" charset="0"/>
+                                </a:rPr>
+                                <m:t>4</m:t>
+                              </m:r>
+                            </m:den>
+                          </m:f>
+                        </m:oMath>
+                      </a14:m>
+                      <a:endParaRPr lang="en-GB" sz="1600" dirty="0"/>
+                    </a:p>
+                  </p:txBody>
+                </p:sp>
+              </mc:Choice>
+              <mc:Fallback>
+                <p:sp>
+                  <p:nvSpPr>
+                    <p:cNvPr id="67" name="TextBox 66">
+                      <a:extLst>
+                        <a:ext uri="{FF2B5EF4-FFF2-40B4-BE49-F238E27FC236}">
+                          <a16:creationId xmlns:a16="http://schemas.microsoft.com/office/drawing/2014/main" id="{DA108C06-DFC5-4089-E587-AD31D5C8FDDE}"/>
+                        </a:ext>
+                      </a:extLst>
+                    </p:cNvPr>
+                    <p:cNvSpPr txBox="1">
+                      <a:spLocks noRot="1" noChangeAspect="1" noMove="1" noResize="1" noEditPoints="1" noAdjustHandles="1" noChangeArrowheads="1" noChangeShapeType="1" noTextEdit="1"/>
+                    </p:cNvSpPr>
+                    <p:nvPr/>
+                  </p:nvSpPr>
+                  <p:spPr>
+                    <a:xfrm>
+                      <a:off x="7759927" y="2963721"/>
+                      <a:ext cx="1094861" cy="701305"/>
+                    </a:xfrm>
+                    <a:prstGeom prst="rect">
+                      <a:avLst/>
+                    </a:prstGeom>
+                    <a:blipFill>
+                      <a:blip r:embed="rId4"/>
+                      <a:stretch>
+                        <a:fillRect l="-5660" r="-1887" b="-16176"/>
+                      </a:stretch>
+                    </a:blipFill>
+                  </p:spPr>
+                  <p:txBody>
+                    <a:bodyPr/>
+                    <a:lstStyle/>
+                    <a:p>
+                      <a:r>
+                        <a:rPr lang="en-GB">
+                          <a:noFill/>
+                        </a:rPr>
+                        <a:t> </a:t>
+                      </a:r>
+                    </a:p>
+                  </p:txBody>
+                </p:sp>
+              </mc:Fallback>
+            </mc:AlternateContent>
+            <p:sp>
+              <p:nvSpPr>
+                <p:cNvPr id="68" name="TextBox 67">
+                  <a:extLst>
+                    <a:ext uri="{FF2B5EF4-FFF2-40B4-BE49-F238E27FC236}">
+                      <a16:creationId xmlns:a16="http://schemas.microsoft.com/office/drawing/2014/main" id="{B8A2F634-2561-D36F-7A29-B3E4BBF61D72}"/>
+                    </a:ext>
+                  </a:extLst>
+                </p:cNvPr>
+                <p:cNvSpPr txBox="1"/>
+                <p:nvPr/>
+              </p:nvSpPr>
+              <p:spPr>
+                <a:xfrm>
+                  <a:off x="3556236" y="1685298"/>
+                  <a:ext cx="673301" cy="524341"/>
+                </a:xfrm>
+                <a:prstGeom prst="rect">
+                  <a:avLst/>
+                </a:prstGeom>
+                <a:noFill/>
+              </p:spPr>
+              <p:txBody>
+                <a:bodyPr wrap="none" rtlCol="0">
+                  <a:spAutoFit/>
+                </a:bodyPr>
+                <a:lstStyle/>
+                <a:p>
+                  <a:r>
+                    <a:rPr lang="en-US" sz="1600" dirty="0">
+                      <a:latin typeface="Arial" panose="020B0604020202020204" pitchFamily="34" charset="0"/>
+                      <a:cs typeface="Arial" panose="020B0604020202020204" pitchFamily="34" charset="0"/>
+                    </a:rPr>
+                    <a:t>Air</a:t>
+                  </a:r>
+                  <a:endParaRPr lang="en-GB" sz="1600" dirty="0">
+                    <a:latin typeface="Arial" panose="020B0604020202020204" pitchFamily="34" charset="0"/>
+                    <a:cs typeface="Arial" panose="020B0604020202020204" pitchFamily="34" charset="0"/>
+                  </a:endParaRPr>
+                </a:p>
+              </p:txBody>
+            </p:sp>
+          </p:grpSp>
           <p:sp>
             <p:nvSpPr>
-              <p:cNvPr id="67" name="TextBox 66">
+              <p:cNvPr id="11" name="TextBox 10">
                 <a:extLst>
                   <a:ext uri="{FF2B5EF4-FFF2-40B4-BE49-F238E27FC236}">
-                    <a16:creationId xmlns:a16="http://schemas.microsoft.com/office/drawing/2014/main" id="{DA108C06-DFC5-4089-E587-AD31D5C8FDDE}"/>
+                    <a16:creationId xmlns:a16="http://schemas.microsoft.com/office/drawing/2014/main" id="{2199031D-E2B1-E1B6-51F3-80E9C3D09253}"/>
                   </a:ext>
                 </a:extLst>
               </p:cNvPr>
@@ -7750,9 +8298,9 @@
               <p:nvPr/>
             </p:nvSpPr>
             <p:spPr>
-              <a:xfrm>
-                <a:off x="8377507" y="2975136"/>
-                <a:ext cx="417102" cy="791307"/>
+              <a:xfrm rot="16200000">
+                <a:off x="8657803" y="672768"/>
+                <a:ext cx="1371273" cy="347591"/>
               </a:xfrm>
               <a:prstGeom prst="rect">
                 <a:avLst/>
@@ -7765,134 +8313,23 @@
               </a:bodyPr>
               <a:lstStyle/>
               <a:p>
-                <a:pPr/>
-                <a14:m>
-                  <m:oMathPara xmlns:m="http://schemas.openxmlformats.org/officeDocument/2006/math">
-                    <m:oMathParaPr>
-                      <m:jc m:val="centerGroup"/>
-                    </m:oMathParaPr>
-                    <m:oMath xmlns:m="http://schemas.openxmlformats.org/officeDocument/2006/math">
-                      <m:f>
-                        <m:fPr>
-                          <m:ctrlPr>
-                            <a:rPr lang="en-GB" sz="2400" i="1" smtClean="0">
-                              <a:latin typeface="Cambria Math" panose="02040503050406030204" pitchFamily="18" charset="0"/>
-                            </a:rPr>
-                          </m:ctrlPr>
-                        </m:fPr>
-                        <m:num>
-                          <m:r>
-                            <a:rPr lang="en-GB" sz="2400" i="1" smtClean="0">
-                              <a:latin typeface="Cambria Math" panose="02040503050406030204" pitchFamily="18" charset="0"/>
-                              <a:ea typeface="Cambria Math" panose="02040503050406030204" pitchFamily="18" charset="0"/>
-                            </a:rPr>
-                            <m:t>𝜆</m:t>
-                          </m:r>
-                        </m:num>
-                        <m:den>
-                          <m:r>
-                            <a:rPr lang="en-US" sz="2400" b="0" i="1" smtClean="0">
-                              <a:latin typeface="Cambria Math" panose="02040503050406030204" pitchFamily="18" charset="0"/>
-                            </a:rPr>
-                            <m:t>4</m:t>
-                          </m:r>
-                        </m:den>
-                      </m:f>
-                    </m:oMath>
-                  </m:oMathPara>
-                </a14:m>
-                <a:endParaRPr lang="en-GB" sz="2400" dirty="0"/>
+                <a:pPr algn="r"/>
+                <a:r>
+                  <a:rPr lang="en-US" sz="1600" dirty="0">
+                    <a:latin typeface="Arial" panose="020B0604020202020204" pitchFamily="34" charset="0"/>
+                    <a:cs typeface="Arial" panose="020B0604020202020204" pitchFamily="34" charset="0"/>
+                  </a:rPr>
+                  <a:t>Incident light</a:t>
+                </a:r>
+                <a:endParaRPr lang="en-GB" sz="1600" dirty="0">
+                  <a:latin typeface="Arial" panose="020B0604020202020204" pitchFamily="34" charset="0"/>
+                  <a:cs typeface="Arial" panose="020B0604020202020204" pitchFamily="34" charset="0"/>
+                </a:endParaRPr>
               </a:p>
             </p:txBody>
           </p:sp>
-        </mc:Choice>
-        <mc:Fallback xmlns="">
-          <p:sp>
-            <p:nvSpPr>
-              <p:cNvPr id="67" name="TextBox 66">
-                <a:extLst>
-                  <a:ext uri="{FF2B5EF4-FFF2-40B4-BE49-F238E27FC236}">
-                    <a16:creationId xmlns:a16="http://schemas.microsoft.com/office/drawing/2014/main" id="{DA108C06-DFC5-4089-E587-AD31D5C8FDDE}"/>
-                  </a:ext>
-                </a:extLst>
-              </p:cNvPr>
-              <p:cNvSpPr txBox="1">
-                <a:spLocks noRot="1" noChangeAspect="1" noMove="1" noResize="1" noEditPoints="1" noAdjustHandles="1" noChangeArrowheads="1" noChangeShapeType="1" noTextEdit="1"/>
-              </p:cNvSpPr>
-              <p:nvPr/>
-            </p:nvSpPr>
-            <p:spPr>
-              <a:xfrm>
-                <a:off x="8377507" y="2975136"/>
-                <a:ext cx="417102" cy="791307"/>
-              </a:xfrm>
-              <a:prstGeom prst="rect">
-                <a:avLst/>
-              </a:prstGeom>
-              <a:blipFill>
-                <a:blip r:embed="rId3"/>
-                <a:stretch>
-                  <a:fillRect/>
-                </a:stretch>
-              </a:blipFill>
-            </p:spPr>
-            <p:txBody>
-              <a:bodyPr/>
-              <a:lstStyle/>
-              <a:p>
-                <a:r>
-                  <a:rPr lang="en-GB">
-                    <a:noFill/>
-                  </a:rPr>
-                  <a:t> </a:t>
-                </a:r>
-              </a:p>
-            </p:txBody>
-          </p:sp>
-        </mc:Fallback>
-      </mc:AlternateContent>
-      <p:sp>
-        <p:nvSpPr>
-          <p:cNvPr id="68" name="TextBox 67">
-            <a:extLst>
-              <a:ext uri="{FF2B5EF4-FFF2-40B4-BE49-F238E27FC236}">
-                <a16:creationId xmlns:a16="http://schemas.microsoft.com/office/drawing/2014/main" id="{B8A2F634-2561-D36F-7A29-B3E4BBF61D72}"/>
-              </a:ext>
-            </a:extLst>
-          </p:cNvPr>
-          <p:cNvSpPr txBox="1"/>
-          <p:nvPr/>
-        </p:nvSpPr>
-        <p:spPr>
-          <a:xfrm>
-            <a:off x="3556236" y="1693806"/>
-            <a:ext cx="561372" cy="461665"/>
-          </a:xfrm>
-          <a:prstGeom prst="rect">
-            <a:avLst/>
-          </a:prstGeom>
-          <a:noFill/>
-        </p:spPr>
-        <p:txBody>
-          <a:bodyPr wrap="none" rtlCol="0">
-            <a:spAutoFit/>
-          </a:bodyPr>
-          <a:lstStyle/>
-          <a:p>
-            <a:r>
-              <a:rPr lang="en-US" sz="2400" dirty="0">
-                <a:latin typeface="Arial" panose="020B0604020202020204" pitchFamily="34" charset="0"/>
-                <a:cs typeface="Arial" panose="020B0604020202020204" pitchFamily="34" charset="0"/>
-              </a:rPr>
-              <a:t>Air</a:t>
-            </a:r>
-            <a:endParaRPr lang="en-GB" sz="2400" dirty="0">
-              <a:latin typeface="Arial" panose="020B0604020202020204" pitchFamily="34" charset="0"/>
-              <a:cs typeface="Arial" panose="020B0604020202020204" pitchFamily="34" charset="0"/>
-            </a:endParaRPr>
-          </a:p>
-        </p:txBody>
-      </p:sp>
+        </p:grpSp>
+      </p:grpSp>
     </p:spTree>
     <p:extLst>
       <p:ext uri="{BB962C8B-B14F-4D97-AF65-F5344CB8AC3E}">
@@ -9403,11 +9840,17 @@
 </file>
 
 <file path=ppt/slides/slide3.xml><?xml version="1.0" encoding="utf-8"?>
-<p:sld xmlns:a="http://schemas.openxmlformats.org/drawingml/2006/main" xmlns:r="http://schemas.openxmlformats.org/officeDocument/2006/relationships" xmlns:p="http://schemas.openxmlformats.org/presentationml/2006/main">
+<p:sld xmlns:a="http://schemas.openxmlformats.org/drawingml/2006/main" xmlns:r="http://schemas.openxmlformats.org/officeDocument/2006/relationships" xmlns:p="http://schemas.openxmlformats.org/presentationml/2006/main" show="0">
   <p:cSld>
     <p:spTree>
       <p:nvGrpSpPr>
-        <p:cNvPr id="1" name=""/>
+        <p:cNvPr id="1" name="">
+          <a:extLst>
+            <a:ext uri="{FF2B5EF4-FFF2-40B4-BE49-F238E27FC236}">
+              <a16:creationId xmlns:a16="http://schemas.microsoft.com/office/drawing/2014/main" id="{E3B9F248-2C86-667B-BE78-0E3747C47E59}"/>
+            </a:ext>
+          </a:extLst>
+        </p:cNvPr>
         <p:cNvGrpSpPr/>
         <p:nvPr/>
       </p:nvGrpSpPr>
@@ -9421,10 +9864,10 @@
       </p:grpSpPr>
       <p:pic>
         <p:nvPicPr>
-          <p:cNvPr id="24" name="Picture 23">
-            <a:extLst>
-              <a:ext uri="{FF2B5EF4-FFF2-40B4-BE49-F238E27FC236}">
-                <a16:creationId xmlns:a16="http://schemas.microsoft.com/office/drawing/2014/main" id="{CDA26CED-98F1-D813-8804-C7718406476D}"/>
+          <p:cNvPr id="8" name="Picture 7">
+            <a:extLst>
+              <a:ext uri="{FF2B5EF4-FFF2-40B4-BE49-F238E27FC236}">
+                <a16:creationId xmlns:a16="http://schemas.microsoft.com/office/drawing/2014/main" id="{60C7E9EE-DF92-0054-0EBD-735BD8F50AA3}"/>
               </a:ext>
             </a:extLst>
           </p:cNvPr>
@@ -9434,32 +9877,638 @@
           <p:nvPr/>
         </p:nvPicPr>
         <p:blipFill>
-          <a:blip r:embed="rId2">
+          <a:blip r:embed="rId3">
             <a:extLst>
               <a:ext uri="{28A0092B-C50C-407E-A947-70E740481C1C}">
                 <a14:useLocalDpi xmlns:a14="http://schemas.microsoft.com/office/drawing/2010/main" val="0"/>
               </a:ext>
             </a:extLst>
           </a:blip>
-          <a:srcRect l="2366" t="3103" r="2366" b="3103"/>
+          <a:srcRect l="7633" t="10921" r="7633" b="4635"/>
           <a:stretch>
             <a:fillRect/>
           </a:stretch>
         </p:blipFill>
         <p:spPr>
           <a:xfrm>
-            <a:off x="491707" y="5020"/>
-            <a:ext cx="10834776" cy="6857585"/>
+            <a:off x="3918326" y="776394"/>
+            <a:ext cx="8273674" cy="5300574"/>
           </a:xfrm>
           <a:prstGeom prst="rect">
             <a:avLst/>
           </a:prstGeom>
         </p:spPr>
       </p:pic>
+      <p:grpSp>
+        <p:nvGrpSpPr>
+          <p:cNvPr id="6" name="Group 5">
+            <a:extLst>
+              <a:ext uri="{FF2B5EF4-FFF2-40B4-BE49-F238E27FC236}">
+                <a16:creationId xmlns:a16="http://schemas.microsoft.com/office/drawing/2014/main" id="{7FA94519-D387-597F-C427-D814586FC8D2}"/>
+              </a:ext>
+            </a:extLst>
+          </p:cNvPr>
+          <p:cNvGrpSpPr/>
+          <p:nvPr/>
+        </p:nvGrpSpPr>
+        <p:grpSpPr>
+          <a:xfrm>
+            <a:off x="430932" y="2905436"/>
+            <a:ext cx="3487394" cy="2749369"/>
+            <a:chOff x="3556236" y="1663700"/>
+            <a:chExt cx="5401156" cy="4258129"/>
+          </a:xfrm>
+          <a:effectLst/>
+        </p:grpSpPr>
+        <p:sp>
+          <p:nvSpPr>
+            <p:cNvPr id="2" name="Rectangle 1">
+              <a:extLst>
+                <a:ext uri="{FF2B5EF4-FFF2-40B4-BE49-F238E27FC236}">
+                  <a16:creationId xmlns:a16="http://schemas.microsoft.com/office/drawing/2014/main" id="{7CEDCD55-6674-8602-E384-98D626832A84}"/>
+                </a:ext>
+              </a:extLst>
+            </p:cNvPr>
+            <p:cNvSpPr/>
+            <p:nvPr/>
+          </p:nvSpPr>
+          <p:spPr>
+            <a:xfrm>
+              <a:off x="3556236" y="3880739"/>
+              <a:ext cx="5281502" cy="1570827"/>
+            </a:xfrm>
+            <a:prstGeom prst="rect">
+              <a:avLst/>
+            </a:prstGeom>
+            <a:solidFill>
+              <a:schemeClr val="tx2">
+                <a:lumMod val="25000"/>
+                <a:lumOff val="75000"/>
+              </a:schemeClr>
+            </a:solidFill>
+            <a:ln>
+              <a:noFill/>
+            </a:ln>
+          </p:spPr>
+          <p:style>
+            <a:lnRef idx="2">
+              <a:schemeClr val="accent1">
+                <a:shade val="15000"/>
+              </a:schemeClr>
+            </a:lnRef>
+            <a:fillRef idx="1">
+              <a:schemeClr val="accent1"/>
+            </a:fillRef>
+            <a:effectRef idx="0">
+              <a:schemeClr val="accent1"/>
+            </a:effectRef>
+            <a:fontRef idx="minor">
+              <a:schemeClr val="lt1"/>
+            </a:fontRef>
+          </p:style>
+          <p:txBody>
+            <a:bodyPr rtlCol="0" anchor="t"/>
+            <a:lstStyle/>
+            <a:p>
+              <a:r>
+                <a:rPr lang="en-US" sz="1600" dirty="0">
+                  <a:solidFill>
+                    <a:schemeClr val="tx1"/>
+                  </a:solidFill>
+                  <a:latin typeface="Arial" panose="020B0604020202020204" pitchFamily="34" charset="0"/>
+                  <a:cs typeface="Arial" panose="020B0604020202020204" pitchFamily="34" charset="0"/>
+                </a:rPr>
+                <a:t>Substrate</a:t>
+              </a:r>
+              <a:endParaRPr lang="en-GB" sz="1600" dirty="0">
+                <a:solidFill>
+                  <a:schemeClr val="tx1"/>
+                </a:solidFill>
+                <a:latin typeface="Arial" panose="020B0604020202020204" pitchFamily="34" charset="0"/>
+                <a:cs typeface="Arial" panose="020B0604020202020204" pitchFamily="34" charset="0"/>
+              </a:endParaRPr>
+            </a:p>
+          </p:txBody>
+        </p:sp>
+        <p:sp>
+          <p:nvSpPr>
+            <p:cNvPr id="3" name="Rectangle 2">
+              <a:extLst>
+                <a:ext uri="{FF2B5EF4-FFF2-40B4-BE49-F238E27FC236}">
+                  <a16:creationId xmlns:a16="http://schemas.microsoft.com/office/drawing/2014/main" id="{461C730B-5E5F-C02D-7E25-A59091F4A995}"/>
+                </a:ext>
+              </a:extLst>
+            </p:cNvPr>
+            <p:cNvSpPr/>
+            <p:nvPr/>
+          </p:nvSpPr>
+          <p:spPr>
+            <a:xfrm>
+              <a:off x="3556237" y="2826744"/>
+              <a:ext cx="5281498" cy="1053996"/>
+            </a:xfrm>
+            <a:prstGeom prst="rect">
+              <a:avLst/>
+            </a:prstGeom>
+            <a:solidFill>
+              <a:schemeClr val="accent3">
+                <a:lumMod val="20000"/>
+                <a:lumOff val="80000"/>
+              </a:schemeClr>
+            </a:solidFill>
+            <a:ln>
+              <a:noFill/>
+            </a:ln>
+          </p:spPr>
+          <p:style>
+            <a:lnRef idx="2">
+              <a:schemeClr val="accent1">
+                <a:shade val="15000"/>
+              </a:schemeClr>
+            </a:lnRef>
+            <a:fillRef idx="1">
+              <a:schemeClr val="accent1"/>
+            </a:fillRef>
+            <a:effectRef idx="0">
+              <a:schemeClr val="accent1"/>
+            </a:effectRef>
+            <a:fontRef idx="minor">
+              <a:schemeClr val="lt1"/>
+            </a:fontRef>
+          </p:style>
+          <p:txBody>
+            <a:bodyPr rtlCol="0" anchor="t"/>
+            <a:lstStyle/>
+            <a:p>
+              <a:r>
+                <a:rPr lang="en-US" sz="1600" dirty="0">
+                  <a:solidFill>
+                    <a:schemeClr val="tx1"/>
+                  </a:solidFill>
+                  <a:latin typeface="Arial" panose="020B0604020202020204" pitchFamily="34" charset="0"/>
+                  <a:cs typeface="Arial" panose="020B0604020202020204" pitchFamily="34" charset="0"/>
+                </a:rPr>
+                <a:t>Film</a:t>
+              </a:r>
+              <a:endParaRPr lang="en-GB" sz="1600" dirty="0">
+                <a:solidFill>
+                  <a:schemeClr val="tx1"/>
+                </a:solidFill>
+                <a:latin typeface="Arial" panose="020B0604020202020204" pitchFamily="34" charset="0"/>
+                <a:cs typeface="Arial" panose="020B0604020202020204" pitchFamily="34" charset="0"/>
+              </a:endParaRPr>
+            </a:p>
+          </p:txBody>
+        </p:sp>
+        <p:cxnSp>
+          <p:nvCxnSpPr>
+            <p:cNvPr id="12" name="Straight Arrow Connector 11">
+              <a:extLst>
+                <a:ext uri="{FF2B5EF4-FFF2-40B4-BE49-F238E27FC236}">
+                  <a16:creationId xmlns:a16="http://schemas.microsoft.com/office/drawing/2014/main" id="{2266168E-13D7-26BB-30B0-CEE71A4C2964}"/>
+                </a:ext>
+              </a:extLst>
+            </p:cNvPr>
+            <p:cNvCxnSpPr>
+              <a:cxnSpLocks/>
+            </p:cNvCxnSpPr>
+            <p:nvPr/>
+          </p:nvCxnSpPr>
+          <p:spPr>
+            <a:xfrm flipV="1">
+              <a:off x="5778020" y="1699731"/>
+              <a:ext cx="2547126" cy="2193709"/>
+            </a:xfrm>
+            <a:prstGeom prst="straightConnector1">
+              <a:avLst/>
+            </a:prstGeom>
+            <a:ln w="57150">
+              <a:solidFill>
+                <a:schemeClr val="accent2"/>
+              </a:solidFill>
+              <a:prstDash val="dash"/>
+              <a:tailEnd type="triangle"/>
+            </a:ln>
+          </p:spPr>
+          <p:style>
+            <a:lnRef idx="2">
+              <a:schemeClr val="accent1"/>
+            </a:lnRef>
+            <a:fillRef idx="0">
+              <a:schemeClr val="accent1"/>
+            </a:fillRef>
+            <a:effectRef idx="1">
+              <a:schemeClr val="accent1"/>
+            </a:effectRef>
+            <a:fontRef idx="minor">
+              <a:schemeClr val="tx1"/>
+            </a:fontRef>
+          </p:style>
+        </p:cxnSp>
+        <p:cxnSp>
+          <p:nvCxnSpPr>
+            <p:cNvPr id="21" name="Straight Arrow Connector 20">
+              <a:extLst>
+                <a:ext uri="{FF2B5EF4-FFF2-40B4-BE49-F238E27FC236}">
+                  <a16:creationId xmlns:a16="http://schemas.microsoft.com/office/drawing/2014/main" id="{D9709AF1-3DE7-1583-CAFB-55BF1855CD93}"/>
+                </a:ext>
+              </a:extLst>
+            </p:cNvPr>
+            <p:cNvCxnSpPr>
+              <a:cxnSpLocks/>
+            </p:cNvCxnSpPr>
+            <p:nvPr/>
+          </p:nvCxnSpPr>
+          <p:spPr>
+            <a:xfrm>
+              <a:off x="5778021" y="1663700"/>
+              <a:ext cx="0" cy="4258129"/>
+            </a:xfrm>
+            <a:prstGeom prst="straightConnector1">
+              <a:avLst/>
+            </a:prstGeom>
+            <a:ln w="76200">
+              <a:solidFill>
+                <a:schemeClr val="accent2"/>
+              </a:solidFill>
+              <a:tailEnd type="triangle"/>
+            </a:ln>
+          </p:spPr>
+          <p:style>
+            <a:lnRef idx="2">
+              <a:schemeClr val="accent1"/>
+            </a:lnRef>
+            <a:fillRef idx="0">
+              <a:schemeClr val="accent1"/>
+            </a:fillRef>
+            <a:effectRef idx="1">
+              <a:schemeClr val="accent1"/>
+            </a:effectRef>
+            <a:fontRef idx="minor">
+              <a:schemeClr val="tx1"/>
+            </a:fontRef>
+          </p:style>
+        </p:cxnSp>
+        <p:sp>
+          <p:nvSpPr>
+            <p:cNvPr id="47" name="TextBox 46">
+              <a:extLst>
+                <a:ext uri="{FF2B5EF4-FFF2-40B4-BE49-F238E27FC236}">
+                  <a16:creationId xmlns:a16="http://schemas.microsoft.com/office/drawing/2014/main" id="{6128A4BB-91FA-1F5A-09C9-52BD9BFC60B5}"/>
+                </a:ext>
+              </a:extLst>
+            </p:cNvPr>
+            <p:cNvSpPr txBox="1"/>
+            <p:nvPr/>
+          </p:nvSpPr>
+          <p:spPr>
+            <a:xfrm>
+              <a:off x="7035335" y="1665960"/>
+              <a:ext cx="521298" cy="905680"/>
+            </a:xfrm>
+            <a:prstGeom prst="rect">
+              <a:avLst/>
+            </a:prstGeom>
+            <a:noFill/>
+          </p:spPr>
+          <p:txBody>
+            <a:bodyPr wrap="square" rtlCol="0">
+              <a:spAutoFit/>
+            </a:bodyPr>
+            <a:lstStyle/>
+            <a:p>
+              <a:r>
+                <a:rPr lang="en-US" sz="1600" dirty="0">
+                  <a:latin typeface="Arial" panose="020B0604020202020204" pitchFamily="34" charset="0"/>
+                  <a:cs typeface="Arial" panose="020B0604020202020204" pitchFamily="34" charset="0"/>
+                </a:rPr>
+                <a:t>R</a:t>
+              </a:r>
+              <a:r>
+                <a:rPr lang="en-US" sz="1600" baseline="-25000" dirty="0">
+                  <a:latin typeface="Arial" panose="020B0604020202020204" pitchFamily="34" charset="0"/>
+                  <a:cs typeface="Arial" panose="020B0604020202020204" pitchFamily="34" charset="0"/>
+                </a:rPr>
+                <a:t>2</a:t>
+              </a:r>
+              <a:endParaRPr lang="en-GB" sz="1600" dirty="0">
+                <a:latin typeface="Arial" panose="020B0604020202020204" pitchFamily="34" charset="0"/>
+                <a:cs typeface="Arial" panose="020B0604020202020204" pitchFamily="34" charset="0"/>
+              </a:endParaRPr>
+            </a:p>
+          </p:txBody>
+        </p:sp>
+        <p:sp>
+          <p:nvSpPr>
+            <p:cNvPr id="48" name="TextBox 47">
+              <a:extLst>
+                <a:ext uri="{FF2B5EF4-FFF2-40B4-BE49-F238E27FC236}">
+                  <a16:creationId xmlns:a16="http://schemas.microsoft.com/office/drawing/2014/main" id="{BC2A9359-C9A0-1FDD-976F-D8B9B006136E}"/>
+                </a:ext>
+              </a:extLst>
+            </p:cNvPr>
+            <p:cNvSpPr txBox="1"/>
+            <p:nvPr/>
+          </p:nvSpPr>
+          <p:spPr>
+            <a:xfrm>
+              <a:off x="8272344" y="1663700"/>
+              <a:ext cx="521298" cy="905680"/>
+            </a:xfrm>
+            <a:prstGeom prst="rect">
+              <a:avLst/>
+            </a:prstGeom>
+            <a:noFill/>
+          </p:spPr>
+          <p:txBody>
+            <a:bodyPr wrap="square" rtlCol="0">
+              <a:spAutoFit/>
+            </a:bodyPr>
+            <a:lstStyle/>
+            <a:p>
+              <a:r>
+                <a:rPr lang="en-US" sz="1600" dirty="0">
+                  <a:latin typeface="Arial" panose="020B0604020202020204" pitchFamily="34" charset="0"/>
+                  <a:cs typeface="Arial" panose="020B0604020202020204" pitchFamily="34" charset="0"/>
+                </a:rPr>
+                <a:t>R</a:t>
+              </a:r>
+              <a:r>
+                <a:rPr lang="en-US" sz="1600" baseline="-25000" dirty="0">
+                  <a:latin typeface="Arial" panose="020B0604020202020204" pitchFamily="34" charset="0"/>
+                  <a:cs typeface="Arial" panose="020B0604020202020204" pitchFamily="34" charset="0"/>
+                </a:rPr>
+                <a:t>1</a:t>
+              </a:r>
+              <a:endParaRPr lang="en-GB" sz="1600" dirty="0">
+                <a:latin typeface="Arial" panose="020B0604020202020204" pitchFamily="34" charset="0"/>
+                <a:cs typeface="Arial" panose="020B0604020202020204" pitchFamily="34" charset="0"/>
+              </a:endParaRPr>
+            </a:p>
+          </p:txBody>
+        </p:sp>
+        <p:cxnSp>
+          <p:nvCxnSpPr>
+            <p:cNvPr id="54" name="Straight Arrow Connector 53">
+              <a:extLst>
+                <a:ext uri="{FF2B5EF4-FFF2-40B4-BE49-F238E27FC236}">
+                  <a16:creationId xmlns:a16="http://schemas.microsoft.com/office/drawing/2014/main" id="{8B0F9F80-0C64-F347-A4C0-3F86EE269F8B}"/>
+                </a:ext>
+              </a:extLst>
+            </p:cNvPr>
+            <p:cNvCxnSpPr>
+              <a:cxnSpLocks/>
+            </p:cNvCxnSpPr>
+            <p:nvPr/>
+          </p:nvCxnSpPr>
+          <p:spPr>
+            <a:xfrm flipV="1">
+              <a:off x="5778020" y="1685297"/>
+              <a:ext cx="1308580" cy="1127013"/>
+            </a:xfrm>
+            <a:prstGeom prst="straightConnector1">
+              <a:avLst/>
+            </a:prstGeom>
+            <a:ln w="57150">
+              <a:solidFill>
+                <a:schemeClr val="accent2"/>
+              </a:solidFill>
+              <a:prstDash val="dash"/>
+              <a:tailEnd type="triangle"/>
+            </a:ln>
+          </p:spPr>
+          <p:style>
+            <a:lnRef idx="2">
+              <a:schemeClr val="accent1"/>
+            </a:lnRef>
+            <a:fillRef idx="0">
+              <a:schemeClr val="accent1"/>
+            </a:fillRef>
+            <a:effectRef idx="1">
+              <a:schemeClr val="accent1"/>
+            </a:effectRef>
+            <a:fontRef idx="minor">
+              <a:schemeClr val="tx1"/>
+            </a:fontRef>
+          </p:style>
+        </p:cxnSp>
+        <p:sp>
+          <p:nvSpPr>
+            <p:cNvPr id="66" name="Right Brace 65">
+              <a:extLst>
+                <a:ext uri="{FF2B5EF4-FFF2-40B4-BE49-F238E27FC236}">
+                  <a16:creationId xmlns:a16="http://schemas.microsoft.com/office/drawing/2014/main" id="{2A415A72-EF85-0A17-0226-7AAD72FF7591}"/>
+                </a:ext>
+              </a:extLst>
+            </p:cNvPr>
+            <p:cNvSpPr/>
+            <p:nvPr/>
+          </p:nvSpPr>
+          <p:spPr>
+            <a:xfrm>
+              <a:off x="7660299" y="2838188"/>
+              <a:ext cx="213360" cy="1030700"/>
+            </a:xfrm>
+            <a:prstGeom prst="rightBrace">
+              <a:avLst>
+                <a:gd name="adj1" fmla="val 8333"/>
+                <a:gd name="adj2" fmla="val 51479"/>
+              </a:avLst>
+            </a:prstGeom>
+            <a:ln>
+              <a:solidFill>
+                <a:schemeClr val="tx1"/>
+              </a:solidFill>
+            </a:ln>
+          </p:spPr>
+          <p:style>
+            <a:lnRef idx="2">
+              <a:schemeClr val="accent1"/>
+            </a:lnRef>
+            <a:fillRef idx="0">
+              <a:schemeClr val="accent1"/>
+            </a:fillRef>
+            <a:effectRef idx="1">
+              <a:schemeClr val="accent1"/>
+            </a:effectRef>
+            <a:fontRef idx="minor">
+              <a:schemeClr val="tx1"/>
+            </a:fontRef>
+          </p:style>
+          <p:txBody>
+            <a:bodyPr rtlCol="0" anchor="ctr"/>
+            <a:lstStyle/>
+            <a:p>
+              <a:pPr algn="ctr"/>
+              <a:endParaRPr lang="en-GB"/>
+            </a:p>
+          </p:txBody>
+        </p:sp>
+        <mc:AlternateContent xmlns:mc="http://schemas.openxmlformats.org/markup-compatibility/2006">
+          <mc:Choice xmlns:a14="http://schemas.microsoft.com/office/drawing/2010/main" Requires="a14">
+            <p:sp>
+              <p:nvSpPr>
+                <p:cNvPr id="67" name="TextBox 66">
+                  <a:extLst>
+                    <a:ext uri="{FF2B5EF4-FFF2-40B4-BE49-F238E27FC236}">
+                      <a16:creationId xmlns:a16="http://schemas.microsoft.com/office/drawing/2014/main" id="{F2B88E51-09CE-9D19-66A4-97103A5B34A6}"/>
+                    </a:ext>
+                  </a:extLst>
+                </p:cNvPr>
+                <p:cNvSpPr txBox="1"/>
+                <p:nvPr/>
+              </p:nvSpPr>
+              <p:spPr>
+                <a:xfrm>
+                  <a:off x="7862531" y="3037009"/>
+                  <a:ext cx="1094861" cy="701306"/>
+                </a:xfrm>
+                <a:prstGeom prst="rect">
+                  <a:avLst/>
+                </a:prstGeom>
+                <a:noFill/>
+              </p:spPr>
+              <p:txBody>
+                <a:bodyPr wrap="none" rtlCol="0">
+                  <a:spAutoFit/>
+                </a:bodyPr>
+                <a:lstStyle/>
+                <a:p>
+                  <a:r>
+                    <a:rPr lang="en-GB" sz="1600" i="1" dirty="0"/>
+                    <a:t>OT</a:t>
+                  </a:r>
+                  <a:r>
+                    <a:rPr lang="en-GB" sz="1600" dirty="0"/>
+                    <a:t> = </a:t>
+                  </a:r>
+                  <a14:m>
+                    <m:oMath xmlns:m="http://schemas.openxmlformats.org/officeDocument/2006/math">
+                      <m:f>
+                        <m:fPr>
+                          <m:ctrlPr>
+                            <a:rPr lang="en-GB" sz="1600" i="1" smtClean="0">
+                              <a:latin typeface="Cambria Math" panose="02040503050406030204" pitchFamily="18" charset="0"/>
+                            </a:rPr>
+                          </m:ctrlPr>
+                        </m:fPr>
+                        <m:num>
+                          <m:r>
+                            <a:rPr lang="en-GB" sz="1600" i="1" smtClean="0">
+                              <a:latin typeface="Cambria Math" panose="02040503050406030204" pitchFamily="18" charset="0"/>
+                              <a:ea typeface="Cambria Math" panose="02040503050406030204" pitchFamily="18" charset="0"/>
+                            </a:rPr>
+                            <m:t>𝜆</m:t>
+                          </m:r>
+                        </m:num>
+                        <m:den>
+                          <m:r>
+                            <a:rPr lang="en-US" sz="1600" b="0" i="1" smtClean="0">
+                              <a:latin typeface="Cambria Math" panose="02040503050406030204" pitchFamily="18" charset="0"/>
+                            </a:rPr>
+                            <m:t>4</m:t>
+                          </m:r>
+                        </m:den>
+                      </m:f>
+                    </m:oMath>
+                  </a14:m>
+                  <a:endParaRPr lang="en-GB" sz="1600" dirty="0"/>
+                </a:p>
+              </p:txBody>
+            </p:sp>
+          </mc:Choice>
+          <mc:Fallback>
+            <p:sp>
+              <p:nvSpPr>
+                <p:cNvPr id="67" name="TextBox 66">
+                  <a:extLst>
+                    <a:ext uri="{FF2B5EF4-FFF2-40B4-BE49-F238E27FC236}">
+                      <a16:creationId xmlns:a16="http://schemas.microsoft.com/office/drawing/2014/main" id="{F2B88E51-09CE-9D19-66A4-97103A5B34A6}"/>
+                    </a:ext>
+                  </a:extLst>
+                </p:cNvPr>
+                <p:cNvSpPr txBox="1">
+                  <a:spLocks noRot="1" noChangeAspect="1" noMove="1" noResize="1" noEditPoints="1" noAdjustHandles="1" noChangeArrowheads="1" noChangeShapeType="1" noTextEdit="1"/>
+                </p:cNvSpPr>
+                <p:nvPr/>
+              </p:nvSpPr>
+              <p:spPr>
+                <a:xfrm>
+                  <a:off x="7862531" y="3037009"/>
+                  <a:ext cx="1094861" cy="701306"/>
+                </a:xfrm>
+                <a:prstGeom prst="rect">
+                  <a:avLst/>
+                </a:prstGeom>
+                <a:blipFill>
+                  <a:blip r:embed="rId4"/>
+                  <a:stretch>
+                    <a:fillRect l="-5172" b="-6757"/>
+                  </a:stretch>
+                </a:blipFill>
+              </p:spPr>
+              <p:txBody>
+                <a:bodyPr/>
+                <a:lstStyle/>
+                <a:p>
+                  <a:r>
+                    <a:rPr lang="en-GB">
+                      <a:noFill/>
+                    </a:rPr>
+                    <a:t> </a:t>
+                  </a:r>
+                </a:p>
+              </p:txBody>
+            </p:sp>
+          </mc:Fallback>
+        </mc:AlternateContent>
+        <p:sp>
+          <p:nvSpPr>
+            <p:cNvPr id="68" name="TextBox 67">
+              <a:extLst>
+                <a:ext uri="{FF2B5EF4-FFF2-40B4-BE49-F238E27FC236}">
+                  <a16:creationId xmlns:a16="http://schemas.microsoft.com/office/drawing/2014/main" id="{9EAACF97-245A-5DC8-30E8-4B290AE51D44}"/>
+                </a:ext>
+              </a:extLst>
+            </p:cNvPr>
+            <p:cNvSpPr txBox="1"/>
+            <p:nvPr/>
+          </p:nvSpPr>
+          <p:spPr>
+            <a:xfrm>
+              <a:off x="3556236" y="1685298"/>
+              <a:ext cx="673301" cy="524341"/>
+            </a:xfrm>
+            <a:prstGeom prst="rect">
+              <a:avLst/>
+            </a:prstGeom>
+            <a:noFill/>
+          </p:spPr>
+          <p:txBody>
+            <a:bodyPr wrap="none" rtlCol="0">
+              <a:spAutoFit/>
+            </a:bodyPr>
+            <a:lstStyle/>
+            <a:p>
+              <a:r>
+                <a:rPr lang="en-US" sz="1600" dirty="0">
+                  <a:latin typeface="Arial" panose="020B0604020202020204" pitchFamily="34" charset="0"/>
+                  <a:cs typeface="Arial" panose="020B0604020202020204" pitchFamily="34" charset="0"/>
+                </a:rPr>
+                <a:t>Air</a:t>
+              </a:r>
+              <a:endParaRPr lang="en-GB" sz="1600" dirty="0">
+                <a:latin typeface="Arial" panose="020B0604020202020204" pitchFamily="34" charset="0"/>
+                <a:cs typeface="Arial" panose="020B0604020202020204" pitchFamily="34" charset="0"/>
+              </a:endParaRPr>
+            </a:p>
+          </p:txBody>
+        </p:sp>
+      </p:grpSp>
     </p:spTree>
     <p:extLst>
       <p:ext uri="{BB962C8B-B14F-4D97-AF65-F5344CB8AC3E}">
-        <p14:creationId xmlns:p14="http://schemas.microsoft.com/office/powerpoint/2010/main" val="962242226"/>
+        <p14:creationId xmlns:p14="http://schemas.microsoft.com/office/powerpoint/2010/main" val="2725721634"/>
       </p:ext>
     </p:extLst>
   </p:cSld>
@@ -9509,15 +10558,15 @@
               </a:ext>
             </a:extLst>
           </a:blip>
-          <a:srcRect l="5714" t="3271" r="5714" b="3271"/>
+          <a:srcRect l="7937" t="10936" r="7937" b="4780"/>
           <a:stretch>
             <a:fillRect/>
           </a:stretch>
         </p:blipFill>
         <p:spPr>
           <a:xfrm>
-            <a:off x="865517" y="-119004"/>
-            <a:ext cx="10278129" cy="6971984"/>
+            <a:off x="1123449" y="452846"/>
+            <a:ext cx="9762266" cy="6287588"/>
           </a:xfrm>
           <a:prstGeom prst="rect">
             <a:avLst/>
@@ -9576,13 +10625,15 @@
               </a:ext>
             </a:extLst>
           </a:blip>
-          <a:srcRect t="4149" b="4149"/>
-          <a:stretch/>
+          <a:srcRect l="3376" t="11053" b="4149"/>
+          <a:stretch>
+            <a:fillRect/>
+          </a:stretch>
         </p:blipFill>
         <p:spPr>
           <a:xfrm>
-            <a:off x="828674" y="438150"/>
-            <a:ext cx="5267325" cy="6210300"/>
+            <a:off x="1006460" y="905690"/>
+            <a:ext cx="5089539" cy="5742759"/>
           </a:xfrm>
           <a:prstGeom prst="rect">
             <a:avLst/>
@@ -9710,15 +10761,15 @@
               </a:ext>
             </a:extLst>
           </a:blip>
-          <a:srcRect t="4012" b="4286"/>
+          <a:srcRect t="10916" r="3376" b="4285"/>
           <a:stretch>
             <a:fillRect/>
           </a:stretch>
         </p:blipFill>
         <p:spPr>
           <a:xfrm>
-            <a:off x="5604293" y="438151"/>
-            <a:ext cx="5267325" cy="6210300"/>
+            <a:off x="5604293" y="905691"/>
+            <a:ext cx="5089539" cy="5742759"/>
           </a:xfrm>
           <a:prstGeom prst="rect">
             <a:avLst/>
@@ -9826,13 +10877,15 @@
               </a:ext>
             </a:extLst>
           </a:blip>
-          <a:srcRect t="4444" b="4444"/>
-          <a:stretch/>
+          <a:srcRect t="7501" b="4444"/>
+          <a:stretch>
+            <a:fillRect/>
+          </a:stretch>
         </p:blipFill>
         <p:spPr>
           <a:xfrm>
-            <a:off x="498553" y="-272"/>
-            <a:ext cx="5857875" cy="6862082"/>
+            <a:off x="498553" y="230020"/>
+            <a:ext cx="5857875" cy="6631790"/>
           </a:xfrm>
           <a:prstGeom prst="rect">
             <a:avLst/>
@@ -9861,13 +10914,15 @@
               </a:ext>
             </a:extLst>
           </a:blip>
-          <a:srcRect t="4444" b="4444"/>
-          <a:stretch/>
+          <a:srcRect t="7503" b="4444"/>
+          <a:stretch>
+            <a:fillRect/>
+          </a:stretch>
         </p:blipFill>
         <p:spPr>
           <a:xfrm>
-            <a:off x="5803978" y="-272"/>
-            <a:ext cx="5854622" cy="6858272"/>
+            <a:off x="5803978" y="230020"/>
+            <a:ext cx="5854622" cy="6627979"/>
           </a:xfrm>
           <a:prstGeom prst="rect">
             <a:avLst/>
@@ -10418,15 +11473,15 @@
               </a:ext>
             </a:extLst>
           </a:blip>
-          <a:srcRect l="3785" t="2647" r="3785" b="2647"/>
+          <a:srcRect l="7621" t="10465" r="7621" b="4506"/>
           <a:stretch>
             <a:fillRect/>
           </a:stretch>
         </p:blipFill>
         <p:spPr>
           <a:xfrm>
-            <a:off x="911281" y="0"/>
-            <a:ext cx="10369966" cy="6857634"/>
+            <a:off x="1009930" y="249956"/>
+            <a:ext cx="10172139" cy="6586174"/>
           </a:xfrm>
           <a:prstGeom prst="rect">
             <a:avLst/>
@@ -10485,6 +11540,7 @@
               </a:ext>
             </a:extLst>
           </a:blip>
+          <a:srcRect b="4423"/>
           <a:stretch>
             <a:fillRect/>
           </a:stretch>
@@ -10492,7 +11548,7 @@
         <p:spPr>
           <a:xfrm>
             <a:off x="2803585" y="3191771"/>
-            <a:ext cx="2983490" cy="3835916"/>
+            <a:ext cx="2983490" cy="3666229"/>
           </a:xfrm>
           <a:prstGeom prst="rect">
             <a:avLst/>
@@ -10521,15 +11577,15 @@
               </a:ext>
             </a:extLst>
           </a:blip>
-          <a:srcRect b="3142"/>
+          <a:srcRect t="3234" b="3142"/>
           <a:stretch>
             <a:fillRect/>
           </a:stretch>
         </p:blipFill>
         <p:spPr>
           <a:xfrm>
-            <a:off x="2803585" y="-77634"/>
-            <a:ext cx="2983490" cy="3715391"/>
+            <a:off x="2803585" y="46428"/>
+            <a:ext cx="2983490" cy="3591329"/>
           </a:xfrm>
           <a:prstGeom prst="rect">
             <a:avLst/>
@@ -10561,6 +11617,7 @@
               </a:ext>
             </a:extLst>
           </a:blip>
+          <a:srcRect b="4423"/>
           <a:stretch>
             <a:fillRect/>
           </a:stretch>
@@ -10568,7 +11625,7 @@
         <p:spPr>
           <a:xfrm>
             <a:off x="5135593" y="3191771"/>
-            <a:ext cx="2983490" cy="3835916"/>
+            <a:ext cx="2983490" cy="3666229"/>
           </a:xfrm>
           <a:prstGeom prst="rect">
             <a:avLst/>
@@ -10597,15 +11654,15 @@
               </a:ext>
             </a:extLst>
           </a:blip>
-          <a:srcRect b="3142"/>
+          <a:srcRect t="3234" b="3142"/>
           <a:stretch>
             <a:fillRect/>
           </a:stretch>
         </p:blipFill>
         <p:spPr>
           <a:xfrm>
-            <a:off x="5135593" y="-77634"/>
-            <a:ext cx="2983490" cy="3715391"/>
+            <a:off x="5135593" y="46428"/>
+            <a:ext cx="2983490" cy="3591329"/>
           </a:xfrm>
           <a:prstGeom prst="rect">
             <a:avLst/>

</xml_diff>

<commit_message>
Reduced to 17 pages
</commit_message>
<xml_diff>
--- a/figs/figures.pptx
+++ b/figs/figures.pptx
@@ -16,7 +16,7 @@
     <p:sldId id="272" r:id="rId7"/>
     <p:sldId id="275" r:id="rId8"/>
     <p:sldId id="274" r:id="rId9"/>
-    <p:sldId id="276" r:id="rId10"/>
+    <p:sldId id="282" r:id="rId10"/>
     <p:sldId id="277" r:id="rId11"/>
     <p:sldId id="278" r:id="rId12"/>
     <p:sldId id="279" r:id="rId13"/>
@@ -220,7 +220,7 @@
           <a:p>
             <a:fld id="{2DD6ECBE-534E-4AEE-8ADA-897E2D67A90F}" type="datetimeFigureOut">
               <a:rPr lang="en-GB" smtClean="0"/>
-              <a:t>26/06/2026</a:t>
+              <a:t>29/06/2026</a:t>
             </a:fld>
             <a:endParaRPr lang="en-GB"/>
           </a:p>
@@ -1018,7 +1018,7 @@
           <a:p>
             <a:fld id="{6DA190FC-D844-4E0A-A0A2-219D558319DC}" type="datetimeFigureOut">
               <a:rPr lang="en-GB" smtClean="0"/>
-              <a:t>26/06/2026</a:t>
+              <a:t>29/06/2026</a:t>
             </a:fld>
             <a:endParaRPr lang="en-GB"/>
           </a:p>
@@ -1218,7 +1218,7 @@
           <a:p>
             <a:fld id="{6DA190FC-D844-4E0A-A0A2-219D558319DC}" type="datetimeFigureOut">
               <a:rPr lang="en-GB" smtClean="0"/>
-              <a:t>26/06/2026</a:t>
+              <a:t>29/06/2026</a:t>
             </a:fld>
             <a:endParaRPr lang="en-GB"/>
           </a:p>
@@ -1428,7 +1428,7 @@
           <a:p>
             <a:fld id="{6DA190FC-D844-4E0A-A0A2-219D558319DC}" type="datetimeFigureOut">
               <a:rPr lang="en-GB" smtClean="0"/>
-              <a:t>26/06/2026</a:t>
+              <a:t>29/06/2026</a:t>
             </a:fld>
             <a:endParaRPr lang="en-GB"/>
           </a:p>
@@ -1628,7 +1628,7 @@
           <a:p>
             <a:fld id="{6DA190FC-D844-4E0A-A0A2-219D558319DC}" type="datetimeFigureOut">
               <a:rPr lang="en-GB" smtClean="0"/>
-              <a:t>26/06/2026</a:t>
+              <a:t>29/06/2026</a:t>
             </a:fld>
             <a:endParaRPr lang="en-GB"/>
           </a:p>
@@ -1904,7 +1904,7 @@
           <a:p>
             <a:fld id="{6DA190FC-D844-4E0A-A0A2-219D558319DC}" type="datetimeFigureOut">
               <a:rPr lang="en-GB" smtClean="0"/>
-              <a:t>26/06/2026</a:t>
+              <a:t>29/06/2026</a:t>
             </a:fld>
             <a:endParaRPr lang="en-GB"/>
           </a:p>
@@ -2172,7 +2172,7 @@
           <a:p>
             <a:fld id="{6DA190FC-D844-4E0A-A0A2-219D558319DC}" type="datetimeFigureOut">
               <a:rPr lang="en-GB" smtClean="0"/>
-              <a:t>26/06/2026</a:t>
+              <a:t>29/06/2026</a:t>
             </a:fld>
             <a:endParaRPr lang="en-GB"/>
           </a:p>
@@ -2587,7 +2587,7 @@
           <a:p>
             <a:fld id="{6DA190FC-D844-4E0A-A0A2-219D558319DC}" type="datetimeFigureOut">
               <a:rPr lang="en-GB" smtClean="0"/>
-              <a:t>26/06/2026</a:t>
+              <a:t>29/06/2026</a:t>
             </a:fld>
             <a:endParaRPr lang="en-GB"/>
           </a:p>
@@ -2729,7 +2729,7 @@
           <a:p>
             <a:fld id="{6DA190FC-D844-4E0A-A0A2-219D558319DC}" type="datetimeFigureOut">
               <a:rPr lang="en-GB" smtClean="0"/>
-              <a:t>26/06/2026</a:t>
+              <a:t>29/06/2026</a:t>
             </a:fld>
             <a:endParaRPr lang="en-GB"/>
           </a:p>
@@ -2842,7 +2842,7 @@
           <a:p>
             <a:fld id="{6DA190FC-D844-4E0A-A0A2-219D558319DC}" type="datetimeFigureOut">
               <a:rPr lang="en-GB" smtClean="0"/>
-              <a:t>26/06/2026</a:t>
+              <a:t>29/06/2026</a:t>
             </a:fld>
             <a:endParaRPr lang="en-GB"/>
           </a:p>
@@ -3155,7 +3155,7 @@
           <a:p>
             <a:fld id="{6DA190FC-D844-4E0A-A0A2-219D558319DC}" type="datetimeFigureOut">
               <a:rPr lang="en-GB" smtClean="0"/>
-              <a:t>26/06/2026</a:t>
+              <a:t>29/06/2026</a:t>
             </a:fld>
             <a:endParaRPr lang="en-GB"/>
           </a:p>
@@ -3444,7 +3444,7 @@
           <a:p>
             <a:fld id="{6DA190FC-D844-4E0A-A0A2-219D558319DC}" type="datetimeFigureOut">
               <a:rPr lang="en-GB" smtClean="0"/>
-              <a:t>26/06/2026</a:t>
+              <a:t>29/06/2026</a:t>
             </a:fld>
             <a:endParaRPr lang="en-GB"/>
           </a:p>
@@ -3687,7 +3687,7 @@
           <a:p>
             <a:fld id="{6DA190FC-D844-4E0A-A0A2-219D558319DC}" type="datetimeFigureOut">
               <a:rPr lang="en-GB" smtClean="0"/>
-              <a:t>26/06/2026</a:t>
+              <a:t>29/06/2026</a:t>
             </a:fld>
             <a:endParaRPr lang="en-GB"/>
           </a:p>
@@ -8123,8 +8123,8 @@
                 </a:p>
               </p:txBody>
             </p:sp>
-            <mc:AlternateContent xmlns:mc="http://schemas.openxmlformats.org/markup-compatibility/2006">
-              <mc:Choice xmlns:a14="http://schemas.microsoft.com/office/drawing/2010/main" Requires="a14">
+            <mc:AlternateContent xmlns:mc="http://schemas.openxmlformats.org/markup-compatibility/2006" xmlns:a14="http://schemas.microsoft.com/office/drawing/2010/main">
+              <mc:Choice Requires="a14">
                 <p:sp>
                   <p:nvSpPr>
                     <p:cNvPr id="67" name="TextBox 66">
@@ -8153,7 +8153,6 @@
                     </a:bodyPr>
                     <a:lstStyle/>
                     <a:p>
-                      <a:pPr/>
                       <a:r>
                         <a:rPr lang="en-GB" sz="1600" i="1" dirty="0"/>
                         <a:t>OT</a:t>
@@ -8197,7 +8196,7 @@
                   </p:txBody>
                 </p:sp>
               </mc:Choice>
-              <mc:Fallback>
+              <mc:Fallback xmlns="">
                 <p:sp>
                   <p:nvSpPr>
                     <p:cNvPr id="67" name="TextBox 66">
@@ -10344,8 +10343,8 @@
             </a:p>
           </p:txBody>
         </p:sp>
-        <mc:AlternateContent xmlns:mc="http://schemas.openxmlformats.org/markup-compatibility/2006">
-          <mc:Choice xmlns:a14="http://schemas.microsoft.com/office/drawing/2010/main" Requires="a14">
+        <mc:AlternateContent xmlns:mc="http://schemas.openxmlformats.org/markup-compatibility/2006" xmlns:a14="http://schemas.microsoft.com/office/drawing/2010/main">
+          <mc:Choice Requires="a14">
             <p:sp>
               <p:nvSpPr>
                 <p:cNvPr id="67" name="TextBox 66">
@@ -10417,7 +10416,7 @@
               </p:txBody>
             </p:sp>
           </mc:Choice>
-          <mc:Fallback>
+          <mc:Fallback xmlns="">
             <p:sp>
               <p:nvSpPr>
                 <p:cNvPr id="67" name="TextBox 66">
@@ -12133,7 +12132,7 @@
           <p:cNvPr id="2" name="Picture 1">
             <a:extLst>
               <a:ext uri="{FF2B5EF4-FFF2-40B4-BE49-F238E27FC236}">
-                <a16:creationId xmlns:a16="http://schemas.microsoft.com/office/drawing/2014/main" id="{EE040C26-0105-1F59-EEAB-03FB983CEACD}"/>
+                <a16:creationId xmlns:a16="http://schemas.microsoft.com/office/drawing/2014/main" id="{D4C5BABE-6032-F125-1CB0-1A5212677C34}"/>
               </a:ext>
             </a:extLst>
           </p:cNvPr>
@@ -12157,8 +12156,8 @@
         </p:blipFill>
         <p:spPr>
           <a:xfrm>
-            <a:off x="1" y="1987826"/>
-            <a:ext cx="4216735" cy="2988000"/>
+            <a:off x="1891250" y="351763"/>
+            <a:ext cx="2946635" cy="2088000"/>
           </a:xfrm>
           <a:prstGeom prst="rect">
             <a:avLst/>
@@ -12170,7 +12169,7 @@
           <p:cNvPr id="3" name="Picture 2">
             <a:extLst>
               <a:ext uri="{FF2B5EF4-FFF2-40B4-BE49-F238E27FC236}">
-                <a16:creationId xmlns:a16="http://schemas.microsoft.com/office/drawing/2014/main" id="{E9F01624-A124-B643-3B03-F651A4EB0807}"/>
+                <a16:creationId xmlns:a16="http://schemas.microsoft.com/office/drawing/2014/main" id="{A343F9DB-D604-AB2A-02D9-239D004807ED}"/>
               </a:ext>
             </a:extLst>
           </p:cNvPr>
@@ -12194,45 +12193,8 @@
         </p:blipFill>
         <p:spPr>
           <a:xfrm>
-            <a:off x="3987632" y="1987826"/>
-            <a:ext cx="4216735" cy="2988000"/>
-          </a:xfrm>
-          <a:prstGeom prst="rect">
-            <a:avLst/>
-          </a:prstGeom>
-        </p:spPr>
-      </p:pic>
-      <p:pic>
-        <p:nvPicPr>
-          <p:cNvPr id="4" name="Picture 3">
-            <a:extLst>
-              <a:ext uri="{FF2B5EF4-FFF2-40B4-BE49-F238E27FC236}">
-                <a16:creationId xmlns:a16="http://schemas.microsoft.com/office/drawing/2014/main" id="{E2EDB843-9DA9-1EB4-5F44-81B183FA0991}"/>
-              </a:ext>
-            </a:extLst>
-          </p:cNvPr>
-          <p:cNvPicPr>
-            <a:picLocks noChangeAspect="1"/>
-          </p:cNvPicPr>
-          <p:nvPr/>
-        </p:nvPicPr>
-        <p:blipFill>
-          <a:blip r:embed="rId4" cstate="print">
-            <a:extLst>
-              <a:ext uri="{28A0092B-C50C-407E-A947-70E740481C1C}">
-                <a14:useLocalDpi xmlns:a14="http://schemas.microsoft.com/office/drawing/2010/main" val="0"/>
-              </a:ext>
-            </a:extLst>
-          </a:blip>
-          <a:srcRect t="5520"/>
-          <a:stretch>
-            <a:fillRect/>
-          </a:stretch>
-        </p:blipFill>
-        <p:spPr>
-          <a:xfrm>
-            <a:off x="7975263" y="1987826"/>
-            <a:ext cx="4216735" cy="2988000"/>
+            <a:off x="4834500" y="351763"/>
+            <a:ext cx="2946635" cy="2088000"/>
           </a:xfrm>
           <a:prstGeom prst="rect">
             <a:avLst/>
@@ -12241,10 +12203,10 @@
       </p:pic>
       <p:sp>
         <p:nvSpPr>
-          <p:cNvPr id="5" name="Text Box 2">
-            <a:extLst>
-              <a:ext uri="{FF2B5EF4-FFF2-40B4-BE49-F238E27FC236}">
-                <a16:creationId xmlns:a16="http://schemas.microsoft.com/office/drawing/2014/main" id="{92241068-DABA-E9C3-A73B-E04AA20B0876}"/>
+          <p:cNvPr id="4" name="Text Box 2">
+            <a:extLst>
+              <a:ext uri="{FF2B5EF4-FFF2-40B4-BE49-F238E27FC236}">
+                <a16:creationId xmlns:a16="http://schemas.microsoft.com/office/drawing/2014/main" id="{4C9CB274-5505-FAC7-10A0-73A6E2334E50}"/>
               </a:ext>
             </a:extLst>
           </p:cNvPr>
@@ -12255,8 +12217,8 @@
         </p:nvSpPr>
         <p:spPr bwMode="auto">
           <a:xfrm>
-            <a:off x="546652" y="1711048"/>
-            <a:ext cx="3269974" cy="307777"/>
+            <a:off x="2212611" y="49595"/>
+            <a:ext cx="2300400" cy="307777"/>
           </a:xfrm>
           <a:prstGeom prst="rect">
             <a:avLst/>
@@ -12275,7 +12237,7 @@
           </a:bodyPr>
           <a:lstStyle/>
           <a:p>
-            <a:pPr algn="just"/>
+            <a:pPr algn="ctr"/>
             <a:r>
               <a:rPr lang="en-GB" sz="1400" b="1" dirty="0">
                 <a:effectLst/>
@@ -12283,158 +12245,19 @@
                 <a:ea typeface="TH Sarabun PSK"/>
                 <a:cs typeface="TH Sarabun PSK"/>
               </a:rPr>
-              <a:t>(a) Single-layer design (Sb</a:t>
-            </a:r>
-            <a:r>
-              <a:rPr lang="en-GB" sz="1400" b="1" baseline="-25000" dirty="0">
-                <a:effectLst/>
-                <a:latin typeface="Arial" panose="020B0604020202020204" pitchFamily="34" charset="0"/>
-                <a:ea typeface="TH Sarabun PSK"/>
-                <a:cs typeface="TH Sarabun PSK"/>
-              </a:rPr>
-              <a:t>2</a:t>
-            </a:r>
-            <a:r>
-              <a:rPr lang="en-GB" sz="1400" b="1" dirty="0">
-                <a:effectLst/>
-                <a:latin typeface="Arial" panose="020B0604020202020204" pitchFamily="34" charset="0"/>
-                <a:ea typeface="TH Sarabun PSK"/>
-                <a:cs typeface="TH Sarabun PSK"/>
-              </a:rPr>
-              <a:t>Se</a:t>
-            </a:r>
-            <a:r>
-              <a:rPr lang="en-GB" sz="1400" b="1" baseline="-25000" dirty="0">
-                <a:effectLst/>
-                <a:latin typeface="Arial" panose="020B0604020202020204" pitchFamily="34" charset="0"/>
-                <a:ea typeface="TH Sarabun PSK"/>
-                <a:cs typeface="TH Sarabun PSK"/>
-              </a:rPr>
-              <a:t>3</a:t>
-            </a:r>
-            <a:r>
-              <a:rPr lang="en-GB" sz="1400" b="1" dirty="0">
-                <a:effectLst/>
-                <a:latin typeface="Arial" panose="020B0604020202020204" pitchFamily="34" charset="0"/>
-                <a:ea typeface="TH Sarabun PSK"/>
-                <a:cs typeface="TH Sarabun PSK"/>
-              </a:rPr>
-              <a:t>)</a:t>
+              <a:t>Single-layer design</a:t>
             </a:r>
           </a:p>
         </p:txBody>
       </p:sp>
-      <p:sp>
-        <p:nvSpPr>
-          <p:cNvPr id="6" name="Text Box 2">
-            <a:extLst>
-              <a:ext uri="{FF2B5EF4-FFF2-40B4-BE49-F238E27FC236}">
-                <a16:creationId xmlns:a16="http://schemas.microsoft.com/office/drawing/2014/main" id="{99A1AE28-3884-7973-041D-319FBD78F4C7}"/>
-              </a:ext>
-            </a:extLst>
-          </p:cNvPr>
-          <p:cNvSpPr txBox="1">
-            <a:spLocks noChangeArrowheads="1"/>
-          </p:cNvSpPr>
-          <p:nvPr/>
-        </p:nvSpPr>
-        <p:spPr bwMode="auto">
-          <a:xfrm>
-            <a:off x="4534283" y="1705439"/>
-            <a:ext cx="3269974" cy="307777"/>
-          </a:xfrm>
-          <a:prstGeom prst="rect">
-            <a:avLst/>
-          </a:prstGeom>
-          <a:noFill/>
-          <a:ln w="9525">
-            <a:noFill/>
-            <a:miter lim="800000"/>
-            <a:headEnd/>
-            <a:tailEnd/>
-          </a:ln>
-        </p:spPr>
-        <p:txBody>
-          <a:bodyPr rot="0" vert="horz" wrap="square" lIns="91440" tIns="45720" rIns="91440" bIns="45720" anchor="t" anchorCtr="0">
-            <a:spAutoFit/>
-          </a:bodyPr>
-          <a:lstStyle/>
-          <a:p>
-            <a:pPr algn="just"/>
-            <a:r>
-              <a:rPr lang="en-GB" sz="1400" b="1" dirty="0">
-                <a:effectLst/>
-                <a:latin typeface="Arial" panose="020B0604020202020204" pitchFamily="34" charset="0"/>
-                <a:ea typeface="TH Sarabun PSK"/>
-                <a:cs typeface="TH Sarabun PSK"/>
-              </a:rPr>
-              <a:t>(b) Two-layers design (Sb</a:t>
-            </a:r>
-            <a:r>
-              <a:rPr lang="en-GB" sz="1400" b="1" baseline="-25000" dirty="0">
-                <a:effectLst/>
-                <a:latin typeface="Arial" panose="020B0604020202020204" pitchFamily="34" charset="0"/>
-                <a:ea typeface="TH Sarabun PSK"/>
-                <a:cs typeface="TH Sarabun PSK"/>
-              </a:rPr>
-              <a:t>2</a:t>
-            </a:r>
-            <a:r>
-              <a:rPr lang="en-GB" sz="1400" b="1" dirty="0">
-                <a:effectLst/>
-                <a:latin typeface="Arial" panose="020B0604020202020204" pitchFamily="34" charset="0"/>
-                <a:ea typeface="TH Sarabun PSK"/>
-                <a:cs typeface="TH Sarabun PSK"/>
-              </a:rPr>
-              <a:t>Se</a:t>
-            </a:r>
-            <a:r>
-              <a:rPr lang="en-GB" sz="1400" b="1" baseline="-25000" dirty="0">
-                <a:effectLst/>
-                <a:latin typeface="Arial" panose="020B0604020202020204" pitchFamily="34" charset="0"/>
-                <a:ea typeface="TH Sarabun PSK"/>
-                <a:cs typeface="TH Sarabun PSK"/>
-              </a:rPr>
-              <a:t>3</a:t>
-            </a:r>
-            <a:r>
-              <a:rPr lang="en-GB" sz="1400" b="1" dirty="0">
-                <a:effectLst/>
-                <a:latin typeface="Arial" panose="020B0604020202020204" pitchFamily="34" charset="0"/>
-                <a:ea typeface="TH Sarabun PSK"/>
-                <a:cs typeface="TH Sarabun PSK"/>
-              </a:rPr>
-              <a:t>/TiO</a:t>
-            </a:r>
-            <a:r>
-              <a:rPr lang="en-GB" sz="1400" b="1" baseline="-25000" dirty="0">
-                <a:effectLst/>
-                <a:latin typeface="Arial" panose="020B0604020202020204" pitchFamily="34" charset="0"/>
-                <a:ea typeface="TH Sarabun PSK"/>
-                <a:cs typeface="TH Sarabun PSK"/>
-              </a:rPr>
-              <a:t>2</a:t>
-            </a:r>
-            <a:r>
-              <a:rPr lang="en-GB" sz="1400" b="1" dirty="0">
-                <a:effectLst/>
-                <a:latin typeface="Arial" panose="020B0604020202020204" pitchFamily="34" charset="0"/>
-                <a:ea typeface="TH Sarabun PSK"/>
-                <a:cs typeface="TH Sarabun PSK"/>
-              </a:rPr>
-              <a:t>)</a:t>
-            </a:r>
-          </a:p>
-        </p:txBody>
-      </p:sp>
-      <mc:AlternateContent xmlns:mc="http://schemas.openxmlformats.org/markup-compatibility/2006" xmlns:a14="http://schemas.microsoft.com/office/drawing/2010/main">
-        <mc:Choice Requires="a14">
+      <mc:AlternateContent xmlns:mc="http://schemas.openxmlformats.org/markup-compatibility/2006">
+        <mc:Choice xmlns:a14="http://schemas.microsoft.com/office/drawing/2010/main" Requires="a14">
           <p:sp>
             <p:nvSpPr>
-              <p:cNvPr id="7" name="Text Box 2">
+              <p:cNvPr id="6" name="Text Box 2">
                 <a:extLst>
                   <a:ext uri="{FF2B5EF4-FFF2-40B4-BE49-F238E27FC236}">
-                    <a16:creationId xmlns:a16="http://schemas.microsoft.com/office/drawing/2014/main" id="{DB388C99-BEAA-7F8E-F94E-5B16D89194D0}"/>
+                    <a16:creationId xmlns:a16="http://schemas.microsoft.com/office/drawing/2014/main" id="{46FD86A5-A5ED-AA0D-AB64-AB58466CF4FA}"/>
                   </a:ext>
                 </a:extLst>
               </p:cNvPr>
@@ -12445,8 +12268,8 @@
             </p:nvSpPr>
             <p:spPr bwMode="auto">
               <a:xfrm>
-                <a:off x="8521914" y="1661453"/>
-                <a:ext cx="3269974" cy="383375"/>
+                <a:off x="8093997" y="80373"/>
+                <a:ext cx="2299063" cy="276999"/>
               </a:xfrm>
               <a:prstGeom prst="rect">
                 <a:avLst/>
@@ -12465,174 +12288,60 @@
               </a:bodyPr>
               <a:lstStyle/>
               <a:p>
-                <a:pPr algn="just"/>
+                <a:pPr algn="ctr"/>
                 <a:r>
-                  <a:rPr lang="en-GB" sz="1300" b="1" dirty="0">
-                    <a:effectLst/>
+                  <a:rPr lang="en-GB" sz="1200" b="1" dirty="0">
                     <a:latin typeface="Arial" panose="020B0604020202020204" pitchFamily="34" charset="0"/>
                     <a:ea typeface="TH Sarabun PSK"/>
                     <a:cs typeface="TH Sarabun PSK"/>
                   </a:rPr>
-                  <a:t>(</a:t>
-                </a:r>
-                <a:r>
-                  <a:rPr lang="en-GB" sz="1300" b="1" dirty="0">
-                    <a:latin typeface="Arial" panose="020B0604020202020204" pitchFamily="34" charset="0"/>
-                    <a:ea typeface="TH Sarabun PSK"/>
-                    <a:cs typeface="TH Sarabun PSK"/>
-                  </a:rPr>
-                  <a:t>c</a:t>
-                </a:r>
-                <a:r>
-                  <a:rPr lang="en-GB" sz="1300" b="1" dirty="0">
-                    <a:effectLst/>
-                    <a:latin typeface="Arial" panose="020B0604020202020204" pitchFamily="34" charset="0"/>
-                    <a:ea typeface="TH Sarabun PSK"/>
-                    <a:cs typeface="TH Sarabun PSK"/>
-                  </a:rPr>
-                  <a:t>) Edge-filter design </a:t>
+                  <a:t>Edge-filter design </a:t>
                 </a:r>
                 <a14:m>
                   <m:oMath xmlns:m="http://schemas.openxmlformats.org/officeDocument/2006/math">
-                    <m:sSup>
-                      <m:sSupPr>
-                        <m:ctrlPr>
-                          <a:rPr lang="en-GB" sz="1300" b="1" i="1" smtClean="0">
-                            <a:effectLst/>
-                            <a:latin typeface="Cambria Math" panose="02040503050406030204" pitchFamily="18" charset="0"/>
-                            <a:cs typeface="Times New Roman" panose="02020603050405020304" pitchFamily="18" charset="0"/>
-                          </a:rPr>
-                        </m:ctrlPr>
-                      </m:sSupPr>
-                      <m:e>
-                        <m:r>
-                          <a:rPr lang="en-GB" sz="1300" b="1">
-                            <a:effectLst/>
-                            <a:latin typeface="Cambria Math" panose="02040503050406030204" pitchFamily="18" charset="0"/>
-                            <a:ea typeface="Yu Gothic" panose="020B0400000000000000" pitchFamily="34" charset="-128"/>
-                            <a:cs typeface="Times New Roman" panose="02020603050405020304" pitchFamily="18" charset="0"/>
-                          </a:rPr>
-                          <m:t>(</m:t>
-                        </m:r>
-                        <m:f>
-                          <m:fPr>
-                            <m:ctrlPr>
-                              <a:rPr lang="en-GB" sz="1300" b="1" i="1">
-                                <a:effectLst/>
-                                <a:latin typeface="Cambria Math" panose="02040503050406030204" pitchFamily="18" charset="0"/>
-                                <a:cs typeface="Times New Roman" panose="02020603050405020304" pitchFamily="18" charset="0"/>
-                              </a:rPr>
-                            </m:ctrlPr>
-                          </m:fPr>
-                          <m:num>
-                            <m:r>
-                              <a:rPr lang="en-GB" sz="1300" b="1" i="1">
-                                <a:effectLst/>
-                                <a:latin typeface="Cambria Math" panose="02040503050406030204" pitchFamily="18" charset="0"/>
-                                <a:ea typeface="Yu Gothic" panose="020B0400000000000000" pitchFamily="34" charset="-128"/>
-                                <a:cs typeface="Times New Roman" panose="02020603050405020304" pitchFamily="18" charset="0"/>
-                              </a:rPr>
-                              <m:t>𝑺𝒃𝑺𝒆</m:t>
-                            </m:r>
-                          </m:num>
-                          <m:den>
-                            <m:r>
-                              <a:rPr lang="en-GB" sz="1300" b="1" i="1">
-                                <a:effectLst/>
-                                <a:latin typeface="Cambria Math" panose="02040503050406030204" pitchFamily="18" charset="0"/>
-                                <a:ea typeface="Yu Gothic" panose="020B0400000000000000" pitchFamily="34" charset="-128"/>
-                                <a:cs typeface="Times New Roman" panose="02020603050405020304" pitchFamily="18" charset="0"/>
-                              </a:rPr>
-                              <m:t>𝟐</m:t>
-                            </m:r>
-                          </m:den>
-                        </m:f>
-                        <m:r>
-                          <a:rPr lang="en-GB" sz="1300" b="1">
-                            <a:effectLst/>
-                            <a:latin typeface="Cambria Math" panose="02040503050406030204" pitchFamily="18" charset="0"/>
-                            <a:ea typeface="Yu Gothic" panose="020B0400000000000000" pitchFamily="34" charset="-128"/>
-                            <a:cs typeface="Times New Roman" panose="02020603050405020304" pitchFamily="18" charset="0"/>
-                          </a:rPr>
-                          <m:t>/</m:t>
-                        </m:r>
-                        <m:r>
-                          <a:rPr lang="en-GB" sz="1300" b="1" i="1">
-                            <a:effectLst/>
-                            <a:latin typeface="Cambria Math" panose="02040503050406030204" pitchFamily="18" charset="0"/>
-                            <a:ea typeface="Yu Gothic" panose="020B0400000000000000" pitchFamily="34" charset="-128"/>
-                            <a:cs typeface="Times New Roman" panose="02020603050405020304" pitchFamily="18" charset="0"/>
-                          </a:rPr>
-                          <m:t>𝐌𝐠𝐅</m:t>
-                        </m:r>
-                        <m:r>
-                          <a:rPr lang="en-GB" sz="1300" b="1">
-                            <a:effectLst/>
-                            <a:latin typeface="Cambria Math" panose="02040503050406030204" pitchFamily="18" charset="0"/>
-                            <a:ea typeface="Yu Gothic" panose="020B0400000000000000" pitchFamily="34" charset="-128"/>
-                            <a:cs typeface="Times New Roman" panose="02020603050405020304" pitchFamily="18" charset="0"/>
-                          </a:rPr>
-                          <m:t>/</m:t>
-                        </m:r>
-                        <m:f>
-                          <m:fPr>
-                            <m:ctrlPr>
-                              <a:rPr lang="en-GB" sz="1300" b="1" i="1">
-                                <a:effectLst/>
-                                <a:latin typeface="Cambria Math" panose="02040503050406030204" pitchFamily="18" charset="0"/>
-                                <a:cs typeface="Times New Roman" panose="02020603050405020304" pitchFamily="18" charset="0"/>
-                              </a:rPr>
-                            </m:ctrlPr>
-                          </m:fPr>
-                          <m:num>
-                            <m:r>
-                              <a:rPr lang="en-GB" sz="1300" b="1" i="1">
-                                <a:effectLst/>
-                                <a:latin typeface="Cambria Math" panose="02040503050406030204" pitchFamily="18" charset="0"/>
-                                <a:ea typeface="Yu Gothic" panose="020B0400000000000000" pitchFamily="34" charset="-128"/>
-                                <a:cs typeface="Times New Roman" panose="02020603050405020304" pitchFamily="18" charset="0"/>
-                              </a:rPr>
-                              <m:t>𝑺𝒃𝑺𝒆</m:t>
-                            </m:r>
-                          </m:num>
-                          <m:den>
-                            <m:r>
-                              <a:rPr lang="en-GB" sz="1300" b="1" i="1">
-                                <a:effectLst/>
-                                <a:latin typeface="Cambria Math" panose="02040503050406030204" pitchFamily="18" charset="0"/>
-                                <a:ea typeface="Yu Gothic" panose="020B0400000000000000" pitchFamily="34" charset="-128"/>
-                                <a:cs typeface="Times New Roman" panose="02020603050405020304" pitchFamily="18" charset="0"/>
-                              </a:rPr>
-                              <m:t>𝟐</m:t>
-                            </m:r>
-                          </m:den>
-                        </m:f>
-                        <m:r>
-                          <a:rPr lang="en-GB" sz="1300" b="1">
-                            <a:effectLst/>
-                            <a:latin typeface="Cambria Math" panose="02040503050406030204" pitchFamily="18" charset="0"/>
-                            <a:ea typeface="Yu Gothic" panose="020B0400000000000000" pitchFamily="34" charset="-128"/>
-                            <a:cs typeface="Times New Roman" panose="02020603050405020304" pitchFamily="18" charset="0"/>
-                          </a:rPr>
-                          <m:t>)</m:t>
-                        </m:r>
-                      </m:e>
-                      <m:sup>
-                        <m:r>
-                          <a:rPr lang="en-GB" sz="1300" b="1" i="1">
-                            <a:effectLst/>
-                            <a:latin typeface="Cambria Math" panose="02040503050406030204" pitchFamily="18" charset="0"/>
-                            <a:ea typeface="Yu Gothic" panose="020B0400000000000000" pitchFamily="34" charset="-128"/>
-                            <a:cs typeface="Times New Roman" panose="02020603050405020304" pitchFamily="18" charset="0"/>
-                          </a:rPr>
-                          <m:t>𝟓</m:t>
-                        </m:r>
-                      </m:sup>
-                    </m:sSup>
+                    <m:r>
+                      <a:rPr lang="en-US" sz="1200" b="1" i="1">
+                        <a:latin typeface="Cambria Math" panose="02040503050406030204" pitchFamily="18" charset="0"/>
+                        <a:ea typeface="TH Sarabun PSK"/>
+                        <a:cs typeface="TH Sarabun PSK"/>
+                      </a:rPr>
+                      <m:t>(</m:t>
+                    </m:r>
+                    <m:r>
+                      <a:rPr lang="en-US" sz="1200" b="1" i="1">
+                        <a:latin typeface="Cambria Math" panose="02040503050406030204" pitchFamily="18" charset="0"/>
+                        <a:ea typeface="TH Sarabun PSK"/>
+                        <a:cs typeface="TH Sarabun PSK"/>
+                      </a:rPr>
+                      <m:t>𝑵</m:t>
+                    </m:r>
+                    <m:r>
+                      <a:rPr lang="en-US" sz="1200" b="1" i="1">
+                        <a:latin typeface="Cambria Math" panose="02040503050406030204" pitchFamily="18" charset="0"/>
+                        <a:ea typeface="TH Sarabun PSK"/>
+                        <a:cs typeface="TH Sarabun PSK"/>
+                      </a:rPr>
+                      <m:t>=</m:t>
+                    </m:r>
+                    <m:r>
+                      <a:rPr lang="en-US" sz="1200" b="1" i="1" smtClean="0">
+                        <a:latin typeface="Cambria Math" panose="02040503050406030204" pitchFamily="18" charset="0"/>
+                        <a:ea typeface="TH Sarabun PSK"/>
+                        <a:cs typeface="TH Sarabun PSK"/>
+                      </a:rPr>
+                      <m:t>𝟓</m:t>
+                    </m:r>
+                    <m:r>
+                      <a:rPr lang="en-US" sz="1200" b="1" i="1">
+                        <a:latin typeface="Cambria Math" panose="02040503050406030204" pitchFamily="18" charset="0"/>
+                        <a:ea typeface="TH Sarabun PSK"/>
+                        <a:cs typeface="TH Sarabun PSK"/>
+                      </a:rPr>
+                      <m:t>)</m:t>
+                    </m:r>
                   </m:oMath>
                 </a14:m>
-                <a:endParaRPr lang="en-GB" sz="1300" b="1" dirty="0">
-                  <a:effectLst/>
+                <a:endParaRPr lang="en-GB" sz="1200" b="1" dirty="0">
                   <a:latin typeface="Arial" panose="020B0604020202020204" pitchFamily="34" charset="0"/>
                   <a:ea typeface="TH Sarabun PSK"/>
                   <a:cs typeface="TH Sarabun PSK"/>
@@ -12641,13 +12350,13 @@
             </p:txBody>
           </p:sp>
         </mc:Choice>
-        <mc:Fallback xmlns="">
+        <mc:Fallback>
           <p:sp>
             <p:nvSpPr>
-              <p:cNvPr id="7" name="Text Box 2">
+              <p:cNvPr id="6" name="Text Box 2">
                 <a:extLst>
                   <a:ext uri="{FF2B5EF4-FFF2-40B4-BE49-F238E27FC236}">
-                    <a16:creationId xmlns:a16="http://schemas.microsoft.com/office/drawing/2014/main" id="{DB388C99-BEAA-7F8E-F94E-5B16D89194D0}"/>
+                    <a16:creationId xmlns:a16="http://schemas.microsoft.com/office/drawing/2014/main" id="{46FD86A5-A5ED-AA0D-AB64-AB58466CF4FA}"/>
                   </a:ext>
                 </a:extLst>
               </p:cNvPr>
@@ -12658,16 +12367,16 @@
             </p:nvSpPr>
             <p:spPr bwMode="auto">
               <a:xfrm>
-                <a:off x="8521914" y="1661453"/>
-                <a:ext cx="3269974" cy="383375"/>
+                <a:off x="8093997" y="80373"/>
+                <a:ext cx="2299063" cy="276999"/>
               </a:xfrm>
               <a:prstGeom prst="rect">
                 <a:avLst/>
               </a:prstGeom>
               <a:blipFill>
-                <a:blip r:embed="rId5"/>
+                <a:blip r:embed="rId4"/>
                 <a:stretch>
-                  <a:fillRect l="-373" b="-3226"/>
+                  <a:fillRect t="-2174" b="-13043"/>
                 </a:stretch>
               </a:blipFill>
               <a:ln w="9525">
@@ -12692,10 +12401,929 @@
           </p:sp>
         </mc:Fallback>
       </mc:AlternateContent>
+      <p:pic>
+        <p:nvPicPr>
+          <p:cNvPr id="7" name="Picture 6">
+            <a:extLst>
+              <a:ext uri="{FF2B5EF4-FFF2-40B4-BE49-F238E27FC236}">
+                <a16:creationId xmlns:a16="http://schemas.microsoft.com/office/drawing/2014/main" id="{861A5E16-E1C8-DC95-0F68-FC1BB4F13481}"/>
+              </a:ext>
+            </a:extLst>
+          </p:cNvPr>
+          <p:cNvPicPr>
+            <a:picLocks noChangeAspect="1"/>
+          </p:cNvPicPr>
+          <p:nvPr/>
+        </p:nvPicPr>
+        <p:blipFill>
+          <a:blip r:embed="rId5" cstate="print">
+            <a:extLst>
+              <a:ext uri="{28A0092B-C50C-407E-A947-70E740481C1C}">
+                <a14:useLocalDpi xmlns:a14="http://schemas.microsoft.com/office/drawing/2010/main" val="0"/>
+              </a:ext>
+            </a:extLst>
+          </a:blip>
+          <a:srcRect t="5520"/>
+          <a:stretch>
+            <a:fillRect/>
+          </a:stretch>
+        </p:blipFill>
+        <p:spPr>
+          <a:xfrm>
+            <a:off x="7773853" y="351763"/>
+            <a:ext cx="2946635" cy="2088000"/>
+          </a:xfrm>
+          <a:prstGeom prst="rect">
+            <a:avLst/>
+          </a:prstGeom>
+        </p:spPr>
+      </p:pic>
+      <p:pic>
+        <p:nvPicPr>
+          <p:cNvPr id="8" name="Picture 7">
+            <a:extLst>
+              <a:ext uri="{FF2B5EF4-FFF2-40B4-BE49-F238E27FC236}">
+                <a16:creationId xmlns:a16="http://schemas.microsoft.com/office/drawing/2014/main" id="{44182A1A-1797-BF94-6EF3-258E6FE3678F}"/>
+              </a:ext>
+            </a:extLst>
+          </p:cNvPr>
+          <p:cNvPicPr>
+            <a:picLocks noChangeAspect="1"/>
+          </p:cNvPicPr>
+          <p:nvPr/>
+        </p:nvPicPr>
+        <p:blipFill>
+          <a:blip r:embed="rId6" cstate="print">
+            <a:extLst>
+              <a:ext uri="{28A0092B-C50C-407E-A947-70E740481C1C}">
+                <a14:useLocalDpi xmlns:a14="http://schemas.microsoft.com/office/drawing/2010/main" val="0"/>
+              </a:ext>
+            </a:extLst>
+          </a:blip>
+          <a:srcRect t="5473"/>
+          <a:stretch>
+            <a:fillRect/>
+          </a:stretch>
+        </p:blipFill>
+        <p:spPr>
+          <a:xfrm>
+            <a:off x="1894891" y="2439763"/>
+            <a:ext cx="2945194" cy="2088000"/>
+          </a:xfrm>
+          <a:prstGeom prst="rect">
+            <a:avLst/>
+          </a:prstGeom>
+        </p:spPr>
+      </p:pic>
+      <p:pic>
+        <p:nvPicPr>
+          <p:cNvPr id="9" name="Picture 8">
+            <a:extLst>
+              <a:ext uri="{FF2B5EF4-FFF2-40B4-BE49-F238E27FC236}">
+                <a16:creationId xmlns:a16="http://schemas.microsoft.com/office/drawing/2014/main" id="{825C9D60-B5D6-A115-49F7-B263821132F4}"/>
+              </a:ext>
+            </a:extLst>
+          </p:cNvPr>
+          <p:cNvPicPr>
+            <a:picLocks noChangeAspect="1"/>
+          </p:cNvPicPr>
+          <p:nvPr/>
+        </p:nvPicPr>
+        <p:blipFill>
+          <a:blip r:embed="rId7" cstate="print">
+            <a:extLst>
+              <a:ext uri="{28A0092B-C50C-407E-A947-70E740481C1C}">
+                <a14:useLocalDpi xmlns:a14="http://schemas.microsoft.com/office/drawing/2010/main" val="0"/>
+              </a:ext>
+            </a:extLst>
+          </a:blip>
+          <a:srcRect t="5285"/>
+          <a:stretch>
+            <a:fillRect/>
+          </a:stretch>
+        </p:blipFill>
+        <p:spPr>
+          <a:xfrm>
+            <a:off x="4834500" y="2445372"/>
+            <a:ext cx="2939353" cy="2088000"/>
+          </a:xfrm>
+          <a:prstGeom prst="rect">
+            <a:avLst/>
+          </a:prstGeom>
+        </p:spPr>
+      </p:pic>
+      <p:pic>
+        <p:nvPicPr>
+          <p:cNvPr id="10" name="Picture 9">
+            <a:extLst>
+              <a:ext uri="{FF2B5EF4-FFF2-40B4-BE49-F238E27FC236}">
+                <a16:creationId xmlns:a16="http://schemas.microsoft.com/office/drawing/2014/main" id="{6C71A0DB-C09D-7B22-6F6E-08237344B603}"/>
+              </a:ext>
+            </a:extLst>
+          </p:cNvPr>
+          <p:cNvPicPr>
+            <a:picLocks noChangeAspect="1"/>
+          </p:cNvPicPr>
+          <p:nvPr/>
+        </p:nvPicPr>
+        <p:blipFill>
+          <a:blip r:embed="rId8" cstate="print">
+            <a:extLst>
+              <a:ext uri="{28A0092B-C50C-407E-A947-70E740481C1C}">
+                <a14:useLocalDpi xmlns:a14="http://schemas.microsoft.com/office/drawing/2010/main" val="0"/>
+              </a:ext>
+            </a:extLst>
+          </a:blip>
+          <a:srcRect t="5285"/>
+          <a:stretch>
+            <a:fillRect/>
+          </a:stretch>
+        </p:blipFill>
+        <p:spPr>
+          <a:xfrm>
+            <a:off x="7773853" y="2439763"/>
+            <a:ext cx="2939353" cy="2088000"/>
+          </a:xfrm>
+          <a:prstGeom prst="rect">
+            <a:avLst/>
+          </a:prstGeom>
+        </p:spPr>
+      </p:pic>
+      <p:pic>
+        <p:nvPicPr>
+          <p:cNvPr id="11" name="Picture 10">
+            <a:extLst>
+              <a:ext uri="{FF2B5EF4-FFF2-40B4-BE49-F238E27FC236}">
+                <a16:creationId xmlns:a16="http://schemas.microsoft.com/office/drawing/2014/main" id="{1547BF8F-0477-D780-DB94-62E18671F1AF}"/>
+              </a:ext>
+            </a:extLst>
+          </p:cNvPr>
+          <p:cNvPicPr>
+            <a:picLocks noChangeAspect="1"/>
+          </p:cNvPicPr>
+          <p:nvPr/>
+        </p:nvPicPr>
+        <p:blipFill>
+          <a:blip r:embed="rId9" cstate="print">
+            <a:extLst>
+              <a:ext uri="{28A0092B-C50C-407E-A947-70E740481C1C}">
+                <a14:useLocalDpi xmlns:a14="http://schemas.microsoft.com/office/drawing/2010/main" val="0"/>
+              </a:ext>
+            </a:extLst>
+          </a:blip>
+          <a:srcRect t="5407"/>
+          <a:stretch>
+            <a:fillRect/>
+          </a:stretch>
+        </p:blipFill>
+        <p:spPr>
+          <a:xfrm>
+            <a:off x="1891250" y="4533372"/>
+            <a:ext cx="2943122" cy="2088000"/>
+          </a:xfrm>
+          <a:prstGeom prst="rect">
+            <a:avLst/>
+          </a:prstGeom>
+        </p:spPr>
+      </p:pic>
+      <p:pic>
+        <p:nvPicPr>
+          <p:cNvPr id="12" name="Picture 11">
+            <a:extLst>
+              <a:ext uri="{FF2B5EF4-FFF2-40B4-BE49-F238E27FC236}">
+                <a16:creationId xmlns:a16="http://schemas.microsoft.com/office/drawing/2014/main" id="{DF8ECAB5-351E-7EBF-6EB8-A3527E21A218}"/>
+              </a:ext>
+            </a:extLst>
+          </p:cNvPr>
+          <p:cNvPicPr>
+            <a:picLocks noChangeAspect="1"/>
+          </p:cNvPicPr>
+          <p:nvPr/>
+        </p:nvPicPr>
+        <p:blipFill>
+          <a:blip r:embed="rId10" cstate="print">
+            <a:extLst>
+              <a:ext uri="{28A0092B-C50C-407E-A947-70E740481C1C}">
+                <a14:useLocalDpi xmlns:a14="http://schemas.microsoft.com/office/drawing/2010/main" val="0"/>
+              </a:ext>
+            </a:extLst>
+          </a:blip>
+          <a:srcRect t="5407"/>
+          <a:stretch>
+            <a:fillRect/>
+          </a:stretch>
+        </p:blipFill>
+        <p:spPr>
+          <a:xfrm>
+            <a:off x="4838013" y="4535370"/>
+            <a:ext cx="2943122" cy="2088000"/>
+          </a:xfrm>
+          <a:prstGeom prst="rect">
+            <a:avLst/>
+          </a:prstGeom>
+        </p:spPr>
+      </p:pic>
+      <p:pic>
+        <p:nvPicPr>
+          <p:cNvPr id="13" name="Picture 12">
+            <a:extLst>
+              <a:ext uri="{FF2B5EF4-FFF2-40B4-BE49-F238E27FC236}">
+                <a16:creationId xmlns:a16="http://schemas.microsoft.com/office/drawing/2014/main" id="{B12757C8-3F1B-92B5-E042-C51F360392BA}"/>
+              </a:ext>
+            </a:extLst>
+          </p:cNvPr>
+          <p:cNvPicPr>
+            <a:picLocks noChangeAspect="1"/>
+          </p:cNvPicPr>
+          <p:nvPr/>
+        </p:nvPicPr>
+        <p:blipFill>
+          <a:blip r:embed="rId11" cstate="print">
+            <a:extLst>
+              <a:ext uri="{28A0092B-C50C-407E-A947-70E740481C1C}">
+                <a14:useLocalDpi xmlns:a14="http://schemas.microsoft.com/office/drawing/2010/main" val="0"/>
+              </a:ext>
+            </a:extLst>
+          </a:blip>
+          <a:srcRect t="5407"/>
+          <a:stretch>
+            <a:fillRect/>
+          </a:stretch>
+        </p:blipFill>
+        <p:spPr>
+          <a:xfrm>
+            <a:off x="7781135" y="4533372"/>
+            <a:ext cx="2943122" cy="2088000"/>
+          </a:xfrm>
+          <a:prstGeom prst="rect">
+            <a:avLst/>
+          </a:prstGeom>
+        </p:spPr>
+      </p:pic>
+      <mc:AlternateContent xmlns:mc="http://schemas.openxmlformats.org/markup-compatibility/2006">
+        <mc:Choice xmlns:a14="http://schemas.microsoft.com/office/drawing/2010/main" Requires="a14">
+          <p:sp>
+            <p:nvSpPr>
+              <p:cNvPr id="15" name="Text Box 2">
+                <a:extLst>
+                  <a:ext uri="{FF2B5EF4-FFF2-40B4-BE49-F238E27FC236}">
+                    <a16:creationId xmlns:a16="http://schemas.microsoft.com/office/drawing/2014/main" id="{634970E3-DFE2-5A5B-D2DB-4D94CDC0A701}"/>
+                  </a:ext>
+                </a:extLst>
+              </p:cNvPr>
+              <p:cNvSpPr txBox="1">
+                <a:spLocks noChangeArrowheads="1"/>
+              </p:cNvSpPr>
+              <p:nvPr/>
+            </p:nvSpPr>
+            <p:spPr bwMode="auto">
+              <a:xfrm>
+                <a:off x="5161224" y="69155"/>
+                <a:ext cx="2299063" cy="276999"/>
+              </a:xfrm>
+              <a:prstGeom prst="rect">
+                <a:avLst/>
+              </a:prstGeom>
+              <a:noFill/>
+              <a:ln w="9525">
+                <a:noFill/>
+                <a:miter lim="800000"/>
+                <a:headEnd/>
+                <a:tailEnd/>
+              </a:ln>
+            </p:spPr>
+            <p:txBody>
+              <a:bodyPr rot="0" vert="horz" wrap="square" lIns="91440" tIns="45720" rIns="91440" bIns="45720" anchor="t" anchorCtr="0">
+                <a:spAutoFit/>
+              </a:bodyPr>
+              <a:lstStyle/>
+              <a:p>
+                <a:pPr algn="ctr"/>
+                <a:r>
+                  <a:rPr lang="en-GB" sz="1200" b="1" dirty="0">
+                    <a:latin typeface="Arial" panose="020B0604020202020204" pitchFamily="34" charset="0"/>
+                    <a:ea typeface="TH Sarabun PSK"/>
+                    <a:cs typeface="TH Sarabun PSK"/>
+                  </a:rPr>
+                  <a:t>Edge-filter design </a:t>
+                </a:r>
+                <a14:m>
+                  <m:oMath xmlns:m="http://schemas.openxmlformats.org/officeDocument/2006/math">
+                    <m:r>
+                      <a:rPr lang="en-US" sz="1200" b="1" i="1">
+                        <a:latin typeface="Cambria Math" panose="02040503050406030204" pitchFamily="18" charset="0"/>
+                        <a:ea typeface="TH Sarabun PSK"/>
+                        <a:cs typeface="TH Sarabun PSK"/>
+                      </a:rPr>
+                      <m:t>(</m:t>
+                    </m:r>
+                    <m:r>
+                      <a:rPr lang="en-US" sz="1200" b="1" i="1">
+                        <a:latin typeface="Cambria Math" panose="02040503050406030204" pitchFamily="18" charset="0"/>
+                        <a:ea typeface="TH Sarabun PSK"/>
+                        <a:cs typeface="TH Sarabun PSK"/>
+                      </a:rPr>
+                      <m:t>𝑵</m:t>
+                    </m:r>
+                    <m:r>
+                      <a:rPr lang="en-US" sz="1200" b="1" i="1">
+                        <a:latin typeface="Cambria Math" panose="02040503050406030204" pitchFamily="18" charset="0"/>
+                        <a:ea typeface="TH Sarabun PSK"/>
+                        <a:cs typeface="TH Sarabun PSK"/>
+                      </a:rPr>
+                      <m:t>=</m:t>
+                    </m:r>
+                    <m:r>
+                      <a:rPr lang="en-US" sz="1200" b="1" i="1" smtClean="0">
+                        <a:latin typeface="Cambria Math" panose="02040503050406030204" pitchFamily="18" charset="0"/>
+                        <a:ea typeface="TH Sarabun PSK"/>
+                        <a:cs typeface="TH Sarabun PSK"/>
+                      </a:rPr>
+                      <m:t>𝟒</m:t>
+                    </m:r>
+                    <m:r>
+                      <a:rPr lang="en-US" sz="1200" b="1" i="1">
+                        <a:latin typeface="Cambria Math" panose="02040503050406030204" pitchFamily="18" charset="0"/>
+                        <a:ea typeface="TH Sarabun PSK"/>
+                        <a:cs typeface="TH Sarabun PSK"/>
+                      </a:rPr>
+                      <m:t>)</m:t>
+                    </m:r>
+                  </m:oMath>
+                </a14:m>
+                <a:endParaRPr lang="en-GB" sz="1200" b="1" dirty="0">
+                  <a:latin typeface="Arial" panose="020B0604020202020204" pitchFamily="34" charset="0"/>
+                  <a:ea typeface="TH Sarabun PSK"/>
+                  <a:cs typeface="TH Sarabun PSK"/>
+                </a:endParaRPr>
+              </a:p>
+            </p:txBody>
+          </p:sp>
+        </mc:Choice>
+        <mc:Fallback>
+          <p:sp>
+            <p:nvSpPr>
+              <p:cNvPr id="15" name="Text Box 2">
+                <a:extLst>
+                  <a:ext uri="{FF2B5EF4-FFF2-40B4-BE49-F238E27FC236}">
+                    <a16:creationId xmlns:a16="http://schemas.microsoft.com/office/drawing/2014/main" id="{634970E3-DFE2-5A5B-D2DB-4D94CDC0A701}"/>
+                  </a:ext>
+                </a:extLst>
+              </p:cNvPr>
+              <p:cNvSpPr txBox="1">
+                <a:spLocks noRot="1" noChangeAspect="1" noMove="1" noResize="1" noEditPoints="1" noAdjustHandles="1" noChangeArrowheads="1" noChangeShapeType="1" noTextEdit="1"/>
+              </p:cNvSpPr>
+              <p:nvPr/>
+            </p:nvSpPr>
+            <p:spPr bwMode="auto">
+              <a:xfrm>
+                <a:off x="5161224" y="69155"/>
+                <a:ext cx="2299063" cy="276999"/>
+              </a:xfrm>
+              <a:prstGeom prst="rect">
+                <a:avLst/>
+              </a:prstGeom>
+              <a:blipFill>
+                <a:blip r:embed="rId12"/>
+                <a:stretch>
+                  <a:fillRect t="-2174" b="-13043"/>
+                </a:stretch>
+              </a:blipFill>
+              <a:ln w="9525">
+                <a:noFill/>
+                <a:miter lim="800000"/>
+                <a:headEnd/>
+                <a:tailEnd/>
+              </a:ln>
+            </p:spPr>
+            <p:txBody>
+              <a:bodyPr/>
+              <a:lstStyle/>
+              <a:p>
+                <a:r>
+                  <a:rPr lang="en-GB">
+                    <a:noFill/>
+                  </a:rPr>
+                  <a:t> </a:t>
+                </a:r>
+              </a:p>
+            </p:txBody>
+          </p:sp>
+        </mc:Fallback>
+      </mc:AlternateContent>
+      <p:sp>
+        <p:nvSpPr>
+          <p:cNvPr id="16" name="Text Box 2">
+            <a:extLst>
+              <a:ext uri="{FF2B5EF4-FFF2-40B4-BE49-F238E27FC236}">
+                <a16:creationId xmlns:a16="http://schemas.microsoft.com/office/drawing/2014/main" id="{5CA60D8C-82E2-C8DF-D8BE-AC28A75436FC}"/>
+              </a:ext>
+            </a:extLst>
+          </p:cNvPr>
+          <p:cNvSpPr txBox="1">
+            <a:spLocks noChangeArrowheads="1"/>
+          </p:cNvSpPr>
+          <p:nvPr/>
+        </p:nvSpPr>
+        <p:spPr bwMode="auto">
+          <a:xfrm>
+            <a:off x="2210411" y="333228"/>
+            <a:ext cx="542519" cy="276999"/>
+          </a:xfrm>
+          <a:prstGeom prst="rect">
+            <a:avLst/>
+          </a:prstGeom>
+          <a:noFill/>
+          <a:ln w="9525">
+            <a:noFill/>
+            <a:miter lim="800000"/>
+            <a:headEnd/>
+            <a:tailEnd/>
+          </a:ln>
+        </p:spPr>
+        <p:txBody>
+          <a:bodyPr rot="0" vert="horz" wrap="square" lIns="91440" tIns="45720" rIns="91440" bIns="45720" anchor="t" anchorCtr="0">
+            <a:spAutoFit/>
+          </a:bodyPr>
+          <a:lstStyle/>
+          <a:p>
+            <a:pPr algn="just"/>
+            <a:r>
+              <a:rPr lang="en-GB" sz="1200" dirty="0">
+                <a:effectLst/>
+                <a:latin typeface="Arial" panose="020B0604020202020204" pitchFamily="34" charset="0"/>
+                <a:ea typeface="TH Sarabun PSK"/>
+                <a:cs typeface="TH Sarabun PSK"/>
+              </a:rPr>
+              <a:t>(a)</a:t>
+            </a:r>
+          </a:p>
+        </p:txBody>
+      </p:sp>
+      <p:sp>
+        <p:nvSpPr>
+          <p:cNvPr id="17" name="Text Box 2">
+            <a:extLst>
+              <a:ext uri="{FF2B5EF4-FFF2-40B4-BE49-F238E27FC236}">
+                <a16:creationId xmlns:a16="http://schemas.microsoft.com/office/drawing/2014/main" id="{3D265D0A-A4ED-C9CB-64B5-DEDAAD84F80C}"/>
+              </a:ext>
+            </a:extLst>
+          </p:cNvPr>
+          <p:cNvSpPr txBox="1">
+            <a:spLocks noChangeArrowheads="1"/>
+          </p:cNvSpPr>
+          <p:nvPr/>
+        </p:nvSpPr>
+        <p:spPr bwMode="auto">
+          <a:xfrm>
+            <a:off x="5153661" y="333228"/>
+            <a:ext cx="542519" cy="276999"/>
+          </a:xfrm>
+          <a:prstGeom prst="rect">
+            <a:avLst/>
+          </a:prstGeom>
+          <a:noFill/>
+          <a:ln w="9525">
+            <a:noFill/>
+            <a:miter lim="800000"/>
+            <a:headEnd/>
+            <a:tailEnd/>
+          </a:ln>
+        </p:spPr>
+        <p:txBody>
+          <a:bodyPr rot="0" vert="horz" wrap="square" lIns="91440" tIns="45720" rIns="91440" bIns="45720" anchor="t" anchorCtr="0">
+            <a:spAutoFit/>
+          </a:bodyPr>
+          <a:lstStyle/>
+          <a:p>
+            <a:pPr algn="just"/>
+            <a:r>
+              <a:rPr lang="en-GB" sz="1200" dirty="0">
+                <a:effectLst/>
+                <a:latin typeface="Arial" panose="020B0604020202020204" pitchFamily="34" charset="0"/>
+                <a:ea typeface="TH Sarabun PSK"/>
+                <a:cs typeface="TH Sarabun PSK"/>
+              </a:rPr>
+              <a:t>(b)</a:t>
+            </a:r>
+          </a:p>
+        </p:txBody>
+      </p:sp>
+      <p:sp>
+        <p:nvSpPr>
+          <p:cNvPr id="18" name="Text Box 2">
+            <a:extLst>
+              <a:ext uri="{FF2B5EF4-FFF2-40B4-BE49-F238E27FC236}">
+                <a16:creationId xmlns:a16="http://schemas.microsoft.com/office/drawing/2014/main" id="{4979E78C-637F-3FDD-3A44-8254A23738EC}"/>
+              </a:ext>
+            </a:extLst>
+          </p:cNvPr>
+          <p:cNvSpPr txBox="1">
+            <a:spLocks noChangeArrowheads="1"/>
+          </p:cNvSpPr>
+          <p:nvPr/>
+        </p:nvSpPr>
+        <p:spPr bwMode="auto">
+          <a:xfrm>
+            <a:off x="8087429" y="341631"/>
+            <a:ext cx="542519" cy="276999"/>
+          </a:xfrm>
+          <a:prstGeom prst="rect">
+            <a:avLst/>
+          </a:prstGeom>
+          <a:noFill/>
+          <a:ln w="9525">
+            <a:noFill/>
+            <a:miter lim="800000"/>
+            <a:headEnd/>
+            <a:tailEnd/>
+          </a:ln>
+        </p:spPr>
+        <p:txBody>
+          <a:bodyPr rot="0" vert="horz" wrap="square" lIns="91440" tIns="45720" rIns="91440" bIns="45720" anchor="t" anchorCtr="0">
+            <a:spAutoFit/>
+          </a:bodyPr>
+          <a:lstStyle/>
+          <a:p>
+            <a:pPr algn="just"/>
+            <a:r>
+              <a:rPr lang="en-GB" sz="1200" dirty="0">
+                <a:effectLst/>
+                <a:latin typeface="Arial" panose="020B0604020202020204" pitchFamily="34" charset="0"/>
+                <a:ea typeface="TH Sarabun PSK"/>
+                <a:cs typeface="TH Sarabun PSK"/>
+              </a:rPr>
+              <a:t>(</a:t>
+            </a:r>
+            <a:r>
+              <a:rPr lang="en-GB" sz="1200" dirty="0">
+                <a:latin typeface="Arial" panose="020B0604020202020204" pitchFamily="34" charset="0"/>
+                <a:ea typeface="TH Sarabun PSK"/>
+                <a:cs typeface="TH Sarabun PSK"/>
+              </a:rPr>
+              <a:t>c</a:t>
+            </a:r>
+            <a:r>
+              <a:rPr lang="en-GB" sz="1200" dirty="0">
+                <a:effectLst/>
+                <a:latin typeface="Arial" panose="020B0604020202020204" pitchFamily="34" charset="0"/>
+                <a:ea typeface="TH Sarabun PSK"/>
+                <a:cs typeface="TH Sarabun PSK"/>
+              </a:rPr>
+              <a:t>)</a:t>
+            </a:r>
+          </a:p>
+        </p:txBody>
+      </p:sp>
+      <p:sp>
+        <p:nvSpPr>
+          <p:cNvPr id="19" name="Text Box 2">
+            <a:extLst>
+              <a:ext uri="{FF2B5EF4-FFF2-40B4-BE49-F238E27FC236}">
+                <a16:creationId xmlns:a16="http://schemas.microsoft.com/office/drawing/2014/main" id="{AB53BA67-BD69-5723-8388-8ECD13F6E8F9}"/>
+              </a:ext>
+            </a:extLst>
+          </p:cNvPr>
+          <p:cNvSpPr txBox="1">
+            <a:spLocks noChangeArrowheads="1"/>
+          </p:cNvSpPr>
+          <p:nvPr/>
+        </p:nvSpPr>
+        <p:spPr bwMode="auto">
+          <a:xfrm>
+            <a:off x="5161454" y="2460125"/>
+            <a:ext cx="542519" cy="276999"/>
+          </a:xfrm>
+          <a:prstGeom prst="rect">
+            <a:avLst/>
+          </a:prstGeom>
+          <a:noFill/>
+          <a:ln w="9525">
+            <a:noFill/>
+            <a:miter lim="800000"/>
+            <a:headEnd/>
+            <a:tailEnd/>
+          </a:ln>
+        </p:spPr>
+        <p:txBody>
+          <a:bodyPr rot="0" vert="horz" wrap="square" lIns="91440" tIns="45720" rIns="91440" bIns="45720" anchor="t" anchorCtr="0">
+            <a:spAutoFit/>
+          </a:bodyPr>
+          <a:lstStyle/>
+          <a:p>
+            <a:pPr algn="just"/>
+            <a:r>
+              <a:rPr lang="en-GB" sz="1200" dirty="0">
+                <a:effectLst/>
+                <a:latin typeface="Arial" panose="020B0604020202020204" pitchFamily="34" charset="0"/>
+                <a:ea typeface="TH Sarabun PSK"/>
+                <a:cs typeface="TH Sarabun PSK"/>
+              </a:rPr>
+              <a:t>(</a:t>
+            </a:r>
+            <a:r>
+              <a:rPr lang="en-GB" sz="1200" dirty="0">
+                <a:latin typeface="Arial" panose="020B0604020202020204" pitchFamily="34" charset="0"/>
+                <a:ea typeface="TH Sarabun PSK"/>
+                <a:cs typeface="TH Sarabun PSK"/>
+              </a:rPr>
+              <a:t>e</a:t>
+            </a:r>
+            <a:r>
+              <a:rPr lang="en-GB" sz="1200" dirty="0">
+                <a:effectLst/>
+                <a:latin typeface="Arial" panose="020B0604020202020204" pitchFamily="34" charset="0"/>
+                <a:ea typeface="TH Sarabun PSK"/>
+                <a:cs typeface="TH Sarabun PSK"/>
+              </a:rPr>
+              <a:t>)</a:t>
+            </a:r>
+          </a:p>
+        </p:txBody>
+      </p:sp>
+      <p:sp>
+        <p:nvSpPr>
+          <p:cNvPr id="20" name="Text Box 2">
+            <a:extLst>
+              <a:ext uri="{FF2B5EF4-FFF2-40B4-BE49-F238E27FC236}">
+                <a16:creationId xmlns:a16="http://schemas.microsoft.com/office/drawing/2014/main" id="{96354FB6-89BE-D023-485C-FE4BC83465F2}"/>
+              </a:ext>
+            </a:extLst>
+          </p:cNvPr>
+          <p:cNvSpPr txBox="1">
+            <a:spLocks noChangeArrowheads="1"/>
+          </p:cNvSpPr>
+          <p:nvPr/>
+        </p:nvSpPr>
+        <p:spPr bwMode="auto">
+          <a:xfrm>
+            <a:off x="8087428" y="2460125"/>
+            <a:ext cx="542519" cy="276999"/>
+          </a:xfrm>
+          <a:prstGeom prst="rect">
+            <a:avLst/>
+          </a:prstGeom>
+          <a:noFill/>
+          <a:ln w="9525">
+            <a:noFill/>
+            <a:miter lim="800000"/>
+            <a:headEnd/>
+            <a:tailEnd/>
+          </a:ln>
+        </p:spPr>
+        <p:txBody>
+          <a:bodyPr rot="0" vert="horz" wrap="square" lIns="91440" tIns="45720" rIns="91440" bIns="45720" anchor="t" anchorCtr="0">
+            <a:spAutoFit/>
+          </a:bodyPr>
+          <a:lstStyle/>
+          <a:p>
+            <a:pPr algn="just"/>
+            <a:r>
+              <a:rPr lang="en-GB" sz="1200" dirty="0">
+                <a:effectLst/>
+                <a:latin typeface="Arial" panose="020B0604020202020204" pitchFamily="34" charset="0"/>
+                <a:ea typeface="TH Sarabun PSK"/>
+                <a:cs typeface="TH Sarabun PSK"/>
+              </a:rPr>
+              <a:t>(f)</a:t>
+            </a:r>
+          </a:p>
+        </p:txBody>
+      </p:sp>
+      <p:sp>
+        <p:nvSpPr>
+          <p:cNvPr id="21" name="Text Box 2">
+            <a:extLst>
+              <a:ext uri="{FF2B5EF4-FFF2-40B4-BE49-F238E27FC236}">
+                <a16:creationId xmlns:a16="http://schemas.microsoft.com/office/drawing/2014/main" id="{95CC9532-72C6-DE6D-15DF-C05EDA535128}"/>
+              </a:ext>
+            </a:extLst>
+          </p:cNvPr>
+          <p:cNvSpPr txBox="1">
+            <a:spLocks noChangeArrowheads="1"/>
+          </p:cNvSpPr>
+          <p:nvPr/>
+        </p:nvSpPr>
+        <p:spPr bwMode="auto">
+          <a:xfrm>
+            <a:off x="2208722" y="2460070"/>
+            <a:ext cx="542519" cy="276999"/>
+          </a:xfrm>
+          <a:prstGeom prst="rect">
+            <a:avLst/>
+          </a:prstGeom>
+          <a:noFill/>
+          <a:ln w="9525">
+            <a:noFill/>
+            <a:miter lim="800000"/>
+            <a:headEnd/>
+            <a:tailEnd/>
+          </a:ln>
+        </p:spPr>
+        <p:txBody>
+          <a:bodyPr rot="0" vert="horz" wrap="square" lIns="91440" tIns="45720" rIns="91440" bIns="45720" anchor="t" anchorCtr="0">
+            <a:spAutoFit/>
+          </a:bodyPr>
+          <a:lstStyle/>
+          <a:p>
+            <a:pPr algn="just"/>
+            <a:r>
+              <a:rPr lang="en-GB" sz="1200" dirty="0">
+                <a:effectLst/>
+                <a:latin typeface="Arial" panose="020B0604020202020204" pitchFamily="34" charset="0"/>
+                <a:ea typeface="TH Sarabun PSK"/>
+                <a:cs typeface="TH Sarabun PSK"/>
+              </a:rPr>
+              <a:t>(d)</a:t>
+            </a:r>
+          </a:p>
+        </p:txBody>
+      </p:sp>
+      <p:sp>
+        <p:nvSpPr>
+          <p:cNvPr id="22" name="Text Box 2">
+            <a:extLst>
+              <a:ext uri="{FF2B5EF4-FFF2-40B4-BE49-F238E27FC236}">
+                <a16:creationId xmlns:a16="http://schemas.microsoft.com/office/drawing/2014/main" id="{F170A06D-E56B-36D2-F229-A79F8B4B4B5C}"/>
+              </a:ext>
+            </a:extLst>
+          </p:cNvPr>
+          <p:cNvSpPr txBox="1">
+            <a:spLocks noChangeArrowheads="1"/>
+          </p:cNvSpPr>
+          <p:nvPr/>
+        </p:nvSpPr>
+        <p:spPr bwMode="auto">
+          <a:xfrm>
+            <a:off x="2197671" y="4553679"/>
+            <a:ext cx="542519" cy="276999"/>
+          </a:xfrm>
+          <a:prstGeom prst="rect">
+            <a:avLst/>
+          </a:prstGeom>
+          <a:noFill/>
+          <a:ln w="9525">
+            <a:noFill/>
+            <a:miter lim="800000"/>
+            <a:headEnd/>
+            <a:tailEnd/>
+          </a:ln>
+        </p:spPr>
+        <p:txBody>
+          <a:bodyPr rot="0" vert="horz" wrap="square" lIns="91440" tIns="45720" rIns="91440" bIns="45720" anchor="t" anchorCtr="0">
+            <a:spAutoFit/>
+          </a:bodyPr>
+          <a:lstStyle/>
+          <a:p>
+            <a:pPr algn="just"/>
+            <a:r>
+              <a:rPr lang="en-GB" sz="1200" dirty="0">
+                <a:effectLst/>
+                <a:latin typeface="Arial" panose="020B0604020202020204" pitchFamily="34" charset="0"/>
+                <a:ea typeface="TH Sarabun PSK"/>
+                <a:cs typeface="TH Sarabun PSK"/>
+              </a:rPr>
+              <a:t>(</a:t>
+            </a:r>
+            <a:r>
+              <a:rPr lang="en-GB" sz="1200" dirty="0">
+                <a:latin typeface="Arial" panose="020B0604020202020204" pitchFamily="34" charset="0"/>
+                <a:ea typeface="TH Sarabun PSK"/>
+                <a:cs typeface="TH Sarabun PSK"/>
+              </a:rPr>
+              <a:t>g</a:t>
+            </a:r>
+            <a:r>
+              <a:rPr lang="en-GB" sz="1200" dirty="0">
+                <a:effectLst/>
+                <a:latin typeface="Arial" panose="020B0604020202020204" pitchFamily="34" charset="0"/>
+                <a:ea typeface="TH Sarabun PSK"/>
+                <a:cs typeface="TH Sarabun PSK"/>
+              </a:rPr>
+              <a:t>)</a:t>
+            </a:r>
+          </a:p>
+        </p:txBody>
+      </p:sp>
+      <p:sp>
+        <p:nvSpPr>
+          <p:cNvPr id="23" name="Text Box 2">
+            <a:extLst>
+              <a:ext uri="{FF2B5EF4-FFF2-40B4-BE49-F238E27FC236}">
+                <a16:creationId xmlns:a16="http://schemas.microsoft.com/office/drawing/2014/main" id="{50E51471-8123-79B2-68B9-734263DE893D}"/>
+              </a:ext>
+            </a:extLst>
+          </p:cNvPr>
+          <p:cNvSpPr txBox="1">
+            <a:spLocks noChangeArrowheads="1"/>
+          </p:cNvSpPr>
+          <p:nvPr/>
+        </p:nvSpPr>
+        <p:spPr bwMode="auto">
+          <a:xfrm>
+            <a:off x="5137745" y="4560029"/>
+            <a:ext cx="542519" cy="276999"/>
+          </a:xfrm>
+          <a:prstGeom prst="rect">
+            <a:avLst/>
+          </a:prstGeom>
+          <a:noFill/>
+          <a:ln w="9525">
+            <a:noFill/>
+            <a:miter lim="800000"/>
+            <a:headEnd/>
+            <a:tailEnd/>
+          </a:ln>
+        </p:spPr>
+        <p:txBody>
+          <a:bodyPr rot="0" vert="horz" wrap="square" lIns="91440" tIns="45720" rIns="91440" bIns="45720" anchor="t" anchorCtr="0">
+            <a:spAutoFit/>
+          </a:bodyPr>
+          <a:lstStyle/>
+          <a:p>
+            <a:pPr algn="just"/>
+            <a:r>
+              <a:rPr lang="en-GB" sz="1200" dirty="0">
+                <a:effectLst/>
+                <a:latin typeface="Arial" panose="020B0604020202020204" pitchFamily="34" charset="0"/>
+                <a:ea typeface="TH Sarabun PSK"/>
+                <a:cs typeface="TH Sarabun PSK"/>
+              </a:rPr>
+              <a:t>(h)</a:t>
+            </a:r>
+          </a:p>
+        </p:txBody>
+      </p:sp>
+      <p:sp>
+        <p:nvSpPr>
+          <p:cNvPr id="24" name="Text Box 2">
+            <a:extLst>
+              <a:ext uri="{FF2B5EF4-FFF2-40B4-BE49-F238E27FC236}">
+                <a16:creationId xmlns:a16="http://schemas.microsoft.com/office/drawing/2014/main" id="{0D8F6B70-FB42-9A4D-D609-D038DA274DD8}"/>
+              </a:ext>
+            </a:extLst>
+          </p:cNvPr>
+          <p:cNvSpPr txBox="1">
+            <a:spLocks noChangeArrowheads="1"/>
+          </p:cNvSpPr>
+          <p:nvPr/>
+        </p:nvSpPr>
+        <p:spPr bwMode="auto">
+          <a:xfrm>
+            <a:off x="8093997" y="4565638"/>
+            <a:ext cx="542519" cy="276999"/>
+          </a:xfrm>
+          <a:prstGeom prst="rect">
+            <a:avLst/>
+          </a:prstGeom>
+          <a:noFill/>
+          <a:ln w="9525">
+            <a:noFill/>
+            <a:miter lim="800000"/>
+            <a:headEnd/>
+            <a:tailEnd/>
+          </a:ln>
+        </p:spPr>
+        <p:txBody>
+          <a:bodyPr rot="0" vert="horz" wrap="square" lIns="91440" tIns="45720" rIns="91440" bIns="45720" anchor="t" anchorCtr="0">
+            <a:spAutoFit/>
+          </a:bodyPr>
+          <a:lstStyle/>
+          <a:p>
+            <a:pPr algn="just"/>
+            <a:r>
+              <a:rPr lang="en-GB" sz="1200" dirty="0">
+                <a:effectLst/>
+                <a:latin typeface="Arial" panose="020B0604020202020204" pitchFamily="34" charset="0"/>
+                <a:ea typeface="TH Sarabun PSK"/>
+                <a:cs typeface="TH Sarabun PSK"/>
+              </a:rPr>
+              <a:t>(</a:t>
+            </a:r>
+            <a:r>
+              <a:rPr lang="en-GB" sz="1200" dirty="0">
+                <a:latin typeface="Arial" panose="020B0604020202020204" pitchFamily="34" charset="0"/>
+                <a:ea typeface="TH Sarabun PSK"/>
+                <a:cs typeface="TH Sarabun PSK"/>
+              </a:rPr>
+              <a:t>i</a:t>
+            </a:r>
+            <a:r>
+              <a:rPr lang="en-GB" sz="1200" dirty="0">
+                <a:effectLst/>
+                <a:latin typeface="Arial" panose="020B0604020202020204" pitchFamily="34" charset="0"/>
+                <a:ea typeface="TH Sarabun PSK"/>
+                <a:cs typeface="TH Sarabun PSK"/>
+              </a:rPr>
+              <a:t>)</a:t>
+            </a:r>
+          </a:p>
+        </p:txBody>
+      </p:sp>
     </p:spTree>
     <p:extLst>
       <p:ext uri="{BB962C8B-B14F-4D97-AF65-F5344CB8AC3E}">
-        <p14:creationId xmlns:p14="http://schemas.microsoft.com/office/powerpoint/2010/main" val="4124847423"/>
+        <p14:creationId xmlns:p14="http://schemas.microsoft.com/office/powerpoint/2010/main" val="4121053639"/>
       </p:ext>
     </p:extLst>
   </p:cSld>

</xml_diff>